<commit_message>
Expand Markdown support and use ps-python-pptx public APIs
</commit_message>
<xml_diff>
--- a/sample/showcase.pptx
+++ b/sample/showcase.pptx
@@ -43,6 +43,9 @@
     <p:sldId xmlns:ns0="http://schemas.openxmlformats.org/officeDocument/2006/relationships" id="287" ns0:id="rId39"/>
     <p:sldId xmlns:ns0="http://schemas.openxmlformats.org/officeDocument/2006/relationships" id="288" ns0:id="rId40"/>
     <p:sldId xmlns:ns0="http://schemas.openxmlformats.org/officeDocument/2006/relationships" id="289" ns0:id="rId41"/>
+    <p:sldId xmlns:ns0="http://schemas.openxmlformats.org/officeDocument/2006/relationships" id="290" ns0:id="rId42"/>
+    <p:sldId xmlns:ns0="http://schemas.openxmlformats.org/officeDocument/2006/relationships" id="291" ns0:id="rId43"/>
+    <p:sldId xmlns:ns0="http://schemas.openxmlformats.org/officeDocument/2006/relationships" id="292" ns0:id="rId44"/>
   </p:sldIdLst>
   <p:sldSz cx="12192000" cy="6858000"/>
   <p:notesSz cx="6858000" cy="9144000"/>
@@ -3473,8 +3476,8 @@
 <p:sldMaster xmlns:p="http://schemas.openxmlformats.org/presentationml/2006/main">
   <p:cSld>
     <p:bg>
-      <p:bgPr>
-        <a:gradFill xmlns:a="http://schemas.openxmlformats.org/drawingml/2006/main" rotWithShape="1">
+      <p:bgPr xmlns:a="http://schemas.openxmlformats.org/drawingml/2006/main">
+        <a:gradFill rotWithShape="1">
           <a:gsLst>
             <a:gs pos="0">
               <a:srgbClr val="F3FAFF"/>
@@ -3488,7 +3491,7 @@
           </a:gsLst>
           <a:lin ang="16200000" scaled="0"/>
         </a:gradFill>
-        <a:effectLst xmlns:a="http://schemas.openxmlformats.org/drawingml/2006/main"/>
+        <a:effectLst/>
       </p:bgPr>
     </p:bg>
     <p:spTree>
@@ -4071,7 +4074,6 @@
           </a:gsLst>
           <a:lin ang="16200000" scaled="0"/>
         </a:gradFill>
-        <a:effectLst xmlns:a="http://schemas.openxmlformats.org/drawingml/2006/main"/>
       </p:bgPr>
     </p:bg>
     <p:spTree>
@@ -4371,573 +4373,573 @@
 </file>
 
 <file path=ppt/slideMasters/theme/theme2.xml><?xml version="1.0" encoding="utf-8"?>
-<ns0:theme xmlns:ns0="http://schemas.openxmlformats.org/drawingml/2006/main" name="Office Theme">
-  <ns0:themeElements>
-    <ns0:clrScheme name="Custom">
-      <ns0:dk1>
-        <ns0:srgbClr val="10263F"/>
-      </ns0:dk1>
-      <ns0:lt1>
-        <ns0:srgbClr val="F9F9F9"/>
-      </ns0:lt1>
-      <ns0:dk2>
-        <ns0:srgbClr val="355A78"/>
-      </ns0:dk2>
-      <ns0:lt2>
-        <ns0:srgbClr val="EEF8FF"/>
-      </ns0:lt2>
-      <ns0:accent1>
-        <ns0:srgbClr val="1D6FA8"/>
-      </ns0:accent1>
-      <ns0:accent2>
-        <ns0:srgbClr val="5AA9E6"/>
-      </ns0:accent2>
-      <ns0:accent3>
-        <ns0:srgbClr val="7FC8F8"/>
-      </ns0:accent3>
-      <ns0:accent4>
-        <ns0:srgbClr val="FFB347"/>
-      </ns0:accent4>
-      <ns0:accent5>
-        <ns0:srgbClr val="FF6392"/>
-      </ns0:accent5>
-      <ns0:accent6>
-        <ns0:srgbClr val="144F79"/>
-      </ns0:accent6>
-      <ns0:hlink>
-        <ns0:srgbClr val="1D6FA8"/>
-      </ns0:hlink>
-      <ns0:folHlink>
-        <ns0:srgbClr val="355A78"/>
-      </ns0:folHlink>
-    </ns0:clrScheme>
-    <ns0:fontScheme name="Office">
-      <ns0:majorFont>
-        <ns0:latin typeface="Aptos Display"/>
-        <ns0:ea typeface=""/>
-        <ns0:cs typeface=""/>
-        <ns0:font script="Jpan" typeface="游ゴシック Light"/>
-        <ns0:font script="Hang" typeface="맑은 고딕"/>
-        <ns0:font script="Hans" typeface="等线 Light"/>
-        <ns0:font script="Hant" typeface="新細明體"/>
-        <ns0:font script="Arab" typeface="Times New Roman"/>
-        <ns0:font script="Hebr" typeface="Times New Roman"/>
-        <ns0:font script="Thai" typeface="Angsana New"/>
-        <ns0:font script="Ethi" typeface="Nyala"/>
-        <ns0:font script="Beng" typeface="Vrinda"/>
-        <ns0:font script="Gujr" typeface="Shruti"/>
-        <ns0:font script="Khmr" typeface="MoolBoran"/>
-        <ns0:font script="Knda" typeface="Tunga"/>
-        <ns0:font script="Guru" typeface="Raavi"/>
-        <ns0:font script="Cans" typeface="Euphemia"/>
-        <ns0:font script="Cher" typeface="Plantagenet Cherokee"/>
-        <ns0:font script="Yiii" typeface="Microsoft Yi Baiti"/>
-        <ns0:font script="Tibt" typeface="Microsoft Himalaya"/>
-        <ns0:font script="Thaa" typeface="MV Boli"/>
-        <ns0:font script="Deva" typeface="Mangal"/>
-        <ns0:font script="Telu" typeface="Gautami"/>
-        <ns0:font script="Taml" typeface="Latha"/>
-        <ns0:font script="Syrc" typeface="Estrangelo Edessa"/>
-        <ns0:font script="Orya" typeface="Kalinga"/>
-        <ns0:font script="Mlym" typeface="Kartika"/>
-        <ns0:font script="Laoo" typeface="DokChampa"/>
-        <ns0:font script="Sinh" typeface="Iskoola Pota"/>
-        <ns0:font script="Mong" typeface="Mongolian Baiti"/>
-        <ns0:font script="Viet" typeface="Times New Roman"/>
-        <ns0:font script="Uigh" typeface="Microsoft Uighur"/>
-        <ns0:font script="Geor" typeface="Sylfaen"/>
-        <ns0:font script="Armn" typeface="Arial"/>
-        <ns0:font script="Bugi" typeface="Leelawadee UI"/>
-        <ns0:font script="Bopo" typeface="Microsoft JhengHei"/>
-        <ns0:font script="Java" typeface="Javanese Text"/>
-        <ns0:font script="Lisu" typeface="Segoe UI"/>
-        <ns0:font script="Mymr" typeface="Myanmar Text"/>
-        <ns0:font script="Nkoo" typeface="Ebrima"/>
-        <ns0:font script="Olck" typeface="Nirmala UI"/>
-        <ns0:font script="Osma" typeface="Ebrima"/>
-        <ns0:font script="Phag" typeface="Phagspa"/>
-        <ns0:font script="Syrn" typeface="Estrangelo Edessa"/>
-        <ns0:font script="Syrj" typeface="Estrangelo Edessa"/>
-        <ns0:font script="Syre" typeface="Estrangelo Edessa"/>
-        <ns0:font script="Sora" typeface="Nirmala UI"/>
-        <ns0:font script="Tale" typeface="Microsoft Tai Le"/>
-        <ns0:font script="Talu" typeface="Microsoft New Tai Lue"/>
-        <ns0:font script="Tfng" typeface="Ebrima"/>
-      </ns0:majorFont>
-      <ns0:minorFont>
-        <ns0:latin typeface="Aptos"/>
-        <ns0:ea typeface=""/>
-        <ns0:cs typeface=""/>
-        <ns0:font script="Jpan" typeface="游ゴシック"/>
-        <ns0:font script="Hang" typeface="맑은 고딕"/>
-        <ns0:font script="Hans" typeface="等线"/>
-        <ns0:font script="Hant" typeface="新細明體"/>
-        <ns0:font script="Arab" typeface="Arial"/>
-        <ns0:font script="Hebr" typeface="Arial"/>
-        <ns0:font script="Thai" typeface="Cordia New"/>
-        <ns0:font script="Ethi" typeface="Nyala"/>
-        <ns0:font script="Beng" typeface="Vrinda"/>
-        <ns0:font script="Gujr" typeface="Shruti"/>
-        <ns0:font script="Khmr" typeface="DaunPenh"/>
-        <ns0:font script="Knda" typeface="Tunga"/>
-        <ns0:font script="Guru" typeface="Raavi"/>
-        <ns0:font script="Cans" typeface="Euphemia"/>
-        <ns0:font script="Cher" typeface="Plantagenet Cherokee"/>
-        <ns0:font script="Yiii" typeface="Microsoft Yi Baiti"/>
-        <ns0:font script="Tibt" typeface="Microsoft Himalaya"/>
-        <ns0:font script="Thaa" typeface="MV Boli"/>
-        <ns0:font script="Deva" typeface="Mangal"/>
-        <ns0:font script="Telu" typeface="Gautami"/>
-        <ns0:font script="Taml" typeface="Latha"/>
-        <ns0:font script="Syrc" typeface="Estrangelo Edessa"/>
-        <ns0:font script="Orya" typeface="Kalinga"/>
-        <ns0:font script="Mlym" typeface="Kartika"/>
-        <ns0:font script="Laoo" typeface="DokChampa"/>
-        <ns0:font script="Sinh" typeface="Iskoola Pota"/>
-        <ns0:font script="Mong" typeface="Mongolian Baiti"/>
-        <ns0:font script="Viet" typeface="Arial"/>
-        <ns0:font script="Uigh" typeface="Microsoft Uighur"/>
-        <ns0:font script="Geor" typeface="Sylfaen"/>
-        <ns0:font script="Armn" typeface="Arial"/>
-        <ns0:font script="Bugi" typeface="Leelawadee UI"/>
-        <ns0:font script="Bopo" typeface="Microsoft JhengHei"/>
-        <ns0:font script="Java" typeface="Javanese Text"/>
-        <ns0:font script="Lisu" typeface="Segoe UI"/>
-        <ns0:font script="Mymr" typeface="Myanmar Text"/>
-        <ns0:font script="Nkoo" typeface="Ebrima"/>
-        <ns0:font script="Olck" typeface="Nirmala UI"/>
-        <ns0:font script="Osma" typeface="Ebrima"/>
-        <ns0:font script="Phag" typeface="Phagspa"/>
-        <ns0:font script="Syrn" typeface="Estrangelo Edessa"/>
-        <ns0:font script="Syrj" typeface="Estrangelo Edessa"/>
-        <ns0:font script="Syre" typeface="Estrangelo Edessa"/>
-        <ns0:font script="Sora" typeface="Nirmala UI"/>
-        <ns0:font script="Tale" typeface="Microsoft Tai Le"/>
-        <ns0:font script="Talu" typeface="Microsoft New Tai Lue"/>
-        <ns0:font script="Tfng" typeface="Ebrima"/>
-      </ns0:minorFont>
-    </ns0:fontScheme>
-    <ns0:fmtScheme name="Office">
-      <ns0:fillStyleLst>
-        <ns0:solidFill>
-          <ns0:schemeClr val="phClr"/>
-        </ns0:solidFill>
-        <ns0:gradFill rotWithShape="1">
-          <ns0:gsLst>
-            <ns0:gs pos="0">
-              <ns0:schemeClr val="phClr">
-                <ns0:tint val="67000"/>
-                <ns0:lumMod val="110000"/>
-                <ns0:satMod val="105000"/>
-              </ns0:schemeClr>
-            </ns0:gs>
-            <ns0:gs pos="50000">
-              <ns0:schemeClr val="phClr">
-                <ns0:tint val="73000"/>
-                <ns0:lumMod val="105000"/>
-                <ns0:satMod val="103000"/>
-              </ns0:schemeClr>
-            </ns0:gs>
-            <ns0:gs pos="100000">
-              <ns0:schemeClr val="phClr">
-                <ns0:tint val="81000"/>
-                <ns0:lumMod val="105000"/>
-                <ns0:satMod val="109000"/>
-              </ns0:schemeClr>
-            </ns0:gs>
-          </ns0:gsLst>
-          <ns0:lin ang="5400000" scaled="0"/>
-        </ns0:gradFill>
-        <ns0:gradFill rotWithShape="1">
-          <ns0:gsLst>
-            <ns0:gs pos="0">
-              <ns0:schemeClr val="phClr">
-                <ns0:tint val="94000"/>
-                <ns0:lumMod val="102000"/>
-                <ns0:satMod val="103000"/>
-              </ns0:schemeClr>
-            </ns0:gs>
-            <ns0:gs pos="50000">
-              <ns0:schemeClr val="phClr">
-                <ns0:shade val="100000"/>
-                <ns0:lumMod val="100000"/>
-                <ns0:satMod val="110000"/>
-              </ns0:schemeClr>
-            </ns0:gs>
-            <ns0:gs pos="100000">
-              <ns0:schemeClr val="phClr">
-                <ns0:shade val="78000"/>
-                <ns0:lumMod val="99000"/>
-                <ns0:satMod val="120000"/>
-              </ns0:schemeClr>
-            </ns0:gs>
-          </ns0:gsLst>
-          <ns0:lin ang="5400000" scaled="0"/>
-        </ns0:gradFill>
-      </ns0:fillStyleLst>
-      <ns0:lnStyleLst>
-        <ns0:ln w="12700">
-          <ns0:solidFill>
-            <ns0:schemeClr val="phClr"/>
-          </ns0:solidFill>
-          <ns0:prstDash val="solid"/>
-        </ns0:ln>
-        <ns0:ln w="19050">
-          <ns0:solidFill>
-            <ns0:schemeClr val="phClr"/>
-          </ns0:solidFill>
-          <ns0:prstDash val="solid"/>
-        </ns0:ln>
-        <ns0:ln w="25400">
-          <ns0:solidFill>
-            <ns0:schemeClr val="phClr"/>
-          </ns0:solidFill>
-          <ns0:prstDash val="solid"/>
-        </ns0:ln>
-      </ns0:lnStyleLst>
-      <ns0:effectStyleLst>
-        <ns0:effectStyle>
-          <ns0:effectLst/>
-        </ns0:effectStyle>
-        <ns0:effectStyle>
-          <ns0:effectLst/>
-        </ns0:effectStyle>
-        <ns0:effectStyle>
-          <ns0:effectLst>
-            <ns0:outerShdw blurRad="57150" dist="19050" dir="5400000" algn="ctr" rotWithShape="0">
-              <ns0:srgbClr val="000000">
-                <ns0:alpha val="63000"/>
-              </ns0:srgbClr>
-            </ns0:outerShdw>
-          </ns0:effectLst>
-        </ns0:effectStyle>
-      </ns0:effectStyleLst>
-      <ns0:bgFillStyleLst>
-        <ns0:solidFill>
-          <ns0:schemeClr val="phClr"/>
-        </ns0:solidFill>
-        <ns0:solidFill>
-          <ns0:schemeClr val="phClr">
-            <ns0:tint val="95000"/>
-            <ns0:satMod val="170000"/>
-          </ns0:schemeClr>
-        </ns0:solidFill>
-        <ns0:gradFill rotWithShape="1">
-          <ns0:gsLst>
-            <ns0:gs pos="0">
-              <ns0:schemeClr val="phClr">
-                <ns0:tint val="93000"/>
-                <ns0:shade val="98000"/>
-                <ns0:lumMod val="102000"/>
-                <ns0:satMod val="150000"/>
-              </ns0:schemeClr>
-            </ns0:gs>
-            <ns0:gs pos="50000">
-              <ns0:schemeClr val="phClr">
-                <ns0:tint val="98000"/>
-                <ns0:shade val="90000"/>
-                <ns0:lumMod val="103000"/>
-                <ns0:satMod val="130000"/>
-              </ns0:schemeClr>
-            </ns0:gs>
-            <ns0:gs pos="100000">
-              <ns0:schemeClr val="phClr">
-                <ns0:shade val="63000"/>
-                <ns0:satMod val="120000"/>
-              </ns0:schemeClr>
-            </ns0:gs>
-          </ns0:gsLst>
-          <ns0:lin ang="5400000" scaled="0"/>
-        </ns0:gradFill>
-      </ns0:bgFillStyleLst>
-    </ns0:fmtScheme>
-  </ns0:themeElements>
-</ns0:theme>
+<a:theme xmlns:a="http://schemas.openxmlformats.org/drawingml/2006/main" name="Office Theme">
+  <a:themeElements>
+    <a:clrScheme name="Custom">
+      <a:dk1>
+        <a:srgbClr val="10263F"/>
+      </a:dk1>
+      <a:lt1>
+        <a:srgbClr val="F9F9F9"/>
+      </a:lt1>
+      <a:dk2>
+        <a:srgbClr val="355A78"/>
+      </a:dk2>
+      <a:lt2>
+        <a:srgbClr val="EEF8FF"/>
+      </a:lt2>
+      <a:accent1>
+        <a:srgbClr val="1D6FA8"/>
+      </a:accent1>
+      <a:accent2>
+        <a:srgbClr val="5AA9E6"/>
+      </a:accent2>
+      <a:accent3>
+        <a:srgbClr val="7FC8F8"/>
+      </a:accent3>
+      <a:accent4>
+        <a:srgbClr val="FFB347"/>
+      </a:accent4>
+      <a:accent5>
+        <a:srgbClr val="FF6392"/>
+      </a:accent5>
+      <a:accent6>
+        <a:srgbClr val="144F79"/>
+      </a:accent6>
+      <a:hlink>
+        <a:srgbClr val="1D6FA8"/>
+      </a:hlink>
+      <a:folHlink>
+        <a:srgbClr val="355A78"/>
+      </a:folHlink>
+    </a:clrScheme>
+    <a:fontScheme name="Office">
+      <a:majorFont>
+        <a:latin typeface="Aptos Display"/>
+        <a:ea typeface=""/>
+        <a:cs typeface=""/>
+        <a:font script="Jpan" typeface="游ゴシック Light"/>
+        <a:font script="Hang" typeface="맑은 고딕"/>
+        <a:font script="Hans" typeface="等线 Light"/>
+        <a:font script="Hant" typeface="新細明體"/>
+        <a:font script="Arab" typeface="Times New Roman"/>
+        <a:font script="Hebr" typeface="Times New Roman"/>
+        <a:font script="Thai" typeface="Angsana New"/>
+        <a:font script="Ethi" typeface="Nyala"/>
+        <a:font script="Beng" typeface="Vrinda"/>
+        <a:font script="Gujr" typeface="Shruti"/>
+        <a:font script="Khmr" typeface="MoolBoran"/>
+        <a:font script="Knda" typeface="Tunga"/>
+        <a:font script="Guru" typeface="Raavi"/>
+        <a:font script="Cans" typeface="Euphemia"/>
+        <a:font script="Cher" typeface="Plantagenet Cherokee"/>
+        <a:font script="Yiii" typeface="Microsoft Yi Baiti"/>
+        <a:font script="Tibt" typeface="Microsoft Himalaya"/>
+        <a:font script="Thaa" typeface="MV Boli"/>
+        <a:font script="Deva" typeface="Mangal"/>
+        <a:font script="Telu" typeface="Gautami"/>
+        <a:font script="Taml" typeface="Latha"/>
+        <a:font script="Syrc" typeface="Estrangelo Edessa"/>
+        <a:font script="Orya" typeface="Kalinga"/>
+        <a:font script="Mlym" typeface="Kartika"/>
+        <a:font script="Laoo" typeface="DokChampa"/>
+        <a:font script="Sinh" typeface="Iskoola Pota"/>
+        <a:font script="Mong" typeface="Mongolian Baiti"/>
+        <a:font script="Viet" typeface="Times New Roman"/>
+        <a:font script="Uigh" typeface="Microsoft Uighur"/>
+        <a:font script="Geor" typeface="Sylfaen"/>
+        <a:font script="Armn" typeface="Arial"/>
+        <a:font script="Bugi" typeface="Leelawadee UI"/>
+        <a:font script="Bopo" typeface="Microsoft JhengHei"/>
+        <a:font script="Java" typeface="Javanese Text"/>
+        <a:font script="Lisu" typeface="Segoe UI"/>
+        <a:font script="Mymr" typeface="Myanmar Text"/>
+        <a:font script="Nkoo" typeface="Ebrima"/>
+        <a:font script="Olck" typeface="Nirmala UI"/>
+        <a:font script="Osma" typeface="Ebrima"/>
+        <a:font script="Phag" typeface="Phagspa"/>
+        <a:font script="Syrn" typeface="Estrangelo Edessa"/>
+        <a:font script="Syrj" typeface="Estrangelo Edessa"/>
+        <a:font script="Syre" typeface="Estrangelo Edessa"/>
+        <a:font script="Sora" typeface="Nirmala UI"/>
+        <a:font script="Tale" typeface="Microsoft Tai Le"/>
+        <a:font script="Talu" typeface="Microsoft New Tai Lue"/>
+        <a:font script="Tfng" typeface="Ebrima"/>
+      </a:majorFont>
+      <a:minorFont>
+        <a:latin typeface="Aptos"/>
+        <a:ea typeface=""/>
+        <a:cs typeface=""/>
+        <a:font script="Jpan" typeface="游ゴシック"/>
+        <a:font script="Hang" typeface="맑은 고딕"/>
+        <a:font script="Hans" typeface="等线"/>
+        <a:font script="Hant" typeface="新細明體"/>
+        <a:font script="Arab" typeface="Arial"/>
+        <a:font script="Hebr" typeface="Arial"/>
+        <a:font script="Thai" typeface="Cordia New"/>
+        <a:font script="Ethi" typeface="Nyala"/>
+        <a:font script="Beng" typeface="Vrinda"/>
+        <a:font script="Gujr" typeface="Shruti"/>
+        <a:font script="Khmr" typeface="DaunPenh"/>
+        <a:font script="Knda" typeface="Tunga"/>
+        <a:font script="Guru" typeface="Raavi"/>
+        <a:font script="Cans" typeface="Euphemia"/>
+        <a:font script="Cher" typeface="Plantagenet Cherokee"/>
+        <a:font script="Yiii" typeface="Microsoft Yi Baiti"/>
+        <a:font script="Tibt" typeface="Microsoft Himalaya"/>
+        <a:font script="Thaa" typeface="MV Boli"/>
+        <a:font script="Deva" typeface="Mangal"/>
+        <a:font script="Telu" typeface="Gautami"/>
+        <a:font script="Taml" typeface="Latha"/>
+        <a:font script="Syrc" typeface="Estrangelo Edessa"/>
+        <a:font script="Orya" typeface="Kalinga"/>
+        <a:font script="Mlym" typeface="Kartika"/>
+        <a:font script="Laoo" typeface="DokChampa"/>
+        <a:font script="Sinh" typeface="Iskoola Pota"/>
+        <a:font script="Mong" typeface="Mongolian Baiti"/>
+        <a:font script="Viet" typeface="Arial"/>
+        <a:font script="Uigh" typeface="Microsoft Uighur"/>
+        <a:font script="Geor" typeface="Sylfaen"/>
+        <a:font script="Armn" typeface="Arial"/>
+        <a:font script="Bugi" typeface="Leelawadee UI"/>
+        <a:font script="Bopo" typeface="Microsoft JhengHei"/>
+        <a:font script="Java" typeface="Javanese Text"/>
+        <a:font script="Lisu" typeface="Segoe UI"/>
+        <a:font script="Mymr" typeface="Myanmar Text"/>
+        <a:font script="Nkoo" typeface="Ebrima"/>
+        <a:font script="Olck" typeface="Nirmala UI"/>
+        <a:font script="Osma" typeface="Ebrima"/>
+        <a:font script="Phag" typeface="Phagspa"/>
+        <a:font script="Syrn" typeface="Estrangelo Edessa"/>
+        <a:font script="Syrj" typeface="Estrangelo Edessa"/>
+        <a:font script="Syre" typeface="Estrangelo Edessa"/>
+        <a:font script="Sora" typeface="Nirmala UI"/>
+        <a:font script="Tale" typeface="Microsoft Tai Le"/>
+        <a:font script="Talu" typeface="Microsoft New Tai Lue"/>
+        <a:font script="Tfng" typeface="Ebrima"/>
+      </a:minorFont>
+    </a:fontScheme>
+    <a:fmtScheme name="Office">
+      <a:fillStyleLst>
+        <a:solidFill>
+          <a:schemeClr val="phClr"/>
+        </a:solidFill>
+        <a:gradFill rotWithShape="1">
+          <a:gsLst>
+            <a:gs pos="0">
+              <a:schemeClr val="phClr">
+                <a:tint val="67000"/>
+                <a:lumMod val="110000"/>
+                <a:satMod val="105000"/>
+              </a:schemeClr>
+            </a:gs>
+            <a:gs pos="50000">
+              <a:schemeClr val="phClr">
+                <a:tint val="73000"/>
+                <a:lumMod val="105000"/>
+                <a:satMod val="103000"/>
+              </a:schemeClr>
+            </a:gs>
+            <a:gs pos="100000">
+              <a:schemeClr val="phClr">
+                <a:tint val="81000"/>
+                <a:lumMod val="105000"/>
+                <a:satMod val="109000"/>
+              </a:schemeClr>
+            </a:gs>
+          </a:gsLst>
+          <a:lin ang="5400000" scaled="0"/>
+        </a:gradFill>
+        <a:gradFill rotWithShape="1">
+          <a:gsLst>
+            <a:gs pos="0">
+              <a:schemeClr val="phClr">
+                <a:tint val="94000"/>
+                <a:lumMod val="102000"/>
+                <a:satMod val="103000"/>
+              </a:schemeClr>
+            </a:gs>
+            <a:gs pos="50000">
+              <a:schemeClr val="phClr">
+                <a:shade val="100000"/>
+                <a:lumMod val="100000"/>
+                <a:satMod val="110000"/>
+              </a:schemeClr>
+            </a:gs>
+            <a:gs pos="100000">
+              <a:schemeClr val="phClr">
+                <a:shade val="78000"/>
+                <a:lumMod val="99000"/>
+                <a:satMod val="120000"/>
+              </a:schemeClr>
+            </a:gs>
+          </a:gsLst>
+          <a:lin ang="5400000" scaled="0"/>
+        </a:gradFill>
+      </a:fillStyleLst>
+      <a:lnStyleLst>
+        <a:ln w="12700">
+          <a:solidFill>
+            <a:schemeClr val="phClr"/>
+          </a:solidFill>
+          <a:prstDash val="solid"/>
+        </a:ln>
+        <a:ln w="19050">
+          <a:solidFill>
+            <a:schemeClr val="phClr"/>
+          </a:solidFill>
+          <a:prstDash val="solid"/>
+        </a:ln>
+        <a:ln w="25400">
+          <a:solidFill>
+            <a:schemeClr val="phClr"/>
+          </a:solidFill>
+          <a:prstDash val="solid"/>
+        </a:ln>
+      </a:lnStyleLst>
+      <a:effectStyleLst>
+        <a:effectStyle>
+          <a:effectLst/>
+        </a:effectStyle>
+        <a:effectStyle>
+          <a:effectLst/>
+        </a:effectStyle>
+        <a:effectStyle>
+          <a:effectLst>
+            <a:outerShdw blurRad="57150" dist="19050" dir="5400000" algn="ctr" rotWithShape="0">
+              <a:srgbClr val="000000">
+                <a:alpha val="63000"/>
+              </a:srgbClr>
+            </a:outerShdw>
+          </a:effectLst>
+        </a:effectStyle>
+      </a:effectStyleLst>
+      <a:bgFillStyleLst>
+        <a:solidFill>
+          <a:schemeClr val="phClr"/>
+        </a:solidFill>
+        <a:solidFill>
+          <a:schemeClr val="phClr">
+            <a:tint val="95000"/>
+            <a:satMod val="170000"/>
+          </a:schemeClr>
+        </a:solidFill>
+        <a:gradFill rotWithShape="1">
+          <a:gsLst>
+            <a:gs pos="0">
+              <a:schemeClr val="phClr">
+                <a:tint val="93000"/>
+                <a:shade val="98000"/>
+                <a:lumMod val="102000"/>
+                <a:satMod val="150000"/>
+              </a:schemeClr>
+            </a:gs>
+            <a:gs pos="50000">
+              <a:schemeClr val="phClr">
+                <a:tint val="98000"/>
+                <a:shade val="90000"/>
+                <a:lumMod val="103000"/>
+                <a:satMod val="130000"/>
+              </a:schemeClr>
+            </a:gs>
+            <a:gs pos="100000">
+              <a:schemeClr val="phClr">
+                <a:shade val="63000"/>
+                <a:satMod val="120000"/>
+              </a:schemeClr>
+            </a:gs>
+          </a:gsLst>
+          <a:lin ang="5400000" scaled="0"/>
+        </a:gradFill>
+      </a:bgFillStyleLst>
+    </a:fmtScheme>
+  </a:themeElements>
+</a:theme>
 </file>
 
 <file path=ppt/slideMasters/theme/theme3.xml><?xml version="1.0" encoding="utf-8"?>
-<ns0:theme xmlns:ns0="http://schemas.openxmlformats.org/drawingml/2006/main" name="Office Theme">
-  <ns0:themeElements>
-    <ns0:clrScheme name="Custom">
-      <ns0:dk1>
-        <ns0:srgbClr val="10263F"/>
-      </ns0:dk1>
-      <ns0:lt1>
-        <ns0:srgbClr val="F9F9F9"/>
-      </ns0:lt1>
-      <ns0:dk2>
-        <ns0:srgbClr val="355A78"/>
-      </ns0:dk2>
-      <ns0:lt2>
-        <ns0:srgbClr val="EEF8FF"/>
-      </ns0:lt2>
-      <ns0:accent1>
-        <ns0:srgbClr val="1D6FA8"/>
-      </ns0:accent1>
-      <ns0:accent2>
-        <ns0:srgbClr val="5AA9E6"/>
-      </ns0:accent2>
-      <ns0:accent3>
-        <ns0:srgbClr val="7FC8F8"/>
-      </ns0:accent3>
-      <ns0:accent4>
-        <ns0:srgbClr val="FFB347"/>
-      </ns0:accent4>
-      <ns0:accent5>
-        <ns0:srgbClr val="FF6392"/>
-      </ns0:accent5>
-      <ns0:accent6>
-        <ns0:srgbClr val="144F79"/>
-      </ns0:accent6>
-      <ns0:hlink>
-        <ns0:srgbClr val="1D6FA8"/>
-      </ns0:hlink>
-      <ns0:folHlink>
-        <ns0:srgbClr val="355A78"/>
-      </ns0:folHlink>
-    </ns0:clrScheme>
-    <ns0:fontScheme name="Office">
-      <ns0:majorFont>
-        <ns0:latin typeface="Aptos Display"/>
-        <ns0:ea typeface=""/>
-        <ns0:cs typeface=""/>
-        <ns0:font script="Jpan" typeface="游ゴシック Light"/>
-        <ns0:font script="Hang" typeface="맑은 고딕"/>
-        <ns0:font script="Hans" typeface="等线 Light"/>
-        <ns0:font script="Hant" typeface="新細明體"/>
-        <ns0:font script="Arab" typeface="Times New Roman"/>
-        <ns0:font script="Hebr" typeface="Times New Roman"/>
-        <ns0:font script="Thai" typeface="Angsana New"/>
-        <ns0:font script="Ethi" typeface="Nyala"/>
-        <ns0:font script="Beng" typeface="Vrinda"/>
-        <ns0:font script="Gujr" typeface="Shruti"/>
-        <ns0:font script="Khmr" typeface="MoolBoran"/>
-        <ns0:font script="Knda" typeface="Tunga"/>
-        <ns0:font script="Guru" typeface="Raavi"/>
-        <ns0:font script="Cans" typeface="Euphemia"/>
-        <ns0:font script="Cher" typeface="Plantagenet Cherokee"/>
-        <ns0:font script="Yiii" typeface="Microsoft Yi Baiti"/>
-        <ns0:font script="Tibt" typeface="Microsoft Himalaya"/>
-        <ns0:font script="Thaa" typeface="MV Boli"/>
-        <ns0:font script="Deva" typeface="Mangal"/>
-        <ns0:font script="Telu" typeface="Gautami"/>
-        <ns0:font script="Taml" typeface="Latha"/>
-        <ns0:font script="Syrc" typeface="Estrangelo Edessa"/>
-        <ns0:font script="Orya" typeface="Kalinga"/>
-        <ns0:font script="Mlym" typeface="Kartika"/>
-        <ns0:font script="Laoo" typeface="DokChampa"/>
-        <ns0:font script="Sinh" typeface="Iskoola Pota"/>
-        <ns0:font script="Mong" typeface="Mongolian Baiti"/>
-        <ns0:font script="Viet" typeface="Times New Roman"/>
-        <ns0:font script="Uigh" typeface="Microsoft Uighur"/>
-        <ns0:font script="Geor" typeface="Sylfaen"/>
-        <ns0:font script="Armn" typeface="Arial"/>
-        <ns0:font script="Bugi" typeface="Leelawadee UI"/>
-        <ns0:font script="Bopo" typeface="Microsoft JhengHei"/>
-        <ns0:font script="Java" typeface="Javanese Text"/>
-        <ns0:font script="Lisu" typeface="Segoe UI"/>
-        <ns0:font script="Mymr" typeface="Myanmar Text"/>
-        <ns0:font script="Nkoo" typeface="Ebrima"/>
-        <ns0:font script="Olck" typeface="Nirmala UI"/>
-        <ns0:font script="Osma" typeface="Ebrima"/>
-        <ns0:font script="Phag" typeface="Phagspa"/>
-        <ns0:font script="Syrn" typeface="Estrangelo Edessa"/>
-        <ns0:font script="Syrj" typeface="Estrangelo Edessa"/>
-        <ns0:font script="Syre" typeface="Estrangelo Edessa"/>
-        <ns0:font script="Sora" typeface="Nirmala UI"/>
-        <ns0:font script="Tale" typeface="Microsoft Tai Le"/>
-        <ns0:font script="Talu" typeface="Microsoft New Tai Lue"/>
-        <ns0:font script="Tfng" typeface="Ebrima"/>
-      </ns0:majorFont>
-      <ns0:minorFont>
-        <ns0:latin typeface="Aptos"/>
-        <ns0:ea typeface=""/>
-        <ns0:cs typeface=""/>
-        <ns0:font script="Jpan" typeface="游ゴシック"/>
-        <ns0:font script="Hang" typeface="맑은 고딕"/>
-        <ns0:font script="Hans" typeface="等线"/>
-        <ns0:font script="Hant" typeface="新細明體"/>
-        <ns0:font script="Arab" typeface="Arial"/>
-        <ns0:font script="Hebr" typeface="Arial"/>
-        <ns0:font script="Thai" typeface="Cordia New"/>
-        <ns0:font script="Ethi" typeface="Nyala"/>
-        <ns0:font script="Beng" typeface="Vrinda"/>
-        <ns0:font script="Gujr" typeface="Shruti"/>
-        <ns0:font script="Khmr" typeface="DaunPenh"/>
-        <ns0:font script="Knda" typeface="Tunga"/>
-        <ns0:font script="Guru" typeface="Raavi"/>
-        <ns0:font script="Cans" typeface="Euphemia"/>
-        <ns0:font script="Cher" typeface="Plantagenet Cherokee"/>
-        <ns0:font script="Yiii" typeface="Microsoft Yi Baiti"/>
-        <ns0:font script="Tibt" typeface="Microsoft Himalaya"/>
-        <ns0:font script="Thaa" typeface="MV Boli"/>
-        <ns0:font script="Deva" typeface="Mangal"/>
-        <ns0:font script="Telu" typeface="Gautami"/>
-        <ns0:font script="Taml" typeface="Latha"/>
-        <ns0:font script="Syrc" typeface="Estrangelo Edessa"/>
-        <ns0:font script="Orya" typeface="Kalinga"/>
-        <ns0:font script="Mlym" typeface="Kartika"/>
-        <ns0:font script="Laoo" typeface="DokChampa"/>
-        <ns0:font script="Sinh" typeface="Iskoola Pota"/>
-        <ns0:font script="Mong" typeface="Mongolian Baiti"/>
-        <ns0:font script="Viet" typeface="Arial"/>
-        <ns0:font script="Uigh" typeface="Microsoft Uighur"/>
-        <ns0:font script="Geor" typeface="Sylfaen"/>
-        <ns0:font script="Armn" typeface="Arial"/>
-        <ns0:font script="Bugi" typeface="Leelawadee UI"/>
-        <ns0:font script="Bopo" typeface="Microsoft JhengHei"/>
-        <ns0:font script="Java" typeface="Javanese Text"/>
-        <ns0:font script="Lisu" typeface="Segoe UI"/>
-        <ns0:font script="Mymr" typeface="Myanmar Text"/>
-        <ns0:font script="Nkoo" typeface="Ebrima"/>
-        <ns0:font script="Olck" typeface="Nirmala UI"/>
-        <ns0:font script="Osma" typeface="Ebrima"/>
-        <ns0:font script="Phag" typeface="Phagspa"/>
-        <ns0:font script="Syrn" typeface="Estrangelo Edessa"/>
-        <ns0:font script="Syrj" typeface="Estrangelo Edessa"/>
-        <ns0:font script="Syre" typeface="Estrangelo Edessa"/>
-        <ns0:font script="Sora" typeface="Nirmala UI"/>
-        <ns0:font script="Tale" typeface="Microsoft Tai Le"/>
-        <ns0:font script="Talu" typeface="Microsoft New Tai Lue"/>
-        <ns0:font script="Tfng" typeface="Ebrima"/>
-      </ns0:minorFont>
-    </ns0:fontScheme>
-    <ns0:fmtScheme name="Office">
-      <ns0:fillStyleLst>
-        <ns0:solidFill>
-          <ns0:schemeClr val="phClr"/>
-        </ns0:solidFill>
-        <ns0:gradFill rotWithShape="1">
-          <ns0:gsLst>
-            <ns0:gs pos="0">
-              <ns0:schemeClr val="phClr">
-                <ns0:tint val="67000"/>
-                <ns0:lumMod val="110000"/>
-                <ns0:satMod val="105000"/>
-              </ns0:schemeClr>
-            </ns0:gs>
-            <ns0:gs pos="50000">
-              <ns0:schemeClr val="phClr">
-                <ns0:tint val="73000"/>
-                <ns0:lumMod val="105000"/>
-                <ns0:satMod val="103000"/>
-              </ns0:schemeClr>
-            </ns0:gs>
-            <ns0:gs pos="100000">
-              <ns0:schemeClr val="phClr">
-                <ns0:tint val="81000"/>
-                <ns0:lumMod val="105000"/>
-                <ns0:satMod val="109000"/>
-              </ns0:schemeClr>
-            </ns0:gs>
-          </ns0:gsLst>
-          <ns0:lin ang="5400000" scaled="0"/>
-        </ns0:gradFill>
-        <ns0:gradFill rotWithShape="1">
-          <ns0:gsLst>
-            <ns0:gs pos="0">
-              <ns0:schemeClr val="phClr">
-                <ns0:tint val="94000"/>
-                <ns0:lumMod val="102000"/>
-                <ns0:satMod val="103000"/>
-              </ns0:schemeClr>
-            </ns0:gs>
-            <ns0:gs pos="50000">
-              <ns0:schemeClr val="phClr">
-                <ns0:shade val="100000"/>
-                <ns0:lumMod val="100000"/>
-                <ns0:satMod val="110000"/>
-              </ns0:schemeClr>
-            </ns0:gs>
-            <ns0:gs pos="100000">
-              <ns0:schemeClr val="phClr">
-                <ns0:shade val="78000"/>
-                <ns0:lumMod val="99000"/>
-                <ns0:satMod val="120000"/>
-              </ns0:schemeClr>
-            </ns0:gs>
-          </ns0:gsLst>
-          <ns0:lin ang="5400000" scaled="0"/>
-        </ns0:gradFill>
-      </ns0:fillStyleLst>
-      <ns0:lnStyleLst>
-        <ns0:ln w="12700">
-          <ns0:solidFill>
-            <ns0:schemeClr val="phClr"/>
-          </ns0:solidFill>
-          <ns0:prstDash val="solid"/>
-        </ns0:ln>
-        <ns0:ln w="19050">
-          <ns0:solidFill>
-            <ns0:schemeClr val="phClr"/>
-          </ns0:solidFill>
-          <ns0:prstDash val="solid"/>
-        </ns0:ln>
-        <ns0:ln w="25400">
-          <ns0:solidFill>
-            <ns0:schemeClr val="phClr"/>
-          </ns0:solidFill>
-          <ns0:prstDash val="solid"/>
-        </ns0:ln>
-      </ns0:lnStyleLst>
-      <ns0:effectStyleLst>
-        <ns0:effectStyle>
-          <ns0:effectLst/>
-        </ns0:effectStyle>
-        <ns0:effectStyle>
-          <ns0:effectLst/>
-        </ns0:effectStyle>
-        <ns0:effectStyle>
-          <ns0:effectLst>
-            <ns0:outerShdw blurRad="57150" dist="19050" dir="5400000" algn="ctr" rotWithShape="0">
-              <ns0:srgbClr val="000000">
-                <ns0:alpha val="63000"/>
-              </ns0:srgbClr>
-            </ns0:outerShdw>
-          </ns0:effectLst>
-        </ns0:effectStyle>
-      </ns0:effectStyleLst>
-      <ns0:bgFillStyleLst>
-        <ns0:solidFill>
-          <ns0:schemeClr val="phClr"/>
-        </ns0:solidFill>
-        <ns0:solidFill>
-          <ns0:schemeClr val="phClr">
-            <ns0:tint val="95000"/>
-            <ns0:satMod val="170000"/>
-          </ns0:schemeClr>
-        </ns0:solidFill>
-        <ns0:gradFill rotWithShape="1">
-          <ns0:gsLst>
-            <ns0:gs pos="0">
-              <ns0:schemeClr val="phClr">
-                <ns0:tint val="93000"/>
-                <ns0:shade val="98000"/>
-                <ns0:lumMod val="102000"/>
-                <ns0:satMod val="150000"/>
-              </ns0:schemeClr>
-            </ns0:gs>
-            <ns0:gs pos="50000">
-              <ns0:schemeClr val="phClr">
-                <ns0:tint val="98000"/>
-                <ns0:shade val="90000"/>
-                <ns0:lumMod val="103000"/>
-                <ns0:satMod val="130000"/>
-              </ns0:schemeClr>
-            </ns0:gs>
-            <ns0:gs pos="100000">
-              <ns0:schemeClr val="phClr">
-                <ns0:shade val="63000"/>
-                <ns0:satMod val="120000"/>
-              </ns0:schemeClr>
-            </ns0:gs>
-          </ns0:gsLst>
-          <ns0:lin ang="5400000" scaled="0"/>
-        </ns0:gradFill>
-      </ns0:bgFillStyleLst>
-    </ns0:fmtScheme>
-  </ns0:themeElements>
-</ns0:theme>
+<a:theme xmlns:a="http://schemas.openxmlformats.org/drawingml/2006/main" name="Office Theme">
+  <a:themeElements>
+    <a:clrScheme name="Custom">
+      <a:dk1>
+        <a:srgbClr val="10263F"/>
+      </a:dk1>
+      <a:lt1>
+        <a:srgbClr val="F9F9F9"/>
+      </a:lt1>
+      <a:dk2>
+        <a:srgbClr val="355A78"/>
+      </a:dk2>
+      <a:lt2>
+        <a:srgbClr val="EEF8FF"/>
+      </a:lt2>
+      <a:accent1>
+        <a:srgbClr val="1D6FA8"/>
+      </a:accent1>
+      <a:accent2>
+        <a:srgbClr val="5AA9E6"/>
+      </a:accent2>
+      <a:accent3>
+        <a:srgbClr val="7FC8F8"/>
+      </a:accent3>
+      <a:accent4>
+        <a:srgbClr val="FFB347"/>
+      </a:accent4>
+      <a:accent5>
+        <a:srgbClr val="FF6392"/>
+      </a:accent5>
+      <a:accent6>
+        <a:srgbClr val="144F79"/>
+      </a:accent6>
+      <a:hlink>
+        <a:srgbClr val="1D6FA8"/>
+      </a:hlink>
+      <a:folHlink>
+        <a:srgbClr val="355A78"/>
+      </a:folHlink>
+    </a:clrScheme>
+    <a:fontScheme name="Office">
+      <a:majorFont>
+        <a:latin typeface="Aptos Display"/>
+        <a:ea typeface=""/>
+        <a:cs typeface=""/>
+        <a:font script="Jpan" typeface="游ゴシック Light"/>
+        <a:font script="Hang" typeface="맑은 고딕"/>
+        <a:font script="Hans" typeface="等线 Light"/>
+        <a:font script="Hant" typeface="新細明體"/>
+        <a:font script="Arab" typeface="Times New Roman"/>
+        <a:font script="Hebr" typeface="Times New Roman"/>
+        <a:font script="Thai" typeface="Angsana New"/>
+        <a:font script="Ethi" typeface="Nyala"/>
+        <a:font script="Beng" typeface="Vrinda"/>
+        <a:font script="Gujr" typeface="Shruti"/>
+        <a:font script="Khmr" typeface="MoolBoran"/>
+        <a:font script="Knda" typeface="Tunga"/>
+        <a:font script="Guru" typeface="Raavi"/>
+        <a:font script="Cans" typeface="Euphemia"/>
+        <a:font script="Cher" typeface="Plantagenet Cherokee"/>
+        <a:font script="Yiii" typeface="Microsoft Yi Baiti"/>
+        <a:font script="Tibt" typeface="Microsoft Himalaya"/>
+        <a:font script="Thaa" typeface="MV Boli"/>
+        <a:font script="Deva" typeface="Mangal"/>
+        <a:font script="Telu" typeface="Gautami"/>
+        <a:font script="Taml" typeface="Latha"/>
+        <a:font script="Syrc" typeface="Estrangelo Edessa"/>
+        <a:font script="Orya" typeface="Kalinga"/>
+        <a:font script="Mlym" typeface="Kartika"/>
+        <a:font script="Laoo" typeface="DokChampa"/>
+        <a:font script="Sinh" typeface="Iskoola Pota"/>
+        <a:font script="Mong" typeface="Mongolian Baiti"/>
+        <a:font script="Viet" typeface="Times New Roman"/>
+        <a:font script="Uigh" typeface="Microsoft Uighur"/>
+        <a:font script="Geor" typeface="Sylfaen"/>
+        <a:font script="Armn" typeface="Arial"/>
+        <a:font script="Bugi" typeface="Leelawadee UI"/>
+        <a:font script="Bopo" typeface="Microsoft JhengHei"/>
+        <a:font script="Java" typeface="Javanese Text"/>
+        <a:font script="Lisu" typeface="Segoe UI"/>
+        <a:font script="Mymr" typeface="Myanmar Text"/>
+        <a:font script="Nkoo" typeface="Ebrima"/>
+        <a:font script="Olck" typeface="Nirmala UI"/>
+        <a:font script="Osma" typeface="Ebrima"/>
+        <a:font script="Phag" typeface="Phagspa"/>
+        <a:font script="Syrn" typeface="Estrangelo Edessa"/>
+        <a:font script="Syrj" typeface="Estrangelo Edessa"/>
+        <a:font script="Syre" typeface="Estrangelo Edessa"/>
+        <a:font script="Sora" typeface="Nirmala UI"/>
+        <a:font script="Tale" typeface="Microsoft Tai Le"/>
+        <a:font script="Talu" typeface="Microsoft New Tai Lue"/>
+        <a:font script="Tfng" typeface="Ebrima"/>
+      </a:majorFont>
+      <a:minorFont>
+        <a:latin typeface="Aptos"/>
+        <a:ea typeface=""/>
+        <a:cs typeface=""/>
+        <a:font script="Jpan" typeface="游ゴシック"/>
+        <a:font script="Hang" typeface="맑은 고딕"/>
+        <a:font script="Hans" typeface="等线"/>
+        <a:font script="Hant" typeface="新細明體"/>
+        <a:font script="Arab" typeface="Arial"/>
+        <a:font script="Hebr" typeface="Arial"/>
+        <a:font script="Thai" typeface="Cordia New"/>
+        <a:font script="Ethi" typeface="Nyala"/>
+        <a:font script="Beng" typeface="Vrinda"/>
+        <a:font script="Gujr" typeface="Shruti"/>
+        <a:font script="Khmr" typeface="DaunPenh"/>
+        <a:font script="Knda" typeface="Tunga"/>
+        <a:font script="Guru" typeface="Raavi"/>
+        <a:font script="Cans" typeface="Euphemia"/>
+        <a:font script="Cher" typeface="Plantagenet Cherokee"/>
+        <a:font script="Yiii" typeface="Microsoft Yi Baiti"/>
+        <a:font script="Tibt" typeface="Microsoft Himalaya"/>
+        <a:font script="Thaa" typeface="MV Boli"/>
+        <a:font script="Deva" typeface="Mangal"/>
+        <a:font script="Telu" typeface="Gautami"/>
+        <a:font script="Taml" typeface="Latha"/>
+        <a:font script="Syrc" typeface="Estrangelo Edessa"/>
+        <a:font script="Orya" typeface="Kalinga"/>
+        <a:font script="Mlym" typeface="Kartika"/>
+        <a:font script="Laoo" typeface="DokChampa"/>
+        <a:font script="Sinh" typeface="Iskoola Pota"/>
+        <a:font script="Mong" typeface="Mongolian Baiti"/>
+        <a:font script="Viet" typeface="Arial"/>
+        <a:font script="Uigh" typeface="Microsoft Uighur"/>
+        <a:font script="Geor" typeface="Sylfaen"/>
+        <a:font script="Armn" typeface="Arial"/>
+        <a:font script="Bugi" typeface="Leelawadee UI"/>
+        <a:font script="Bopo" typeface="Microsoft JhengHei"/>
+        <a:font script="Java" typeface="Javanese Text"/>
+        <a:font script="Lisu" typeface="Segoe UI"/>
+        <a:font script="Mymr" typeface="Myanmar Text"/>
+        <a:font script="Nkoo" typeface="Ebrima"/>
+        <a:font script="Olck" typeface="Nirmala UI"/>
+        <a:font script="Osma" typeface="Ebrima"/>
+        <a:font script="Phag" typeface="Phagspa"/>
+        <a:font script="Syrn" typeface="Estrangelo Edessa"/>
+        <a:font script="Syrj" typeface="Estrangelo Edessa"/>
+        <a:font script="Syre" typeface="Estrangelo Edessa"/>
+        <a:font script="Sora" typeface="Nirmala UI"/>
+        <a:font script="Tale" typeface="Microsoft Tai Le"/>
+        <a:font script="Talu" typeface="Microsoft New Tai Lue"/>
+        <a:font script="Tfng" typeface="Ebrima"/>
+      </a:minorFont>
+    </a:fontScheme>
+    <a:fmtScheme name="Office">
+      <a:fillStyleLst>
+        <a:solidFill>
+          <a:schemeClr val="phClr"/>
+        </a:solidFill>
+        <a:gradFill rotWithShape="1">
+          <a:gsLst>
+            <a:gs pos="0">
+              <a:schemeClr val="phClr">
+                <a:tint val="67000"/>
+                <a:lumMod val="110000"/>
+                <a:satMod val="105000"/>
+              </a:schemeClr>
+            </a:gs>
+            <a:gs pos="50000">
+              <a:schemeClr val="phClr">
+                <a:tint val="73000"/>
+                <a:lumMod val="105000"/>
+                <a:satMod val="103000"/>
+              </a:schemeClr>
+            </a:gs>
+            <a:gs pos="100000">
+              <a:schemeClr val="phClr">
+                <a:tint val="81000"/>
+                <a:lumMod val="105000"/>
+                <a:satMod val="109000"/>
+              </a:schemeClr>
+            </a:gs>
+          </a:gsLst>
+          <a:lin ang="5400000" scaled="0"/>
+        </a:gradFill>
+        <a:gradFill rotWithShape="1">
+          <a:gsLst>
+            <a:gs pos="0">
+              <a:schemeClr val="phClr">
+                <a:tint val="94000"/>
+                <a:lumMod val="102000"/>
+                <a:satMod val="103000"/>
+              </a:schemeClr>
+            </a:gs>
+            <a:gs pos="50000">
+              <a:schemeClr val="phClr">
+                <a:shade val="100000"/>
+                <a:lumMod val="100000"/>
+                <a:satMod val="110000"/>
+              </a:schemeClr>
+            </a:gs>
+            <a:gs pos="100000">
+              <a:schemeClr val="phClr">
+                <a:shade val="78000"/>
+                <a:lumMod val="99000"/>
+                <a:satMod val="120000"/>
+              </a:schemeClr>
+            </a:gs>
+          </a:gsLst>
+          <a:lin ang="5400000" scaled="0"/>
+        </a:gradFill>
+      </a:fillStyleLst>
+      <a:lnStyleLst>
+        <a:ln w="12700">
+          <a:solidFill>
+            <a:schemeClr val="phClr"/>
+          </a:solidFill>
+          <a:prstDash val="solid"/>
+        </a:ln>
+        <a:ln w="19050">
+          <a:solidFill>
+            <a:schemeClr val="phClr"/>
+          </a:solidFill>
+          <a:prstDash val="solid"/>
+        </a:ln>
+        <a:ln w="25400">
+          <a:solidFill>
+            <a:schemeClr val="phClr"/>
+          </a:solidFill>
+          <a:prstDash val="solid"/>
+        </a:ln>
+      </a:lnStyleLst>
+      <a:effectStyleLst>
+        <a:effectStyle>
+          <a:effectLst/>
+        </a:effectStyle>
+        <a:effectStyle>
+          <a:effectLst/>
+        </a:effectStyle>
+        <a:effectStyle>
+          <a:effectLst>
+            <a:outerShdw blurRad="57150" dist="19050" dir="5400000" algn="ctr" rotWithShape="0">
+              <a:srgbClr val="000000">
+                <a:alpha val="63000"/>
+              </a:srgbClr>
+            </a:outerShdw>
+          </a:effectLst>
+        </a:effectStyle>
+      </a:effectStyleLst>
+      <a:bgFillStyleLst>
+        <a:solidFill>
+          <a:schemeClr val="phClr"/>
+        </a:solidFill>
+        <a:solidFill>
+          <a:schemeClr val="phClr">
+            <a:tint val="95000"/>
+            <a:satMod val="170000"/>
+          </a:schemeClr>
+        </a:solidFill>
+        <a:gradFill rotWithShape="1">
+          <a:gsLst>
+            <a:gs pos="0">
+              <a:schemeClr val="phClr">
+                <a:tint val="93000"/>
+                <a:shade val="98000"/>
+                <a:lumMod val="102000"/>
+                <a:satMod val="150000"/>
+              </a:schemeClr>
+            </a:gs>
+            <a:gs pos="50000">
+              <a:schemeClr val="phClr">
+                <a:tint val="98000"/>
+                <a:shade val="90000"/>
+                <a:lumMod val="103000"/>
+                <a:satMod val="130000"/>
+              </a:schemeClr>
+            </a:gs>
+            <a:gs pos="100000">
+              <a:schemeClr val="phClr">
+                <a:shade val="63000"/>
+                <a:satMod val="120000"/>
+              </a:schemeClr>
+            </a:gs>
+          </a:gsLst>
+          <a:lin ang="5400000" scaled="0"/>
+        </a:gradFill>
+      </a:bgFillStyleLst>
+    </a:fmtScheme>
+  </a:themeElements>
+</a:theme>
 </file>
 
 <file path=ppt/slides/slide1.xml><?xml version="1.0" encoding="utf-8"?>
@@ -5017,12 +5019,12 @@
             </a:pPr>
             <a:r>
               <a:rPr b="0" i="0">
+                <a:solidFill>
+                  <a:schemeClr val="dk1"/>
+                </a:solidFill>
                 <a:latin typeface="+mn-lt"/>
                 <a:ea typeface="+mn-ea"/>
                 <a:cs typeface="+mn-cs"/>
-                <a:solidFill>
-                  <a:schemeClr val="dk1"/>
-                </a:solidFill>
               </a:rPr>
               <a:t>Markdown in. Editable PowerPoint out.</a:t>
             </a:r>
@@ -5058,10 +5060,10 @@
             <a:gs pos="20000">
               <a:schemeClr val="lt1"/>
             </a:gs>
-            <a:gs pos="27272">
+            <a:gs pos="27273">
               <a:schemeClr val="lt1"/>
             </a:gs>
-            <a:gs pos="27272">
+            <a:gs pos="27273">
               <a:schemeClr val="dk2"/>
             </a:gs>
             <a:gs pos="34545">
@@ -5082,10 +5084,10 @@
             <a:gs pos="49091">
               <a:schemeClr val="accent2"/>
             </a:gs>
-            <a:gs pos="56363">
+            <a:gs pos="56364">
               <a:schemeClr val="accent2"/>
             </a:gs>
-            <a:gs pos="56363">
+            <a:gs pos="56364">
               <a:schemeClr val="accent3"/>
             </a:gs>
             <a:gs pos="63636">
@@ -5259,32 +5261,32 @@
             </a:pPr>
             <a:r>
               <a:rPr b="0" i="0">
+                <a:solidFill>
+                  <a:schemeClr val="dk1"/>
+                </a:solidFill>
                 <a:latin typeface="+mn-lt"/>
                 <a:ea typeface="+mn-ea"/>
                 <a:cs typeface="+mn-cs"/>
-                <a:solidFill>
-                  <a:schemeClr val="dk1"/>
-                </a:solidFill>
               </a:rPr>
               <a:t>Each slide after this one isolates a single </a:t>
             </a:r>
             <a:r>
               <a:rPr b="0" i="0">
+                <a:solidFill>
+                  <a:schemeClr val="dk1"/>
+                </a:solidFill>
                 <a:latin typeface="Consolas"/>
-                <a:solidFill>
-                  <a:schemeClr val="dk1"/>
-                </a:solidFill>
               </a:rPr>
               <a:t>markdown-pptx</a:t>
             </a:r>
             <a:r>
               <a:rPr b="0" i="0">
+                <a:solidFill>
+                  <a:schemeClr val="dk1"/>
+                </a:solidFill>
                 <a:latin typeface="+mn-lt"/>
                 <a:ea typeface="+mn-ea"/>
                 <a:cs typeface="+mn-cs"/>
-                <a:solidFill>
-                  <a:schemeClr val="dk1"/>
-                </a:solidFill>
               </a:rPr>
               <a:t> feature.</a:t>
             </a:r>
@@ -5381,12 +5383,12 @@
             </a:pPr>
             <a:r>
               <a:rPr b="0" i="0">
+                <a:solidFill>
+                  <a:schemeClr val="dk1"/>
+                </a:solidFill>
                 <a:latin typeface="+mn-lt"/>
                 <a:ea typeface="+mn-ea"/>
                 <a:cs typeface="+mn-cs"/>
-                <a:solidFill>
-                  <a:schemeClr val="dk1"/>
-                </a:solidFill>
               </a:rPr>
               <a:t>This slide uses the Title Slide layout.</a:t>
             </a:r>
@@ -5483,12 +5485,12 @@
             </a:pPr>
             <a:r>
               <a:rPr b="0" i="0">
+                <a:solidFill>
+                  <a:schemeClr val="dk1"/>
+                </a:solidFill>
                 <a:latin typeface="+mn-lt"/>
                 <a:ea typeface="+mn-ea"/>
                 <a:cs typeface="+mn-cs"/>
-                <a:solidFill>
-                  <a:schemeClr val="dk1"/>
-                </a:solidFill>
               </a:rPr>
               <a:t>This slide uses the Section Header layout.</a:t>
             </a:r>
@@ -5585,12 +5587,12 @@
             </a:pPr>
             <a:r>
               <a:rPr b="0" i="0">
+                <a:solidFill>
+                  <a:schemeClr val="dk1"/>
+                </a:solidFill>
                 <a:latin typeface="+mn-lt"/>
                 <a:ea typeface="+mn-ea"/>
                 <a:cs typeface="+mn-cs"/>
-                <a:solidFill>
-                  <a:schemeClr val="dk1"/>
-                </a:solidFill>
               </a:rPr>
               <a:t>This slide explicitly uses master 1 and its Title and Content layout.</a:t>
             </a:r>
@@ -5745,67 +5747,67 @@
             </a:pPr>
             <a:r>
               <a:rPr b="0" i="0">
+                <a:solidFill>
+                  <a:schemeClr val="dk1"/>
+                </a:solidFill>
                 <a:latin typeface="Consolas"/>
-                <a:solidFill>
-                  <a:schemeClr val="dk1"/>
-                </a:solidFill>
               </a:rPr>
               <a:t>markdown-pptx</a:t>
             </a:r>
             <a:r>
               <a:rPr b="0" i="0">
+                <a:solidFill>
+                  <a:schemeClr val="dk1"/>
+                </a:solidFill>
                 <a:latin typeface="+mn-lt"/>
                 <a:ea typeface="+mn-ea"/>
                 <a:cs typeface="+mn-cs"/>
-                <a:solidFill>
-                  <a:schemeClr val="dk1"/>
-                </a:solidFill>
               </a:rPr>
               <a:t> can include links in normal body text, such as the </a:t>
             </a:r>
             <a:r>
               <a:rPr b="0" i="0">
-                <a:hlinkClick r:id="rId2"/>
+                <a:solidFill>
+                  <a:schemeClr val="dk1"/>
+                </a:solidFill>
                 <a:latin typeface="+mn-lt"/>
                 <a:ea typeface="+mn-ea"/>
                 <a:cs typeface="+mn-cs"/>
-                <a:solidFill>
-                  <a:schemeClr val="dk1"/>
-                </a:solidFill>
+                <a:hlinkClick r:id="rId2"/>
               </a:rPr>
               <a:t>project repository</a:t>
             </a:r>
             <a:r>
               <a:rPr b="0" i="0">
+                <a:solidFill>
+                  <a:schemeClr val="dk1"/>
+                </a:solidFill>
                 <a:latin typeface="+mn-lt"/>
                 <a:ea typeface="+mn-ea"/>
                 <a:cs typeface="+mn-cs"/>
-                <a:solidFill>
-                  <a:schemeClr val="dk1"/>
-                </a:solidFill>
               </a:rPr>
               <a:t> and the </a:t>
             </a:r>
             <a:r>
               <a:rPr b="0" i="0">
-                <a:hlinkClick r:id="rId3"/>
+                <a:solidFill>
+                  <a:schemeClr val="dk1"/>
+                </a:solidFill>
                 <a:latin typeface="+mn-lt"/>
                 <a:ea typeface="+mn-ea"/>
                 <a:cs typeface="+mn-cs"/>
-                <a:solidFill>
-                  <a:schemeClr val="dk1"/>
-                </a:solidFill>
+                <a:hlinkClick r:id="rId3"/>
               </a:rPr>
               <a:t>python-pptx documentation</a:t>
             </a:r>
             <a:r>
               <a:rPr b="0" i="0">
+                <a:solidFill>
+                  <a:schemeClr val="dk1"/>
+                </a:solidFill>
                 <a:latin typeface="+mn-lt"/>
                 <a:ea typeface="+mn-ea"/>
                 <a:cs typeface="+mn-cs"/>
-                <a:solidFill>
-                  <a:schemeClr val="dk1"/>
-                </a:solidFill>
               </a:rPr>
               <a:t>.</a:t>
             </a:r>
@@ -5902,99 +5904,176 @@
             </a:pPr>
             <a:r>
               <a:rPr b="0" i="0">
+                <a:solidFill>
+                  <a:schemeClr val="dk1"/>
+                </a:solidFill>
                 <a:latin typeface="+mn-lt"/>
                 <a:ea typeface="+mn-ea"/>
                 <a:cs typeface="+mn-cs"/>
-                <a:solidFill>
-                  <a:schemeClr val="dk1"/>
-                </a:solidFill>
               </a:rPr>
               <a:t>Normal text can mix </a:t>
             </a:r>
             <a:r>
               <a:rPr b="1" i="0">
+                <a:solidFill>
+                  <a:schemeClr val="dk1"/>
+                </a:solidFill>
                 <a:latin typeface="+mn-lt"/>
                 <a:ea typeface="+mn-ea"/>
                 <a:cs typeface="+mn-cs"/>
-                <a:solidFill>
-                  <a:schemeClr val="dk1"/>
-                </a:solidFill>
-              </a:rPr>
-              <a:t>strong emphasis</a:t>
-            </a:r>
-            <a:r>
-              <a:rPr b="0" i="0">
+              </a:rPr>
+              <a:t>strong with </a:t>
+            </a:r>
+            <a:r>
+              <a:rPr b="1" i="1">
+                <a:solidFill>
+                  <a:schemeClr val="dk1"/>
+                </a:solidFill>
                 <a:latin typeface="+mn-lt"/>
                 <a:ea typeface="+mn-ea"/>
                 <a:cs typeface="+mn-cs"/>
-                <a:solidFill>
-                  <a:schemeClr val="dk1"/>
-                </a:solidFill>
-              </a:rPr>
-              <a:t>, </a:t>
-            </a:r>
-            <a:r>
-              <a:rPr b="0" i="1">
+              </a:rPr>
+              <a:t>nested italic</a:t>
+            </a:r>
+            <a:r>
+              <a:rPr b="0" i="0">
+                <a:solidFill>
+                  <a:schemeClr val="dk1"/>
+                </a:solidFill>
                 <a:latin typeface="+mn-lt"/>
                 <a:ea typeface="+mn-ea"/>
                 <a:cs typeface="+mn-cs"/>
-                <a:solidFill>
-                  <a:schemeClr val="dk1"/>
-                </a:solidFill>
-              </a:rPr>
-              <a:t>italic emphasis</a:t>
-            </a:r>
-            <a:r>
-              <a:rPr b="0" i="0">
+              </a:rPr>
+              <a:t>, </a:t>
+            </a:r>
+            <a:r>
+              <a:rPr b="0" i="1">
+                <a:solidFill>
+                  <a:schemeClr val="dk1"/>
+                </a:solidFill>
                 <a:latin typeface="+mn-lt"/>
                 <a:ea typeface="+mn-ea"/>
                 <a:cs typeface="+mn-cs"/>
-                <a:solidFill>
-                  <a:schemeClr val="dk1"/>
-                </a:solidFill>
-              </a:rPr>
-              <a:t>, </a:t>
-            </a:r>
-            <a:r>
-              <a:rPr b="0" i="0">
-                <a:latin typeface="Consolas"/>
-                <a:solidFill>
-                  <a:schemeClr val="dk1"/>
-                </a:solidFill>
-              </a:rPr>
-              <a:t>inline code</a:t>
-            </a:r>
-            <a:r>
-              <a:rPr b="0" i="0">
+              </a:rPr>
+              <a:t>italic emphasis</a:t>
+            </a:r>
+            <a:r>
+              <a:rPr b="0" i="0">
+                <a:solidFill>
+                  <a:schemeClr val="dk1"/>
+                </a:solidFill>
                 <a:latin typeface="+mn-lt"/>
                 <a:ea typeface="+mn-ea"/>
                 <a:cs typeface="+mn-cs"/>
-                <a:solidFill>
-                  <a:schemeClr val="dk1"/>
-                </a:solidFill>
-              </a:rPr>
-              <a:t>, and </a:t>
-            </a:r>
-            <a:r>
-              <a:rPr b="0" i="0">
-                <a:hlinkClick r:id="rId2"/>
+              </a:rPr>
+              <a:t>, </a:t>
+            </a:r>
+            <a:r>
+              <a:rPr b="0" i="0">
+                <a:solidFill>
+                  <a:schemeClr val="dk1"/>
+                </a:solidFill>
+                <a:latin typeface="Consolas"/>
+              </a:rPr>
+              <a:t>inline code</a:t>
+            </a:r>
+            <a:r>
+              <a:rPr b="0" i="0">
+                <a:solidFill>
+                  <a:schemeClr val="dk1"/>
+                </a:solidFill>
                 <a:latin typeface="+mn-lt"/>
                 <a:ea typeface="+mn-ea"/>
                 <a:cs typeface="+mn-cs"/>
-                <a:solidFill>
-                  <a:schemeClr val="dk1"/>
-                </a:solidFill>
-              </a:rPr>
-              <a:t>hyperlinks</a:t>
-            </a:r>
-            <a:r>
-              <a:rPr b="0" i="0">
+              </a:rPr>
+              <a:t>, </a:t>
+            </a:r>
+            <a:r>
+              <a:rPr b="0" i="0" strike="sngStrike">
+                <a:solidFill>
+                  <a:schemeClr val="dk1"/>
+                </a:solidFill>
                 <a:latin typeface="+mn-lt"/>
                 <a:ea typeface="+mn-ea"/>
                 <a:cs typeface="+mn-cs"/>
-                <a:solidFill>
-                  <a:schemeClr val="dk1"/>
-                </a:solidFill>
+              </a:rPr>
+              <a:t>deleted text</a:t>
+            </a:r>
+            <a:r>
+              <a:rPr b="0" i="0">
+                <a:solidFill>
+                  <a:schemeClr val="dk1"/>
+                </a:solidFill>
+                <a:latin typeface="+mn-lt"/>
+                <a:ea typeface="+mn-ea"/>
+                <a:cs typeface="+mn-cs"/>
+              </a:rPr>
+              <a:t>, H</a:t>
+            </a:r>
+            <a:r>
+              <a:rPr b="0" i="0" baseline="-25000" sz="2000">
+                <a:solidFill>
+                  <a:schemeClr val="dk1"/>
+                </a:solidFill>
+                <a:latin typeface="+mn-lt"/>
+                <a:ea typeface="+mn-ea"/>
+                <a:cs typeface="+mn-cs"/>
+              </a:rPr>
+              <a:t>2</a:t>
+            </a:r>
+            <a:r>
+              <a:rPr b="0" i="0">
+                <a:solidFill>
+                  <a:schemeClr val="dk1"/>
+                </a:solidFill>
+                <a:latin typeface="+mn-lt"/>
+                <a:ea typeface="+mn-ea"/>
+                <a:cs typeface="+mn-cs"/>
+              </a:rPr>
+              <a:t>O, x</a:t>
+            </a:r>
+            <a:r>
+              <a:rPr b="0" i="0" baseline="30000" sz="2000">
+                <a:solidFill>
+                  <a:schemeClr val="dk1"/>
+                </a:solidFill>
+                <a:latin typeface="+mn-lt"/>
+                <a:ea typeface="+mn-ea"/>
+                <a:cs typeface="+mn-cs"/>
+              </a:rPr>
+              <a:t>2</a:t>
+            </a:r>
+            <a:r>
+              <a:rPr b="0" i="0">
+                <a:solidFill>
+                  <a:schemeClr val="dk1"/>
+                </a:solidFill>
+                <a:latin typeface="+mn-lt"/>
+                <a:ea typeface="+mn-ea"/>
+                <a:cs typeface="+mn-cs"/>
+              </a:rPr>
+              <a:t>, and </a:t>
+            </a:r>
+            <a:r>
+              <a:rPr b="1" i="0">
+                <a:solidFill>
+                  <a:schemeClr val="dk1"/>
+                </a:solidFill>
+                <a:latin typeface="+mn-lt"/>
+                <a:ea typeface="+mn-ea"/>
+                <a:cs typeface="+mn-cs"/>
+                <a:hlinkClick r:id="rId2"/>
+              </a:rPr>
+              <a:t>formatted links</a:t>
+            </a:r>
+            <a:r>
+              <a:rPr b="0" i="0">
+                <a:solidFill>
+                  <a:schemeClr val="dk1"/>
+                </a:solidFill>
+                <a:latin typeface="+mn-lt"/>
+                <a:ea typeface="+mn-ea"/>
+                <a:cs typeface="+mn-cs"/>
               </a:rPr>
               <a:t> in the same editable placeholder.</a:t>
             </a:r>
@@ -6054,7 +6133,7 @@
                   <a:schemeClr val="accent6"/>
                 </a:solidFill>
               </a:rPr>
-              <a:t>H2 through H6 headings</a:t>
+              <a:t>Line breaks</a:t>
             </a:r>
             <a:endParaRPr>
               <a:solidFill>
@@ -6090,15 +6169,37 @@
               </a:defRPr>
             </a:pPr>
             <a:r>
-              <a:rPr sz="3700" b="1">
-                <a:latin typeface="+mj-lt"/>
-                <a:ea typeface="+mj-ea"/>
-                <a:cs typeface="+mj-cs"/>
-                <a:solidFill>
-                  <a:schemeClr val="dk1"/>
-                </a:solidFill>
-              </a:rPr>
-              <a:t>H2 heading</a:t>
+              <a:rPr b="0" i="0">
+                <a:solidFill>
+                  <a:schemeClr val="dk1"/>
+                </a:solidFill>
+                <a:latin typeface="+mn-lt"/>
+                <a:ea typeface="+mn-ea"/>
+                <a:cs typeface="+mn-cs"/>
+              </a:rPr>
+              <a:t>This source line wraps</a:t>
+            </a:r>
+            <a:r>
+              <a:rPr b="0" i="0">
+                <a:solidFill>
+                  <a:schemeClr val="dk1"/>
+                </a:solidFill>
+                <a:latin typeface="+mn-lt"/>
+                <a:ea typeface="+mn-ea"/>
+                <a:cs typeface="+mn-cs"/>
+              </a:rPr>
+              <a:t> </a:t>
+            </a:r>
+            <a:r>
+              <a:rPr b="0" i="0">
+                <a:solidFill>
+                  <a:schemeClr val="dk1"/>
+                </a:solidFill>
+                <a:latin typeface="+mn-lt"/>
+                <a:ea typeface="+mn-ea"/>
+                <a:cs typeface="+mn-cs"/>
+              </a:rPr>
+              <a:t>without forcing a visual break.</a:t>
             </a:r>
             <a:endParaRPr>
               <a:solidFill>
@@ -6116,93 +6217,27 @@
               </a:defRPr>
             </a:pPr>
             <a:r>
-              <a:rPr sz="3400" b="1">
-                <a:latin typeface="+mj-lt"/>
-                <a:ea typeface="+mj-ea"/>
-                <a:cs typeface="+mj-cs"/>
-                <a:solidFill>
-                  <a:schemeClr val="dk1"/>
-                </a:solidFill>
-              </a:rPr>
-              <a:t>H3 heading</a:t>
-            </a:r>
-            <a:endParaRPr>
-              <a:solidFill>
-                <a:schemeClr val="dk1"/>
-              </a:solidFill>
-            </a:endParaRPr>
-          </a:p>
-          <a:p>
-            <a:pPr marL="0" indent="0">
-              <a:buNone/>
-              <a:defRPr>
-                <a:solidFill>
-                  <a:schemeClr val="dk1"/>
-                </a:solidFill>
-              </a:defRPr>
-            </a:pPr>
-            <a:r>
-              <a:rPr sz="3100" b="1">
-                <a:latin typeface="+mj-lt"/>
-                <a:ea typeface="+mj-ea"/>
-                <a:cs typeface="+mj-cs"/>
-                <a:solidFill>
-                  <a:schemeClr val="dk1"/>
-                </a:solidFill>
-              </a:rPr>
-              <a:t>H4 heading</a:t>
-            </a:r>
-            <a:endParaRPr>
-              <a:solidFill>
-                <a:schemeClr val="dk1"/>
-              </a:solidFill>
-            </a:endParaRPr>
-          </a:p>
-          <a:p>
-            <a:pPr marL="0" indent="0">
-              <a:buNone/>
-              <a:defRPr>
-                <a:solidFill>
-                  <a:schemeClr val="dk1"/>
-                </a:solidFill>
-              </a:defRPr>
-            </a:pPr>
-            <a:r>
-              <a:rPr sz="2900" b="1">
-                <a:latin typeface="+mj-lt"/>
-                <a:ea typeface="+mj-ea"/>
-                <a:cs typeface="+mj-cs"/>
-                <a:solidFill>
-                  <a:schemeClr val="dk1"/>
-                </a:solidFill>
-              </a:rPr>
-              <a:t>H5 heading</a:t>
-            </a:r>
-            <a:endParaRPr>
-              <a:solidFill>
-                <a:schemeClr val="dk1"/>
-              </a:solidFill>
-            </a:endParaRPr>
-          </a:p>
-          <a:p>
-            <a:pPr marL="0" indent="0">
-              <a:buNone/>
-              <a:defRPr>
-                <a:solidFill>
-                  <a:schemeClr val="dk1"/>
-                </a:solidFill>
-              </a:defRPr>
-            </a:pPr>
-            <a:r>
-              <a:rPr sz="2800" b="1">
-                <a:latin typeface="+mj-lt"/>
-                <a:ea typeface="+mj-ea"/>
-                <a:cs typeface="+mj-cs"/>
-                <a:solidFill>
-                  <a:schemeClr val="dk1"/>
-                </a:solidFill>
-              </a:rPr>
-              <a:t>H6 heading</a:t>
+              <a:rPr b="0" i="0">
+                <a:solidFill>
+                  <a:schemeClr val="dk1"/>
+                </a:solidFill>
+                <a:latin typeface="+mn-lt"/>
+                <a:ea typeface="+mn-ea"/>
+                <a:cs typeface="+mn-cs"/>
+              </a:rPr>
+              <a:t>This line ends here.</a:t>
+            </a:r>
+            <a:br/>
+            <a:r>
+              <a:rPr b="0" i="0">
+                <a:solidFill>
+                  <a:schemeClr val="dk1"/>
+                </a:solidFill>
+                <a:latin typeface="+mn-lt"/>
+                <a:ea typeface="+mn-ea"/>
+                <a:cs typeface="+mn-cs"/>
+              </a:rPr>
+              <a:t>The next line stays in the same paragraph.</a:t>
             </a:r>
             <a:endParaRPr>
               <a:solidFill>
@@ -6260,7 +6295,7 @@
                   <a:schemeClr val="accent6"/>
                 </a:solidFill>
               </a:rPr>
-              <a:t>Bulleted list</a:t>
+              <a:t>H2 through H6 headings</a:t>
             </a:r>
             <a:endParaRPr>
               <a:solidFill>
@@ -6287,7 +6322,8 @@
           </a:bodyPr>
           <a:lstStyle/>
           <a:p>
-            <a:pPr>
+            <a:pPr marL="0" indent="0">
+              <a:buNone/>
               <a:defRPr>
                 <a:solidFill>
                   <a:schemeClr val="dk1"/>
@@ -6295,15 +6331,15 @@
               </a:defRPr>
             </a:pPr>
             <a:r>
-              <a:rPr b="0" i="0">
-                <a:latin typeface="+mn-lt"/>
-                <a:ea typeface="+mn-ea"/>
-                <a:cs typeface="+mn-cs"/>
-                <a:solidFill>
-                  <a:schemeClr val="dk1"/>
-                </a:solidFill>
-              </a:rPr>
-              <a:t>Write a readable Markdown deck</a:t>
+              <a:rPr sz="3700" b="1" i="0">
+                <a:solidFill>
+                  <a:schemeClr val="dk1"/>
+                </a:solidFill>
+                <a:latin typeface="+mj-lt"/>
+                <a:ea typeface="+mj-ea"/>
+                <a:cs typeface="+mj-cs"/>
+              </a:rPr>
+              <a:t>H2 heading</a:t>
             </a:r>
             <a:endParaRPr>
               <a:solidFill>
@@ -6312,7 +6348,8 @@
             </a:endParaRPr>
           </a:p>
           <a:p>
-            <a:pPr>
+            <a:pPr marL="0" indent="0">
+              <a:buNone/>
               <a:defRPr>
                 <a:solidFill>
                   <a:schemeClr val="dk1"/>
@@ -6320,15 +6357,15 @@
               </a:defRPr>
             </a:pPr>
             <a:r>
-              <a:rPr b="0" i="0">
-                <a:latin typeface="+mn-lt"/>
-                <a:ea typeface="+mn-ea"/>
-                <a:cs typeface="+mn-cs"/>
-                <a:solidFill>
-                  <a:schemeClr val="dk1"/>
-                </a:solidFill>
-              </a:rPr>
-              <a:t>Choose a template if needed</a:t>
+              <a:rPr sz="3400" b="1" i="0">
+                <a:solidFill>
+                  <a:schemeClr val="dk1"/>
+                </a:solidFill>
+                <a:latin typeface="+mj-lt"/>
+                <a:ea typeface="+mj-ea"/>
+                <a:cs typeface="+mj-cs"/>
+              </a:rPr>
+              <a:t>H3 heading</a:t>
             </a:r>
             <a:endParaRPr>
               <a:solidFill>
@@ -6337,7 +6374,8 @@
             </a:endParaRPr>
           </a:p>
           <a:p>
-            <a:pPr>
+            <a:pPr marL="0" indent="0">
+              <a:buNone/>
               <a:defRPr>
                 <a:solidFill>
                   <a:schemeClr val="dk1"/>
@@ -6345,15 +6383,93 @@
               </a:defRPr>
             </a:pPr>
             <a:r>
-              <a:rPr b="0" i="0">
-                <a:latin typeface="+mn-lt"/>
-                <a:ea typeface="+mn-ea"/>
-                <a:cs typeface="+mn-cs"/>
-                <a:solidFill>
-                  <a:schemeClr val="dk1"/>
-                </a:solidFill>
-              </a:rPr>
-              <a:t>Render an editable PowerPoint file</a:t>
+              <a:rPr sz="3100" b="1" i="0">
+                <a:solidFill>
+                  <a:schemeClr val="dk1"/>
+                </a:solidFill>
+                <a:latin typeface="+mj-lt"/>
+                <a:ea typeface="+mj-ea"/>
+                <a:cs typeface="+mj-cs"/>
+              </a:rPr>
+              <a:t>H4 heading</a:t>
+            </a:r>
+            <a:endParaRPr>
+              <a:solidFill>
+                <a:schemeClr val="dk1"/>
+              </a:solidFill>
+            </a:endParaRPr>
+          </a:p>
+          <a:p>
+            <a:pPr marL="0" indent="0">
+              <a:buNone/>
+              <a:defRPr>
+                <a:solidFill>
+                  <a:schemeClr val="dk1"/>
+                </a:solidFill>
+              </a:defRPr>
+            </a:pPr>
+            <a:r>
+              <a:rPr sz="2900" b="1" i="0">
+                <a:solidFill>
+                  <a:schemeClr val="dk1"/>
+                </a:solidFill>
+                <a:latin typeface="+mj-lt"/>
+                <a:ea typeface="+mj-ea"/>
+                <a:cs typeface="+mj-cs"/>
+              </a:rPr>
+              <a:t>H5 heading</a:t>
+            </a:r>
+            <a:endParaRPr>
+              <a:solidFill>
+                <a:schemeClr val="dk1"/>
+              </a:solidFill>
+            </a:endParaRPr>
+          </a:p>
+          <a:p>
+            <a:pPr marL="0" indent="0">
+              <a:buNone/>
+              <a:defRPr>
+                <a:solidFill>
+                  <a:schemeClr val="dk1"/>
+                </a:solidFill>
+              </a:defRPr>
+            </a:pPr>
+            <a:r>
+              <a:rPr sz="2800" b="1" i="0">
+                <a:solidFill>
+                  <a:schemeClr val="dk1"/>
+                </a:solidFill>
+                <a:latin typeface="+mj-lt"/>
+                <a:ea typeface="+mj-ea"/>
+                <a:cs typeface="+mj-cs"/>
+              </a:rPr>
+              <a:t>H6 heading</a:t>
+            </a:r>
+            <a:endParaRPr>
+              <a:solidFill>
+                <a:schemeClr val="dk1"/>
+              </a:solidFill>
+            </a:endParaRPr>
+          </a:p>
+          <a:p>
+            <a:pPr marL="0" indent="0">
+              <a:buNone/>
+              <a:defRPr>
+                <a:solidFill>
+                  <a:schemeClr val="dk1"/>
+                </a:solidFill>
+              </a:defRPr>
+            </a:pPr>
+            <a:r>
+              <a:rPr sz="3700" b="1" i="0">
+                <a:solidFill>
+                  <a:schemeClr val="dk1"/>
+                </a:solidFill>
+                <a:latin typeface="+mj-lt"/>
+                <a:ea typeface="+mj-ea"/>
+                <a:cs typeface="+mj-cs"/>
+              </a:rPr>
+              <a:t>Setext H2 heading</a:t>
             </a:r>
             <a:endParaRPr>
               <a:solidFill>
@@ -6448,41 +6564,41 @@
             </a:pPr>
             <a:r>
               <a:rPr b="0" i="0">
+                <a:solidFill>
+                  <a:schemeClr val="dk1"/>
+                </a:solidFill>
                 <a:latin typeface="Consolas"/>
-                <a:solidFill>
-                  <a:schemeClr val="dk1"/>
-                </a:solidFill>
               </a:rPr>
               <a:t>markdown-pptx</a:t>
             </a:r>
             <a:r>
               <a:rPr b="0" i="0">
+                <a:solidFill>
+                  <a:schemeClr val="dk1"/>
+                </a:solidFill>
                 <a:latin typeface="+mn-lt"/>
                 <a:ea typeface="+mn-ea"/>
                 <a:cs typeface="+mn-cs"/>
-                <a:solidFill>
-                  <a:schemeClr val="dk1"/>
-                </a:solidFill>
               </a:rPr>
               <a:t> converts constrained Markdown slide decks into editable PowerPoint </a:t>
             </a:r>
             <a:r>
               <a:rPr b="0" i="0">
+                <a:solidFill>
+                  <a:schemeClr val="dk1"/>
+                </a:solidFill>
                 <a:latin typeface="Consolas"/>
-                <a:solidFill>
-                  <a:schemeClr val="dk1"/>
-                </a:solidFill>
               </a:rPr>
               <a:t>.pptx</a:t>
             </a:r>
             <a:r>
               <a:rPr b="0" i="0">
+                <a:solidFill>
+                  <a:schemeClr val="dk1"/>
+                </a:solidFill>
                 <a:latin typeface="+mn-lt"/>
                 <a:ea typeface="+mn-ea"/>
                 <a:cs typeface="+mn-cs"/>
-                <a:solidFill>
-                  <a:schemeClr val="dk1"/>
-                </a:solidFill>
               </a:rPr>
               <a:t> presentations.</a:t>
             </a:r>
@@ -6503,12 +6619,12 @@
             </a:pPr>
             <a:r>
               <a:rPr b="0" i="0">
+                <a:solidFill>
+                  <a:schemeClr val="dk1"/>
+                </a:solidFill>
                 <a:latin typeface="+mn-lt"/>
                 <a:ea typeface="+mn-ea"/>
                 <a:cs typeface="+mn-cs"/>
-                <a:solidFill>
-                  <a:schemeClr val="dk1"/>
-                </a:solidFill>
               </a:rPr>
               <a:t>It uses real PowerPoint layouts and placeholders, so the output stays easy to edit in PowerPoint instead of becoming a pile of free-positioned text boxes.</a:t>
             </a:r>
@@ -6568,7 +6684,7 @@
                   <a:schemeClr val="accent6"/>
                 </a:solidFill>
               </a:rPr>
-              <a:t>Nested lists</a:t>
+              <a:t>Setext H1 slide</a:t>
             </a:r>
             <a:endParaRPr>
               <a:solidFill>
@@ -6595,7 +6711,8 @@
           </a:bodyPr>
           <a:lstStyle/>
           <a:p>
-            <a:pPr>
+            <a:pPr marL="0" indent="0">
+              <a:buNone/>
               <a:defRPr>
                 <a:solidFill>
                   <a:schemeClr val="dk1"/>
@@ -6604,139 +6721,14 @@
             </a:pPr>
             <a:r>
               <a:rPr b="0" i="0">
+                <a:solidFill>
+                  <a:schemeClr val="dk1"/>
+                </a:solidFill>
                 <a:latin typeface="+mn-lt"/>
                 <a:ea typeface="+mn-ea"/>
                 <a:cs typeface="+mn-cs"/>
-                <a:solidFill>
-                  <a:schemeClr val="dk1"/>
-                </a:solidFill>
-              </a:rPr>
-              <a:t>Inspect the template</a:t>
-            </a:r>
-            <a:endParaRPr>
-              <a:solidFill>
-                <a:schemeClr val="dk1"/>
-              </a:solidFill>
-            </a:endParaRPr>
-          </a:p>
-          <a:p>
-            <a:pPr lvl="1">
-              <a:defRPr>
-                <a:solidFill>
-                  <a:schemeClr val="dk1"/>
-                </a:solidFill>
-              </a:defRPr>
-            </a:pPr>
-            <a:r>
-              <a:rPr b="0" i="0">
-                <a:latin typeface="+mn-lt"/>
-                <a:ea typeface="+mn-ea"/>
-                <a:cs typeface="+mn-cs"/>
-                <a:solidFill>
-                  <a:schemeClr val="dk1"/>
-                </a:solidFill>
-              </a:rPr>
-              <a:t>Select a master</a:t>
-            </a:r>
-            <a:endParaRPr>
-              <a:solidFill>
-                <a:schemeClr val="dk1"/>
-              </a:solidFill>
-            </a:endParaRPr>
-          </a:p>
-          <a:p>
-            <a:pPr lvl="2">
-              <a:defRPr>
-                <a:solidFill>
-                  <a:schemeClr val="dk1"/>
-                </a:solidFill>
-              </a:defRPr>
-            </a:pPr>
-            <a:r>
-              <a:rPr b="0" i="0">
-                <a:latin typeface="+mn-lt"/>
-                <a:ea typeface="+mn-ea"/>
-                <a:cs typeface="+mn-cs"/>
-                <a:solidFill>
-                  <a:schemeClr val="dk1"/>
-                </a:solidFill>
-              </a:rPr>
-              <a:t>Choose a compatible layout</a:t>
-            </a:r>
-            <a:endParaRPr>
-              <a:solidFill>
-                <a:schemeClr val="dk1"/>
-              </a:solidFill>
-            </a:endParaRPr>
-          </a:p>
-          <a:p>
-            <a:pPr>
-              <a:defRPr>
-                <a:solidFill>
-                  <a:schemeClr val="dk1"/>
-                </a:solidFill>
-              </a:defRPr>
-            </a:pPr>
-            <a:r>
-              <a:rPr b="0" i="0">
-                <a:latin typeface="+mn-lt"/>
-                <a:ea typeface="+mn-ea"/>
-                <a:cs typeface="+mn-cs"/>
-                <a:solidFill>
-                  <a:schemeClr val="dk1"/>
-                </a:solidFill>
-              </a:rPr>
-              <a:t>Write the Markdown</a:t>
-            </a:r>
-            <a:endParaRPr>
-              <a:solidFill>
-                <a:schemeClr val="dk1"/>
-              </a:solidFill>
-            </a:endParaRPr>
-          </a:p>
-          <a:p>
-            <a:pPr lvl="1">
-              <a:defRPr>
-                <a:solidFill>
-                  <a:schemeClr val="dk1"/>
-                </a:solidFill>
-              </a:defRPr>
-            </a:pPr>
-            <a:r>
-              <a:rPr b="0" i="0">
-                <a:latin typeface="+mn-lt"/>
-                <a:ea typeface="+mn-ea"/>
-                <a:cs typeface="+mn-cs"/>
-                <a:solidFill>
-                  <a:schemeClr val="dk1"/>
-                </a:solidFill>
-              </a:rPr>
-              <a:t>Keep each slide focused</a:t>
-            </a:r>
-            <a:endParaRPr>
-              <a:solidFill>
-                <a:schemeClr val="dk1"/>
-              </a:solidFill>
-            </a:endParaRPr>
-          </a:p>
-          <a:p>
-            <a:pPr>
-              <a:defRPr>
-                <a:solidFill>
-                  <a:schemeClr val="dk1"/>
-                </a:solidFill>
-              </a:defRPr>
-            </a:pPr>
-            <a:r>
-              <a:rPr b="0" i="0">
-                <a:latin typeface="+mn-lt"/>
-                <a:ea typeface="+mn-ea"/>
-                <a:cs typeface="+mn-cs"/>
-                <a:solidFill>
-                  <a:schemeClr val="dk1"/>
-                </a:solidFill>
-              </a:rPr>
-              <a:t>Render and review the PowerPoint</a:t>
+              </a:rPr>
+              <a:t>An H1 underline can start a slide without an ATX marker.</a:t>
             </a:r>
             <a:endParaRPr>
               <a:solidFill>
@@ -6794,7 +6786,7 @@
                   <a:schemeClr val="accent6"/>
                 </a:solidFill>
               </a:rPr>
-              <a:t>Numbered list</a:t>
+              <a:t>Bulleted list</a:t>
             </a:r>
             <a:endParaRPr>
               <a:solidFill>
@@ -6821,8 +6813,7 @@
           </a:bodyPr>
           <a:lstStyle/>
           <a:p>
-            <a:pPr>
-              <a:buAutoNum type="arabicPeriod" startAt="1"/>
+            <a:pPr marL="411480" indent="-201168">
               <a:defRPr>
                 <a:solidFill>
                   <a:schemeClr val="dk1"/>
@@ -6831,14 +6822,14 @@
             </a:pPr>
             <a:r>
               <a:rPr b="0" i="0">
+                <a:solidFill>
+                  <a:schemeClr val="dk1"/>
+                </a:solidFill>
                 <a:latin typeface="+mn-lt"/>
                 <a:ea typeface="+mn-ea"/>
                 <a:cs typeface="+mn-cs"/>
-                <a:solidFill>
-                  <a:schemeClr val="dk1"/>
-                </a:solidFill>
-              </a:rPr>
-              <a:t>Write the markdown source</a:t>
+              </a:rPr>
+              <a:t>Write a readable Markdown deck</a:t>
             </a:r>
             <a:endParaRPr>
               <a:solidFill>
@@ -6847,8 +6838,7 @@
             </a:endParaRPr>
           </a:p>
           <a:p>
-            <a:pPr>
-              <a:buAutoNum type="arabicPeriod" startAt="2"/>
+            <a:pPr marL="411480" indent="-201168">
               <a:defRPr>
                 <a:solidFill>
                   <a:schemeClr val="dk1"/>
@@ -6857,14 +6847,14 @@
             </a:pPr>
             <a:r>
               <a:rPr b="0" i="0">
+                <a:solidFill>
+                  <a:schemeClr val="dk1"/>
+                </a:solidFill>
                 <a:latin typeface="+mn-lt"/>
                 <a:ea typeface="+mn-ea"/>
                 <a:cs typeface="+mn-cs"/>
-                <a:solidFill>
-                  <a:schemeClr val="dk1"/>
-                </a:solidFill>
-              </a:rPr>
-              <a:t>Run the CLI</a:t>
+              </a:rPr>
+              <a:t>Choose a template if needed</a:t>
             </a:r>
             <a:endParaRPr>
               <a:solidFill>
@@ -6873,8 +6863,7 @@
             </a:endParaRPr>
           </a:p>
           <a:p>
-            <a:pPr>
-              <a:buAutoNum type="arabicPeriod" startAt="3"/>
+            <a:pPr marL="411480" indent="-201168">
               <a:defRPr>
                 <a:solidFill>
                   <a:schemeClr val="dk1"/>
@@ -6883,23 +6872,14 @@
             </a:pPr>
             <a:r>
               <a:rPr b="0" i="0">
+                <a:solidFill>
+                  <a:schemeClr val="dk1"/>
+                </a:solidFill>
                 <a:latin typeface="+mn-lt"/>
                 <a:ea typeface="+mn-ea"/>
                 <a:cs typeface="+mn-cs"/>
-                <a:solidFill>
-                  <a:schemeClr val="dk1"/>
-                </a:solidFill>
-              </a:rPr>
-              <a:t>Open the generated </a:t>
-            </a:r>
-            <a:r>
-              <a:rPr b="0" i="0">
-                <a:latin typeface="Consolas"/>
-                <a:solidFill>
-                  <a:schemeClr val="dk1"/>
-                </a:solidFill>
-              </a:rPr>
-              <a:t>.pptx</a:t>
+              </a:rPr>
+              <a:t>Render an editable PowerPoint file</a:t>
             </a:r>
             <a:endParaRPr>
               <a:solidFill>
@@ -6918,6 +6898,623 @@
 </file>
 
 <file path=ppt/slides/slide22.xml><?xml version="1.0" encoding="utf-8"?>
+<p:sld xmlns:a="http://schemas.openxmlformats.org/drawingml/2006/main" xmlns:p="http://schemas.openxmlformats.org/presentationml/2006/main" xmlns:r="http://schemas.openxmlformats.org/officeDocument/2006/relationships">
+  <p:cSld>
+    <p:spTree>
+      <p:nvGrpSpPr>
+        <p:cNvPr id="1" name=""/>
+        <p:cNvGrpSpPr/>
+        <p:nvPr/>
+      </p:nvGrpSpPr>
+      <p:grpSpPr/>
+      <p:sp>
+        <p:nvSpPr>
+          <p:cNvPr id="2" name="Title 1"/>
+          <p:cNvSpPr>
+            <a:spLocks noGrp="1"/>
+          </p:cNvSpPr>
+          <p:nvPr>
+            <p:ph type="title"/>
+          </p:nvPr>
+        </p:nvSpPr>
+        <p:spPr/>
+        <p:txBody>
+          <a:bodyPr>
+            <a:normAutofit/>
+          </a:bodyPr>
+          <a:lstStyle/>
+          <a:p>
+            <a:pPr>
+              <a:defRPr>
+                <a:solidFill>
+                  <a:schemeClr val="accent6"/>
+                </a:solidFill>
+              </a:defRPr>
+            </a:pPr>
+            <a:r>
+              <a:rPr>
+                <a:solidFill>
+                  <a:schemeClr val="accent6"/>
+                </a:solidFill>
+              </a:rPr>
+              <a:t>Nested lists</a:t>
+            </a:r>
+            <a:endParaRPr>
+              <a:solidFill>
+                <a:schemeClr val="accent6"/>
+              </a:solidFill>
+            </a:endParaRPr>
+          </a:p>
+        </p:txBody>
+      </p:sp>
+      <p:sp>
+        <p:nvSpPr>
+          <p:cNvPr id="3" name="Content Placeholder 2"/>
+          <p:cNvSpPr>
+            <a:spLocks noGrp="1"/>
+          </p:cNvSpPr>
+          <p:nvPr>
+            <p:ph idx="1"/>
+          </p:nvPr>
+        </p:nvSpPr>
+        <p:spPr/>
+        <p:txBody>
+          <a:bodyPr wrap="square">
+            <a:normAutofit/>
+          </a:bodyPr>
+          <a:lstStyle/>
+          <a:p>
+            <a:pPr marL="411480" indent="-201168">
+              <a:defRPr>
+                <a:solidFill>
+                  <a:schemeClr val="dk1"/>
+                </a:solidFill>
+              </a:defRPr>
+            </a:pPr>
+            <a:r>
+              <a:rPr b="0" i="0">
+                <a:solidFill>
+                  <a:schemeClr val="dk1"/>
+                </a:solidFill>
+                <a:latin typeface="+mn-lt"/>
+                <a:ea typeface="+mn-ea"/>
+                <a:cs typeface="+mn-cs"/>
+              </a:rPr>
+              <a:t>Inspect the template</a:t>
+            </a:r>
+            <a:endParaRPr>
+              <a:solidFill>
+                <a:schemeClr val="dk1"/>
+              </a:solidFill>
+            </a:endParaRPr>
+          </a:p>
+          <a:p>
+            <a:pPr lvl="1" marL="822960" indent="-201168">
+              <a:defRPr>
+                <a:solidFill>
+                  <a:schemeClr val="dk1"/>
+                </a:solidFill>
+              </a:defRPr>
+            </a:pPr>
+            <a:r>
+              <a:rPr b="0" i="0">
+                <a:solidFill>
+                  <a:schemeClr val="dk1"/>
+                </a:solidFill>
+                <a:latin typeface="+mn-lt"/>
+                <a:ea typeface="+mn-ea"/>
+                <a:cs typeface="+mn-cs"/>
+              </a:rPr>
+              <a:t>Select a master</a:t>
+            </a:r>
+            <a:endParaRPr>
+              <a:solidFill>
+                <a:schemeClr val="dk1"/>
+              </a:solidFill>
+            </a:endParaRPr>
+          </a:p>
+          <a:p>
+            <a:pPr lvl="2" marL="1234440" indent="-201168">
+              <a:defRPr>
+                <a:solidFill>
+                  <a:schemeClr val="dk1"/>
+                </a:solidFill>
+              </a:defRPr>
+            </a:pPr>
+            <a:r>
+              <a:rPr b="0" i="0">
+                <a:solidFill>
+                  <a:schemeClr val="dk1"/>
+                </a:solidFill>
+                <a:latin typeface="+mn-lt"/>
+                <a:ea typeface="+mn-ea"/>
+                <a:cs typeface="+mn-cs"/>
+              </a:rPr>
+              <a:t>Choose a compatible layout</a:t>
+            </a:r>
+            <a:endParaRPr>
+              <a:solidFill>
+                <a:schemeClr val="dk1"/>
+              </a:solidFill>
+            </a:endParaRPr>
+          </a:p>
+          <a:p>
+            <a:pPr marL="411480" indent="-201168">
+              <a:defRPr>
+                <a:solidFill>
+                  <a:schemeClr val="dk1"/>
+                </a:solidFill>
+              </a:defRPr>
+            </a:pPr>
+            <a:r>
+              <a:rPr b="0" i="0">
+                <a:solidFill>
+                  <a:schemeClr val="dk1"/>
+                </a:solidFill>
+                <a:latin typeface="+mn-lt"/>
+                <a:ea typeface="+mn-ea"/>
+                <a:cs typeface="+mn-cs"/>
+              </a:rPr>
+              <a:t>Write the Markdown</a:t>
+            </a:r>
+            <a:endParaRPr>
+              <a:solidFill>
+                <a:schemeClr val="dk1"/>
+              </a:solidFill>
+            </a:endParaRPr>
+          </a:p>
+          <a:p>
+            <a:pPr lvl="1" marL="822960" indent="-201168">
+              <a:defRPr>
+                <a:solidFill>
+                  <a:schemeClr val="dk1"/>
+                </a:solidFill>
+              </a:defRPr>
+            </a:pPr>
+            <a:r>
+              <a:rPr b="0" i="0">
+                <a:solidFill>
+                  <a:schemeClr val="dk1"/>
+                </a:solidFill>
+                <a:latin typeface="+mn-lt"/>
+                <a:ea typeface="+mn-ea"/>
+                <a:cs typeface="+mn-cs"/>
+              </a:rPr>
+              <a:t>Keep each slide focused</a:t>
+            </a:r>
+            <a:endParaRPr>
+              <a:solidFill>
+                <a:schemeClr val="dk1"/>
+              </a:solidFill>
+            </a:endParaRPr>
+          </a:p>
+          <a:p>
+            <a:pPr marL="411480" indent="-201168">
+              <a:defRPr>
+                <a:solidFill>
+                  <a:schemeClr val="dk1"/>
+                </a:solidFill>
+              </a:defRPr>
+            </a:pPr>
+            <a:r>
+              <a:rPr b="0" i="0">
+                <a:solidFill>
+                  <a:schemeClr val="dk1"/>
+                </a:solidFill>
+                <a:latin typeface="+mn-lt"/>
+                <a:ea typeface="+mn-ea"/>
+                <a:cs typeface="+mn-cs"/>
+              </a:rPr>
+              <a:t>Render and review the PowerPoint</a:t>
+            </a:r>
+            <a:endParaRPr>
+              <a:solidFill>
+                <a:schemeClr val="dk1"/>
+              </a:solidFill>
+            </a:endParaRPr>
+          </a:p>
+        </p:txBody>
+      </p:sp>
+    </p:spTree>
+  </p:cSld>
+  <p:clrMapOvr>
+    <a:masterClrMapping/>
+  </p:clrMapOvr>
+</p:sld>
+</file>
+
+<file path=ppt/slides/slide23.xml><?xml version="1.0" encoding="utf-8"?>
+<p:sld xmlns:a="http://schemas.openxmlformats.org/drawingml/2006/main" xmlns:p="http://schemas.openxmlformats.org/presentationml/2006/main" xmlns:r="http://schemas.openxmlformats.org/officeDocument/2006/relationships">
+  <p:cSld>
+    <p:spTree>
+      <p:nvGrpSpPr>
+        <p:cNvPr id="1" name=""/>
+        <p:cNvGrpSpPr/>
+        <p:nvPr/>
+      </p:nvGrpSpPr>
+      <p:grpSpPr/>
+      <p:sp>
+        <p:nvSpPr>
+          <p:cNvPr id="2" name="Title 1"/>
+          <p:cNvSpPr>
+            <a:spLocks noGrp="1"/>
+          </p:cNvSpPr>
+          <p:nvPr>
+            <p:ph type="title"/>
+          </p:nvPr>
+        </p:nvSpPr>
+        <p:spPr/>
+        <p:txBody>
+          <a:bodyPr>
+            <a:normAutofit/>
+          </a:bodyPr>
+          <a:lstStyle/>
+          <a:p>
+            <a:pPr>
+              <a:defRPr>
+                <a:solidFill>
+                  <a:schemeClr val="accent6"/>
+                </a:solidFill>
+              </a:defRPr>
+            </a:pPr>
+            <a:r>
+              <a:rPr>
+                <a:solidFill>
+                  <a:schemeClr val="accent6"/>
+                </a:solidFill>
+              </a:rPr>
+              <a:t>Numbered list</a:t>
+            </a:r>
+            <a:endParaRPr>
+              <a:solidFill>
+                <a:schemeClr val="accent6"/>
+              </a:solidFill>
+            </a:endParaRPr>
+          </a:p>
+        </p:txBody>
+      </p:sp>
+      <p:sp>
+        <p:nvSpPr>
+          <p:cNvPr id="3" name="Content Placeholder 2"/>
+          <p:cNvSpPr>
+            <a:spLocks noGrp="1"/>
+          </p:cNvSpPr>
+          <p:nvPr>
+            <p:ph idx="1"/>
+          </p:nvPr>
+        </p:nvSpPr>
+        <p:spPr/>
+        <p:txBody>
+          <a:bodyPr wrap="square">
+            <a:normAutofit/>
+          </a:bodyPr>
+          <a:lstStyle/>
+          <a:p>
+            <a:pPr marL="576072" indent="-365760">
+              <a:buAutoNum type="arabicPeriod" startAt="1"/>
+              <a:defRPr>
+                <a:solidFill>
+                  <a:schemeClr val="dk1"/>
+                </a:solidFill>
+              </a:defRPr>
+            </a:pPr>
+            <a:r>
+              <a:rPr b="0" i="0">
+                <a:solidFill>
+                  <a:schemeClr val="dk1"/>
+                </a:solidFill>
+                <a:latin typeface="+mn-lt"/>
+                <a:ea typeface="+mn-ea"/>
+                <a:cs typeface="+mn-cs"/>
+              </a:rPr>
+              <a:t>Write the markdown source</a:t>
+            </a:r>
+            <a:endParaRPr>
+              <a:solidFill>
+                <a:schemeClr val="dk1"/>
+              </a:solidFill>
+            </a:endParaRPr>
+          </a:p>
+          <a:p>
+            <a:pPr marL="576072" indent="-365760">
+              <a:buAutoNum type="arabicPeriod" startAt="2"/>
+              <a:defRPr>
+                <a:solidFill>
+                  <a:schemeClr val="dk1"/>
+                </a:solidFill>
+              </a:defRPr>
+            </a:pPr>
+            <a:r>
+              <a:rPr b="0" i="0">
+                <a:solidFill>
+                  <a:schemeClr val="dk1"/>
+                </a:solidFill>
+                <a:latin typeface="+mn-lt"/>
+                <a:ea typeface="+mn-ea"/>
+                <a:cs typeface="+mn-cs"/>
+              </a:rPr>
+              <a:t>Run the CLI</a:t>
+            </a:r>
+            <a:endParaRPr>
+              <a:solidFill>
+                <a:schemeClr val="dk1"/>
+              </a:solidFill>
+            </a:endParaRPr>
+          </a:p>
+          <a:p>
+            <a:pPr marL="576072" indent="-365760">
+              <a:buAutoNum type="arabicPeriod" startAt="3"/>
+              <a:defRPr>
+                <a:solidFill>
+                  <a:schemeClr val="dk1"/>
+                </a:solidFill>
+              </a:defRPr>
+            </a:pPr>
+            <a:r>
+              <a:rPr b="0" i="0">
+                <a:solidFill>
+                  <a:schemeClr val="dk1"/>
+                </a:solidFill>
+                <a:latin typeface="+mn-lt"/>
+                <a:ea typeface="+mn-ea"/>
+                <a:cs typeface="+mn-cs"/>
+              </a:rPr>
+              <a:t>Open the generated </a:t>
+            </a:r>
+            <a:r>
+              <a:rPr b="0" i="0">
+                <a:solidFill>
+                  <a:schemeClr val="dk1"/>
+                </a:solidFill>
+                <a:latin typeface="Consolas"/>
+              </a:rPr>
+              <a:t>.pptx</a:t>
+            </a:r>
+            <a:endParaRPr>
+              <a:solidFill>
+                <a:schemeClr val="dk1"/>
+              </a:solidFill>
+            </a:endParaRPr>
+          </a:p>
+        </p:txBody>
+      </p:sp>
+    </p:spTree>
+  </p:cSld>
+  <p:clrMapOvr>
+    <a:masterClrMapping/>
+  </p:clrMapOvr>
+</p:sld>
+</file>
+
+<file path=ppt/slides/slide24.xml><?xml version="1.0" encoding="utf-8"?>
+<p:sld xmlns:a="http://schemas.openxmlformats.org/drawingml/2006/main" xmlns:p="http://schemas.openxmlformats.org/presentationml/2006/main" xmlns:r="http://schemas.openxmlformats.org/officeDocument/2006/relationships">
+  <p:cSld>
+    <p:spTree>
+      <p:nvGrpSpPr>
+        <p:cNvPr id="1" name=""/>
+        <p:cNvGrpSpPr/>
+        <p:nvPr/>
+      </p:nvGrpSpPr>
+      <p:grpSpPr/>
+      <p:sp>
+        <p:nvSpPr>
+          <p:cNvPr id="2" name="Title 1"/>
+          <p:cNvSpPr>
+            <a:spLocks noGrp="1"/>
+          </p:cNvSpPr>
+          <p:nvPr>
+            <p:ph type="title"/>
+          </p:nvPr>
+        </p:nvSpPr>
+        <p:spPr/>
+        <p:txBody>
+          <a:bodyPr>
+            <a:normAutofit/>
+          </a:bodyPr>
+          <a:lstStyle/>
+          <a:p>
+            <a:pPr>
+              <a:defRPr>
+                <a:solidFill>
+                  <a:schemeClr val="accent6"/>
+                </a:solidFill>
+              </a:defRPr>
+            </a:pPr>
+            <a:r>
+              <a:rPr>
+                <a:solidFill>
+                  <a:schemeClr val="accent6"/>
+                </a:solidFill>
+              </a:rPr>
+              <a:t>Task lists and continuations</a:t>
+            </a:r>
+            <a:endParaRPr>
+              <a:solidFill>
+                <a:schemeClr val="accent6"/>
+              </a:solidFill>
+            </a:endParaRPr>
+          </a:p>
+        </p:txBody>
+      </p:sp>
+      <p:sp>
+        <p:nvSpPr>
+          <p:cNvPr id="3" name="Content Placeholder 2"/>
+          <p:cNvSpPr>
+            <a:spLocks noGrp="1"/>
+          </p:cNvSpPr>
+          <p:nvPr>
+            <p:ph idx="1"/>
+          </p:nvPr>
+        </p:nvSpPr>
+        <p:spPr/>
+        <p:txBody>
+          <a:bodyPr wrap="square">
+            <a:normAutofit/>
+          </a:bodyPr>
+          <a:lstStyle/>
+          <a:p>
+            <a:pPr marL="0" indent="0">
+              <a:buNone/>
+              <a:defRPr>
+                <a:solidFill>
+                  <a:schemeClr val="dk1"/>
+                </a:solidFill>
+              </a:defRPr>
+            </a:pPr>
+            <a:r>
+              <a:rPr b="0" i="0">
+                <a:solidFill>
+                  <a:schemeClr val="dk1"/>
+                </a:solidFill>
+                <a:latin typeface="+mn-lt"/>
+                <a:ea typeface="+mn-ea"/>
+                <a:cs typeface="+mn-cs"/>
+              </a:rPr>
+              <a:t>☑ </a:t>
+            </a:r>
+            <a:r>
+              <a:rPr b="0" i="0">
+                <a:solidFill>
+                  <a:schemeClr val="dk1"/>
+                </a:solidFill>
+                <a:latin typeface="+mn-lt"/>
+                <a:ea typeface="+mn-ea"/>
+                <a:cs typeface="+mn-cs"/>
+              </a:rPr>
+              <a:t>Create the editable deck</a:t>
+            </a:r>
+            <a:endParaRPr>
+              <a:solidFill>
+                <a:schemeClr val="dk1"/>
+              </a:solidFill>
+            </a:endParaRPr>
+          </a:p>
+          <a:p>
+            <a:pPr marL="0" indent="0">
+              <a:buNone/>
+              <a:defRPr>
+                <a:solidFill>
+                  <a:schemeClr val="dk1"/>
+                </a:solidFill>
+              </a:defRPr>
+            </a:pPr>
+            <a:r>
+              <a:rPr b="0" i="0">
+                <a:solidFill>
+                  <a:schemeClr val="dk1"/>
+                </a:solidFill>
+                <a:latin typeface="+mn-lt"/>
+                <a:ea typeface="+mn-ea"/>
+                <a:cs typeface="+mn-cs"/>
+              </a:rPr>
+              <a:t>☐ </a:t>
+            </a:r>
+            <a:r>
+              <a:rPr b="0" i="0">
+                <a:solidFill>
+                  <a:schemeClr val="dk1"/>
+                </a:solidFill>
+                <a:latin typeface="+mn-lt"/>
+                <a:ea typeface="+mn-ea"/>
+                <a:cs typeface="+mn-cs"/>
+              </a:rPr>
+              <a:t>Review the slides</a:t>
+            </a:r>
+            <a:endParaRPr>
+              <a:solidFill>
+                <a:schemeClr val="dk1"/>
+              </a:solidFill>
+            </a:endParaRPr>
+          </a:p>
+          <a:p>
+            <a:pPr marL="576072" indent="-365760">
+              <a:buAutoNum type="arabicPeriod" startAt="1"/>
+              <a:defRPr>
+                <a:solidFill>
+                  <a:schemeClr val="dk1"/>
+                </a:solidFill>
+              </a:defRPr>
+            </a:pPr>
+            <a:r>
+              <a:rPr b="0" i="0">
+                <a:solidFill>
+                  <a:schemeClr val="dk1"/>
+                </a:solidFill>
+                <a:latin typeface="+mn-lt"/>
+                <a:ea typeface="+mn-ea"/>
+                <a:cs typeface="+mn-cs"/>
+              </a:rPr>
+              <a:t>Begin with a numbered item</a:t>
+            </a:r>
+            <a:endParaRPr>
+              <a:solidFill>
+                <a:schemeClr val="dk1"/>
+              </a:solidFill>
+            </a:endParaRPr>
+          </a:p>
+          <a:p>
+            <a:pPr marL="576072" indent="0">
+              <a:buNone/>
+              <a:defRPr>
+                <a:solidFill>
+                  <a:schemeClr val="dk1"/>
+                </a:solidFill>
+              </a:defRPr>
+            </a:pPr>
+            <a:r>
+              <a:rPr b="0" i="0">
+                <a:solidFill>
+                  <a:schemeClr val="dk1"/>
+                </a:solidFill>
+                <a:latin typeface="+mn-lt"/>
+                <a:ea typeface="+mn-ea"/>
+                <a:cs typeface="+mn-cs"/>
+              </a:rPr>
+              <a:t>Continue its explanation without another number.</a:t>
+            </a:r>
+            <a:endParaRPr>
+              <a:solidFill>
+                <a:schemeClr val="dk1"/>
+              </a:solidFill>
+            </a:endParaRPr>
+          </a:p>
+          <a:p>
+            <a:pPr marL="576072" indent="-365760">
+              <a:buAutoNum type="arabicPeriod" startAt="2"/>
+              <a:defRPr>
+                <a:solidFill>
+                  <a:schemeClr val="dk1"/>
+                </a:solidFill>
+              </a:defRPr>
+            </a:pPr>
+            <a:r>
+              <a:rPr b="0" i="0">
+                <a:solidFill>
+                  <a:schemeClr val="dk1"/>
+                </a:solidFill>
+                <a:latin typeface="+mn-lt"/>
+                <a:ea typeface="+mn-ea"/>
+                <a:cs typeface="+mn-cs"/>
+              </a:rPr>
+              <a:t>Finish the sequence</a:t>
+            </a:r>
+            <a:endParaRPr>
+              <a:solidFill>
+                <a:schemeClr val="dk1"/>
+              </a:solidFill>
+            </a:endParaRPr>
+          </a:p>
+        </p:txBody>
+      </p:sp>
+    </p:spTree>
+  </p:cSld>
+  <p:clrMapOvr>
+    <a:masterClrMapping/>
+  </p:clrMapOvr>
+</p:sld>
+</file>
+
+<file path=ppt/slides/slide25.xml><?xml version="1.0" encoding="utf-8"?>
 <p:sld xmlns:a="http://schemas.openxmlformats.org/drawingml/2006/main" xmlns:p="http://schemas.openxmlformats.org/presentationml/2006/main" xmlns:r="http://schemas.openxmlformats.org/officeDocument/2006/relationships">
   <p:cSld>
     <p:spTree>
@@ -7234,7 +7831,7 @@
 </p:sld>
 </file>
 
-<file path=ppt/slides/slide23.xml><?xml version="1.0" encoding="utf-8"?>
+<file path=ppt/slides/slide26.xml><?xml version="1.0" encoding="utf-8"?>
 <p:sld xmlns:a="http://schemas.openxmlformats.org/drawingml/2006/main" xmlns:p="http://schemas.openxmlformats.org/presentationml/2006/main" xmlns:r="http://schemas.openxmlformats.org/officeDocument/2006/relationships">
   <p:cSld>
     <p:spTree>
@@ -7301,7 +7898,7 @@
           </a:bodyPr>
           <a:lstStyle/>
           <a:p>
-            <a:pPr marL="0" indent="0">
+            <a:pPr marL="274320" indent="0">
               <a:spcBef>
                 <a:spcPts val="600"/>
               </a:spcBef>
@@ -7311,15 +7908,50 @@
               <a:buNone/>
             </a:pPr>
             <a:r>
-              <a:rPr i="1">
+              <a:rPr b="0" i="1">
+                <a:solidFill>
+                  <a:schemeClr val="accent1"/>
+                </a:solidFill>
                 <a:latin typeface="+mn-lt"/>
                 <a:ea typeface="+mn-ea"/>
                 <a:cs typeface="+mn-cs"/>
+              </a:rPr>
+              <a:t>markdown-pptx keeps the source format simple enough to read directly while still producing a real presentation.</a:t>
+            </a:r>
+          </a:p>
+          <a:p>
+            <a:pPr marL="685800" indent="-201168">
+              <a:spcBef>
+                <a:spcPts val="600"/>
+              </a:spcBef>
+              <a:spcAft>
+                <a:spcPts val="600"/>
+              </a:spcAft>
+            </a:pPr>
+            <a:r>
+              <a:rPr b="0" i="1">
                 <a:solidFill>
                   <a:schemeClr val="accent1"/>
                 </a:solidFill>
-              </a:rPr>
-              <a:t>markdown-pptx keeps the source format simple enough to read directly while still producing a real presentation.</a:t>
+                <a:latin typeface="+mn-lt"/>
+                <a:ea typeface="+mn-ea"/>
+                <a:cs typeface="+mn-cs"/>
+              </a:rPr>
+              <a:t>Quoted lists keep their bullets.</a:t>
+            </a:r>
+          </a:p>
+          <a:p>
+            <a:pPr marL="274320" indent="0">
+              <a:spcBef>
+                <a:spcPts val="600"/>
+              </a:spcBef>
+              <a:spcAft>
+                <a:spcPts val="600"/>
+              </a:spcAft>
+              <a:buNone/>
+            </a:pPr>
+            <a:r>
+              <a:t/>
             </a:r>
           </a:p>
         </p:txBody>
@@ -7332,7 +7964,7 @@
 </p:sld>
 </file>
 
-<file path=ppt/slides/slide24.xml><?xml version="1.0" encoding="utf-8"?>
+<file path=ppt/slides/slide27.xml><?xml version="1.0" encoding="utf-8"?>
 <p:sld xmlns:a="http://schemas.openxmlformats.org/drawingml/2006/main" xmlns:p="http://schemas.openxmlformats.org/presentationml/2006/main" xmlns:r="http://schemas.openxmlformats.org/officeDocument/2006/relationships">
   <p:cSld>
     <p:spTree>
@@ -7409,12 +8041,255 @@
             </a:pPr>
             <a:r>
               <a:rPr b="0" i="0">
+                <a:solidFill>
+                  <a:schemeClr val="dk1"/>
+                </a:solidFill>
                 <a:latin typeface="Consolas"/>
-                <a:solidFill>
-                  <a:schemeClr val="dk1"/>
-                </a:solidFill>
-              </a:rPr>
-              <a:t>uvx markdown-pptx sample/showcase.md sample/showcase.pptx --template sample/showcase-template.pptx --force</a:t>
+              </a:rPr>
+              <a:t>uvx</a:t>
+            </a:r>
+            <a:r>
+              <a:rPr b="0" i="0">
+                <a:solidFill>
+                  <a:schemeClr val="dk1"/>
+                </a:solidFill>
+                <a:latin typeface="Consolas"/>
+              </a:rPr>
+              <a:t> </a:t>
+            </a:r>
+            <a:r>
+              <a:rPr b="0" i="0">
+                <a:solidFill>
+                  <a:schemeClr val="dk1"/>
+                </a:solidFill>
+                <a:latin typeface="Consolas"/>
+              </a:rPr>
+              <a:t>markdown</a:t>
+            </a:r>
+            <a:r>
+              <a:rPr b="0" i="0">
+                <a:solidFill>
+                  <a:schemeClr val="dk1"/>
+                </a:solidFill>
+                <a:latin typeface="Consolas"/>
+              </a:rPr>
+              <a:t>-pptx</a:t>
+            </a:r>
+            <a:r>
+              <a:rPr b="0" i="0">
+                <a:solidFill>
+                  <a:schemeClr val="dk1"/>
+                </a:solidFill>
+                <a:latin typeface="Consolas"/>
+              </a:rPr>
+              <a:t> </a:t>
+            </a:r>
+            <a:r>
+              <a:rPr b="0" i="0">
+                <a:solidFill>
+                  <a:schemeClr val="dk1"/>
+                </a:solidFill>
+                <a:latin typeface="Consolas"/>
+              </a:rPr>
+              <a:t>sample</a:t>
+            </a:r>
+            <a:r>
+              <a:rPr b="0" i="0">
+                <a:solidFill>
+                  <a:schemeClr val="dk1"/>
+                </a:solidFill>
+                <a:latin typeface="Consolas"/>
+              </a:rPr>
+              <a:t>/</a:t>
+            </a:r>
+            <a:r>
+              <a:rPr b="0" i="0">
+                <a:solidFill>
+                  <a:schemeClr val="dk1"/>
+                </a:solidFill>
+                <a:latin typeface="Consolas"/>
+              </a:rPr>
+              <a:t>showcase</a:t>
+            </a:r>
+            <a:r>
+              <a:rPr b="0" i="0">
+                <a:solidFill>
+                  <a:schemeClr val="dk1"/>
+                </a:solidFill>
+                <a:latin typeface="Consolas"/>
+              </a:rPr>
+              <a:t>.</a:t>
+            </a:r>
+            <a:r>
+              <a:rPr b="0" i="0">
+                <a:solidFill>
+                  <a:srgbClr val="008000"/>
+                </a:solidFill>
+                <a:latin typeface="Consolas"/>
+              </a:rPr>
+              <a:t>md </a:t>
+            </a:r>
+            <a:r>
+              <a:rPr b="0" i="0">
+                <a:solidFill>
+                  <a:schemeClr val="dk1"/>
+                </a:solidFill>
+                <a:latin typeface="Consolas"/>
+              </a:rPr>
+              <a:t>sample</a:t>
+            </a:r>
+            <a:r>
+              <a:rPr b="0" i="0">
+                <a:solidFill>
+                  <a:schemeClr val="dk1"/>
+                </a:solidFill>
+                <a:latin typeface="Consolas"/>
+              </a:rPr>
+              <a:t>/</a:t>
+            </a:r>
+            <a:r>
+              <a:rPr b="0" i="0">
+                <a:solidFill>
+                  <a:schemeClr val="dk1"/>
+                </a:solidFill>
+                <a:latin typeface="Consolas"/>
+              </a:rPr>
+              <a:t>showcase</a:t>
+            </a:r>
+            <a:r>
+              <a:rPr b="0" i="0">
+                <a:solidFill>
+                  <a:schemeClr val="dk1"/>
+                </a:solidFill>
+                <a:latin typeface="Consolas"/>
+              </a:rPr>
+              <a:t>.</a:t>
+            </a:r>
+            <a:r>
+              <a:rPr b="0" i="0">
+                <a:solidFill>
+                  <a:schemeClr val="dk1"/>
+                </a:solidFill>
+                <a:latin typeface="Consolas"/>
+              </a:rPr>
+              <a:t>pptx</a:t>
+            </a:r>
+            <a:r>
+              <a:rPr b="0" i="0">
+                <a:solidFill>
+                  <a:schemeClr val="dk1"/>
+                </a:solidFill>
+                <a:latin typeface="Consolas"/>
+              </a:rPr>
+              <a:t> </a:t>
+            </a:r>
+            <a:r>
+              <a:rPr b="0" i="0">
+                <a:solidFill>
+                  <a:schemeClr val="dk1"/>
+                </a:solidFill>
+                <a:latin typeface="Consolas"/>
+              </a:rPr>
+              <a:t>-</a:t>
+            </a:r>
+            <a:r>
+              <a:rPr b="0" i="0">
+                <a:solidFill>
+                  <a:schemeClr val="dk1"/>
+                </a:solidFill>
+                <a:latin typeface="Consolas"/>
+              </a:rPr>
+              <a:t>-template</a:t>
+            </a:r>
+            <a:r>
+              <a:rPr b="0" i="0">
+                <a:solidFill>
+                  <a:schemeClr val="dk1"/>
+                </a:solidFill>
+                <a:latin typeface="Consolas"/>
+              </a:rPr>
+              <a:t> </a:t>
+            </a:r>
+            <a:r>
+              <a:rPr b="0" i="0">
+                <a:solidFill>
+                  <a:schemeClr val="dk1"/>
+                </a:solidFill>
+                <a:latin typeface="Consolas"/>
+              </a:rPr>
+              <a:t>sample</a:t>
+            </a:r>
+            <a:r>
+              <a:rPr b="0" i="0">
+                <a:solidFill>
+                  <a:schemeClr val="dk1"/>
+                </a:solidFill>
+                <a:latin typeface="Consolas"/>
+              </a:rPr>
+              <a:t>/</a:t>
+            </a:r>
+            <a:r>
+              <a:rPr b="0" i="0">
+                <a:solidFill>
+                  <a:schemeClr val="dk1"/>
+                </a:solidFill>
+                <a:latin typeface="Consolas"/>
+              </a:rPr>
+              <a:t>showcase</a:t>
+            </a:r>
+            <a:r>
+              <a:rPr b="0" i="0">
+                <a:solidFill>
+                  <a:schemeClr val="dk1"/>
+                </a:solidFill>
+                <a:latin typeface="Consolas"/>
+              </a:rPr>
+              <a:t>-template</a:t>
+            </a:r>
+            <a:r>
+              <a:rPr b="0" i="0">
+                <a:solidFill>
+                  <a:schemeClr val="dk1"/>
+                </a:solidFill>
+                <a:latin typeface="Consolas"/>
+              </a:rPr>
+              <a:t>.</a:t>
+            </a:r>
+            <a:r>
+              <a:rPr b="0" i="0">
+                <a:solidFill>
+                  <a:schemeClr val="dk1"/>
+                </a:solidFill>
+                <a:latin typeface="Consolas"/>
+              </a:rPr>
+              <a:t>pptx</a:t>
+            </a:r>
+            <a:r>
+              <a:rPr b="0" i="0">
+                <a:solidFill>
+                  <a:schemeClr val="dk1"/>
+                </a:solidFill>
+                <a:latin typeface="Consolas"/>
+              </a:rPr>
+              <a:t> </a:t>
+            </a:r>
+            <a:r>
+              <a:rPr b="0" i="0">
+                <a:solidFill>
+                  <a:schemeClr val="dk1"/>
+                </a:solidFill>
+                <a:latin typeface="Consolas"/>
+              </a:rPr>
+              <a:t>-</a:t>
+            </a:r>
+            <a:r>
+              <a:rPr b="0" i="0">
+                <a:solidFill>
+                  <a:schemeClr val="dk1"/>
+                </a:solidFill>
+                <a:latin typeface="Consolas"/>
+              </a:rPr>
+              <a:t>-force</a:t>
             </a:r>
             <a:endParaRPr>
               <a:solidFill>
@@ -7432,7 +8307,7 @@
 </p:sld>
 </file>
 
-<file path=ppt/slides/slide25.xml><?xml version="1.0" encoding="utf-8"?>
+<file path=ppt/slides/slide28.xml><?xml version="1.0" encoding="utf-8"?>
 <p:sld xmlns:a="http://schemas.openxmlformats.org/drawingml/2006/main" xmlns:p="http://schemas.openxmlformats.org/presentationml/2006/main" xmlns:r="http://schemas.openxmlformats.org/officeDocument/2006/relationships">
   <p:cSld>
     <p:spTree>
@@ -7501,7 +8376,9 @@
       </p:sp>
       <p:pic>
         <p:nvPicPr>
-          <p:cNvPr id="4" name="MarkdownSlidesImage" descr="showcase-local.png"/>
+          <p:cNvPr id="4" name="MarkdownSlidesImage" descr="Local markdown-pptx sample image" title="Showcase image">
+            <a:hlinkClick r:id="rId3"/>
+          </p:cNvPr>
           <p:cNvPicPr>
             <a:picLocks noChangeAspect="1"/>
           </p:cNvPicPr>
@@ -7531,7 +8408,7 @@
 </p:sld>
 </file>
 
-<file path=ppt/slides/slide26.xml><?xml version="1.0" encoding="utf-8"?>
+<file path=ppt/slides/slide29.xml><?xml version="1.0" encoding="utf-8"?>
 <p:sld xmlns:a="http://schemas.openxmlformats.org/drawingml/2006/main" xmlns:p="http://schemas.openxmlformats.org/presentationml/2006/main" xmlns:r="http://schemas.openxmlformats.org/officeDocument/2006/relationships">
   <p:cSld>
     <p:spTree>
@@ -7600,7 +8477,7 @@
       </p:sp>
       <p:pic>
         <p:nvPicPr>
-          <p:cNvPr id="4" name="MarkdownSlidesImage" descr="image.png"/>
+          <p:cNvPr id="4" name="MarkdownSlidesImage" descr="Remote Python logo"/>
           <p:cNvPicPr>
             <a:picLocks noChangeAspect="1"/>
           </p:cNvPicPr>
@@ -7630,7 +8507,155 @@
 </p:sld>
 </file>
 
-<file path=ppt/slides/slide27.xml><?xml version="1.0" encoding="utf-8"?>
+<file path=ppt/slides/slide3.xml><?xml version="1.0" encoding="utf-8"?>
+<p:sld xmlns:a="http://schemas.openxmlformats.org/drawingml/2006/main" xmlns:p="http://schemas.openxmlformats.org/presentationml/2006/main" xmlns:r="http://schemas.openxmlformats.org/officeDocument/2006/relationships">
+  <p:cSld>
+    <p:spTree>
+      <p:nvGrpSpPr>
+        <p:cNvPr id="1" name=""/>
+        <p:cNvGrpSpPr/>
+        <p:nvPr/>
+      </p:nvGrpSpPr>
+      <p:grpSpPr/>
+      <p:sp>
+        <p:nvSpPr>
+          <p:cNvPr id="2" name="Title 1"/>
+          <p:cNvSpPr>
+            <a:spLocks noGrp="1"/>
+          </p:cNvSpPr>
+          <p:nvPr>
+            <p:ph type="title"/>
+          </p:nvPr>
+        </p:nvSpPr>
+        <p:spPr/>
+        <p:txBody>
+          <a:bodyPr>
+            <a:normAutofit/>
+          </a:bodyPr>
+          <a:lstStyle/>
+          <a:p>
+            <a:pPr>
+              <a:defRPr>
+                <a:solidFill>
+                  <a:schemeClr val="accent6"/>
+                </a:solidFill>
+              </a:defRPr>
+            </a:pPr>
+            <a:r>
+              <a:rPr>
+                <a:solidFill>
+                  <a:schemeClr val="accent6"/>
+                </a:solidFill>
+              </a:rPr>
+              <a:t>How the format works</a:t>
+            </a:r>
+            <a:endParaRPr>
+              <a:solidFill>
+                <a:schemeClr val="accent6"/>
+              </a:solidFill>
+            </a:endParaRPr>
+          </a:p>
+        </p:txBody>
+      </p:sp>
+      <p:sp>
+        <p:nvSpPr>
+          <p:cNvPr id="3" name="Content Placeholder 2"/>
+          <p:cNvSpPr>
+            <a:spLocks noGrp="1"/>
+          </p:cNvSpPr>
+          <p:nvPr>
+            <p:ph idx="1"/>
+          </p:nvPr>
+        </p:nvSpPr>
+        <p:spPr/>
+        <p:txBody>
+          <a:bodyPr wrap="square">
+            <a:normAutofit/>
+          </a:bodyPr>
+          <a:lstStyle/>
+          <a:p>
+            <a:pPr marL="0" indent="0">
+              <a:buNone/>
+              <a:defRPr>
+                <a:solidFill>
+                  <a:schemeClr val="dk1"/>
+                </a:solidFill>
+              </a:defRPr>
+            </a:pPr>
+            <a:r>
+              <a:rPr b="0" i="0">
+                <a:solidFill>
+                  <a:schemeClr val="dk1"/>
+                </a:solidFill>
+                <a:latin typeface="+mn-lt"/>
+                <a:ea typeface="+mn-ea"/>
+                <a:cs typeface="+mn-cs"/>
+              </a:rPr>
+              <a:t>An optional document front matter block sets deck-wide defaults such as aspect ratio, fonts, colors, and background behavior.</a:t>
+            </a:r>
+            <a:endParaRPr>
+              <a:solidFill>
+                <a:schemeClr val="dk1"/>
+              </a:solidFill>
+            </a:endParaRPr>
+          </a:p>
+          <a:p>
+            <a:pPr marL="0" indent="0">
+              <a:buNone/>
+              <a:defRPr>
+                <a:solidFill>
+                  <a:schemeClr val="dk1"/>
+                </a:solidFill>
+              </a:defRPr>
+            </a:pPr>
+            <a:r>
+              <a:rPr b="0" i="0">
+                <a:solidFill>
+                  <a:schemeClr val="dk1"/>
+                </a:solidFill>
+                <a:latin typeface="+mn-lt"/>
+                <a:ea typeface="+mn-ea"/>
+                <a:cs typeface="+mn-cs"/>
+              </a:rPr>
+              <a:t>Each ATX </a:t>
+            </a:r>
+            <a:r>
+              <a:rPr b="0" i="0">
+                <a:solidFill>
+                  <a:schemeClr val="dk1"/>
+                </a:solidFill>
+                <a:latin typeface="Consolas"/>
+              </a:rPr>
+              <a:t># H1</a:t>
+            </a:r>
+            <a:r>
+              <a:rPr b="0" i="0">
+                <a:solidFill>
+                  <a:schemeClr val="dk1"/>
+                </a:solidFill>
+                <a:latin typeface="+mn-lt"/>
+                <a:ea typeface="+mn-ea"/>
+                <a:cs typeface="+mn-cs"/>
+              </a:rPr>
+              <a:t> or Setext H1 starts a new slide. Optional slide front matter appears immediately after the heading. Everything until the next H1 belongs to that slide.</a:t>
+            </a:r>
+            <a:endParaRPr>
+              <a:solidFill>
+                <a:schemeClr val="dk1"/>
+              </a:solidFill>
+            </a:endParaRPr>
+          </a:p>
+        </p:txBody>
+      </p:sp>
+    </p:spTree>
+  </p:cSld>
+  <p:clrMapOvr>
+    <a:masterClrMapping/>
+  </p:clrMapOvr>
+</p:sld>
+</file>
+
+<file path=ppt/slides/slide30.xml><?xml version="1.0" encoding="utf-8"?>
 <p:sld xmlns:a="http://schemas.openxmlformats.org/drawingml/2006/main" xmlns:p="http://schemas.openxmlformats.org/presentationml/2006/main" xmlns:r="http://schemas.openxmlformats.org/officeDocument/2006/relationships">
   <p:cSld>
     <p:bg>
@@ -7715,12 +8740,12 @@
             </a:pPr>
             <a:r>
               <a:rPr b="0" i="0">
+                <a:solidFill>
+                  <a:schemeClr val="dk1"/>
+                </a:solidFill>
                 <a:latin typeface="+mn-lt"/>
                 <a:ea typeface="+mn-ea"/>
                 <a:cs typeface="+mn-cs"/>
-                <a:solidFill>
-                  <a:schemeClr val="dk1"/>
-                </a:solidFill>
               </a:rPr>
               <a:t>This slide uses a solid slide background color.</a:t>
             </a:r>
@@ -7740,7 +8765,7 @@
 </p:sld>
 </file>
 
-<file path=ppt/slides/slide28.xml><?xml version="1.0" encoding="utf-8"?>
+<file path=ppt/slides/slide31.xml><?xml version="1.0" encoding="utf-8"?>
 <p:sld xmlns:a="http://schemas.openxmlformats.org/drawingml/2006/main" xmlns:p="http://schemas.openxmlformats.org/presentationml/2006/main" xmlns:r="http://schemas.openxmlformats.org/officeDocument/2006/relationships" showMasterSp="0">
   <p:cSld>
     <p:bg>
@@ -7823,12 +8848,12 @@
             </a:pPr>
             <a:r>
               <a:rPr b="0" i="0">
+                <a:solidFill>
+                  <a:schemeClr val="dk1"/>
+                </a:solidFill>
                 <a:latin typeface="+mn-lt"/>
                 <a:ea typeface="+mn-ea"/>
                 <a:cs typeface="+mn-cs"/>
-                <a:solidFill>
-                  <a:schemeClr val="dk1"/>
-                </a:solidFill>
               </a:rPr>
               <a:t>This slide removes its slide-level fill and hides the orange accent graphic inherited from the alternate master.</a:t>
             </a:r>
@@ -7848,7 +8873,7 @@
 </p:sld>
 </file>
 
-<file path=ppt/slides/slide29.xml><?xml version="1.0" encoding="utf-8"?>
+<file path=ppt/slides/slide32.xml><?xml version="1.0" encoding="utf-8"?>
 <p:sld xmlns:a="http://schemas.openxmlformats.org/drawingml/2006/main" xmlns:p="http://schemas.openxmlformats.org/presentationml/2006/main" xmlns:r="http://schemas.openxmlformats.org/officeDocument/2006/relationships">
   <p:cSld>
     <p:spTree>
@@ -7890,155 +8915,7 @@
 </p:sld>
 </file>
 
-<file path=ppt/slides/slide3.xml><?xml version="1.0" encoding="utf-8"?>
-<p:sld xmlns:a="http://schemas.openxmlformats.org/drawingml/2006/main" xmlns:p="http://schemas.openxmlformats.org/presentationml/2006/main" xmlns:r="http://schemas.openxmlformats.org/officeDocument/2006/relationships">
-  <p:cSld>
-    <p:spTree>
-      <p:nvGrpSpPr>
-        <p:cNvPr id="1" name=""/>
-        <p:cNvGrpSpPr/>
-        <p:nvPr/>
-      </p:nvGrpSpPr>
-      <p:grpSpPr/>
-      <p:sp>
-        <p:nvSpPr>
-          <p:cNvPr id="2" name="Title 1"/>
-          <p:cNvSpPr>
-            <a:spLocks noGrp="1"/>
-          </p:cNvSpPr>
-          <p:nvPr>
-            <p:ph type="title"/>
-          </p:nvPr>
-        </p:nvSpPr>
-        <p:spPr/>
-        <p:txBody>
-          <a:bodyPr>
-            <a:normAutofit/>
-          </a:bodyPr>
-          <a:lstStyle/>
-          <a:p>
-            <a:pPr>
-              <a:defRPr>
-                <a:solidFill>
-                  <a:schemeClr val="accent6"/>
-                </a:solidFill>
-              </a:defRPr>
-            </a:pPr>
-            <a:r>
-              <a:rPr>
-                <a:solidFill>
-                  <a:schemeClr val="accent6"/>
-                </a:solidFill>
-              </a:rPr>
-              <a:t>How the format works</a:t>
-            </a:r>
-            <a:endParaRPr>
-              <a:solidFill>
-                <a:schemeClr val="accent6"/>
-              </a:solidFill>
-            </a:endParaRPr>
-          </a:p>
-        </p:txBody>
-      </p:sp>
-      <p:sp>
-        <p:nvSpPr>
-          <p:cNvPr id="3" name="Content Placeholder 2"/>
-          <p:cNvSpPr>
-            <a:spLocks noGrp="1"/>
-          </p:cNvSpPr>
-          <p:nvPr>
-            <p:ph idx="1"/>
-          </p:nvPr>
-        </p:nvSpPr>
-        <p:spPr/>
-        <p:txBody>
-          <a:bodyPr wrap="square">
-            <a:normAutofit/>
-          </a:bodyPr>
-          <a:lstStyle/>
-          <a:p>
-            <a:pPr marL="0" indent="0">
-              <a:buNone/>
-              <a:defRPr>
-                <a:solidFill>
-                  <a:schemeClr val="dk1"/>
-                </a:solidFill>
-              </a:defRPr>
-            </a:pPr>
-            <a:r>
-              <a:rPr b="0" i="0">
-                <a:latin typeface="+mn-lt"/>
-                <a:ea typeface="+mn-ea"/>
-                <a:cs typeface="+mn-cs"/>
-                <a:solidFill>
-                  <a:schemeClr val="dk1"/>
-                </a:solidFill>
-              </a:rPr>
-              <a:t>An optional document front matter block sets deck-wide defaults such as aspect ratio, fonts, colors, and background behavior.</a:t>
-            </a:r>
-            <a:endParaRPr>
-              <a:solidFill>
-                <a:schemeClr val="dk1"/>
-              </a:solidFill>
-            </a:endParaRPr>
-          </a:p>
-          <a:p>
-            <a:pPr marL="0" indent="0">
-              <a:buNone/>
-              <a:defRPr>
-                <a:solidFill>
-                  <a:schemeClr val="dk1"/>
-                </a:solidFill>
-              </a:defRPr>
-            </a:pPr>
-            <a:r>
-              <a:rPr b="0" i="0">
-                <a:latin typeface="+mn-lt"/>
-                <a:ea typeface="+mn-ea"/>
-                <a:cs typeface="+mn-cs"/>
-                <a:solidFill>
-                  <a:schemeClr val="dk1"/>
-                </a:solidFill>
-              </a:rPr>
-              <a:t>Each </a:t>
-            </a:r>
-            <a:r>
-              <a:rPr b="0" i="0">
-                <a:latin typeface="Consolas"/>
-                <a:solidFill>
-                  <a:schemeClr val="dk1"/>
-                </a:solidFill>
-              </a:rPr>
-              <a:t># H1</a:t>
-            </a:r>
-            <a:r>
-              <a:rPr b="0" i="0">
-                <a:latin typeface="+mn-lt"/>
-                <a:ea typeface="+mn-ea"/>
-                <a:cs typeface="+mn-cs"/>
-                <a:solidFill>
-                  <a:schemeClr val="dk1"/>
-                </a:solidFill>
-              </a:rPr>
-              <a:t> starts a new slide, optional slide front matter appears immediately after the H1, and everything until the next H1 becomes that slide's content.</a:t>
-            </a:r>
-            <a:endParaRPr>
-              <a:solidFill>
-                <a:schemeClr val="dk1"/>
-              </a:solidFill>
-            </a:endParaRPr>
-          </a:p>
-        </p:txBody>
-      </p:sp>
-    </p:spTree>
-  </p:cSld>
-  <p:clrMapOvr>
-    <a:masterClrMapping/>
-  </p:clrMapOvr>
-</p:sld>
-</file>
-
-<file path=ppt/slides/slide30.xml><?xml version="1.0" encoding="utf-8"?>
+<file path=ppt/slides/slide33.xml><?xml version="1.0" encoding="utf-8"?>
 <p:sld xmlns:a="http://schemas.openxmlformats.org/drawingml/2006/main" xmlns:p="http://schemas.openxmlformats.org/presentationml/2006/main" xmlns:r="http://schemas.openxmlformats.org/officeDocument/2006/relationships">
   <p:cSld>
     <p:bg>
@@ -8134,12 +9011,12 @@
             </a:pPr>
             <a:r>
               <a:rPr b="0" i="0">
+                <a:solidFill>
+                  <a:schemeClr val="dk1"/>
+                </a:solidFill>
                 <a:latin typeface="+mn-lt"/>
                 <a:ea typeface="+mn-ea"/>
                 <a:cs typeface="+mn-cs"/>
-                <a:solidFill>
-                  <a:schemeClr val="dk1"/>
-                </a:solidFill>
               </a:rPr>
               <a:t>This slide uses a three-stop linear gradient background.</a:t>
             </a:r>
@@ -8159,7 +9036,7 @@
 </p:sld>
 </file>
 
-<file path=ppt/slides/slide31.xml><?xml version="1.0" encoding="utf-8"?>
+<file path=ppt/slides/slide34.xml><?xml version="1.0" encoding="utf-8"?>
 <p:sld xmlns:a="http://schemas.openxmlformats.org/drawingml/2006/main" xmlns:p="http://schemas.openxmlformats.org/presentationml/2006/main" xmlns:r="http://schemas.openxmlformats.org/officeDocument/2006/relationships">
   <p:cSld>
     <p:bg>
@@ -8169,7 +9046,7 @@
             <a:gs pos="0">
               <a:schemeClr val="accent2"/>
             </a:gs>
-            <a:gs pos="57999">
+            <a:gs pos="58000">
               <a:schemeClr val="accent4"/>
             </a:gs>
             <a:gs pos="100000">
@@ -8257,12 +9134,12 @@
             </a:pPr>
             <a:r>
               <a:rPr b="0" i="0">
+                <a:solidFill>
+                  <a:schemeClr val="dk1"/>
+                </a:solidFill>
                 <a:latin typeface="+mn-lt"/>
                 <a:ea typeface="+mn-ea"/>
                 <a:cs typeface="+mn-cs"/>
-                <a:solidFill>
-                  <a:schemeClr val="dk1"/>
-                </a:solidFill>
               </a:rPr>
               <a:t>This slide uses a radial gradient background.</a:t>
             </a:r>
@@ -8282,7 +9159,7 @@
 </p:sld>
 </file>
 
-<file path=ppt/slides/slide32.xml><?xml version="1.0" encoding="utf-8"?>
+<file path=ppt/slides/slide35.xml><?xml version="1.0" encoding="utf-8"?>
 <p:sld xmlns:a="http://schemas.openxmlformats.org/drawingml/2006/main" xmlns:p="http://schemas.openxmlformats.org/presentationml/2006/main" xmlns:r="http://schemas.openxmlformats.org/officeDocument/2006/relationships">
   <p:cSld>
     <p:bg>
@@ -8375,12 +9252,12 @@
             </a:pPr>
             <a:r>
               <a:rPr b="0" i="0">
+                <a:solidFill>
+                  <a:schemeClr val="lt1"/>
+                </a:solidFill>
                 <a:latin typeface="+mn-lt"/>
                 <a:ea typeface="+mn-ea"/>
                 <a:cs typeface="+mn-cs"/>
-                <a:solidFill>
-                  <a:schemeClr val="lt1"/>
-                </a:solidFill>
               </a:rPr>
               <a:t>This slide overrides the document-level title and body colors.</a:t>
             </a:r>
@@ -8400,7 +9277,7 @@
 </p:sld>
 </file>
 
-<file path=ppt/slides/slide33.xml><?xml version="1.0" encoding="utf-8"?>
+<file path=ppt/slides/slide36.xml><?xml version="1.0" encoding="utf-8"?>
 <p:sld xmlns:a="http://schemas.openxmlformats.org/drawingml/2006/main" xmlns:p="http://schemas.openxmlformats.org/presentationml/2006/main" xmlns:r="http://schemas.openxmlformats.org/officeDocument/2006/relationships">
   <p:cSld>
     <p:spTree>
@@ -8418,7 +9295,7 @@
 </p:sld>
 </file>
 
-<file path=ppt/slides/slide34.xml><?xml version="1.0" encoding="utf-8"?>
+<file path=ppt/slides/slide37.xml><?xml version="1.0" encoding="utf-8"?>
 <p:sld xmlns:a="http://schemas.openxmlformats.org/drawingml/2006/main" xmlns:p="http://schemas.openxmlformats.org/presentationml/2006/main" xmlns:r="http://schemas.openxmlformats.org/officeDocument/2006/relationships">
   <p:cSld>
     <p:spTree>
@@ -8495,32 +9372,32 @@
             </a:pPr>
             <a:r>
               <a:rPr b="0" i="0">
+                <a:solidFill>
+                  <a:schemeClr val="dk1"/>
+                </a:solidFill>
                 <a:latin typeface="+mn-lt"/>
                 <a:ea typeface="+mn-ea"/>
                 <a:cs typeface="+mn-cs"/>
-                <a:solidFill>
-                  <a:schemeClr val="dk1"/>
-                </a:solidFill>
               </a:rPr>
               <a:t>Run </a:t>
             </a:r>
             <a:r>
               <a:rPr b="0" i="0">
+                <a:solidFill>
+                  <a:schemeClr val="dk1"/>
+                </a:solidFill>
                 <a:latin typeface="Consolas"/>
-                <a:solidFill>
-                  <a:schemeClr val="dk1"/>
-                </a:solidFill>
               </a:rPr>
               <a:t>uvx markdown-pptx --help</a:t>
             </a:r>
             <a:r>
               <a:rPr b="0" i="0">
+                <a:solidFill>
+                  <a:schemeClr val="dk1"/>
+                </a:solidFill>
                 <a:latin typeface="+mn-lt"/>
                 <a:ea typeface="+mn-ea"/>
                 <a:cs typeface="+mn-cs"/>
-                <a:solidFill>
-                  <a:schemeClr val="dk1"/>
-                </a:solidFill>
               </a:rPr>
               <a:t> to get started.</a:t>
             </a:r>
@@ -8617,52 +9494,52 @@
             </a:pPr>
             <a:r>
               <a:rPr b="0" i="0">
+                <a:solidFill>
+                  <a:schemeClr val="dk1"/>
+                </a:solidFill>
                 <a:latin typeface="+mn-lt"/>
                 <a:ea typeface="+mn-ea"/>
                 <a:cs typeface="+mn-cs"/>
-                <a:solidFill>
-                  <a:schemeClr val="dk1"/>
-                </a:solidFill>
               </a:rPr>
               <a:t>Run </a:t>
             </a:r>
             <a:r>
               <a:rPr b="0" i="0">
+                <a:solidFill>
+                  <a:schemeClr val="dk1"/>
+                </a:solidFill>
                 <a:latin typeface="Consolas"/>
-                <a:solidFill>
-                  <a:schemeClr val="dk1"/>
-                </a:solidFill>
               </a:rPr>
               <a:t>uvx markdown-pptx deck.md</a:t>
             </a:r>
             <a:r>
               <a:rPr b="0" i="0">
+                <a:solidFill>
+                  <a:schemeClr val="dk1"/>
+                </a:solidFill>
                 <a:latin typeface="+mn-lt"/>
                 <a:ea typeface="+mn-ea"/>
                 <a:cs typeface="+mn-cs"/>
-                <a:solidFill>
-                  <a:schemeClr val="dk1"/>
-                </a:solidFill>
               </a:rPr>
               <a:t> to write </a:t>
             </a:r>
             <a:r>
               <a:rPr b="0" i="0">
+                <a:solidFill>
+                  <a:schemeClr val="dk1"/>
+                </a:solidFill>
                 <a:latin typeface="Consolas"/>
-                <a:solidFill>
-                  <a:schemeClr val="dk1"/>
-                </a:solidFill>
               </a:rPr>
               <a:t>deck.pptx</a:t>
             </a:r>
             <a:r>
               <a:rPr b="0" i="0">
+                <a:solidFill>
+                  <a:schemeClr val="dk1"/>
+                </a:solidFill>
                 <a:latin typeface="+mn-lt"/>
                 <a:ea typeface="+mn-ea"/>
                 <a:cs typeface="+mn-cs"/>
-                <a:solidFill>
-                  <a:schemeClr val="dk1"/>
-                </a:solidFill>
               </a:rPr>
               <a:t> next to the source markdown file.</a:t>
             </a:r>
@@ -8683,72 +9560,72 @@
             </a:pPr>
             <a:r>
               <a:rPr b="0" i="0">
+                <a:solidFill>
+                  <a:schemeClr val="dk1"/>
+                </a:solidFill>
                 <a:latin typeface="+mn-lt"/>
                 <a:ea typeface="+mn-ea"/>
                 <a:cs typeface="+mn-cs"/>
-                <a:solidFill>
-                  <a:schemeClr val="dk1"/>
-                </a:solidFill>
               </a:rPr>
               <a:t>Use </a:t>
             </a:r>
             <a:r>
               <a:rPr b="0" i="0">
+                <a:solidFill>
+                  <a:schemeClr val="dk1"/>
+                </a:solidFill>
                 <a:latin typeface="Consolas"/>
-                <a:solidFill>
-                  <a:schemeClr val="dk1"/>
-                </a:solidFill>
               </a:rPr>
               <a:t>uvx markdown-pptx deck.md out.pptx</a:t>
             </a:r>
             <a:r>
               <a:rPr b="0" i="0">
+                <a:solidFill>
+                  <a:schemeClr val="dk1"/>
+                </a:solidFill>
                 <a:latin typeface="+mn-lt"/>
                 <a:ea typeface="+mn-ea"/>
                 <a:cs typeface="+mn-cs"/>
-                <a:solidFill>
-                  <a:schemeClr val="dk1"/>
-                </a:solidFill>
               </a:rPr>
               <a:t> to choose the output path, </a:t>
             </a:r>
             <a:r>
               <a:rPr b="0" i="0">
+                <a:solidFill>
+                  <a:schemeClr val="dk1"/>
+                </a:solidFill>
                 <a:latin typeface="Consolas"/>
-                <a:solidFill>
-                  <a:schemeClr val="dk1"/>
-                </a:solidFill>
               </a:rPr>
               <a:t>--template theme.pptx</a:t>
             </a:r>
             <a:r>
               <a:rPr b="0" i="0">
+                <a:solidFill>
+                  <a:schemeClr val="dk1"/>
+                </a:solidFill>
                 <a:latin typeface="+mn-lt"/>
                 <a:ea typeface="+mn-ea"/>
                 <a:cs typeface="+mn-cs"/>
-                <a:solidFill>
-                  <a:schemeClr val="dk1"/>
-                </a:solidFill>
               </a:rPr>
               <a:t> to render against an existing PowerPoint template, and </a:t>
             </a:r>
             <a:r>
               <a:rPr b="0" i="0">
+                <a:solidFill>
+                  <a:schemeClr val="dk1"/>
+                </a:solidFill>
                 <a:latin typeface="Consolas"/>
-                <a:solidFill>
-                  <a:schemeClr val="dk1"/>
-                </a:solidFill>
               </a:rPr>
               <a:t>--force</a:t>
             </a:r>
             <a:r>
               <a:rPr b="0" i="0">
+                <a:solidFill>
+                  <a:schemeClr val="dk1"/>
+                </a:solidFill>
                 <a:latin typeface="+mn-lt"/>
                 <a:ea typeface="+mn-ea"/>
                 <a:cs typeface="+mn-cs"/>
-                <a:solidFill>
-                  <a:schemeClr val="dk1"/>
-                </a:solidFill>
               </a:rPr>
               <a:t> to overwrite an existing file.</a:t>
             </a:r>
@@ -8769,52 +9646,52 @@
             </a:pPr>
             <a:r>
               <a:rPr b="0" i="0">
+                <a:solidFill>
+                  <a:schemeClr val="dk1"/>
+                </a:solidFill>
                 <a:latin typeface="+mn-lt"/>
                 <a:ea typeface="+mn-ea"/>
                 <a:cs typeface="+mn-cs"/>
-                <a:solidFill>
-                  <a:schemeClr val="dk1"/>
-                </a:solidFill>
               </a:rPr>
               <a:t>Run </a:t>
             </a:r>
             <a:r>
               <a:rPr b="0" i="0">
+                <a:solidFill>
+                  <a:schemeClr val="dk1"/>
+                </a:solidFill>
                 <a:latin typeface="Consolas"/>
-                <a:solidFill>
-                  <a:schemeClr val="dk1"/>
-                </a:solidFill>
               </a:rPr>
               <a:t>uvx markdown-pptx</a:t>
             </a:r>
             <a:r>
               <a:rPr b="0" i="0">
+                <a:solidFill>
+                  <a:schemeClr val="dk1"/>
+                </a:solidFill>
                 <a:latin typeface="+mn-lt"/>
                 <a:ea typeface="+mn-ea"/>
                 <a:cs typeface="+mn-cs"/>
-                <a:solidFill>
-                  <a:schemeClr val="dk1"/>
-                </a:solidFill>
               </a:rPr>
               <a:t> with no arguments for the quick reference or use </a:t>
             </a:r>
             <a:r>
               <a:rPr b="0" i="0">
+                <a:solidFill>
+                  <a:schemeClr val="dk1"/>
+                </a:solidFill>
                 <a:latin typeface="Consolas"/>
-                <a:solidFill>
-                  <a:schemeClr val="dk1"/>
-                </a:solidFill>
               </a:rPr>
               <a:t>--about</a:t>
             </a:r>
             <a:r>
               <a:rPr b="0" i="0">
+                <a:solidFill>
+                  <a:schemeClr val="dk1"/>
+                </a:solidFill>
                 <a:latin typeface="+mn-lt"/>
                 <a:ea typeface="+mn-ea"/>
                 <a:cs typeface="+mn-cs"/>
-                <a:solidFill>
-                  <a:schemeClr val="dk1"/>
-                </a:solidFill>
               </a:rPr>
               <a:t> for project metadata.</a:t>
             </a:r>
@@ -8911,92 +9788,92 @@
             </a:pPr>
             <a:r>
               <a:rPr b="0" i="0">
+                <a:solidFill>
+                  <a:schemeClr val="dk1"/>
+                </a:solidFill>
                 <a:latin typeface="+mn-lt"/>
                 <a:ea typeface="+mn-ea"/>
                 <a:cs typeface="+mn-cs"/>
-                <a:solidFill>
-                  <a:schemeClr val="dk1"/>
-                </a:solidFill>
               </a:rPr>
               <a:t>Use </a:t>
             </a:r>
             <a:r>
               <a:rPr b="0" i="0">
+                <a:solidFill>
+                  <a:schemeClr val="dk1"/>
+                </a:solidFill>
                 <a:latin typeface="Consolas"/>
-                <a:solidFill>
-                  <a:schemeClr val="dk1"/>
-                </a:solidFill>
               </a:rPr>
               <a:t>--syntax</a:t>
             </a:r>
             <a:r>
               <a:rPr b="0" i="0">
+                <a:solidFill>
+                  <a:schemeClr val="dk1"/>
+                </a:solidFill>
                 <a:latin typeface="+mn-lt"/>
                 <a:ea typeface="+mn-ea"/>
                 <a:cs typeface="+mn-cs"/>
-                <a:solidFill>
-                  <a:schemeClr val="dk1"/>
-                </a:solidFill>
               </a:rPr>
               <a:t> to print the supported deck format, </a:t>
             </a:r>
             <a:r>
               <a:rPr b="0" i="0">
+                <a:solidFill>
+                  <a:schemeClr val="dk1"/>
+                </a:solidFill>
                 <a:latin typeface="Consolas"/>
-                <a:solidFill>
-                  <a:schemeClr val="dk1"/>
-                </a:solidFill>
               </a:rPr>
               <a:t>--list-masters</a:t>
             </a:r>
             <a:r>
               <a:rPr b="0" i="0">
+                <a:solidFill>
+                  <a:schemeClr val="dk1"/>
+                </a:solidFill>
                 <a:latin typeface="+mn-lt"/>
                 <a:ea typeface="+mn-ea"/>
                 <a:cs typeface="+mn-cs"/>
-                <a:solidFill>
-                  <a:schemeClr val="dk1"/>
-                </a:solidFill>
               </a:rPr>
               <a:t> to inspect a template's slide masters, </a:t>
             </a:r>
             <a:r>
               <a:rPr b="0" i="0">
+                <a:solidFill>
+                  <a:schemeClr val="dk1"/>
+                </a:solidFill>
                 <a:latin typeface="Consolas"/>
-                <a:solidFill>
-                  <a:schemeClr val="dk1"/>
-                </a:solidFill>
               </a:rPr>
               <a:t>--list-layouts</a:t>
             </a:r>
             <a:r>
               <a:rPr b="0" i="0">
+                <a:solidFill>
+                  <a:schemeClr val="dk1"/>
+                </a:solidFill>
                 <a:latin typeface="+mn-lt"/>
                 <a:ea typeface="+mn-ea"/>
                 <a:cs typeface="+mn-cs"/>
-                <a:solidFill>
-                  <a:schemeClr val="dk1"/>
-                </a:solidFill>
               </a:rPr>
               <a:t> to inspect layouts on a selected master, and </a:t>
             </a:r>
             <a:r>
               <a:rPr b="0" i="0">
+                <a:solidFill>
+                  <a:schemeClr val="dk1"/>
+                </a:solidFill>
                 <a:latin typeface="Consolas"/>
-                <a:solidFill>
-                  <a:schemeClr val="dk1"/>
-                </a:solidFill>
               </a:rPr>
               <a:t>--list-color-schemes</a:t>
             </a:r>
             <a:r>
               <a:rPr b="0" i="0">
+                <a:solidFill>
+                  <a:schemeClr val="dk1"/>
+                </a:solidFill>
                 <a:latin typeface="+mn-lt"/>
                 <a:ea typeface="+mn-ea"/>
                 <a:cs typeface="+mn-cs"/>
-                <a:solidFill>
-                  <a:schemeClr val="dk1"/>
-                </a:solidFill>
               </a:rPr>
               <a:t> to see the built-in theme presets.</a:t>
             </a:r>
@@ -9017,32 +9894,32 @@
             </a:pPr>
             <a:r>
               <a:rPr b="0" i="0">
+                <a:solidFill>
+                  <a:schemeClr val="dk1"/>
+                </a:solidFill>
                 <a:latin typeface="+mn-lt"/>
                 <a:ea typeface="+mn-ea"/>
                 <a:cs typeface="+mn-cs"/>
-                <a:solidFill>
-                  <a:schemeClr val="dk1"/>
-                </a:solidFill>
               </a:rPr>
               <a:t>Add </a:t>
             </a:r>
             <a:r>
               <a:rPr b="0" i="0">
+                <a:solidFill>
+                  <a:schemeClr val="dk1"/>
+                </a:solidFill>
                 <a:latin typeface="Consolas"/>
-                <a:solidFill>
-                  <a:schemeClr val="dk1"/>
-                </a:solidFill>
               </a:rPr>
               <a:t>--json</a:t>
             </a:r>
             <a:r>
               <a:rPr b="0" i="0">
+                <a:solidFill>
+                  <a:schemeClr val="dk1"/>
+                </a:solidFill>
                 <a:latin typeface="+mn-lt"/>
                 <a:ea typeface="+mn-ea"/>
                 <a:cs typeface="+mn-cs"/>
-                <a:solidFill>
-                  <a:schemeClr val="dk1"/>
-                </a:solidFill>
               </a:rPr>
               <a:t> for structured results. Master and layout inspection report names, indices, placeholder inventory, and compatibility so people and coding agents can discover valid inputs before generating a deck.</a:t>
             </a:r>
@@ -9139,32 +10016,32 @@
             </a:pPr>
             <a:r>
               <a:rPr b="0" i="0">
+                <a:solidFill>
+                  <a:schemeClr val="dk1"/>
+                </a:solidFill>
                 <a:latin typeface="+mn-lt"/>
                 <a:ea typeface="+mn-ea"/>
                 <a:cs typeface="+mn-cs"/>
-                <a:solidFill>
-                  <a:schemeClr val="dk1"/>
-                </a:solidFill>
               </a:rPr>
               <a:t>This slide uses the template's </a:t>
             </a:r>
             <a:r>
               <a:rPr b="0" i="0">
+                <a:solidFill>
+                  <a:schemeClr val="dk1"/>
+                </a:solidFill>
                 <a:latin typeface="Consolas"/>
-                <a:solidFill>
-                  <a:schemeClr val="dk1"/>
-                </a:solidFill>
               </a:rPr>
               <a:t>Showcase Alternate</a:t>
             </a:r>
             <a:r>
               <a:rPr b="0" i="0">
+                <a:solidFill>
+                  <a:schemeClr val="dk1"/>
+                </a:solidFill>
                 <a:latin typeface="+mn-lt"/>
                 <a:ea typeface="+mn-ea"/>
                 <a:cs typeface="+mn-cs"/>
-                <a:solidFill>
-                  <a:schemeClr val="dk1"/>
-                </a:solidFill>
               </a:rPr>
               <a:t> master while the rest of the deck defaults to master 1. Templates keep every embedded master in the output.</a:t>
             </a:r>
@@ -9185,12 +10062,12 @@
             </a:pPr>
             <a:r>
               <a:rPr b="0" i="0">
+                <a:solidFill>
+                  <a:schemeClr val="dk1"/>
+                </a:solidFill>
                 <a:latin typeface="+mn-lt"/>
                 <a:ea typeface="+mn-ea"/>
                 <a:cs typeface="+mn-cs"/>
-                <a:solidFill>
-                  <a:schemeClr val="dk1"/>
-                </a:solidFill>
               </a:rPr>
               <a:t>Master selection uses slide metadata first, then the CLI default, then master 1. Layout names are resolved within the selected master.</a:t>
             </a:r>
@@ -9287,72 +10164,72 @@
             </a:pPr>
             <a:r>
               <a:rPr b="0" i="0">
+                <a:solidFill>
+                  <a:schemeClr val="dk1"/>
+                </a:solidFill>
                 <a:latin typeface="+mn-lt"/>
                 <a:ea typeface="+mn-ea"/>
                 <a:cs typeface="+mn-cs"/>
-                <a:solidFill>
-                  <a:schemeClr val="dk1"/>
-                </a:solidFill>
               </a:rPr>
               <a:t>Run </a:t>
             </a:r>
             <a:r>
               <a:rPr b="0" i="0">
+                <a:solidFill>
+                  <a:schemeClr val="dk1"/>
+                </a:solidFill>
                 <a:latin typeface="Consolas"/>
-                <a:solidFill>
-                  <a:schemeClr val="dk1"/>
-                </a:solidFill>
               </a:rPr>
               <a:t>uvx markdown-pptx skill install</a:t>
             </a:r>
             <a:r>
               <a:rPr b="0" i="0">
+                <a:solidFill>
+                  <a:schemeClr val="dk1"/>
+                </a:solidFill>
                 <a:latin typeface="+mn-lt"/>
                 <a:ea typeface="+mn-ea"/>
                 <a:cs typeface="+mn-cs"/>
-                <a:solidFill>
-                  <a:schemeClr val="dk1"/>
-                </a:solidFill>
               </a:rPr>
               <a:t> to install the managed agent skill under </a:t>
             </a:r>
             <a:r>
               <a:rPr b="0" i="0">
+                <a:solidFill>
+                  <a:schemeClr val="dk1"/>
+                </a:solidFill>
                 <a:latin typeface="Consolas"/>
-                <a:solidFill>
-                  <a:schemeClr val="dk1"/>
-                </a:solidFill>
               </a:rPr>
               <a:t>~/.agents/skills</a:t>
             </a:r>
             <a:r>
               <a:rPr b="0" i="0">
+                <a:solidFill>
+                  <a:schemeClr val="dk1"/>
+                </a:solidFill>
                 <a:latin typeface="+mn-lt"/>
                 <a:ea typeface="+mn-ea"/>
                 <a:cs typeface="+mn-cs"/>
-                <a:solidFill>
-                  <a:schemeClr val="dk1"/>
-                </a:solidFill>
               </a:rPr>
               <a:t>, or </a:t>
             </a:r>
             <a:r>
               <a:rPr b="0" i="0">
+                <a:solidFill>
+                  <a:schemeClr val="dk1"/>
+                </a:solidFill>
                 <a:latin typeface="Consolas"/>
-                <a:solidFill>
-                  <a:schemeClr val="dk1"/>
-                </a:solidFill>
               </a:rPr>
               <a:t>uvx markdown-pptx skill remove</a:t>
             </a:r>
             <a:r>
               <a:rPr b="0" i="0">
+                <a:solidFill>
+                  <a:schemeClr val="dk1"/>
+                </a:solidFill>
                 <a:latin typeface="+mn-lt"/>
                 <a:ea typeface="+mn-ea"/>
                 <a:cs typeface="+mn-cs"/>
-                <a:solidFill>
-                  <a:schemeClr val="dk1"/>
-                </a:solidFill>
               </a:rPr>
               <a:t> to remove it safely.</a:t>
             </a:r>
@@ -9373,12 +10250,12 @@
             </a:pPr>
             <a:r>
               <a:rPr b="0" i="0">
+                <a:solidFill>
+                  <a:schemeClr val="dk1"/>
+                </a:solidFill>
                 <a:latin typeface="+mn-lt"/>
                 <a:ea typeface="+mn-ea"/>
                 <a:cs typeface="+mn-cs"/>
-                <a:solidFill>
-                  <a:schemeClr val="dk1"/>
-                </a:solidFill>
               </a:rPr>
               <a:t>The skill teaches agents to inspect syntax, masters, and layouts; prefer structured output; respect overwrite safety; and handle local or remote images predictably.</a:t>
             </a:r>
@@ -9475,72 +10352,72 @@
             </a:pPr>
             <a:r>
               <a:rPr b="0" i="0">
+                <a:solidFill>
+                  <a:schemeClr val="dk1"/>
+                </a:solidFill>
                 <a:latin typeface="+mn-lt"/>
                 <a:ea typeface="+mn-ea"/>
                 <a:cs typeface="+mn-cs"/>
-                <a:solidFill>
-                  <a:schemeClr val="dk1"/>
-                </a:solidFill>
               </a:rPr>
               <a:t>Markdown can set document-level and slide-level colors with </a:t>
             </a:r>
             <a:r>
               <a:rPr b="0" i="0">
+                <a:solidFill>
+                  <a:schemeClr val="dk1"/>
+                </a:solidFill>
                 <a:latin typeface="Consolas"/>
-                <a:solidFill>
-                  <a:schemeClr val="dk1"/>
-                </a:solidFill>
               </a:rPr>
               <a:t>color_scheme</a:t>
             </a:r>
             <a:r>
               <a:rPr b="0" i="0">
+                <a:solidFill>
+                  <a:schemeClr val="dk1"/>
+                </a:solidFill>
                 <a:latin typeface="+mn-lt"/>
                 <a:ea typeface="+mn-ea"/>
                 <a:cs typeface="+mn-cs"/>
-                <a:solidFill>
-                  <a:schemeClr val="dk1"/>
-                </a:solidFill>
               </a:rPr>
               <a:t>, </a:t>
             </a:r>
             <a:r>
               <a:rPr b="0" i="0">
+                <a:solidFill>
+                  <a:schemeClr val="dk1"/>
+                </a:solidFill>
                 <a:latin typeface="Consolas"/>
-                <a:solidFill>
-                  <a:schemeClr val="dk1"/>
-                </a:solidFill>
               </a:rPr>
               <a:t>title_color</a:t>
             </a:r>
             <a:r>
               <a:rPr b="0" i="0">
+                <a:solidFill>
+                  <a:schemeClr val="dk1"/>
+                </a:solidFill>
                 <a:latin typeface="+mn-lt"/>
                 <a:ea typeface="+mn-ea"/>
                 <a:cs typeface="+mn-cs"/>
-                <a:solidFill>
-                  <a:schemeClr val="dk1"/>
-                </a:solidFill>
               </a:rPr>
               <a:t>, </a:t>
             </a:r>
             <a:r>
               <a:rPr b="0" i="0">
+                <a:solidFill>
+                  <a:schemeClr val="dk1"/>
+                </a:solidFill>
                 <a:latin typeface="Consolas"/>
-                <a:solidFill>
-                  <a:schemeClr val="dk1"/>
-                </a:solidFill>
               </a:rPr>
               <a:t>body_color</a:t>
             </a:r>
             <a:r>
               <a:rPr b="0" i="0">
+                <a:solidFill>
+                  <a:schemeClr val="dk1"/>
+                </a:solidFill>
                 <a:latin typeface="+mn-lt"/>
                 <a:ea typeface="+mn-ea"/>
                 <a:cs typeface="+mn-cs"/>
-                <a:solidFill>
-                  <a:schemeClr val="dk1"/>
-                </a:solidFill>
               </a:rPr>
               <a:t>, and background values such as solid colors, gradients, and images.</a:t>
             </a:r>
@@ -9561,52 +10438,52 @@
             </a:pPr>
             <a:r>
               <a:rPr b="0" i="0">
+                <a:solidFill>
+                  <a:schemeClr val="dk1"/>
+                </a:solidFill>
                 <a:latin typeface="+mn-lt"/>
                 <a:ea typeface="+mn-ea"/>
                 <a:cs typeface="+mn-cs"/>
-                <a:solidFill>
-                  <a:schemeClr val="dk1"/>
-                </a:solidFill>
               </a:rPr>
               <a:t>When a template already has the colors you want, </a:t>
             </a:r>
             <a:r>
               <a:rPr b="0" i="0">
+                <a:solidFill>
+                  <a:schemeClr val="dk1"/>
+                </a:solidFill>
                 <a:latin typeface="Consolas"/>
-                <a:solidFill>
-                  <a:schemeClr val="dk1"/>
-                </a:solidFill>
               </a:rPr>
               <a:t>--ignore-document-colors</a:t>
             </a:r>
             <a:r>
               <a:rPr b="0" i="0">
+                <a:solidFill>
+                  <a:schemeClr val="dk1"/>
+                </a:solidFill>
                 <a:latin typeface="+mn-lt"/>
                 <a:ea typeface="+mn-ea"/>
                 <a:cs typeface="+mn-cs"/>
-                <a:solidFill>
-                  <a:schemeClr val="dk1"/>
-                </a:solidFill>
               </a:rPr>
               <a:t> and </a:t>
             </a:r>
             <a:r>
               <a:rPr b="0" i="0">
+                <a:solidFill>
+                  <a:schemeClr val="dk1"/>
+                </a:solidFill>
                 <a:latin typeface="Consolas"/>
-                <a:solidFill>
-                  <a:schemeClr val="dk1"/>
-                </a:solidFill>
               </a:rPr>
               <a:t>--ignore-slide-colors</a:t>
             </a:r>
             <a:r>
               <a:rPr b="0" i="0">
+                <a:solidFill>
+                  <a:schemeClr val="dk1"/>
+                </a:solidFill>
                 <a:latin typeface="+mn-lt"/>
                 <a:ea typeface="+mn-ea"/>
                 <a:cs typeface="+mn-cs"/>
-                <a:solidFill>
-                  <a:schemeClr val="dk1"/>
-                </a:solidFill>
               </a:rPr>
               <a:t> let the template remain the source of truth for those color settings.</a:t>
             </a:r>

</xml_diff>

<commit_message>
Regenerate showcase with two-content examples
</commit_message>
<xml_diff>
--- a/sample/showcase.pptx
+++ b/sample/showcase.pptx
@@ -46,6 +46,8 @@
     <p:sldId xmlns:ns0="http://schemas.openxmlformats.org/officeDocument/2006/relationships" id="290" ns0:id="rId42"/>
     <p:sldId xmlns:ns0="http://schemas.openxmlformats.org/officeDocument/2006/relationships" id="291" ns0:id="rId43"/>
     <p:sldId xmlns:ns0="http://schemas.openxmlformats.org/officeDocument/2006/relationships" id="292" ns0:id="rId44"/>
+    <p:sldId xmlns:ns0="http://schemas.openxmlformats.org/officeDocument/2006/relationships" id="293" ns0:id="rId45"/>
+    <p:sldId xmlns:ns0="http://schemas.openxmlformats.org/officeDocument/2006/relationships" id="294" ns0:id="rId46"/>
   </p:sldIdLst>
   <p:sldSz cx="12192000" cy="6858000"/>
   <p:notesSz cx="6858000" cy="9144000"/>
@@ -750,6 +752,76 @@
           <a:p>
             <a:r>
               <a:t>This slide intentionally demonstrates the Blank layout.</a:t>
+            </a:r>
+          </a:p>
+        </p:txBody>
+      </p:sp>
+      <p:sp>
+        <p:nvSpPr>
+          <p:cNvPr id="4" name="Slide Number Placeholder 3"/>
+          <p:cNvSpPr>
+            <a:spLocks noGrp="1"/>
+          </p:cNvSpPr>
+          <p:nvPr>
+            <p:ph type="sldNum" idx="5" sz="quarter"/>
+          </p:nvPr>
+        </p:nvSpPr>
+        <p:spPr/>
+      </p:sp>
+    </p:spTree>
+  </p:cSld>
+  <p:clrMapOvr>
+    <a:masterClrMapping/>
+  </p:clrMapOvr>
+</p:notes>
+</file>
+
+<file path=ppt/notesSlides/notesSlide5.xml><?xml version="1.0" encoding="utf-8"?>
+<p:notes xmlns:a="http://schemas.openxmlformats.org/drawingml/2006/main" xmlns:p="http://schemas.openxmlformats.org/presentationml/2006/main" xmlns:r="http://schemas.openxmlformats.org/officeDocument/2006/relationships">
+  <p:cSld>
+    <p:spTree>
+      <p:nvGrpSpPr>
+        <p:cNvPr id="1" name=""/>
+        <p:cNvGrpSpPr/>
+        <p:nvPr/>
+      </p:nvGrpSpPr>
+      <p:grpSpPr>
+        <a:xfrm>
+          <a:off x="0" y="0"/>
+          <a:ext cx="0" cy="0"/>
+          <a:chOff x="0" y="0"/>
+          <a:chExt cx="0" cy="0"/>
+        </a:xfrm>
+      </p:grpSpPr>
+      <p:sp>
+        <p:nvSpPr>
+          <p:cNvPr id="2" name="Slide Image Placeholder 1"/>
+          <p:cNvSpPr>
+            <a:spLocks noGrp="1"/>
+          </p:cNvSpPr>
+          <p:nvPr>
+            <p:ph type="sldImg" idx="2"/>
+          </p:nvPr>
+        </p:nvSpPr>
+        <p:spPr/>
+      </p:sp>
+      <p:sp>
+        <p:nvSpPr>
+          <p:cNvPr id="3" name="Notes Placeholder 2"/>
+          <p:cNvSpPr>
+            <a:spLocks noGrp="1"/>
+          </p:cNvSpPr>
+          <p:nvPr>
+            <p:ph type="body" idx="3" sz="quarter"/>
+          </p:nvPr>
+        </p:nvSpPr>
+        <p:spPr/>
+        <p:txBody>
+          <a:bodyPr/>
+          <a:lstStyle/>
+          <a:p>
+            <a:r>
+              <a:t>A single top-level thematic break separates the left and right placeholders.</a:t>
             </a:r>
           </a:p>
         </p:txBody>
@@ -9312,6 +9384,579 @@
             <a:spLocks noGrp="1"/>
           </p:cNvSpPr>
           <p:nvPr>
+            <p:ph type="title"/>
+          </p:nvPr>
+        </p:nvSpPr>
+        <p:spPr/>
+        <p:txBody>
+          <a:bodyPr>
+            <a:normAutofit/>
+          </a:bodyPr>
+          <a:lstStyle/>
+          <a:p>
+            <a:pPr>
+              <a:defRPr>
+                <a:solidFill>
+                  <a:schemeClr val="accent6"/>
+                </a:solidFill>
+              </a:defRPr>
+            </a:pPr>
+            <a:r>
+              <a:rPr>
+                <a:solidFill>
+                  <a:schemeClr val="accent6"/>
+                </a:solidFill>
+              </a:rPr>
+              <a:t>Two content areas</a:t>
+            </a:r>
+            <a:endParaRPr>
+              <a:solidFill>
+                <a:schemeClr val="accent6"/>
+              </a:solidFill>
+            </a:endParaRPr>
+          </a:p>
+        </p:txBody>
+      </p:sp>
+      <p:sp>
+        <p:nvSpPr>
+          <p:cNvPr id="3" name="Content Placeholder 2"/>
+          <p:cNvSpPr>
+            <a:spLocks noGrp="1"/>
+          </p:cNvSpPr>
+          <p:nvPr>
+            <p:ph idx="1"/>
+          </p:nvPr>
+        </p:nvSpPr>
+        <p:spPr/>
+        <p:txBody>
+          <a:bodyPr wrap="square">
+            <a:normAutofit/>
+          </a:bodyPr>
+          <a:lstStyle/>
+          <a:p>
+            <a:pPr marL="0" indent="0">
+              <a:buNone/>
+              <a:defRPr>
+                <a:solidFill>
+                  <a:schemeClr val="dk1"/>
+                </a:solidFill>
+              </a:defRPr>
+            </a:pPr>
+            <a:r>
+              <a:rPr sz="3700" b="1" i="0">
+                <a:solidFill>
+                  <a:schemeClr val="dk1"/>
+                </a:solidFill>
+                <a:latin typeface="+mj-lt"/>
+                <a:ea typeface="+mj-ea"/>
+                <a:cs typeface="+mj-cs"/>
+              </a:rPr>
+              <a:t>First option</a:t>
+            </a:r>
+            <a:endParaRPr>
+              <a:solidFill>
+                <a:schemeClr val="dk1"/>
+              </a:solidFill>
+            </a:endParaRPr>
+          </a:p>
+          <a:p>
+            <a:pPr marL="411480" indent="-201168">
+              <a:defRPr>
+                <a:solidFill>
+                  <a:schemeClr val="dk1"/>
+                </a:solidFill>
+              </a:defRPr>
+            </a:pPr>
+            <a:r>
+              <a:rPr b="0" i="0">
+                <a:solidFill>
+                  <a:schemeClr val="dk1"/>
+                </a:solidFill>
+                <a:latin typeface="+mn-lt"/>
+                <a:ea typeface="+mn-ea"/>
+                <a:cs typeface="+mn-cs"/>
+              </a:rPr>
+              <a:t>Small initial scope</a:t>
+            </a:r>
+            <a:endParaRPr>
+              <a:solidFill>
+                <a:schemeClr val="dk1"/>
+              </a:solidFill>
+            </a:endParaRPr>
+          </a:p>
+          <a:p>
+            <a:pPr marL="411480" indent="-201168">
+              <a:defRPr>
+                <a:solidFill>
+                  <a:schemeClr val="dk1"/>
+                </a:solidFill>
+              </a:defRPr>
+            </a:pPr>
+            <a:r>
+              <a:rPr b="0" i="0">
+                <a:solidFill>
+                  <a:schemeClr val="dk1"/>
+                </a:solidFill>
+                <a:latin typeface="+mn-lt"/>
+                <a:ea typeface="+mn-ea"/>
+                <a:cs typeface="+mn-cs"/>
+              </a:rPr>
+              <a:t>Quick feedback</a:t>
+            </a:r>
+            <a:endParaRPr>
+              <a:solidFill>
+                <a:schemeClr val="dk1"/>
+              </a:solidFill>
+            </a:endParaRPr>
+          </a:p>
+        </p:txBody>
+      </p:sp>
+      <p:sp>
+        <p:nvSpPr>
+          <p:cNvPr id="4" name="Content Placeholder 3"/>
+          <p:cNvSpPr>
+            <a:spLocks noGrp="1"/>
+          </p:cNvSpPr>
+          <p:nvPr>
+            <p:ph idx="2"/>
+          </p:nvPr>
+        </p:nvSpPr>
+        <p:spPr/>
+        <p:txBody>
+          <a:bodyPr wrap="square">
+            <a:normAutofit/>
+          </a:bodyPr>
+          <a:lstStyle/>
+          <a:p>
+            <a:pPr marL="0" indent="0">
+              <a:buNone/>
+              <a:defRPr>
+                <a:solidFill>
+                  <a:schemeClr val="dk1"/>
+                </a:solidFill>
+              </a:defRPr>
+            </a:pPr>
+            <a:r>
+              <a:rPr sz="3700" b="1" i="0">
+                <a:solidFill>
+                  <a:schemeClr val="dk1"/>
+                </a:solidFill>
+                <a:latin typeface="+mj-lt"/>
+                <a:ea typeface="+mj-ea"/>
+                <a:cs typeface="+mj-cs"/>
+              </a:rPr>
+              <a:t>Second option</a:t>
+            </a:r>
+            <a:endParaRPr>
+              <a:solidFill>
+                <a:schemeClr val="dk1"/>
+              </a:solidFill>
+            </a:endParaRPr>
+          </a:p>
+          <a:p>
+            <a:pPr marL="411480" indent="-201168">
+              <a:defRPr>
+                <a:solidFill>
+                  <a:schemeClr val="dk1"/>
+                </a:solidFill>
+              </a:defRPr>
+            </a:pPr>
+            <a:r>
+              <a:rPr b="0" i="0">
+                <a:solidFill>
+                  <a:schemeClr val="dk1"/>
+                </a:solidFill>
+                <a:latin typeface="+mn-lt"/>
+                <a:ea typeface="+mn-ea"/>
+                <a:cs typeface="+mn-cs"/>
+              </a:rPr>
+              <a:t>Broader initial scope</a:t>
+            </a:r>
+            <a:endParaRPr>
+              <a:solidFill>
+                <a:schemeClr val="dk1"/>
+              </a:solidFill>
+            </a:endParaRPr>
+          </a:p>
+          <a:p>
+            <a:pPr marL="411480" indent="-201168">
+              <a:defRPr>
+                <a:solidFill>
+                  <a:schemeClr val="dk1"/>
+                </a:solidFill>
+              </a:defRPr>
+            </a:pPr>
+            <a:r>
+              <a:rPr b="0" i="0">
+                <a:solidFill>
+                  <a:schemeClr val="dk1"/>
+                </a:solidFill>
+                <a:latin typeface="+mn-lt"/>
+                <a:ea typeface="+mn-ea"/>
+                <a:cs typeface="+mn-cs"/>
+              </a:rPr>
+              <a:t>More preparation</a:t>
+            </a:r>
+            <a:endParaRPr>
+              <a:solidFill>
+                <a:schemeClr val="dk1"/>
+              </a:solidFill>
+            </a:endParaRPr>
+          </a:p>
+        </p:txBody>
+      </p:sp>
+    </p:spTree>
+  </p:cSld>
+  <p:clrMapOvr>
+    <a:masterClrMapping/>
+  </p:clrMapOvr>
+</p:sld>
+</file>
+
+<file path=ppt/slides/slide38.xml><?xml version="1.0" encoding="utf-8"?>
+<p:sld xmlns:a="http://schemas.openxmlformats.org/drawingml/2006/main" xmlns:p="http://schemas.openxmlformats.org/presentationml/2006/main" xmlns:r="http://schemas.openxmlformats.org/officeDocument/2006/relationships">
+  <p:cSld>
+    <p:spTree>
+      <p:nvGrpSpPr>
+        <p:cNvPr id="1" name=""/>
+        <p:cNvGrpSpPr/>
+        <p:nvPr/>
+      </p:nvGrpSpPr>
+      <p:grpSpPr/>
+      <p:sp>
+        <p:nvSpPr>
+          <p:cNvPr id="2" name="Title 1"/>
+          <p:cNvSpPr>
+            <a:spLocks noGrp="1"/>
+          </p:cNvSpPr>
+          <p:nvPr>
+            <p:ph type="title"/>
+          </p:nvPr>
+        </p:nvSpPr>
+        <p:spPr/>
+        <p:txBody>
+          <a:bodyPr>
+            <a:normAutofit/>
+          </a:bodyPr>
+          <a:lstStyle/>
+          <a:p>
+            <a:pPr>
+              <a:defRPr>
+                <a:solidFill>
+                  <a:schemeClr val="accent6"/>
+                </a:solidFill>
+              </a:defRPr>
+            </a:pPr>
+            <a:r>
+              <a:rPr>
+                <a:solidFill>
+                  <a:schemeClr val="accent6"/>
+                </a:solidFill>
+              </a:rPr>
+              <a:t>Text beside a table</a:t>
+            </a:r>
+            <a:endParaRPr>
+              <a:solidFill>
+                <a:schemeClr val="accent6"/>
+              </a:solidFill>
+            </a:endParaRPr>
+          </a:p>
+        </p:txBody>
+      </p:sp>
+      <p:sp>
+        <p:nvSpPr>
+          <p:cNvPr id="3" name="Content Placeholder 2"/>
+          <p:cNvSpPr>
+            <a:spLocks noGrp="1"/>
+          </p:cNvSpPr>
+          <p:nvPr>
+            <p:ph idx="1"/>
+          </p:nvPr>
+        </p:nvSpPr>
+        <p:spPr/>
+        <p:txBody>
+          <a:bodyPr wrap="square">
+            <a:normAutofit/>
+          </a:bodyPr>
+          <a:lstStyle/>
+          <a:p>
+            <a:pPr marL="0" indent="0">
+              <a:buNone/>
+              <a:defRPr>
+                <a:solidFill>
+                  <a:schemeClr val="dk1"/>
+                </a:solidFill>
+              </a:defRPr>
+            </a:pPr>
+            <a:r>
+              <a:rPr sz="3700" b="1" i="0">
+                <a:solidFill>
+                  <a:schemeClr val="dk1"/>
+                </a:solidFill>
+                <a:latin typeface="+mj-lt"/>
+                <a:ea typeface="+mj-ea"/>
+                <a:cs typeface="+mj-cs"/>
+              </a:rPr>
+              <a:t>Progress</a:t>
+            </a:r>
+            <a:endParaRPr>
+              <a:solidFill>
+                <a:schemeClr val="dk1"/>
+              </a:solidFill>
+            </a:endParaRPr>
+          </a:p>
+          <a:p>
+            <a:pPr marL="0" indent="0">
+              <a:buNone/>
+              <a:defRPr>
+                <a:solidFill>
+                  <a:schemeClr val="dk1"/>
+                </a:solidFill>
+              </a:defRPr>
+            </a:pPr>
+            <a:r>
+              <a:rPr b="0" i="0">
+                <a:solidFill>
+                  <a:schemeClr val="dk1"/>
+                </a:solidFill>
+                <a:latin typeface="+mn-lt"/>
+                <a:ea typeface="+mn-ea"/>
+                <a:cs typeface="+mn-cs"/>
+              </a:rPr>
+              <a:t>☑ </a:t>
+            </a:r>
+            <a:r>
+              <a:rPr b="0" i="0">
+                <a:solidFill>
+                  <a:schemeClr val="dk1"/>
+                </a:solidFill>
+                <a:latin typeface="+mn-lt"/>
+                <a:ea typeface="+mn-ea"/>
+                <a:cs typeface="+mn-cs"/>
+              </a:rPr>
+              <a:t>Design agreed</a:t>
+            </a:r>
+            <a:endParaRPr>
+              <a:solidFill>
+                <a:schemeClr val="dk1"/>
+              </a:solidFill>
+            </a:endParaRPr>
+          </a:p>
+          <a:p>
+            <a:pPr marL="0" indent="0">
+              <a:buNone/>
+              <a:defRPr>
+                <a:solidFill>
+                  <a:schemeClr val="dk1"/>
+                </a:solidFill>
+              </a:defRPr>
+            </a:pPr>
+            <a:r>
+              <a:rPr b="0" i="0">
+                <a:solidFill>
+                  <a:schemeClr val="dk1"/>
+                </a:solidFill>
+                <a:latin typeface="+mn-lt"/>
+                <a:ea typeface="+mn-ea"/>
+                <a:cs typeface="+mn-cs"/>
+              </a:rPr>
+              <a:t>☐ </a:t>
+            </a:r>
+            <a:r>
+              <a:rPr b="0" i="0">
+                <a:solidFill>
+                  <a:schemeClr val="dk1"/>
+                </a:solidFill>
+                <a:latin typeface="+mn-lt"/>
+                <a:ea typeface="+mn-ea"/>
+                <a:cs typeface="+mn-cs"/>
+              </a:rPr>
+              <a:t>Delivery scheduled</a:t>
+            </a:r>
+            <a:endParaRPr>
+              <a:solidFill>
+                <a:schemeClr val="dk1"/>
+              </a:solidFill>
+            </a:endParaRPr>
+          </a:p>
+        </p:txBody>
+      </p:sp>
+      <p:sp>
+        <p:nvSpPr>
+          <p:cNvPr id="4" name="Content Placeholder 3"/>
+          <p:cNvSpPr>
+            <a:spLocks noGrp="1"/>
+          </p:cNvSpPr>
+          <p:nvPr>
+            <p:ph idx="2"/>
+          </p:nvPr>
+        </p:nvSpPr>
+        <p:spPr/>
+        <p:txBody>
+          <a:bodyPr/>
+          <a:lstStyle/>
+          <a:p/>
+        </p:txBody>
+      </p:sp>
+      <p:graphicFrame>
+        <p:nvGraphicFramePr>
+          <p:cNvPr id="5" name="MarkdownSlidesTable"/>
+          <p:cNvGraphicFramePr>
+            <a:graphicFrameLocks noGrp="1"/>
+          </p:cNvGraphicFramePr>
+          <p:nvPr/>
+        </p:nvGraphicFramePr>
+        <p:xfrm>
+          <a:off x="6172200" y="1825625"/>
+          <a:ext cx="5181600" cy="4351338"/>
+        </p:xfrm>
+        <a:graphic>
+          <a:graphicData uri="http://schemas.openxmlformats.org/drawingml/2006/table">
+            <a:tbl>
+              <a:tblPr firstRow="1" bandRow="1" firstCol="1">
+                <a:tableStyleId>{B301B821-A1FF-4177-AEE7-76D212191A09}</a:tableStyleId>
+              </a:tblPr>
+              <a:tblGrid>
+                <a:gridCol w="2590800"/>
+                <a:gridCol w="2590800"/>
+              </a:tblGrid>
+              <a:tr h="1450446">
+                <a:tc>
+                  <a:txBody>
+                    <a:bodyPr/>
+                    <a:lstStyle/>
+                    <a:p>
+                      <a:r>
+                        <a:rPr>
+                          <a:latin typeface="+mn-lt"/>
+                          <a:ea typeface="+mn-ea"/>
+                          <a:cs typeface="+mn-cs"/>
+                        </a:rPr>
+                        <a:t>Milestone</a:t>
+                      </a:r>
+                    </a:p>
+                  </a:txBody>
+                  <a:tcPr/>
+                </a:tc>
+                <a:tc>
+                  <a:txBody>
+                    <a:bodyPr/>
+                    <a:lstStyle/>
+                    <a:p>
+                      <a:r>
+                        <a:rPr>
+                          <a:latin typeface="+mn-lt"/>
+                          <a:ea typeface="+mn-ea"/>
+                          <a:cs typeface="+mn-cs"/>
+                        </a:rPr>
+                        <a:t>Status</a:t>
+                      </a:r>
+                    </a:p>
+                  </a:txBody>
+                  <a:tcPr/>
+                </a:tc>
+              </a:tr>
+              <a:tr h="1450446">
+                <a:tc>
+                  <a:txBody>
+                    <a:bodyPr/>
+                    <a:lstStyle/>
+                    <a:p>
+                      <a:r>
+                        <a:rPr>
+                          <a:latin typeface="+mn-lt"/>
+                          <a:ea typeface="+mn-ea"/>
+                          <a:cs typeface="+mn-cs"/>
+                        </a:rPr>
+                        <a:t>Design</a:t>
+                      </a:r>
+                    </a:p>
+                  </a:txBody>
+                  <a:tcPr/>
+                </a:tc>
+                <a:tc>
+                  <a:txBody>
+                    <a:bodyPr/>
+                    <a:lstStyle/>
+                    <a:p>
+                      <a:r>
+                        <a:rPr>
+                          <a:latin typeface="+mn-lt"/>
+                          <a:ea typeface="+mn-ea"/>
+                          <a:cs typeface="+mn-cs"/>
+                        </a:rPr>
+                        <a:t>Complete</a:t>
+                      </a:r>
+                    </a:p>
+                  </a:txBody>
+                  <a:tcPr/>
+                </a:tc>
+              </a:tr>
+              <a:tr h="1450446">
+                <a:tc>
+                  <a:txBody>
+                    <a:bodyPr/>
+                    <a:lstStyle/>
+                    <a:p>
+                      <a:r>
+                        <a:rPr>
+                          <a:latin typeface="+mn-lt"/>
+                          <a:ea typeface="+mn-ea"/>
+                          <a:cs typeface="+mn-cs"/>
+                        </a:rPr>
+                        <a:t>Delivery</a:t>
+                      </a:r>
+                    </a:p>
+                  </a:txBody>
+                  <a:tcPr/>
+                </a:tc>
+                <a:tc>
+                  <a:txBody>
+                    <a:bodyPr/>
+                    <a:lstStyle/>
+                    <a:p>
+                      <a:r>
+                        <a:rPr>
+                          <a:latin typeface="+mn-lt"/>
+                          <a:ea typeface="+mn-ea"/>
+                          <a:cs typeface="+mn-cs"/>
+                        </a:rPr>
+                        <a:t>Planned</a:t>
+                      </a:r>
+                    </a:p>
+                  </a:txBody>
+                  <a:tcPr/>
+                </a:tc>
+              </a:tr>
+            </a:tbl>
+          </a:graphicData>
+        </a:graphic>
+      </p:graphicFrame>
+    </p:spTree>
+  </p:cSld>
+  <p:clrMapOvr>
+    <a:masterClrMapping/>
+  </p:clrMapOvr>
+</p:sld>
+</file>
+
+<file path=ppt/slides/slide39.xml><?xml version="1.0" encoding="utf-8"?>
+<p:sld xmlns:a="http://schemas.openxmlformats.org/drawingml/2006/main" xmlns:p="http://schemas.openxmlformats.org/presentationml/2006/main" xmlns:r="http://schemas.openxmlformats.org/officeDocument/2006/relationships">
+  <p:cSld>
+    <p:spTree>
+      <p:nvGrpSpPr>
+        <p:cNvPr id="1" name=""/>
+        <p:cNvGrpSpPr/>
+        <p:nvPr/>
+      </p:nvGrpSpPr>
+      <p:grpSpPr/>
+      <p:sp>
+        <p:nvSpPr>
+          <p:cNvPr id="2" name="Title 1"/>
+          <p:cNvSpPr>
+            <a:spLocks noGrp="1"/>
+          </p:cNvSpPr>
+          <p:nvPr>
             <p:ph type="ctrTitle"/>
           </p:nvPr>
         </p:nvSpPr>

</xml_diff>

<commit_message>
Show syntax highlighting for Python TypeScript HTML and CSS
</commit_message>
<xml_diff>
--- a/sample/showcase.pptx
+++ b/sample/showcase.pptx
@@ -48,6 +48,10 @@
     <p:sldId xmlns:ns0="http://schemas.openxmlformats.org/officeDocument/2006/relationships" id="292" ns0:id="rId44"/>
     <p:sldId xmlns:ns0="http://schemas.openxmlformats.org/officeDocument/2006/relationships" id="293" ns0:id="rId45"/>
     <p:sldId xmlns:ns0="http://schemas.openxmlformats.org/officeDocument/2006/relationships" id="294" ns0:id="rId46"/>
+    <p:sldId xmlns:ns0="http://schemas.openxmlformats.org/officeDocument/2006/relationships" id="295" ns0:id="rId47"/>
+    <p:sldId xmlns:ns0="http://schemas.openxmlformats.org/officeDocument/2006/relationships" id="296" ns0:id="rId48"/>
+    <p:sldId xmlns:ns0="http://schemas.openxmlformats.org/officeDocument/2006/relationships" id="297" ns0:id="rId49"/>
+    <p:sldId xmlns:ns0="http://schemas.openxmlformats.org/officeDocument/2006/relationships" id="298" ns0:id="rId50"/>
   </p:sldIdLst>
   <p:sldSz cx="12192000" cy="6858000"/>
   <p:notesSz cx="6858000" cy="9144000"/>
@@ -601,17 +605,7 @@
           <a:lstStyle/>
           <a:p>
             <a:r>
-              <a:t>This slide demonstrates downloading a remote image during rendering.</a:t>
-            </a:r>
-          </a:p>
-          <a:p>
-            <a:r>
-              <a:t>[Sources]</a:t>
-            </a:r>
-          </a:p>
-          <a:p>
-            <a:r>
-              <a:t>- https://raw.githubusercontent.com/github/explore/main/topics/python/python.png (Python logo)</a:t>
+              <a:t>Language labels select syntax coloring. The highlighted code remains editable PowerPoint text.</a:t>
             </a:r>
           </a:p>
         </p:txBody>
@@ -681,7 +675,7 @@
           <a:lstStyle/>
           <a:p>
             <a:r>
-              <a:t>This slide demonstrates a full-slide background image on the Blank layout.</a:t>
+              <a:t>TypeScript highlights type declarations, keywords, strings, and numeric values.</a:t>
             </a:r>
           </a:p>
         </p:txBody>
@@ -751,7 +745,7 @@
           <a:lstStyle/>
           <a:p>
             <a:r>
-              <a:t>This slide intentionally demonstrates the Blank layout.</a:t>
+              <a:t>HTML highlights tags, attribute names, quoted values, and comments.</a:t>
             </a:r>
           </a:p>
         </p:txBody>
@@ -777,6 +771,296 @@
 </file>
 
 <file path=ppt/notesSlides/notesSlide5.xml><?xml version="1.0" encoding="utf-8"?>
+<p:notes xmlns:a="http://schemas.openxmlformats.org/drawingml/2006/main" xmlns:p="http://schemas.openxmlformats.org/presentationml/2006/main" xmlns:r="http://schemas.openxmlformats.org/officeDocument/2006/relationships">
+  <p:cSld>
+    <p:spTree>
+      <p:nvGrpSpPr>
+        <p:cNvPr id="1" name=""/>
+        <p:cNvGrpSpPr/>
+        <p:nvPr/>
+      </p:nvGrpSpPr>
+      <p:grpSpPr>
+        <a:xfrm>
+          <a:off x="0" y="0"/>
+          <a:ext cx="0" cy="0"/>
+          <a:chOff x="0" y="0"/>
+          <a:chExt cx="0" cy="0"/>
+        </a:xfrm>
+      </p:grpSpPr>
+      <p:sp>
+        <p:nvSpPr>
+          <p:cNvPr id="2" name="Slide Image Placeholder 1"/>
+          <p:cNvSpPr>
+            <a:spLocks noGrp="1"/>
+          </p:cNvSpPr>
+          <p:nvPr>
+            <p:ph type="sldImg" idx="2"/>
+          </p:nvPr>
+        </p:nvSpPr>
+        <p:spPr/>
+      </p:sp>
+      <p:sp>
+        <p:nvSpPr>
+          <p:cNvPr id="3" name="Notes Placeholder 2"/>
+          <p:cNvSpPr>
+            <a:spLocks noGrp="1"/>
+          </p:cNvSpPr>
+          <p:nvPr>
+            <p:ph type="body" idx="3" sz="quarter"/>
+          </p:nvPr>
+        </p:nvSpPr>
+        <p:spPr/>
+        <p:txBody>
+          <a:bodyPr/>
+          <a:lstStyle/>
+          <a:p>
+            <a:r>
+              <a:t>CSS highlights selectors, property names, color values, and units.</a:t>
+            </a:r>
+          </a:p>
+        </p:txBody>
+      </p:sp>
+      <p:sp>
+        <p:nvSpPr>
+          <p:cNvPr id="4" name="Slide Number Placeholder 3"/>
+          <p:cNvSpPr>
+            <a:spLocks noGrp="1"/>
+          </p:cNvSpPr>
+          <p:nvPr>
+            <p:ph type="sldNum" idx="5" sz="quarter"/>
+          </p:nvPr>
+        </p:nvSpPr>
+        <p:spPr/>
+      </p:sp>
+    </p:spTree>
+  </p:cSld>
+  <p:clrMapOvr>
+    <a:masterClrMapping/>
+  </p:clrMapOvr>
+</p:notes>
+</file>
+
+<file path=ppt/notesSlides/notesSlide6.xml><?xml version="1.0" encoding="utf-8"?>
+<p:notes xmlns:a="http://schemas.openxmlformats.org/drawingml/2006/main" xmlns:p="http://schemas.openxmlformats.org/presentationml/2006/main" xmlns:r="http://schemas.openxmlformats.org/officeDocument/2006/relationships">
+  <p:cSld>
+    <p:spTree>
+      <p:nvGrpSpPr>
+        <p:cNvPr id="1" name=""/>
+        <p:cNvGrpSpPr/>
+        <p:nvPr/>
+      </p:nvGrpSpPr>
+      <p:grpSpPr>
+        <a:xfrm>
+          <a:off x="0" y="0"/>
+          <a:ext cx="0" cy="0"/>
+          <a:chOff x="0" y="0"/>
+          <a:chExt cx="0" cy="0"/>
+        </a:xfrm>
+      </p:grpSpPr>
+      <p:sp>
+        <p:nvSpPr>
+          <p:cNvPr id="2" name="Slide Image Placeholder 1"/>
+          <p:cNvSpPr>
+            <a:spLocks noGrp="1"/>
+          </p:cNvSpPr>
+          <p:nvPr>
+            <p:ph type="sldImg" idx="2"/>
+          </p:nvPr>
+        </p:nvSpPr>
+        <p:spPr/>
+      </p:sp>
+      <p:sp>
+        <p:nvSpPr>
+          <p:cNvPr id="3" name="Notes Placeholder 2"/>
+          <p:cNvSpPr>
+            <a:spLocks noGrp="1"/>
+          </p:cNvSpPr>
+          <p:nvPr>
+            <p:ph type="body" idx="3" sz="quarter"/>
+          </p:nvPr>
+        </p:nvSpPr>
+        <p:spPr/>
+        <p:txBody>
+          <a:bodyPr/>
+          <a:lstStyle/>
+          <a:p>
+            <a:r>
+              <a:t>This slide demonstrates downloading a remote image during rendering.</a:t>
+            </a:r>
+          </a:p>
+          <a:p>
+            <a:r>
+              <a:t>[Sources]</a:t>
+            </a:r>
+          </a:p>
+          <a:p>
+            <a:r>
+              <a:t>- https://raw.githubusercontent.com/github/explore/main/topics/python/python.png (Python logo)</a:t>
+            </a:r>
+          </a:p>
+        </p:txBody>
+      </p:sp>
+      <p:sp>
+        <p:nvSpPr>
+          <p:cNvPr id="4" name="Slide Number Placeholder 3"/>
+          <p:cNvSpPr>
+            <a:spLocks noGrp="1"/>
+          </p:cNvSpPr>
+          <p:nvPr>
+            <p:ph type="sldNum" idx="5" sz="quarter"/>
+          </p:nvPr>
+        </p:nvSpPr>
+        <p:spPr/>
+      </p:sp>
+    </p:spTree>
+  </p:cSld>
+  <p:clrMapOvr>
+    <a:masterClrMapping/>
+  </p:clrMapOvr>
+</p:notes>
+</file>
+
+<file path=ppt/notesSlides/notesSlide7.xml><?xml version="1.0" encoding="utf-8"?>
+<p:notes xmlns:a="http://schemas.openxmlformats.org/drawingml/2006/main" xmlns:p="http://schemas.openxmlformats.org/presentationml/2006/main" xmlns:r="http://schemas.openxmlformats.org/officeDocument/2006/relationships">
+  <p:cSld>
+    <p:spTree>
+      <p:nvGrpSpPr>
+        <p:cNvPr id="1" name=""/>
+        <p:cNvGrpSpPr/>
+        <p:nvPr/>
+      </p:nvGrpSpPr>
+      <p:grpSpPr>
+        <a:xfrm>
+          <a:off x="0" y="0"/>
+          <a:ext cx="0" cy="0"/>
+          <a:chOff x="0" y="0"/>
+          <a:chExt cx="0" cy="0"/>
+        </a:xfrm>
+      </p:grpSpPr>
+      <p:sp>
+        <p:nvSpPr>
+          <p:cNvPr id="2" name="Slide Image Placeholder 1"/>
+          <p:cNvSpPr>
+            <a:spLocks noGrp="1"/>
+          </p:cNvSpPr>
+          <p:nvPr>
+            <p:ph type="sldImg" idx="2"/>
+          </p:nvPr>
+        </p:nvSpPr>
+        <p:spPr/>
+      </p:sp>
+      <p:sp>
+        <p:nvSpPr>
+          <p:cNvPr id="3" name="Notes Placeholder 2"/>
+          <p:cNvSpPr>
+            <a:spLocks noGrp="1"/>
+          </p:cNvSpPr>
+          <p:nvPr>
+            <p:ph type="body" idx="3" sz="quarter"/>
+          </p:nvPr>
+        </p:nvSpPr>
+        <p:spPr/>
+        <p:txBody>
+          <a:bodyPr/>
+          <a:lstStyle/>
+          <a:p>
+            <a:r>
+              <a:t>This slide demonstrates a full-slide background image on the Blank layout.</a:t>
+            </a:r>
+          </a:p>
+        </p:txBody>
+      </p:sp>
+      <p:sp>
+        <p:nvSpPr>
+          <p:cNvPr id="4" name="Slide Number Placeholder 3"/>
+          <p:cNvSpPr>
+            <a:spLocks noGrp="1"/>
+          </p:cNvSpPr>
+          <p:nvPr>
+            <p:ph type="sldNum" idx="5" sz="quarter"/>
+          </p:nvPr>
+        </p:nvSpPr>
+        <p:spPr/>
+      </p:sp>
+    </p:spTree>
+  </p:cSld>
+  <p:clrMapOvr>
+    <a:masterClrMapping/>
+  </p:clrMapOvr>
+</p:notes>
+</file>
+
+<file path=ppt/notesSlides/notesSlide8.xml><?xml version="1.0" encoding="utf-8"?>
+<p:notes xmlns:a="http://schemas.openxmlformats.org/drawingml/2006/main" xmlns:p="http://schemas.openxmlformats.org/presentationml/2006/main" xmlns:r="http://schemas.openxmlformats.org/officeDocument/2006/relationships">
+  <p:cSld>
+    <p:spTree>
+      <p:nvGrpSpPr>
+        <p:cNvPr id="1" name=""/>
+        <p:cNvGrpSpPr/>
+        <p:nvPr/>
+      </p:nvGrpSpPr>
+      <p:grpSpPr>
+        <a:xfrm>
+          <a:off x="0" y="0"/>
+          <a:ext cx="0" cy="0"/>
+          <a:chOff x="0" y="0"/>
+          <a:chExt cx="0" cy="0"/>
+        </a:xfrm>
+      </p:grpSpPr>
+      <p:sp>
+        <p:nvSpPr>
+          <p:cNvPr id="2" name="Slide Image Placeholder 1"/>
+          <p:cNvSpPr>
+            <a:spLocks noGrp="1"/>
+          </p:cNvSpPr>
+          <p:nvPr>
+            <p:ph type="sldImg" idx="2"/>
+          </p:nvPr>
+        </p:nvSpPr>
+        <p:spPr/>
+      </p:sp>
+      <p:sp>
+        <p:nvSpPr>
+          <p:cNvPr id="3" name="Notes Placeholder 2"/>
+          <p:cNvSpPr>
+            <a:spLocks noGrp="1"/>
+          </p:cNvSpPr>
+          <p:nvPr>
+            <p:ph type="body" idx="3" sz="quarter"/>
+          </p:nvPr>
+        </p:nvSpPr>
+        <p:spPr/>
+        <p:txBody>
+          <a:bodyPr/>
+          <a:lstStyle/>
+          <a:p>
+            <a:r>
+              <a:t>This slide intentionally demonstrates the Blank layout.</a:t>
+            </a:r>
+          </a:p>
+        </p:txBody>
+      </p:sp>
+      <p:sp>
+        <p:nvSpPr>
+          <p:cNvPr id="4" name="Slide Number Placeholder 3"/>
+          <p:cNvSpPr>
+            <a:spLocks noGrp="1"/>
+          </p:cNvSpPr>
+          <p:nvPr>
+            <p:ph type="sldNum" idx="5" sz="quarter"/>
+          </p:nvPr>
+        </p:nvSpPr>
+        <p:spPr/>
+      </p:sp>
+    </p:spTree>
+  </p:cSld>
+  <p:clrMapOvr>
+    <a:masterClrMapping/>
+  </p:clrMapOvr>
+</p:notes>
+</file>
+
+<file path=ppt/notesSlides/notesSlide9.xml><?xml version="1.0" encoding="utf-8"?>
 <p:notes xmlns:a="http://schemas.openxmlformats.org/drawingml/2006/main" xmlns:p="http://schemas.openxmlformats.org/presentationml/2006/main" xmlns:r="http://schemas.openxmlformats.org/officeDocument/2006/relationships">
   <p:cSld>
     <p:spTree>
@@ -8076,7 +8360,7 @@
                   <a:schemeClr val="accent6"/>
                 </a:solidFill>
               </a:rPr>
-              <a:t>Code block</a:t>
+              <a:t>Code block: PowerShell</a:t>
             </a:r>
             <a:endParaRPr>
               <a:solidFill>
@@ -8380,6 +8664,3242 @@
 </file>
 
 <file path=ppt/slides/slide28.xml><?xml version="1.0" encoding="utf-8"?>
+<p:sld xmlns:a="http://schemas.openxmlformats.org/drawingml/2006/main" xmlns:p="http://schemas.openxmlformats.org/presentationml/2006/main" xmlns:r="http://schemas.openxmlformats.org/officeDocument/2006/relationships">
+  <p:cSld>
+    <p:spTree>
+      <p:nvGrpSpPr>
+        <p:cNvPr id="1" name=""/>
+        <p:cNvGrpSpPr/>
+        <p:nvPr/>
+      </p:nvGrpSpPr>
+      <p:grpSpPr/>
+      <p:sp>
+        <p:nvSpPr>
+          <p:cNvPr id="2" name="Title 1"/>
+          <p:cNvSpPr>
+            <a:spLocks noGrp="1"/>
+          </p:cNvSpPr>
+          <p:nvPr>
+            <p:ph type="title"/>
+          </p:nvPr>
+        </p:nvSpPr>
+        <p:spPr/>
+        <p:txBody>
+          <a:bodyPr>
+            <a:normAutofit/>
+          </a:bodyPr>
+          <a:lstStyle/>
+          <a:p>
+            <a:pPr>
+              <a:defRPr>
+                <a:solidFill>
+                  <a:schemeClr val="accent6"/>
+                </a:solidFill>
+              </a:defRPr>
+            </a:pPr>
+            <a:r>
+              <a:rPr>
+                <a:solidFill>
+                  <a:schemeClr val="accent6"/>
+                </a:solidFill>
+              </a:rPr>
+              <a:t>Syntax highlighting: Python</a:t>
+            </a:r>
+            <a:endParaRPr>
+              <a:solidFill>
+                <a:schemeClr val="accent6"/>
+              </a:solidFill>
+            </a:endParaRPr>
+          </a:p>
+        </p:txBody>
+      </p:sp>
+      <p:sp>
+        <p:nvSpPr>
+          <p:cNvPr id="3" name="Content Placeholder 2"/>
+          <p:cNvSpPr>
+            <a:spLocks noGrp="1"/>
+          </p:cNvSpPr>
+          <p:nvPr>
+            <p:ph idx="1"/>
+          </p:nvPr>
+        </p:nvSpPr>
+        <p:spPr/>
+        <p:txBody>
+          <a:bodyPr wrap="square">
+            <a:normAutofit/>
+          </a:bodyPr>
+          <a:lstStyle/>
+          <a:p>
+            <a:pPr marL="0" indent="0">
+              <a:buNone/>
+              <a:defRPr>
+                <a:solidFill>
+                  <a:schemeClr val="dk1"/>
+                </a:solidFill>
+              </a:defRPr>
+            </a:pPr>
+            <a:r>
+              <a:rPr b="0" i="1">
+                <a:solidFill>
+                  <a:srgbClr val="3D7B7B"/>
+                </a:solidFill>
+                <a:latin typeface="Consolas"/>
+              </a:rPr>
+              <a:t># Summarize completed work</a:t>
+            </a:r>
+            <a:br/>
+            <a:r>
+              <a:rPr b="1" i="0">
+                <a:solidFill>
+                  <a:srgbClr val="008000"/>
+                </a:solidFill>
+                <a:latin typeface="Consolas"/>
+              </a:rPr>
+              <a:t>def</a:t>
+            </a:r>
+            <a:r>
+              <a:rPr b="0" i="0">
+                <a:solidFill>
+                  <a:schemeClr val="dk1"/>
+                </a:solidFill>
+                <a:latin typeface="Consolas"/>
+              </a:rPr>
+              <a:t> </a:t>
+            </a:r>
+            <a:r>
+              <a:rPr b="0" i="0">
+                <a:solidFill>
+                  <a:srgbClr val="0000FF"/>
+                </a:solidFill>
+                <a:latin typeface="Consolas"/>
+              </a:rPr>
+              <a:t>summarize</a:t>
+            </a:r>
+            <a:r>
+              <a:rPr b="0" i="0">
+                <a:solidFill>
+                  <a:schemeClr val="dk1"/>
+                </a:solidFill>
+                <a:latin typeface="Consolas"/>
+              </a:rPr>
+              <a:t>(</a:t>
+            </a:r>
+            <a:r>
+              <a:rPr b="0" i="0">
+                <a:solidFill>
+                  <a:schemeClr val="dk1"/>
+                </a:solidFill>
+                <a:latin typeface="Consolas"/>
+              </a:rPr>
+              <a:t>tasks</a:t>
+            </a:r>
+            <a:r>
+              <a:rPr b="0" i="0">
+                <a:solidFill>
+                  <a:schemeClr val="dk1"/>
+                </a:solidFill>
+                <a:latin typeface="Consolas"/>
+              </a:rPr>
+              <a:t>:</a:t>
+            </a:r>
+            <a:r>
+              <a:rPr b="0" i="0">
+                <a:solidFill>
+                  <a:schemeClr val="dk1"/>
+                </a:solidFill>
+                <a:latin typeface="Consolas"/>
+              </a:rPr>
+              <a:t> </a:t>
+            </a:r>
+            <a:r>
+              <a:rPr b="0" i="0">
+                <a:solidFill>
+                  <a:srgbClr val="008000"/>
+                </a:solidFill>
+                <a:latin typeface="Consolas"/>
+              </a:rPr>
+              <a:t>list</a:t>
+            </a:r>
+            <a:r>
+              <a:rPr b="0" i="0">
+                <a:solidFill>
+                  <a:schemeClr val="dk1"/>
+                </a:solidFill>
+                <a:latin typeface="Consolas"/>
+              </a:rPr>
+              <a:t>[</a:t>
+            </a:r>
+            <a:r>
+              <a:rPr b="0" i="0">
+                <a:solidFill>
+                  <a:srgbClr val="008000"/>
+                </a:solidFill>
+                <a:latin typeface="Consolas"/>
+              </a:rPr>
+              <a:t>str</a:t>
+            </a:r>
+            <a:r>
+              <a:rPr b="0" i="0">
+                <a:solidFill>
+                  <a:schemeClr val="dk1"/>
+                </a:solidFill>
+                <a:latin typeface="Consolas"/>
+              </a:rPr>
+              <a:t>]</a:t>
+            </a:r>
+            <a:r>
+              <a:rPr b="0" i="0">
+                <a:solidFill>
+                  <a:schemeClr val="dk1"/>
+                </a:solidFill>
+                <a:latin typeface="Consolas"/>
+              </a:rPr>
+              <a:t>)</a:t>
+            </a:r>
+            <a:r>
+              <a:rPr b="0" i="0">
+                <a:solidFill>
+                  <a:schemeClr val="dk1"/>
+                </a:solidFill>
+                <a:latin typeface="Consolas"/>
+              </a:rPr>
+              <a:t> </a:t>
+            </a:r>
+            <a:r>
+              <a:rPr b="0" i="0">
+                <a:solidFill>
+                  <a:srgbClr val="666666"/>
+                </a:solidFill>
+                <a:latin typeface="Consolas"/>
+              </a:rPr>
+              <a:t>-</a:t>
+            </a:r>
+            <a:r>
+              <a:rPr b="0" i="0">
+                <a:solidFill>
+                  <a:srgbClr val="666666"/>
+                </a:solidFill>
+                <a:latin typeface="Consolas"/>
+              </a:rPr>
+              <a:t>&gt;</a:t>
+            </a:r>
+            <a:r>
+              <a:rPr b="0" i="0">
+                <a:solidFill>
+                  <a:schemeClr val="dk1"/>
+                </a:solidFill>
+                <a:latin typeface="Consolas"/>
+              </a:rPr>
+              <a:t> </a:t>
+            </a:r>
+            <a:r>
+              <a:rPr b="0" i="0">
+                <a:solidFill>
+                  <a:srgbClr val="008000"/>
+                </a:solidFill>
+                <a:latin typeface="Consolas"/>
+              </a:rPr>
+              <a:t>str</a:t>
+            </a:r>
+            <a:r>
+              <a:rPr b="0" i="0">
+                <a:solidFill>
+                  <a:schemeClr val="dk1"/>
+                </a:solidFill>
+                <a:latin typeface="Consolas"/>
+              </a:rPr>
+              <a:t>:</a:t>
+            </a:r>
+            <a:br/>
+            <a:r>
+              <a:rPr b="0" i="0">
+                <a:solidFill>
+                  <a:schemeClr val="dk1"/>
+                </a:solidFill>
+                <a:latin typeface="Consolas"/>
+              </a:rPr>
+              <a:t>    </a:t>
+            </a:r>
+            <a:r>
+              <a:rPr b="0" i="0">
+                <a:solidFill>
+                  <a:schemeClr val="dk1"/>
+                </a:solidFill>
+                <a:latin typeface="Consolas"/>
+              </a:rPr>
+              <a:t>count</a:t>
+            </a:r>
+            <a:r>
+              <a:rPr b="0" i="0">
+                <a:solidFill>
+                  <a:schemeClr val="dk1"/>
+                </a:solidFill>
+                <a:latin typeface="Consolas"/>
+              </a:rPr>
+              <a:t> </a:t>
+            </a:r>
+            <a:r>
+              <a:rPr b="0" i="0">
+                <a:solidFill>
+                  <a:srgbClr val="666666"/>
+                </a:solidFill>
+                <a:latin typeface="Consolas"/>
+              </a:rPr>
+              <a:t>=</a:t>
+            </a:r>
+            <a:r>
+              <a:rPr b="0" i="0">
+                <a:solidFill>
+                  <a:schemeClr val="dk1"/>
+                </a:solidFill>
+                <a:latin typeface="Consolas"/>
+              </a:rPr>
+              <a:t> </a:t>
+            </a:r>
+            <a:r>
+              <a:rPr b="0" i="0">
+                <a:solidFill>
+                  <a:srgbClr val="008000"/>
+                </a:solidFill>
+                <a:latin typeface="Consolas"/>
+              </a:rPr>
+              <a:t>len</a:t>
+            </a:r>
+            <a:r>
+              <a:rPr b="0" i="0">
+                <a:solidFill>
+                  <a:schemeClr val="dk1"/>
+                </a:solidFill>
+                <a:latin typeface="Consolas"/>
+              </a:rPr>
+              <a:t>(</a:t>
+            </a:r>
+            <a:r>
+              <a:rPr b="0" i="0">
+                <a:solidFill>
+                  <a:schemeClr val="dk1"/>
+                </a:solidFill>
+                <a:latin typeface="Consolas"/>
+              </a:rPr>
+              <a:t>tasks</a:t>
+            </a:r>
+            <a:r>
+              <a:rPr b="0" i="0">
+                <a:solidFill>
+                  <a:schemeClr val="dk1"/>
+                </a:solidFill>
+                <a:latin typeface="Consolas"/>
+              </a:rPr>
+              <a:t>)</a:t>
+            </a:r>
+            <a:br/>
+            <a:r>
+              <a:rPr b="0" i="0">
+                <a:solidFill>
+                  <a:schemeClr val="dk1"/>
+                </a:solidFill>
+                <a:latin typeface="Consolas"/>
+              </a:rPr>
+              <a:t>    </a:t>
+            </a:r>
+            <a:r>
+              <a:rPr b="1" i="0">
+                <a:solidFill>
+                  <a:srgbClr val="008000"/>
+                </a:solidFill>
+                <a:latin typeface="Consolas"/>
+              </a:rPr>
+              <a:t>return</a:t>
+            </a:r>
+            <a:r>
+              <a:rPr b="0" i="0">
+                <a:solidFill>
+                  <a:schemeClr val="dk1"/>
+                </a:solidFill>
+                <a:latin typeface="Consolas"/>
+              </a:rPr>
+              <a:t> </a:t>
+            </a:r>
+            <a:r>
+              <a:rPr b="0" i="0">
+                <a:solidFill>
+                  <a:srgbClr val="BA2121"/>
+                </a:solidFill>
+                <a:latin typeface="Consolas"/>
+              </a:rPr>
+              <a:t>f</a:t>
+            </a:r>
+            <a:r>
+              <a:rPr b="0" i="0">
+                <a:solidFill>
+                  <a:srgbClr val="BA2121"/>
+                </a:solidFill>
+                <a:latin typeface="Consolas"/>
+              </a:rPr>
+              <a:t>"</a:t>
+            </a:r>
+            <a:r>
+              <a:rPr b="0" i="0">
+                <a:solidFill>
+                  <a:srgbClr val="BA2121"/>
+                </a:solidFill>
+                <a:latin typeface="Consolas"/>
+              </a:rPr>
+              <a:t>Completed </a:t>
+            </a:r>
+            <a:r>
+              <a:rPr b="1" i="0">
+                <a:solidFill>
+                  <a:srgbClr val="A45A77"/>
+                </a:solidFill>
+                <a:latin typeface="Consolas"/>
+              </a:rPr>
+              <a:t>{</a:t>
+            </a:r>
+            <a:r>
+              <a:rPr b="0" i="0">
+                <a:solidFill>
+                  <a:schemeClr val="dk1"/>
+                </a:solidFill>
+                <a:latin typeface="Consolas"/>
+              </a:rPr>
+              <a:t>count</a:t>
+            </a:r>
+            <a:r>
+              <a:rPr b="1" i="0">
+                <a:solidFill>
+                  <a:srgbClr val="A45A77"/>
+                </a:solidFill>
+                <a:latin typeface="Consolas"/>
+              </a:rPr>
+              <a:t>}</a:t>
+            </a:r>
+            <a:r>
+              <a:rPr b="0" i="0">
+                <a:solidFill>
+                  <a:srgbClr val="BA2121"/>
+                </a:solidFill>
+                <a:latin typeface="Consolas"/>
+              </a:rPr>
+              <a:t> tasks</a:t>
+            </a:r>
+            <a:r>
+              <a:rPr b="0" i="0">
+                <a:solidFill>
+                  <a:srgbClr val="BA2121"/>
+                </a:solidFill>
+                <a:latin typeface="Consolas"/>
+              </a:rPr>
+              <a:t>"</a:t>
+            </a:r>
+            <a:br/>
+            <a:br/>
+            <a:r>
+              <a:rPr b="0" i="0">
+                <a:solidFill>
+                  <a:schemeClr val="dk1"/>
+                </a:solidFill>
+                <a:latin typeface="Consolas"/>
+              </a:rPr>
+              <a:t>tasks</a:t>
+            </a:r>
+            <a:r>
+              <a:rPr b="0" i="0">
+                <a:solidFill>
+                  <a:schemeClr val="dk1"/>
+                </a:solidFill>
+                <a:latin typeface="Consolas"/>
+              </a:rPr>
+              <a:t> </a:t>
+            </a:r>
+            <a:r>
+              <a:rPr b="0" i="0">
+                <a:solidFill>
+                  <a:srgbClr val="666666"/>
+                </a:solidFill>
+                <a:latin typeface="Consolas"/>
+              </a:rPr>
+              <a:t>=</a:t>
+            </a:r>
+            <a:r>
+              <a:rPr b="0" i="0">
+                <a:solidFill>
+                  <a:schemeClr val="dk1"/>
+                </a:solidFill>
+                <a:latin typeface="Consolas"/>
+              </a:rPr>
+              <a:t> </a:t>
+            </a:r>
+            <a:r>
+              <a:rPr b="0" i="0">
+                <a:solidFill>
+                  <a:schemeClr val="dk1"/>
+                </a:solidFill>
+                <a:latin typeface="Consolas"/>
+              </a:rPr>
+              <a:t>[</a:t>
+            </a:r>
+            <a:r>
+              <a:rPr b="0" i="0">
+                <a:solidFill>
+                  <a:srgbClr val="BA2121"/>
+                </a:solidFill>
+                <a:latin typeface="Consolas"/>
+              </a:rPr>
+              <a:t>"</a:t>
+            </a:r>
+            <a:r>
+              <a:rPr b="0" i="0">
+                <a:solidFill>
+                  <a:srgbClr val="BA2121"/>
+                </a:solidFill>
+                <a:latin typeface="Consolas"/>
+              </a:rPr>
+              <a:t>Design</a:t>
+            </a:r>
+            <a:r>
+              <a:rPr b="0" i="0">
+                <a:solidFill>
+                  <a:srgbClr val="BA2121"/>
+                </a:solidFill>
+                <a:latin typeface="Consolas"/>
+              </a:rPr>
+              <a:t>"</a:t>
+            </a:r>
+            <a:r>
+              <a:rPr b="0" i="0">
+                <a:solidFill>
+                  <a:schemeClr val="dk1"/>
+                </a:solidFill>
+                <a:latin typeface="Consolas"/>
+              </a:rPr>
+              <a:t>,</a:t>
+            </a:r>
+            <a:r>
+              <a:rPr b="0" i="0">
+                <a:solidFill>
+                  <a:schemeClr val="dk1"/>
+                </a:solidFill>
+                <a:latin typeface="Consolas"/>
+              </a:rPr>
+              <a:t> </a:t>
+            </a:r>
+            <a:r>
+              <a:rPr b="0" i="0">
+                <a:solidFill>
+                  <a:srgbClr val="BA2121"/>
+                </a:solidFill>
+                <a:latin typeface="Consolas"/>
+              </a:rPr>
+              <a:t>"</a:t>
+            </a:r>
+            <a:r>
+              <a:rPr b="0" i="0">
+                <a:solidFill>
+                  <a:srgbClr val="BA2121"/>
+                </a:solidFill>
+                <a:latin typeface="Consolas"/>
+              </a:rPr>
+              <a:t>Build</a:t>
+            </a:r>
+            <a:r>
+              <a:rPr b="0" i="0">
+                <a:solidFill>
+                  <a:srgbClr val="BA2121"/>
+                </a:solidFill>
+                <a:latin typeface="Consolas"/>
+              </a:rPr>
+              <a:t>"</a:t>
+            </a:r>
+            <a:r>
+              <a:rPr b="0" i="0">
+                <a:solidFill>
+                  <a:schemeClr val="dk1"/>
+                </a:solidFill>
+                <a:latin typeface="Consolas"/>
+              </a:rPr>
+              <a:t>,</a:t>
+            </a:r>
+            <a:r>
+              <a:rPr b="0" i="0">
+                <a:solidFill>
+                  <a:schemeClr val="dk1"/>
+                </a:solidFill>
+                <a:latin typeface="Consolas"/>
+              </a:rPr>
+              <a:t> </a:t>
+            </a:r>
+            <a:r>
+              <a:rPr b="0" i="0">
+                <a:solidFill>
+                  <a:srgbClr val="BA2121"/>
+                </a:solidFill>
+                <a:latin typeface="Consolas"/>
+              </a:rPr>
+              <a:t>"</a:t>
+            </a:r>
+            <a:r>
+              <a:rPr b="0" i="0">
+                <a:solidFill>
+                  <a:srgbClr val="BA2121"/>
+                </a:solidFill>
+                <a:latin typeface="Consolas"/>
+              </a:rPr>
+              <a:t>Review</a:t>
+            </a:r>
+            <a:r>
+              <a:rPr b="0" i="0">
+                <a:solidFill>
+                  <a:srgbClr val="BA2121"/>
+                </a:solidFill>
+                <a:latin typeface="Consolas"/>
+              </a:rPr>
+              <a:t>"</a:t>
+            </a:r>
+            <a:r>
+              <a:rPr b="0" i="0">
+                <a:solidFill>
+                  <a:schemeClr val="dk1"/>
+                </a:solidFill>
+                <a:latin typeface="Consolas"/>
+              </a:rPr>
+              <a:t>]</a:t>
+            </a:r>
+            <a:br/>
+            <a:r>
+              <a:rPr b="1" i="0">
+                <a:solidFill>
+                  <a:srgbClr val="008000"/>
+                </a:solidFill>
+                <a:latin typeface="Consolas"/>
+              </a:rPr>
+              <a:t>if</a:t>
+            </a:r>
+            <a:r>
+              <a:rPr b="0" i="0">
+                <a:solidFill>
+                  <a:schemeClr val="dk1"/>
+                </a:solidFill>
+                <a:latin typeface="Consolas"/>
+              </a:rPr>
+              <a:t> </a:t>
+            </a:r>
+            <a:r>
+              <a:rPr b="0" i="0">
+                <a:solidFill>
+                  <a:srgbClr val="008000"/>
+                </a:solidFill>
+                <a:latin typeface="Consolas"/>
+              </a:rPr>
+              <a:t>len</a:t>
+            </a:r>
+            <a:r>
+              <a:rPr b="0" i="0">
+                <a:solidFill>
+                  <a:schemeClr val="dk1"/>
+                </a:solidFill>
+                <a:latin typeface="Consolas"/>
+              </a:rPr>
+              <a:t>(</a:t>
+            </a:r>
+            <a:r>
+              <a:rPr b="0" i="0">
+                <a:solidFill>
+                  <a:schemeClr val="dk1"/>
+                </a:solidFill>
+                <a:latin typeface="Consolas"/>
+              </a:rPr>
+              <a:t>tasks</a:t>
+            </a:r>
+            <a:r>
+              <a:rPr b="0" i="0">
+                <a:solidFill>
+                  <a:schemeClr val="dk1"/>
+                </a:solidFill>
+                <a:latin typeface="Consolas"/>
+              </a:rPr>
+              <a:t>)</a:t>
+            </a:r>
+            <a:r>
+              <a:rPr b="0" i="0">
+                <a:solidFill>
+                  <a:schemeClr val="dk1"/>
+                </a:solidFill>
+                <a:latin typeface="Consolas"/>
+              </a:rPr>
+              <a:t> </a:t>
+            </a:r>
+            <a:r>
+              <a:rPr b="0" i="0">
+                <a:solidFill>
+                  <a:srgbClr val="666666"/>
+                </a:solidFill>
+                <a:latin typeface="Consolas"/>
+              </a:rPr>
+              <a:t>&gt;</a:t>
+            </a:r>
+            <a:r>
+              <a:rPr b="0" i="0">
+                <a:solidFill>
+                  <a:srgbClr val="666666"/>
+                </a:solidFill>
+                <a:latin typeface="Consolas"/>
+              </a:rPr>
+              <a:t>=</a:t>
+            </a:r>
+            <a:r>
+              <a:rPr b="0" i="0">
+                <a:solidFill>
+                  <a:schemeClr val="dk1"/>
+                </a:solidFill>
+                <a:latin typeface="Consolas"/>
+              </a:rPr>
+              <a:t> </a:t>
+            </a:r>
+            <a:r>
+              <a:rPr b="0" i="0">
+                <a:solidFill>
+                  <a:srgbClr val="666666"/>
+                </a:solidFill>
+                <a:latin typeface="Consolas"/>
+              </a:rPr>
+              <a:t>3</a:t>
+            </a:r>
+            <a:r>
+              <a:rPr b="0" i="0">
+                <a:solidFill>
+                  <a:schemeClr val="dk1"/>
+                </a:solidFill>
+                <a:latin typeface="Consolas"/>
+              </a:rPr>
+              <a:t>:</a:t>
+            </a:r>
+            <a:br/>
+            <a:r>
+              <a:rPr b="0" i="0">
+                <a:solidFill>
+                  <a:schemeClr val="dk1"/>
+                </a:solidFill>
+                <a:latin typeface="Consolas"/>
+              </a:rPr>
+              <a:t>    </a:t>
+            </a:r>
+            <a:r>
+              <a:rPr b="0" i="0">
+                <a:solidFill>
+                  <a:srgbClr val="008000"/>
+                </a:solidFill>
+                <a:latin typeface="Consolas"/>
+              </a:rPr>
+              <a:t>print</a:t>
+            </a:r>
+            <a:r>
+              <a:rPr b="0" i="0">
+                <a:solidFill>
+                  <a:schemeClr val="dk1"/>
+                </a:solidFill>
+                <a:latin typeface="Consolas"/>
+              </a:rPr>
+              <a:t>(</a:t>
+            </a:r>
+            <a:r>
+              <a:rPr b="0" i="0">
+                <a:solidFill>
+                  <a:schemeClr val="dk1"/>
+                </a:solidFill>
+                <a:latin typeface="Consolas"/>
+              </a:rPr>
+              <a:t>summarize</a:t>
+            </a:r>
+            <a:r>
+              <a:rPr b="0" i="0">
+                <a:solidFill>
+                  <a:schemeClr val="dk1"/>
+                </a:solidFill>
+                <a:latin typeface="Consolas"/>
+              </a:rPr>
+              <a:t>(</a:t>
+            </a:r>
+            <a:r>
+              <a:rPr b="0" i="0">
+                <a:solidFill>
+                  <a:schemeClr val="dk1"/>
+                </a:solidFill>
+                <a:latin typeface="Consolas"/>
+              </a:rPr>
+              <a:t>tasks</a:t>
+            </a:r>
+            <a:r>
+              <a:rPr b="0" i="0">
+                <a:solidFill>
+                  <a:schemeClr val="dk1"/>
+                </a:solidFill>
+                <a:latin typeface="Consolas"/>
+              </a:rPr>
+              <a:t>)</a:t>
+            </a:r>
+            <a:r>
+              <a:rPr b="0" i="0">
+                <a:solidFill>
+                  <a:schemeClr val="dk1"/>
+                </a:solidFill>
+                <a:latin typeface="Consolas"/>
+              </a:rPr>
+              <a:t>)</a:t>
+            </a:r>
+            <a:endParaRPr>
+              <a:solidFill>
+                <a:schemeClr val="dk1"/>
+              </a:solidFill>
+            </a:endParaRPr>
+          </a:p>
+        </p:txBody>
+      </p:sp>
+    </p:spTree>
+  </p:cSld>
+  <p:clrMapOvr>
+    <a:masterClrMapping/>
+  </p:clrMapOvr>
+</p:sld>
+</file>
+
+<file path=ppt/slides/slide29.xml><?xml version="1.0" encoding="utf-8"?>
+<p:sld xmlns:a="http://schemas.openxmlformats.org/drawingml/2006/main" xmlns:p="http://schemas.openxmlformats.org/presentationml/2006/main" xmlns:r="http://schemas.openxmlformats.org/officeDocument/2006/relationships">
+  <p:cSld>
+    <p:spTree>
+      <p:nvGrpSpPr>
+        <p:cNvPr id="1" name=""/>
+        <p:cNvGrpSpPr/>
+        <p:nvPr/>
+      </p:nvGrpSpPr>
+      <p:grpSpPr/>
+      <p:sp>
+        <p:nvSpPr>
+          <p:cNvPr id="2" name="Title 1"/>
+          <p:cNvSpPr>
+            <a:spLocks noGrp="1"/>
+          </p:cNvSpPr>
+          <p:nvPr>
+            <p:ph type="title"/>
+          </p:nvPr>
+        </p:nvSpPr>
+        <p:spPr/>
+        <p:txBody>
+          <a:bodyPr>
+            <a:normAutofit/>
+          </a:bodyPr>
+          <a:lstStyle/>
+          <a:p>
+            <a:pPr>
+              <a:defRPr>
+                <a:solidFill>
+                  <a:schemeClr val="accent6"/>
+                </a:solidFill>
+              </a:defRPr>
+            </a:pPr>
+            <a:r>
+              <a:rPr>
+                <a:solidFill>
+                  <a:schemeClr val="accent6"/>
+                </a:solidFill>
+              </a:rPr>
+              <a:t>Syntax highlighting: TypeScript</a:t>
+            </a:r>
+            <a:endParaRPr>
+              <a:solidFill>
+                <a:schemeClr val="accent6"/>
+              </a:solidFill>
+            </a:endParaRPr>
+          </a:p>
+        </p:txBody>
+      </p:sp>
+      <p:sp>
+        <p:nvSpPr>
+          <p:cNvPr id="3" name="Content Placeholder 2"/>
+          <p:cNvSpPr>
+            <a:spLocks noGrp="1"/>
+          </p:cNvSpPr>
+          <p:nvPr>
+            <p:ph idx="1"/>
+          </p:nvPr>
+        </p:nvSpPr>
+        <p:spPr/>
+        <p:txBody>
+          <a:bodyPr wrap="square">
+            <a:normAutofit/>
+          </a:bodyPr>
+          <a:lstStyle/>
+          <a:p>
+            <a:pPr marL="0" indent="0">
+              <a:buNone/>
+              <a:defRPr>
+                <a:solidFill>
+                  <a:schemeClr val="dk1"/>
+                </a:solidFill>
+              </a:defRPr>
+            </a:pPr>
+            <a:r>
+              <a:rPr b="0" i="1">
+                <a:solidFill>
+                  <a:srgbClr val="3D7B7B"/>
+                </a:solidFill>
+                <a:latin typeface="Consolas"/>
+              </a:rPr>
+              <a:t>// Calculate the remaining work</a:t>
+            </a:r>
+            <a:br/>
+            <a:r>
+              <a:rPr b="1" i="0">
+                <a:solidFill>
+                  <a:srgbClr val="008000"/>
+                </a:solidFill>
+                <a:latin typeface="Consolas"/>
+              </a:rPr>
+              <a:t>type</a:t>
+            </a:r>
+            <a:r>
+              <a:rPr b="0" i="0">
+                <a:solidFill>
+                  <a:schemeClr val="dk1"/>
+                </a:solidFill>
+                <a:latin typeface="Consolas"/>
+              </a:rPr>
+              <a:t> </a:t>
+            </a:r>
+            <a:r>
+              <a:rPr b="0" i="0">
+                <a:solidFill>
+                  <a:schemeClr val="dk1"/>
+                </a:solidFill>
+                <a:latin typeface="Consolas"/>
+              </a:rPr>
+              <a:t>Project</a:t>
+            </a:r>
+            <a:r>
+              <a:rPr b="0" i="0">
+                <a:solidFill>
+                  <a:schemeClr val="dk1"/>
+                </a:solidFill>
+                <a:latin typeface="Consolas"/>
+              </a:rPr>
+              <a:t> </a:t>
+            </a:r>
+            <a:r>
+              <a:rPr b="0" i="0">
+                <a:solidFill>
+                  <a:srgbClr val="666666"/>
+                </a:solidFill>
+                <a:latin typeface="Consolas"/>
+              </a:rPr>
+              <a:t>=</a:t>
+            </a:r>
+            <a:r>
+              <a:rPr b="0" i="0">
+                <a:solidFill>
+                  <a:schemeClr val="dk1"/>
+                </a:solidFill>
+                <a:latin typeface="Consolas"/>
+              </a:rPr>
+              <a:t> </a:t>
+            </a:r>
+            <a:r>
+              <a:rPr b="0" i="0">
+                <a:solidFill>
+                  <a:schemeClr val="dk1"/>
+                </a:solidFill>
+                <a:latin typeface="Consolas"/>
+              </a:rPr>
+              <a:t>{</a:t>
+            </a:r>
+            <a:r>
+              <a:rPr b="0" i="0">
+                <a:solidFill>
+                  <a:schemeClr val="dk1"/>
+                </a:solidFill>
+                <a:latin typeface="Consolas"/>
+              </a:rPr>
+              <a:t> </a:t>
+            </a:r>
+            <a:r>
+              <a:rPr b="0" i="0">
+                <a:solidFill>
+                  <a:schemeClr val="dk1"/>
+                </a:solidFill>
+                <a:latin typeface="Consolas"/>
+              </a:rPr>
+              <a:t>name</a:t>
+            </a:r>
+            <a:r>
+              <a:rPr b="0" i="0">
+                <a:solidFill>
+                  <a:srgbClr val="666666"/>
+                </a:solidFill>
+                <a:latin typeface="Consolas"/>
+              </a:rPr>
+              <a:t>:</a:t>
+            </a:r>
+            <a:r>
+              <a:rPr b="0" i="0">
+                <a:solidFill>
+                  <a:schemeClr val="dk1"/>
+                </a:solidFill>
+                <a:latin typeface="Consolas"/>
+              </a:rPr>
+              <a:t> </a:t>
+            </a:r>
+            <a:r>
+              <a:rPr b="0" i="0">
+                <a:solidFill>
+                  <a:srgbClr val="B00040"/>
+                </a:solidFill>
+                <a:latin typeface="Consolas"/>
+              </a:rPr>
+              <a:t>string</a:t>
+            </a:r>
+            <a:r>
+              <a:rPr b="0" i="0">
+                <a:solidFill>
+                  <a:schemeClr val="dk1"/>
+                </a:solidFill>
+                <a:latin typeface="Consolas"/>
+              </a:rPr>
+              <a:t>,</a:t>
+            </a:r>
+            <a:r>
+              <a:rPr b="0" i="0">
+                <a:solidFill>
+                  <a:schemeClr val="dk1"/>
+                </a:solidFill>
+                <a:latin typeface="Consolas"/>
+              </a:rPr>
+              <a:t> </a:t>
+            </a:r>
+            <a:r>
+              <a:rPr b="0" i="0">
+                <a:solidFill>
+                  <a:schemeClr val="dk1"/>
+                </a:solidFill>
+                <a:latin typeface="Consolas"/>
+              </a:rPr>
+              <a:t>completed</a:t>
+            </a:r>
+            <a:r>
+              <a:rPr b="0" i="0">
+                <a:solidFill>
+                  <a:srgbClr val="666666"/>
+                </a:solidFill>
+                <a:latin typeface="Consolas"/>
+              </a:rPr>
+              <a:t>:</a:t>
+            </a:r>
+            <a:r>
+              <a:rPr b="0" i="0">
+                <a:solidFill>
+                  <a:schemeClr val="dk1"/>
+                </a:solidFill>
+                <a:latin typeface="Consolas"/>
+              </a:rPr>
+              <a:t> </a:t>
+            </a:r>
+            <a:r>
+              <a:rPr b="0" i="0">
+                <a:solidFill>
+                  <a:srgbClr val="B00040"/>
+                </a:solidFill>
+                <a:latin typeface="Consolas"/>
+              </a:rPr>
+              <a:t>number</a:t>
+            </a:r>
+            <a:r>
+              <a:rPr b="0" i="0">
+                <a:solidFill>
+                  <a:schemeClr val="dk1"/>
+                </a:solidFill>
+                <a:latin typeface="Consolas"/>
+              </a:rPr>
+              <a:t> </a:t>
+            </a:r>
+            <a:r>
+              <a:rPr b="0" i="0">
+                <a:solidFill>
+                  <a:schemeClr val="dk1"/>
+                </a:solidFill>
+                <a:latin typeface="Consolas"/>
+              </a:rPr>
+              <a:t>}</a:t>
+            </a:r>
+            <a:br/>
+            <a:br/>
+            <a:r>
+              <a:rPr b="1" i="0">
+                <a:solidFill>
+                  <a:srgbClr val="008000"/>
+                </a:solidFill>
+                <a:latin typeface="Consolas"/>
+              </a:rPr>
+              <a:t>const</a:t>
+            </a:r>
+            <a:r>
+              <a:rPr b="0" i="0">
+                <a:solidFill>
+                  <a:schemeClr val="dk1"/>
+                </a:solidFill>
+                <a:latin typeface="Consolas"/>
+              </a:rPr>
+              <a:t> </a:t>
+            </a:r>
+            <a:r>
+              <a:rPr b="0" i="0">
+                <a:solidFill>
+                  <a:schemeClr val="dk1"/>
+                </a:solidFill>
+                <a:latin typeface="Consolas"/>
+              </a:rPr>
+              <a:t>remaining</a:t>
+            </a:r>
+            <a:r>
+              <a:rPr b="0" i="0">
+                <a:solidFill>
+                  <a:schemeClr val="dk1"/>
+                </a:solidFill>
+                <a:latin typeface="Consolas"/>
+              </a:rPr>
+              <a:t> </a:t>
+            </a:r>
+            <a:r>
+              <a:rPr b="0" i="0">
+                <a:solidFill>
+                  <a:srgbClr val="666666"/>
+                </a:solidFill>
+                <a:latin typeface="Consolas"/>
+              </a:rPr>
+              <a:t>=</a:t>
+            </a:r>
+            <a:r>
+              <a:rPr b="0" i="0">
+                <a:solidFill>
+                  <a:schemeClr val="dk1"/>
+                </a:solidFill>
+                <a:latin typeface="Consolas"/>
+              </a:rPr>
+              <a:t> </a:t>
+            </a:r>
+            <a:r>
+              <a:rPr b="0" i="0">
+                <a:solidFill>
+                  <a:schemeClr val="dk1"/>
+                </a:solidFill>
+                <a:latin typeface="Consolas"/>
+              </a:rPr>
+              <a:t>(</a:t>
+            </a:r>
+            <a:r>
+              <a:rPr b="0" i="0">
+                <a:solidFill>
+                  <a:schemeClr val="dk1"/>
+                </a:solidFill>
+                <a:latin typeface="Consolas"/>
+              </a:rPr>
+              <a:t>project</a:t>
+            </a:r>
+            <a:r>
+              <a:rPr b="0" i="0">
+                <a:solidFill>
+                  <a:srgbClr val="666666"/>
+                </a:solidFill>
+                <a:latin typeface="Consolas"/>
+              </a:rPr>
+              <a:t>:</a:t>
+            </a:r>
+            <a:r>
+              <a:rPr b="0" i="0">
+                <a:solidFill>
+                  <a:schemeClr val="dk1"/>
+                </a:solidFill>
+                <a:latin typeface="Consolas"/>
+              </a:rPr>
+              <a:t> </a:t>
+            </a:r>
+            <a:r>
+              <a:rPr b="0" i="0">
+                <a:solidFill>
+                  <a:srgbClr val="B00040"/>
+                </a:solidFill>
+                <a:latin typeface="Consolas"/>
+              </a:rPr>
+              <a:t>Project</a:t>
+            </a:r>
+            <a:r>
+              <a:rPr b="0" i="0">
+                <a:solidFill>
+                  <a:schemeClr val="dk1"/>
+                </a:solidFill>
+                <a:latin typeface="Consolas"/>
+              </a:rPr>
+              <a:t>)</a:t>
+            </a:r>
+            <a:r>
+              <a:rPr b="0" i="0">
+                <a:solidFill>
+                  <a:srgbClr val="666666"/>
+                </a:solidFill>
+                <a:latin typeface="Consolas"/>
+              </a:rPr>
+              <a:t>:</a:t>
+            </a:r>
+            <a:r>
+              <a:rPr b="0" i="0">
+                <a:solidFill>
+                  <a:schemeClr val="dk1"/>
+                </a:solidFill>
+                <a:latin typeface="Consolas"/>
+              </a:rPr>
+              <a:t> </a:t>
+            </a:r>
+            <a:r>
+              <a:rPr b="0" i="0">
+                <a:solidFill>
+                  <a:srgbClr val="B00040"/>
+                </a:solidFill>
+                <a:latin typeface="Consolas"/>
+              </a:rPr>
+              <a:t>number</a:t>
+            </a:r>
+            <a:r>
+              <a:rPr b="0" i="0">
+                <a:solidFill>
+                  <a:schemeClr val="dk1"/>
+                </a:solidFill>
+                <a:latin typeface="Consolas"/>
+              </a:rPr>
+              <a:t> </a:t>
+            </a:r>
+            <a:r>
+              <a:rPr b="0" i="0">
+                <a:solidFill>
+                  <a:schemeClr val="dk1"/>
+                </a:solidFill>
+                <a:latin typeface="Consolas"/>
+              </a:rPr>
+              <a:t>=&gt;</a:t>
+            </a:r>
+            <a:r>
+              <a:rPr b="0" i="0">
+                <a:solidFill>
+                  <a:schemeClr val="dk1"/>
+                </a:solidFill>
+                <a:latin typeface="Consolas"/>
+              </a:rPr>
+              <a:t> </a:t>
+            </a:r>
+            <a:r>
+              <a:rPr b="0" i="0">
+                <a:solidFill>
+                  <a:schemeClr val="dk1"/>
+                </a:solidFill>
+                <a:latin typeface="Consolas"/>
+              </a:rPr>
+              <a:t>{</a:t>
+            </a:r>
+            <a:br/>
+            <a:r>
+              <a:rPr b="0" i="0">
+                <a:solidFill>
+                  <a:schemeClr val="dk1"/>
+                </a:solidFill>
+                <a:latin typeface="Consolas"/>
+              </a:rPr>
+              <a:t>  </a:t>
+            </a:r>
+            <a:r>
+              <a:rPr b="1" i="0">
+                <a:solidFill>
+                  <a:srgbClr val="008000"/>
+                </a:solidFill>
+                <a:latin typeface="Consolas"/>
+              </a:rPr>
+              <a:t>return</a:t>
+            </a:r>
+            <a:r>
+              <a:rPr b="0" i="0">
+                <a:solidFill>
+                  <a:schemeClr val="dk1"/>
+                </a:solidFill>
+                <a:latin typeface="Consolas"/>
+              </a:rPr>
+              <a:t> </a:t>
+            </a:r>
+            <a:r>
+              <a:rPr b="0" i="0">
+                <a:solidFill>
+                  <a:srgbClr val="008000"/>
+                </a:solidFill>
+                <a:latin typeface="Consolas"/>
+              </a:rPr>
+              <a:t>Math</a:t>
+            </a:r>
+            <a:r>
+              <a:rPr b="0" i="0">
+                <a:solidFill>
+                  <a:schemeClr val="dk1"/>
+                </a:solidFill>
+                <a:latin typeface="Consolas"/>
+              </a:rPr>
+              <a:t>.</a:t>
+            </a:r>
+            <a:r>
+              <a:rPr b="0" i="0">
+                <a:solidFill>
+                  <a:schemeClr val="dk1"/>
+                </a:solidFill>
+                <a:latin typeface="Consolas"/>
+              </a:rPr>
+              <a:t>max</a:t>
+            </a:r>
+            <a:r>
+              <a:rPr b="0" i="0">
+                <a:solidFill>
+                  <a:schemeClr val="dk1"/>
+                </a:solidFill>
+                <a:latin typeface="Consolas"/>
+              </a:rPr>
+              <a:t>(</a:t>
+            </a:r>
+            <a:r>
+              <a:rPr b="0" i="0">
+                <a:solidFill>
+                  <a:srgbClr val="666666"/>
+                </a:solidFill>
+                <a:latin typeface="Consolas"/>
+              </a:rPr>
+              <a:t>0</a:t>
+            </a:r>
+            <a:r>
+              <a:rPr b="0" i="0">
+                <a:solidFill>
+                  <a:schemeClr val="dk1"/>
+                </a:solidFill>
+                <a:latin typeface="Consolas"/>
+              </a:rPr>
+              <a:t>,</a:t>
+            </a:r>
+            <a:r>
+              <a:rPr b="0" i="0">
+                <a:solidFill>
+                  <a:schemeClr val="dk1"/>
+                </a:solidFill>
+                <a:latin typeface="Consolas"/>
+              </a:rPr>
+              <a:t> </a:t>
+            </a:r>
+            <a:r>
+              <a:rPr b="0" i="0">
+                <a:solidFill>
+                  <a:srgbClr val="666666"/>
+                </a:solidFill>
+                <a:latin typeface="Consolas"/>
+              </a:rPr>
+              <a:t>10</a:t>
+            </a:r>
+            <a:r>
+              <a:rPr b="0" i="0">
+                <a:solidFill>
+                  <a:schemeClr val="dk1"/>
+                </a:solidFill>
+                <a:latin typeface="Consolas"/>
+              </a:rPr>
+              <a:t> </a:t>
+            </a:r>
+            <a:r>
+              <a:rPr b="0" i="0">
+                <a:solidFill>
+                  <a:srgbClr val="666666"/>
+                </a:solidFill>
+                <a:latin typeface="Consolas"/>
+              </a:rPr>
+              <a:t>-</a:t>
+            </a:r>
+            <a:r>
+              <a:rPr b="0" i="0">
+                <a:solidFill>
+                  <a:schemeClr val="dk1"/>
+                </a:solidFill>
+                <a:latin typeface="Consolas"/>
+              </a:rPr>
+              <a:t> </a:t>
+            </a:r>
+            <a:r>
+              <a:rPr b="0" i="0">
+                <a:solidFill>
+                  <a:schemeClr val="dk1"/>
+                </a:solidFill>
+                <a:latin typeface="Consolas"/>
+              </a:rPr>
+              <a:t>project</a:t>
+            </a:r>
+            <a:r>
+              <a:rPr b="0" i="0">
+                <a:solidFill>
+                  <a:schemeClr val="dk1"/>
+                </a:solidFill>
+                <a:latin typeface="Consolas"/>
+              </a:rPr>
+              <a:t>.</a:t>
+            </a:r>
+            <a:r>
+              <a:rPr b="0" i="0">
+                <a:solidFill>
+                  <a:schemeClr val="dk1"/>
+                </a:solidFill>
+                <a:latin typeface="Consolas"/>
+              </a:rPr>
+              <a:t>completed</a:t>
+            </a:r>
+            <a:r>
+              <a:rPr b="0" i="0">
+                <a:solidFill>
+                  <a:schemeClr val="dk1"/>
+                </a:solidFill>
+                <a:latin typeface="Consolas"/>
+              </a:rPr>
+              <a:t>)</a:t>
+            </a:r>
+            <a:br/>
+            <a:r>
+              <a:rPr b="0" i="0">
+                <a:solidFill>
+                  <a:schemeClr val="dk1"/>
+                </a:solidFill>
+                <a:latin typeface="Consolas"/>
+              </a:rPr>
+              <a:t>}</a:t>
+            </a:r>
+            <a:br/>
+            <a:br/>
+            <a:r>
+              <a:rPr b="1" i="0">
+                <a:solidFill>
+                  <a:srgbClr val="008000"/>
+                </a:solidFill>
+                <a:latin typeface="Consolas"/>
+              </a:rPr>
+              <a:t>const</a:t>
+            </a:r>
+            <a:r>
+              <a:rPr b="0" i="0">
+                <a:solidFill>
+                  <a:schemeClr val="dk1"/>
+                </a:solidFill>
+                <a:latin typeface="Consolas"/>
+              </a:rPr>
+              <a:t> </a:t>
+            </a:r>
+            <a:r>
+              <a:rPr b="0" i="0">
+                <a:solidFill>
+                  <a:schemeClr val="dk1"/>
+                </a:solidFill>
+                <a:latin typeface="Consolas"/>
+              </a:rPr>
+              <a:t>launch</a:t>
+            </a:r>
+            <a:r>
+              <a:rPr b="0" i="0">
+                <a:solidFill>
+                  <a:schemeClr val="dk1"/>
+                </a:solidFill>
+                <a:latin typeface="Consolas"/>
+              </a:rPr>
+              <a:t> </a:t>
+            </a:r>
+            <a:r>
+              <a:rPr b="0" i="0">
+                <a:solidFill>
+                  <a:srgbClr val="666666"/>
+                </a:solidFill>
+                <a:latin typeface="Consolas"/>
+              </a:rPr>
+              <a:t>=</a:t>
+            </a:r>
+            <a:r>
+              <a:rPr b="0" i="0">
+                <a:solidFill>
+                  <a:schemeClr val="dk1"/>
+                </a:solidFill>
+                <a:latin typeface="Consolas"/>
+              </a:rPr>
+              <a:t> </a:t>
+            </a:r>
+            <a:r>
+              <a:rPr b="0" i="0">
+                <a:solidFill>
+                  <a:schemeClr val="dk1"/>
+                </a:solidFill>
+                <a:latin typeface="Consolas"/>
+              </a:rPr>
+              <a:t>{</a:t>
+            </a:r>
+            <a:r>
+              <a:rPr b="0" i="0">
+                <a:solidFill>
+                  <a:schemeClr val="dk1"/>
+                </a:solidFill>
+                <a:latin typeface="Consolas"/>
+              </a:rPr>
+              <a:t> </a:t>
+            </a:r>
+            <a:r>
+              <a:rPr b="0" i="0">
+                <a:solidFill>
+                  <a:schemeClr val="dk1"/>
+                </a:solidFill>
+                <a:latin typeface="Consolas"/>
+              </a:rPr>
+              <a:t>name</a:t>
+            </a:r>
+            <a:r>
+              <a:rPr b="0" i="0">
+                <a:solidFill>
+                  <a:srgbClr val="666666"/>
+                </a:solidFill>
+                <a:latin typeface="Consolas"/>
+              </a:rPr>
+              <a:t>:</a:t>
+            </a:r>
+            <a:r>
+              <a:rPr b="0" i="0">
+                <a:solidFill>
+                  <a:schemeClr val="dk1"/>
+                </a:solidFill>
+                <a:latin typeface="Consolas"/>
+              </a:rPr>
+              <a:t> </a:t>
+            </a:r>
+            <a:r>
+              <a:rPr b="0" i="0">
+                <a:solidFill>
+                  <a:srgbClr val="BA2121"/>
+                </a:solidFill>
+                <a:latin typeface="Consolas"/>
+              </a:rPr>
+              <a:t>"Launch"</a:t>
+            </a:r>
+            <a:r>
+              <a:rPr b="0" i="0">
+                <a:solidFill>
+                  <a:schemeClr val="dk1"/>
+                </a:solidFill>
+                <a:latin typeface="Consolas"/>
+              </a:rPr>
+              <a:t>,</a:t>
+            </a:r>
+            <a:r>
+              <a:rPr b="0" i="0">
+                <a:solidFill>
+                  <a:schemeClr val="dk1"/>
+                </a:solidFill>
+                <a:latin typeface="Consolas"/>
+              </a:rPr>
+              <a:t> </a:t>
+            </a:r>
+            <a:r>
+              <a:rPr b="0" i="0">
+                <a:solidFill>
+                  <a:schemeClr val="dk1"/>
+                </a:solidFill>
+                <a:latin typeface="Consolas"/>
+              </a:rPr>
+              <a:t>completed</a:t>
+            </a:r>
+            <a:r>
+              <a:rPr b="0" i="0">
+                <a:solidFill>
+                  <a:srgbClr val="666666"/>
+                </a:solidFill>
+                <a:latin typeface="Consolas"/>
+              </a:rPr>
+              <a:t>:</a:t>
+            </a:r>
+            <a:r>
+              <a:rPr b="0" i="0">
+                <a:solidFill>
+                  <a:schemeClr val="dk1"/>
+                </a:solidFill>
+                <a:latin typeface="Consolas"/>
+              </a:rPr>
+              <a:t> </a:t>
+            </a:r>
+            <a:r>
+              <a:rPr b="0" i="0">
+                <a:solidFill>
+                  <a:srgbClr val="B00040"/>
+                </a:solidFill>
+                <a:latin typeface="Consolas"/>
+              </a:rPr>
+              <a:t>7</a:t>
+            </a:r>
+            <a:r>
+              <a:rPr b="0" i="0">
+                <a:solidFill>
+                  <a:schemeClr val="dk1"/>
+                </a:solidFill>
+                <a:latin typeface="Consolas"/>
+              </a:rPr>
+              <a:t> </a:t>
+            </a:r>
+            <a:r>
+              <a:rPr b="0" i="0">
+                <a:solidFill>
+                  <a:schemeClr val="dk1"/>
+                </a:solidFill>
+                <a:latin typeface="Consolas"/>
+              </a:rPr>
+              <a:t>}</a:t>
+            </a:r>
+            <a:br/>
+            <a:r>
+              <a:rPr b="0" i="0">
+                <a:solidFill>
+                  <a:schemeClr val="dk1"/>
+                </a:solidFill>
+                <a:latin typeface="Consolas"/>
+              </a:rPr>
+              <a:t>console</a:t>
+            </a:r>
+            <a:r>
+              <a:rPr b="0" i="0">
+                <a:solidFill>
+                  <a:schemeClr val="dk1"/>
+                </a:solidFill>
+                <a:latin typeface="Consolas"/>
+              </a:rPr>
+              <a:t>.</a:t>
+            </a:r>
+            <a:r>
+              <a:rPr b="0" i="0">
+                <a:solidFill>
+                  <a:schemeClr val="dk1"/>
+                </a:solidFill>
+                <a:latin typeface="Consolas"/>
+              </a:rPr>
+              <a:t>log</a:t>
+            </a:r>
+            <a:r>
+              <a:rPr b="0" i="0">
+                <a:solidFill>
+                  <a:schemeClr val="dk1"/>
+                </a:solidFill>
+                <a:latin typeface="Consolas"/>
+              </a:rPr>
+              <a:t>(</a:t>
+            </a:r>
+            <a:r>
+              <a:rPr b="0" i="0">
+                <a:solidFill>
+                  <a:srgbClr val="BA2121"/>
+                </a:solidFill>
+                <a:latin typeface="Consolas"/>
+              </a:rPr>
+              <a:t>`</a:t>
+            </a:r>
+            <a:r>
+              <a:rPr b="0" i="0">
+                <a:solidFill>
+                  <a:srgbClr val="BA2121"/>
+                </a:solidFill>
+                <a:latin typeface="Consolas"/>
+              </a:rPr>
+              <a:t>Remaining: </a:t>
+            </a:r>
+            <a:r>
+              <a:rPr b="1" i="0">
+                <a:solidFill>
+                  <a:srgbClr val="A45A77"/>
+                </a:solidFill>
+                <a:latin typeface="Consolas"/>
+              </a:rPr>
+              <a:t>${</a:t>
+            </a:r>
+            <a:r>
+              <a:rPr b="0" i="0">
+                <a:solidFill>
+                  <a:schemeClr val="dk1"/>
+                </a:solidFill>
+                <a:latin typeface="Consolas"/>
+              </a:rPr>
+              <a:t>remaining</a:t>
+            </a:r>
+            <a:r>
+              <a:rPr b="0" i="0">
+                <a:solidFill>
+                  <a:schemeClr val="dk1"/>
+                </a:solidFill>
+                <a:latin typeface="Consolas"/>
+              </a:rPr>
+              <a:t>(</a:t>
+            </a:r>
+            <a:r>
+              <a:rPr b="0" i="0">
+                <a:solidFill>
+                  <a:schemeClr val="dk1"/>
+                </a:solidFill>
+                <a:latin typeface="Consolas"/>
+              </a:rPr>
+              <a:t>launch</a:t>
+            </a:r>
+            <a:r>
+              <a:rPr b="0" i="0">
+                <a:solidFill>
+                  <a:schemeClr val="dk1"/>
+                </a:solidFill>
+                <a:latin typeface="Consolas"/>
+              </a:rPr>
+              <a:t>)</a:t>
+            </a:r>
+            <a:r>
+              <a:rPr b="1" i="0">
+                <a:solidFill>
+                  <a:srgbClr val="A45A77"/>
+                </a:solidFill>
+                <a:latin typeface="Consolas"/>
+              </a:rPr>
+              <a:t>}</a:t>
+            </a:r>
+            <a:r>
+              <a:rPr b="0" i="0">
+                <a:solidFill>
+                  <a:srgbClr val="BA2121"/>
+                </a:solidFill>
+                <a:latin typeface="Consolas"/>
+              </a:rPr>
+              <a:t>`</a:t>
+            </a:r>
+            <a:r>
+              <a:rPr b="0" i="0">
+                <a:solidFill>
+                  <a:schemeClr val="dk1"/>
+                </a:solidFill>
+                <a:latin typeface="Consolas"/>
+              </a:rPr>
+              <a:t>)</a:t>
+            </a:r>
+            <a:endParaRPr>
+              <a:solidFill>
+                <a:schemeClr val="dk1"/>
+              </a:solidFill>
+            </a:endParaRPr>
+          </a:p>
+        </p:txBody>
+      </p:sp>
+    </p:spTree>
+  </p:cSld>
+  <p:clrMapOvr>
+    <a:masterClrMapping/>
+  </p:clrMapOvr>
+</p:sld>
+</file>
+
+<file path=ppt/slides/slide3.xml><?xml version="1.0" encoding="utf-8"?>
+<p:sld xmlns:a="http://schemas.openxmlformats.org/drawingml/2006/main" xmlns:p="http://schemas.openxmlformats.org/presentationml/2006/main" xmlns:r="http://schemas.openxmlformats.org/officeDocument/2006/relationships">
+  <p:cSld>
+    <p:spTree>
+      <p:nvGrpSpPr>
+        <p:cNvPr id="1" name=""/>
+        <p:cNvGrpSpPr/>
+        <p:nvPr/>
+      </p:nvGrpSpPr>
+      <p:grpSpPr/>
+      <p:sp>
+        <p:nvSpPr>
+          <p:cNvPr id="2" name="Title 1"/>
+          <p:cNvSpPr>
+            <a:spLocks noGrp="1"/>
+          </p:cNvSpPr>
+          <p:nvPr>
+            <p:ph type="title"/>
+          </p:nvPr>
+        </p:nvSpPr>
+        <p:spPr/>
+        <p:txBody>
+          <a:bodyPr>
+            <a:normAutofit/>
+          </a:bodyPr>
+          <a:lstStyle/>
+          <a:p>
+            <a:pPr>
+              <a:defRPr>
+                <a:solidFill>
+                  <a:schemeClr val="accent6"/>
+                </a:solidFill>
+              </a:defRPr>
+            </a:pPr>
+            <a:r>
+              <a:rPr>
+                <a:solidFill>
+                  <a:schemeClr val="accent6"/>
+                </a:solidFill>
+              </a:rPr>
+              <a:t>How the format works</a:t>
+            </a:r>
+            <a:endParaRPr>
+              <a:solidFill>
+                <a:schemeClr val="accent6"/>
+              </a:solidFill>
+            </a:endParaRPr>
+          </a:p>
+        </p:txBody>
+      </p:sp>
+      <p:sp>
+        <p:nvSpPr>
+          <p:cNvPr id="3" name="Content Placeholder 2"/>
+          <p:cNvSpPr>
+            <a:spLocks noGrp="1"/>
+          </p:cNvSpPr>
+          <p:nvPr>
+            <p:ph idx="1"/>
+          </p:nvPr>
+        </p:nvSpPr>
+        <p:spPr/>
+        <p:txBody>
+          <a:bodyPr wrap="square">
+            <a:normAutofit/>
+          </a:bodyPr>
+          <a:lstStyle/>
+          <a:p>
+            <a:pPr marL="0" indent="0">
+              <a:buNone/>
+              <a:defRPr>
+                <a:solidFill>
+                  <a:schemeClr val="dk1"/>
+                </a:solidFill>
+              </a:defRPr>
+            </a:pPr>
+            <a:r>
+              <a:rPr b="0" i="0">
+                <a:solidFill>
+                  <a:schemeClr val="dk1"/>
+                </a:solidFill>
+                <a:latin typeface="+mn-lt"/>
+                <a:ea typeface="+mn-ea"/>
+                <a:cs typeface="+mn-cs"/>
+              </a:rPr>
+              <a:t>An optional document front matter block sets deck-wide defaults such as aspect ratio, fonts, colors, and background behavior.</a:t>
+            </a:r>
+            <a:endParaRPr>
+              <a:solidFill>
+                <a:schemeClr val="dk1"/>
+              </a:solidFill>
+            </a:endParaRPr>
+          </a:p>
+          <a:p>
+            <a:pPr marL="0" indent="0">
+              <a:buNone/>
+              <a:defRPr>
+                <a:solidFill>
+                  <a:schemeClr val="dk1"/>
+                </a:solidFill>
+              </a:defRPr>
+            </a:pPr>
+            <a:r>
+              <a:rPr b="0" i="0">
+                <a:solidFill>
+                  <a:schemeClr val="dk1"/>
+                </a:solidFill>
+                <a:latin typeface="+mn-lt"/>
+                <a:ea typeface="+mn-ea"/>
+                <a:cs typeface="+mn-cs"/>
+              </a:rPr>
+              <a:t>Each ATX </a:t>
+            </a:r>
+            <a:r>
+              <a:rPr b="0" i="0">
+                <a:solidFill>
+                  <a:schemeClr val="dk1"/>
+                </a:solidFill>
+                <a:latin typeface="Consolas"/>
+              </a:rPr>
+              <a:t># H1</a:t>
+            </a:r>
+            <a:r>
+              <a:rPr b="0" i="0">
+                <a:solidFill>
+                  <a:schemeClr val="dk1"/>
+                </a:solidFill>
+                <a:latin typeface="+mn-lt"/>
+                <a:ea typeface="+mn-ea"/>
+                <a:cs typeface="+mn-cs"/>
+              </a:rPr>
+              <a:t> or Setext H1 starts a new slide. Optional slide front matter appears immediately after the heading. Everything until the next H1 belongs to that slide.</a:t>
+            </a:r>
+            <a:endParaRPr>
+              <a:solidFill>
+                <a:schemeClr val="dk1"/>
+              </a:solidFill>
+            </a:endParaRPr>
+          </a:p>
+        </p:txBody>
+      </p:sp>
+    </p:spTree>
+  </p:cSld>
+  <p:clrMapOvr>
+    <a:masterClrMapping/>
+  </p:clrMapOvr>
+</p:sld>
+</file>
+
+<file path=ppt/slides/slide30.xml><?xml version="1.0" encoding="utf-8"?>
+<p:sld xmlns:a="http://schemas.openxmlformats.org/drawingml/2006/main" xmlns:p="http://schemas.openxmlformats.org/presentationml/2006/main" xmlns:r="http://schemas.openxmlformats.org/officeDocument/2006/relationships">
+  <p:cSld>
+    <p:spTree>
+      <p:nvGrpSpPr>
+        <p:cNvPr id="1" name=""/>
+        <p:cNvGrpSpPr/>
+        <p:nvPr/>
+      </p:nvGrpSpPr>
+      <p:grpSpPr/>
+      <p:sp>
+        <p:nvSpPr>
+          <p:cNvPr id="2" name="Title 1"/>
+          <p:cNvSpPr>
+            <a:spLocks noGrp="1"/>
+          </p:cNvSpPr>
+          <p:nvPr>
+            <p:ph type="title"/>
+          </p:nvPr>
+        </p:nvSpPr>
+        <p:spPr/>
+        <p:txBody>
+          <a:bodyPr>
+            <a:normAutofit/>
+          </a:bodyPr>
+          <a:lstStyle/>
+          <a:p>
+            <a:pPr>
+              <a:defRPr>
+                <a:solidFill>
+                  <a:schemeClr val="accent6"/>
+                </a:solidFill>
+              </a:defRPr>
+            </a:pPr>
+            <a:r>
+              <a:rPr>
+                <a:solidFill>
+                  <a:schemeClr val="accent6"/>
+                </a:solidFill>
+              </a:rPr>
+              <a:t>Syntax highlighting: HTML</a:t>
+            </a:r>
+            <a:endParaRPr>
+              <a:solidFill>
+                <a:schemeClr val="accent6"/>
+              </a:solidFill>
+            </a:endParaRPr>
+          </a:p>
+        </p:txBody>
+      </p:sp>
+      <p:sp>
+        <p:nvSpPr>
+          <p:cNvPr id="3" name="Content Placeholder 2"/>
+          <p:cNvSpPr>
+            <a:spLocks noGrp="1"/>
+          </p:cNvSpPr>
+          <p:nvPr>
+            <p:ph idx="1"/>
+          </p:nvPr>
+        </p:nvSpPr>
+        <p:spPr/>
+        <p:txBody>
+          <a:bodyPr wrap="square">
+            <a:normAutofit/>
+          </a:bodyPr>
+          <a:lstStyle/>
+          <a:p>
+            <a:pPr marL="0" indent="0">
+              <a:buNone/>
+              <a:defRPr>
+                <a:solidFill>
+                  <a:schemeClr val="dk1"/>
+                </a:solidFill>
+              </a:defRPr>
+            </a:pPr>
+            <a:r>
+              <a:rPr b="0" i="1">
+                <a:solidFill>
+                  <a:srgbClr val="3D7B7B"/>
+                </a:solidFill>
+                <a:latin typeface="Consolas"/>
+              </a:rPr>
+              <a:t>&lt;!-- A compact project card --&gt;</a:t>
+            </a:r>
+            <a:br/>
+            <a:r>
+              <a:rPr b="0" i="0">
+                <a:solidFill>
+                  <a:schemeClr val="dk1"/>
+                </a:solidFill>
+                <a:latin typeface="Consolas"/>
+              </a:rPr>
+              <a:t>&lt;</a:t>
+            </a:r>
+            <a:r>
+              <a:rPr b="1" i="0">
+                <a:solidFill>
+                  <a:srgbClr val="008000"/>
+                </a:solidFill>
+                <a:latin typeface="Consolas"/>
+              </a:rPr>
+              <a:t>article</a:t>
+            </a:r>
+            <a:r>
+              <a:rPr b="0" i="0">
+                <a:solidFill>
+                  <a:schemeClr val="dk1"/>
+                </a:solidFill>
+                <a:latin typeface="Consolas"/>
+              </a:rPr>
+              <a:t> </a:t>
+            </a:r>
+            <a:r>
+              <a:rPr b="0" i="0">
+                <a:solidFill>
+                  <a:srgbClr val="687822"/>
+                </a:solidFill>
+                <a:latin typeface="Consolas"/>
+              </a:rPr>
+              <a:t>class</a:t>
+            </a:r>
+            <a:r>
+              <a:rPr b="0" i="0">
+                <a:solidFill>
+                  <a:srgbClr val="666666"/>
+                </a:solidFill>
+                <a:latin typeface="Consolas"/>
+              </a:rPr>
+              <a:t>=</a:t>
+            </a:r>
+            <a:r>
+              <a:rPr b="0" i="0">
+                <a:solidFill>
+                  <a:srgbClr val="BA2121"/>
+                </a:solidFill>
+                <a:latin typeface="Consolas"/>
+              </a:rPr>
+              <a:t>"project-card"</a:t>
+            </a:r>
+            <a:r>
+              <a:rPr b="0" i="0">
+                <a:solidFill>
+                  <a:schemeClr val="dk1"/>
+                </a:solidFill>
+                <a:latin typeface="Consolas"/>
+              </a:rPr>
+              <a:t>&gt;</a:t>
+            </a:r>
+            <a:br/>
+            <a:r>
+              <a:rPr b="0" i="0">
+                <a:solidFill>
+                  <a:schemeClr val="dk1"/>
+                </a:solidFill>
+                <a:latin typeface="Consolas"/>
+              </a:rPr>
+              <a:t>  </a:t>
+            </a:r>
+            <a:r>
+              <a:rPr b="0" i="0">
+                <a:solidFill>
+                  <a:schemeClr val="dk1"/>
+                </a:solidFill>
+                <a:latin typeface="Consolas"/>
+              </a:rPr>
+              <a:t>&lt;</a:t>
+            </a:r>
+            <a:r>
+              <a:rPr b="1" i="0">
+                <a:solidFill>
+                  <a:srgbClr val="008000"/>
+                </a:solidFill>
+                <a:latin typeface="Consolas"/>
+              </a:rPr>
+              <a:t>h2</a:t>
+            </a:r>
+            <a:r>
+              <a:rPr b="0" i="0">
+                <a:solidFill>
+                  <a:schemeClr val="dk1"/>
+                </a:solidFill>
+                <a:latin typeface="Consolas"/>
+              </a:rPr>
+              <a:t> </a:t>
+            </a:r>
+            <a:r>
+              <a:rPr b="0" i="0">
+                <a:solidFill>
+                  <a:srgbClr val="687822"/>
+                </a:solidFill>
+                <a:latin typeface="Consolas"/>
+              </a:rPr>
+              <a:t>id</a:t>
+            </a:r>
+            <a:r>
+              <a:rPr b="0" i="0">
+                <a:solidFill>
+                  <a:srgbClr val="666666"/>
+                </a:solidFill>
+                <a:latin typeface="Consolas"/>
+              </a:rPr>
+              <a:t>=</a:t>
+            </a:r>
+            <a:r>
+              <a:rPr b="0" i="0">
+                <a:solidFill>
+                  <a:srgbClr val="BA2121"/>
+                </a:solidFill>
+                <a:latin typeface="Consolas"/>
+              </a:rPr>
+              <a:t>"title"</a:t>
+            </a:r>
+            <a:r>
+              <a:rPr b="0" i="0">
+                <a:solidFill>
+                  <a:schemeClr val="dk1"/>
+                </a:solidFill>
+                <a:latin typeface="Consolas"/>
+              </a:rPr>
+              <a:t>&gt;</a:t>
+            </a:r>
+            <a:r>
+              <a:rPr b="0" i="0">
+                <a:solidFill>
+                  <a:schemeClr val="dk1"/>
+                </a:solidFill>
+                <a:latin typeface="Consolas"/>
+              </a:rPr>
+              <a:t>Launch checklist</a:t>
+            </a:r>
+            <a:r>
+              <a:rPr b="0" i="0">
+                <a:solidFill>
+                  <a:schemeClr val="dk1"/>
+                </a:solidFill>
+                <a:latin typeface="Consolas"/>
+              </a:rPr>
+              <a:t>&lt;</a:t>
+            </a:r>
+            <a:r>
+              <a:rPr b="0" i="0">
+                <a:solidFill>
+                  <a:schemeClr val="dk1"/>
+                </a:solidFill>
+                <a:latin typeface="Consolas"/>
+              </a:rPr>
+              <a:t>/</a:t>
+            </a:r>
+            <a:r>
+              <a:rPr b="1" i="0">
+                <a:solidFill>
+                  <a:srgbClr val="008000"/>
+                </a:solidFill>
+                <a:latin typeface="Consolas"/>
+              </a:rPr>
+              <a:t>h2</a:t>
+            </a:r>
+            <a:r>
+              <a:rPr b="0" i="0">
+                <a:solidFill>
+                  <a:schemeClr val="dk1"/>
+                </a:solidFill>
+                <a:latin typeface="Consolas"/>
+              </a:rPr>
+              <a:t>&gt;</a:t>
+            </a:r>
+            <a:br/>
+            <a:r>
+              <a:rPr b="0" i="0">
+                <a:solidFill>
+                  <a:schemeClr val="dk1"/>
+                </a:solidFill>
+                <a:latin typeface="Consolas"/>
+              </a:rPr>
+              <a:t>  </a:t>
+            </a:r>
+            <a:r>
+              <a:rPr b="0" i="0">
+                <a:solidFill>
+                  <a:schemeClr val="dk1"/>
+                </a:solidFill>
+                <a:latin typeface="Consolas"/>
+              </a:rPr>
+              <a:t>&lt;</a:t>
+            </a:r>
+            <a:r>
+              <a:rPr b="1" i="0">
+                <a:solidFill>
+                  <a:srgbClr val="008000"/>
+                </a:solidFill>
+                <a:latin typeface="Consolas"/>
+              </a:rPr>
+              <a:t>p</a:t>
+            </a:r>
+            <a:r>
+              <a:rPr b="0" i="0">
+                <a:solidFill>
+                  <a:schemeClr val="dk1"/>
+                </a:solidFill>
+                <a:latin typeface="Consolas"/>
+              </a:rPr>
+              <a:t>&gt;</a:t>
+            </a:r>
+            <a:r>
+              <a:rPr b="0" i="0">
+                <a:solidFill>
+                  <a:schemeClr val="dk1"/>
+                </a:solidFill>
+                <a:latin typeface="Consolas"/>
+              </a:rPr>
+              <a:t>Three steps remain before release.</a:t>
+            </a:r>
+            <a:r>
+              <a:rPr b="0" i="0">
+                <a:solidFill>
+                  <a:schemeClr val="dk1"/>
+                </a:solidFill>
+                <a:latin typeface="Consolas"/>
+              </a:rPr>
+              <a:t>&lt;</a:t>
+            </a:r>
+            <a:r>
+              <a:rPr b="0" i="0">
+                <a:solidFill>
+                  <a:schemeClr val="dk1"/>
+                </a:solidFill>
+                <a:latin typeface="Consolas"/>
+              </a:rPr>
+              <a:t>/</a:t>
+            </a:r>
+            <a:r>
+              <a:rPr b="1" i="0">
+                <a:solidFill>
+                  <a:srgbClr val="008000"/>
+                </a:solidFill>
+                <a:latin typeface="Consolas"/>
+              </a:rPr>
+              <a:t>p</a:t>
+            </a:r>
+            <a:r>
+              <a:rPr b="0" i="0">
+                <a:solidFill>
+                  <a:schemeClr val="dk1"/>
+                </a:solidFill>
+                <a:latin typeface="Consolas"/>
+              </a:rPr>
+              <a:t>&gt;</a:t>
+            </a:r>
+            <a:br/>
+            <a:r>
+              <a:rPr b="0" i="0">
+                <a:solidFill>
+                  <a:schemeClr val="dk1"/>
+                </a:solidFill>
+                <a:latin typeface="Consolas"/>
+              </a:rPr>
+              <a:t>  </a:t>
+            </a:r>
+            <a:r>
+              <a:rPr b="0" i="0">
+                <a:solidFill>
+                  <a:schemeClr val="dk1"/>
+                </a:solidFill>
+                <a:latin typeface="Consolas"/>
+              </a:rPr>
+              <a:t>&lt;</a:t>
+            </a:r>
+            <a:r>
+              <a:rPr b="1" i="0">
+                <a:solidFill>
+                  <a:srgbClr val="008000"/>
+                </a:solidFill>
+                <a:latin typeface="Consolas"/>
+              </a:rPr>
+              <a:t>ul</a:t>
+            </a:r>
+            <a:r>
+              <a:rPr b="0" i="0">
+                <a:solidFill>
+                  <a:schemeClr val="dk1"/>
+                </a:solidFill>
+                <a:latin typeface="Consolas"/>
+              </a:rPr>
+              <a:t>&gt;</a:t>
+            </a:r>
+            <a:br/>
+            <a:r>
+              <a:rPr b="0" i="0">
+                <a:solidFill>
+                  <a:schemeClr val="dk1"/>
+                </a:solidFill>
+                <a:latin typeface="Consolas"/>
+              </a:rPr>
+              <a:t>    </a:t>
+            </a:r>
+            <a:r>
+              <a:rPr b="0" i="0">
+                <a:solidFill>
+                  <a:schemeClr val="dk1"/>
+                </a:solidFill>
+                <a:latin typeface="Consolas"/>
+              </a:rPr>
+              <a:t>&lt;</a:t>
+            </a:r>
+            <a:r>
+              <a:rPr b="1" i="0">
+                <a:solidFill>
+                  <a:srgbClr val="008000"/>
+                </a:solidFill>
+                <a:latin typeface="Consolas"/>
+              </a:rPr>
+              <a:t>li</a:t>
+            </a:r>
+            <a:r>
+              <a:rPr b="0" i="0">
+                <a:solidFill>
+                  <a:schemeClr val="dk1"/>
+                </a:solidFill>
+                <a:latin typeface="Consolas"/>
+              </a:rPr>
+              <a:t>&gt;</a:t>
+            </a:r>
+            <a:r>
+              <a:rPr b="0" i="0">
+                <a:solidFill>
+                  <a:schemeClr val="dk1"/>
+                </a:solidFill>
+                <a:latin typeface="Consolas"/>
+              </a:rPr>
+              <a:t>Review the preview</a:t>
+            </a:r>
+            <a:r>
+              <a:rPr b="0" i="0">
+                <a:solidFill>
+                  <a:schemeClr val="dk1"/>
+                </a:solidFill>
+                <a:latin typeface="Consolas"/>
+              </a:rPr>
+              <a:t>&lt;</a:t>
+            </a:r>
+            <a:r>
+              <a:rPr b="0" i="0">
+                <a:solidFill>
+                  <a:schemeClr val="dk1"/>
+                </a:solidFill>
+                <a:latin typeface="Consolas"/>
+              </a:rPr>
+              <a:t>/</a:t>
+            </a:r>
+            <a:r>
+              <a:rPr b="1" i="0">
+                <a:solidFill>
+                  <a:srgbClr val="008000"/>
+                </a:solidFill>
+                <a:latin typeface="Consolas"/>
+              </a:rPr>
+              <a:t>li</a:t>
+            </a:r>
+            <a:r>
+              <a:rPr b="0" i="0">
+                <a:solidFill>
+                  <a:schemeClr val="dk1"/>
+                </a:solidFill>
+                <a:latin typeface="Consolas"/>
+              </a:rPr>
+              <a:t>&gt;</a:t>
+            </a:r>
+            <a:br/>
+            <a:r>
+              <a:rPr b="0" i="0">
+                <a:solidFill>
+                  <a:schemeClr val="dk1"/>
+                </a:solidFill>
+                <a:latin typeface="Consolas"/>
+              </a:rPr>
+              <a:t>    </a:t>
+            </a:r>
+            <a:r>
+              <a:rPr b="0" i="0">
+                <a:solidFill>
+                  <a:schemeClr val="dk1"/>
+                </a:solidFill>
+                <a:latin typeface="Consolas"/>
+              </a:rPr>
+              <a:t>&lt;</a:t>
+            </a:r>
+            <a:r>
+              <a:rPr b="1" i="0">
+                <a:solidFill>
+                  <a:srgbClr val="008000"/>
+                </a:solidFill>
+                <a:latin typeface="Consolas"/>
+              </a:rPr>
+              <a:t>li</a:t>
+            </a:r>
+            <a:r>
+              <a:rPr b="0" i="0">
+                <a:solidFill>
+                  <a:schemeClr val="dk1"/>
+                </a:solidFill>
+                <a:latin typeface="Consolas"/>
+              </a:rPr>
+              <a:t>&gt;</a:t>
+            </a:r>
+            <a:r>
+              <a:rPr b="0" i="0">
+                <a:solidFill>
+                  <a:schemeClr val="dk1"/>
+                </a:solidFill>
+                <a:latin typeface="Consolas"/>
+              </a:rPr>
+              <a:t>Publish the update</a:t>
+            </a:r>
+            <a:r>
+              <a:rPr b="0" i="0">
+                <a:solidFill>
+                  <a:schemeClr val="dk1"/>
+                </a:solidFill>
+                <a:latin typeface="Consolas"/>
+              </a:rPr>
+              <a:t>&lt;</a:t>
+            </a:r>
+            <a:r>
+              <a:rPr b="0" i="0">
+                <a:solidFill>
+                  <a:schemeClr val="dk1"/>
+                </a:solidFill>
+                <a:latin typeface="Consolas"/>
+              </a:rPr>
+              <a:t>/</a:t>
+            </a:r>
+            <a:r>
+              <a:rPr b="1" i="0">
+                <a:solidFill>
+                  <a:srgbClr val="008000"/>
+                </a:solidFill>
+                <a:latin typeface="Consolas"/>
+              </a:rPr>
+              <a:t>li</a:t>
+            </a:r>
+            <a:r>
+              <a:rPr b="0" i="0">
+                <a:solidFill>
+                  <a:schemeClr val="dk1"/>
+                </a:solidFill>
+                <a:latin typeface="Consolas"/>
+              </a:rPr>
+              <a:t>&gt;</a:t>
+            </a:r>
+            <a:br/>
+            <a:r>
+              <a:rPr b="0" i="0">
+                <a:solidFill>
+                  <a:schemeClr val="dk1"/>
+                </a:solidFill>
+                <a:latin typeface="Consolas"/>
+              </a:rPr>
+              <a:t>  </a:t>
+            </a:r>
+            <a:r>
+              <a:rPr b="0" i="0">
+                <a:solidFill>
+                  <a:schemeClr val="dk1"/>
+                </a:solidFill>
+                <a:latin typeface="Consolas"/>
+              </a:rPr>
+              <a:t>&lt;</a:t>
+            </a:r>
+            <a:r>
+              <a:rPr b="0" i="0">
+                <a:solidFill>
+                  <a:schemeClr val="dk1"/>
+                </a:solidFill>
+                <a:latin typeface="Consolas"/>
+              </a:rPr>
+              <a:t>/</a:t>
+            </a:r>
+            <a:r>
+              <a:rPr b="1" i="0">
+                <a:solidFill>
+                  <a:srgbClr val="008000"/>
+                </a:solidFill>
+                <a:latin typeface="Consolas"/>
+              </a:rPr>
+              <a:t>ul</a:t>
+            </a:r>
+            <a:r>
+              <a:rPr b="0" i="0">
+                <a:solidFill>
+                  <a:schemeClr val="dk1"/>
+                </a:solidFill>
+                <a:latin typeface="Consolas"/>
+              </a:rPr>
+              <a:t>&gt;</a:t>
+            </a:r>
+            <a:br/>
+            <a:r>
+              <a:rPr b="0" i="0">
+                <a:solidFill>
+                  <a:schemeClr val="dk1"/>
+                </a:solidFill>
+                <a:latin typeface="Consolas"/>
+              </a:rPr>
+              <a:t>  </a:t>
+            </a:r>
+            <a:r>
+              <a:rPr b="0" i="0">
+                <a:solidFill>
+                  <a:schemeClr val="dk1"/>
+                </a:solidFill>
+                <a:latin typeface="Consolas"/>
+              </a:rPr>
+              <a:t>&lt;</a:t>
+            </a:r>
+            <a:r>
+              <a:rPr b="1" i="0">
+                <a:solidFill>
+                  <a:srgbClr val="008000"/>
+                </a:solidFill>
+                <a:latin typeface="Consolas"/>
+              </a:rPr>
+              <a:t>a</a:t>
+            </a:r>
+            <a:r>
+              <a:rPr b="0" i="0">
+                <a:solidFill>
+                  <a:schemeClr val="dk1"/>
+                </a:solidFill>
+                <a:latin typeface="Consolas"/>
+              </a:rPr>
+              <a:t> </a:t>
+            </a:r>
+            <a:r>
+              <a:rPr b="0" i="0">
+                <a:solidFill>
+                  <a:srgbClr val="687822"/>
+                </a:solidFill>
+                <a:latin typeface="Consolas"/>
+              </a:rPr>
+              <a:t>href</a:t>
+            </a:r>
+            <a:r>
+              <a:rPr b="0" i="0">
+                <a:solidFill>
+                  <a:srgbClr val="666666"/>
+                </a:solidFill>
+                <a:latin typeface="Consolas"/>
+              </a:rPr>
+              <a:t>=</a:t>
+            </a:r>
+            <a:r>
+              <a:rPr b="0" i="0">
+                <a:solidFill>
+                  <a:srgbClr val="BA2121"/>
+                </a:solidFill>
+                <a:latin typeface="Consolas"/>
+              </a:rPr>
+              <a:t>"/projects/launch"</a:t>
+            </a:r>
+            <a:r>
+              <a:rPr b="0" i="0">
+                <a:solidFill>
+                  <a:schemeClr val="dk1"/>
+                </a:solidFill>
+                <a:latin typeface="Consolas"/>
+              </a:rPr>
+              <a:t>&gt;</a:t>
+            </a:r>
+            <a:r>
+              <a:rPr b="0" i="0">
+                <a:solidFill>
+                  <a:schemeClr val="dk1"/>
+                </a:solidFill>
+                <a:latin typeface="Consolas"/>
+              </a:rPr>
+              <a:t>View project</a:t>
+            </a:r>
+            <a:r>
+              <a:rPr b="0" i="0">
+                <a:solidFill>
+                  <a:schemeClr val="dk1"/>
+                </a:solidFill>
+                <a:latin typeface="Consolas"/>
+              </a:rPr>
+              <a:t>&lt;</a:t>
+            </a:r>
+            <a:r>
+              <a:rPr b="0" i="0">
+                <a:solidFill>
+                  <a:schemeClr val="dk1"/>
+                </a:solidFill>
+                <a:latin typeface="Consolas"/>
+              </a:rPr>
+              <a:t>/</a:t>
+            </a:r>
+            <a:r>
+              <a:rPr b="1" i="0">
+                <a:solidFill>
+                  <a:srgbClr val="008000"/>
+                </a:solidFill>
+                <a:latin typeface="Consolas"/>
+              </a:rPr>
+              <a:t>a</a:t>
+            </a:r>
+            <a:r>
+              <a:rPr b="0" i="0">
+                <a:solidFill>
+                  <a:schemeClr val="dk1"/>
+                </a:solidFill>
+                <a:latin typeface="Consolas"/>
+              </a:rPr>
+              <a:t>&gt;</a:t>
+            </a:r>
+            <a:br/>
+            <a:r>
+              <a:rPr b="0" i="0">
+                <a:solidFill>
+                  <a:schemeClr val="dk1"/>
+                </a:solidFill>
+                <a:latin typeface="Consolas"/>
+              </a:rPr>
+              <a:t>&lt;</a:t>
+            </a:r>
+            <a:r>
+              <a:rPr b="0" i="0">
+                <a:solidFill>
+                  <a:schemeClr val="dk1"/>
+                </a:solidFill>
+                <a:latin typeface="Consolas"/>
+              </a:rPr>
+              <a:t>/</a:t>
+            </a:r>
+            <a:r>
+              <a:rPr b="1" i="0">
+                <a:solidFill>
+                  <a:srgbClr val="008000"/>
+                </a:solidFill>
+                <a:latin typeface="Consolas"/>
+              </a:rPr>
+              <a:t>article</a:t>
+            </a:r>
+            <a:r>
+              <a:rPr b="0" i="0">
+                <a:solidFill>
+                  <a:schemeClr val="dk1"/>
+                </a:solidFill>
+                <a:latin typeface="Consolas"/>
+              </a:rPr>
+              <a:t>&gt;</a:t>
+            </a:r>
+            <a:endParaRPr>
+              <a:solidFill>
+                <a:schemeClr val="dk1"/>
+              </a:solidFill>
+            </a:endParaRPr>
+          </a:p>
+        </p:txBody>
+      </p:sp>
+    </p:spTree>
+  </p:cSld>
+  <p:clrMapOvr>
+    <a:masterClrMapping/>
+  </p:clrMapOvr>
+</p:sld>
+</file>
+
+<file path=ppt/slides/slide31.xml><?xml version="1.0" encoding="utf-8"?>
+<p:sld xmlns:a="http://schemas.openxmlformats.org/drawingml/2006/main" xmlns:p="http://schemas.openxmlformats.org/presentationml/2006/main" xmlns:r="http://schemas.openxmlformats.org/officeDocument/2006/relationships">
+  <p:cSld>
+    <p:spTree>
+      <p:nvGrpSpPr>
+        <p:cNvPr id="1" name=""/>
+        <p:cNvGrpSpPr/>
+        <p:nvPr/>
+      </p:nvGrpSpPr>
+      <p:grpSpPr/>
+      <p:sp>
+        <p:nvSpPr>
+          <p:cNvPr id="2" name="Title 1"/>
+          <p:cNvSpPr>
+            <a:spLocks noGrp="1"/>
+          </p:cNvSpPr>
+          <p:nvPr>
+            <p:ph type="title"/>
+          </p:nvPr>
+        </p:nvSpPr>
+        <p:spPr/>
+        <p:txBody>
+          <a:bodyPr>
+            <a:normAutofit/>
+          </a:bodyPr>
+          <a:lstStyle/>
+          <a:p>
+            <a:pPr>
+              <a:defRPr>
+                <a:solidFill>
+                  <a:schemeClr val="accent6"/>
+                </a:solidFill>
+              </a:defRPr>
+            </a:pPr>
+            <a:r>
+              <a:rPr>
+                <a:solidFill>
+                  <a:schemeClr val="accent6"/>
+                </a:solidFill>
+              </a:rPr>
+              <a:t>Syntax highlighting: CSS</a:t>
+            </a:r>
+            <a:endParaRPr>
+              <a:solidFill>
+                <a:schemeClr val="accent6"/>
+              </a:solidFill>
+            </a:endParaRPr>
+          </a:p>
+        </p:txBody>
+      </p:sp>
+      <p:sp>
+        <p:nvSpPr>
+          <p:cNvPr id="3" name="Content Placeholder 2"/>
+          <p:cNvSpPr>
+            <a:spLocks noGrp="1"/>
+          </p:cNvSpPr>
+          <p:nvPr>
+            <p:ph idx="1"/>
+          </p:nvPr>
+        </p:nvSpPr>
+        <p:spPr/>
+        <p:txBody>
+          <a:bodyPr wrap="square">
+            <a:normAutofit/>
+          </a:bodyPr>
+          <a:lstStyle/>
+          <a:p>
+            <a:pPr marL="0" indent="0">
+              <a:buNone/>
+              <a:defRPr>
+                <a:solidFill>
+                  <a:schemeClr val="dk1"/>
+                </a:solidFill>
+              </a:defRPr>
+            </a:pPr>
+            <a:r>
+              <a:rPr b="0" i="1">
+                <a:solidFill>
+                  <a:srgbClr val="3D7B7B"/>
+                </a:solidFill>
+                <a:latin typeface="Consolas"/>
+              </a:rPr>
+              <a:t>/* Style the project card */</a:t>
+            </a:r>
+            <a:br/>
+            <a:r>
+              <a:rPr b="0" i="0">
+                <a:solidFill>
+                  <a:schemeClr val="dk1"/>
+                </a:solidFill>
+                <a:latin typeface="Consolas"/>
+              </a:rPr>
+              <a:t>.</a:t>
+            </a:r>
+            <a:r>
+              <a:rPr b="1" i="0">
+                <a:solidFill>
+                  <a:srgbClr val="0000FF"/>
+                </a:solidFill>
+                <a:latin typeface="Consolas"/>
+              </a:rPr>
+              <a:t>project-card</a:t>
+            </a:r>
+            <a:r>
+              <a:rPr b="0" i="0">
+                <a:solidFill>
+                  <a:schemeClr val="dk1"/>
+                </a:solidFill>
+                <a:latin typeface="Consolas"/>
+              </a:rPr>
+              <a:t> </a:t>
+            </a:r>
+            <a:r>
+              <a:rPr b="0" i="0">
+                <a:solidFill>
+                  <a:schemeClr val="dk1"/>
+                </a:solidFill>
+                <a:latin typeface="Consolas"/>
+              </a:rPr>
+              <a:t>{</a:t>
+            </a:r>
+            <a:br/>
+            <a:r>
+              <a:rPr b="0" i="0">
+                <a:solidFill>
+                  <a:schemeClr val="dk1"/>
+                </a:solidFill>
+                <a:latin typeface="Consolas"/>
+              </a:rPr>
+              <a:t>  </a:t>
+            </a:r>
+            <a:r>
+              <a:rPr b="1" i="0">
+                <a:solidFill>
+                  <a:srgbClr val="008000"/>
+                </a:solidFill>
+                <a:latin typeface="Consolas"/>
+              </a:rPr>
+              <a:t>display</a:t>
+            </a:r>
+            <a:r>
+              <a:rPr b="0" i="0">
+                <a:solidFill>
+                  <a:schemeClr val="dk1"/>
+                </a:solidFill>
+                <a:latin typeface="Consolas"/>
+              </a:rPr>
+              <a:t>:</a:t>
+            </a:r>
+            <a:r>
+              <a:rPr b="0" i="0">
+                <a:solidFill>
+                  <a:schemeClr val="dk1"/>
+                </a:solidFill>
+                <a:latin typeface="Consolas"/>
+              </a:rPr>
+              <a:t> </a:t>
+            </a:r>
+            <a:r>
+              <a:rPr b="1" i="0">
+                <a:solidFill>
+                  <a:srgbClr val="008000"/>
+                </a:solidFill>
+                <a:latin typeface="Consolas"/>
+              </a:rPr>
+              <a:t>grid</a:t>
+            </a:r>
+            <a:r>
+              <a:rPr b="0" i="0">
+                <a:solidFill>
+                  <a:schemeClr val="dk1"/>
+                </a:solidFill>
+                <a:latin typeface="Consolas"/>
+              </a:rPr>
+              <a:t>;</a:t>
+            </a:r>
+            <a:br/>
+            <a:r>
+              <a:rPr b="0" i="0">
+                <a:solidFill>
+                  <a:schemeClr val="dk1"/>
+                </a:solidFill>
+                <a:latin typeface="Consolas"/>
+              </a:rPr>
+              <a:t>  </a:t>
+            </a:r>
+            <a:r>
+              <a:rPr b="1" i="0">
+                <a:solidFill>
+                  <a:srgbClr val="008000"/>
+                </a:solidFill>
+                <a:latin typeface="Consolas"/>
+              </a:rPr>
+              <a:t>gap</a:t>
+            </a:r>
+            <a:r>
+              <a:rPr b="0" i="0">
+                <a:solidFill>
+                  <a:schemeClr val="dk1"/>
+                </a:solidFill>
+                <a:latin typeface="Consolas"/>
+              </a:rPr>
+              <a:t>:</a:t>
+            </a:r>
+            <a:r>
+              <a:rPr b="0" i="0">
+                <a:solidFill>
+                  <a:schemeClr val="dk1"/>
+                </a:solidFill>
+                <a:latin typeface="Consolas"/>
+              </a:rPr>
+              <a:t> </a:t>
+            </a:r>
+            <a:r>
+              <a:rPr b="0" i="0">
+                <a:solidFill>
+                  <a:srgbClr val="666666"/>
+                </a:solidFill>
+                <a:latin typeface="Consolas"/>
+              </a:rPr>
+              <a:t>12</a:t>
+            </a:r>
+            <a:r>
+              <a:rPr b="0" i="0">
+                <a:solidFill>
+                  <a:srgbClr val="B00040"/>
+                </a:solidFill>
+                <a:latin typeface="Consolas"/>
+              </a:rPr>
+              <a:t>px</a:t>
+            </a:r>
+            <a:r>
+              <a:rPr b="0" i="0">
+                <a:solidFill>
+                  <a:schemeClr val="dk1"/>
+                </a:solidFill>
+                <a:latin typeface="Consolas"/>
+              </a:rPr>
+              <a:t>;</a:t>
+            </a:r>
+            <a:br/>
+            <a:r>
+              <a:rPr b="0" i="0">
+                <a:solidFill>
+                  <a:schemeClr val="dk1"/>
+                </a:solidFill>
+                <a:latin typeface="Consolas"/>
+              </a:rPr>
+              <a:t>  </a:t>
+            </a:r>
+            <a:r>
+              <a:rPr b="1" i="0">
+                <a:solidFill>
+                  <a:srgbClr val="008000"/>
+                </a:solidFill>
+                <a:latin typeface="Consolas"/>
+              </a:rPr>
+              <a:t>padding</a:t>
+            </a:r>
+            <a:r>
+              <a:rPr b="0" i="0">
+                <a:solidFill>
+                  <a:schemeClr val="dk1"/>
+                </a:solidFill>
+                <a:latin typeface="Consolas"/>
+              </a:rPr>
+              <a:t>:</a:t>
+            </a:r>
+            <a:r>
+              <a:rPr b="0" i="0">
+                <a:solidFill>
+                  <a:schemeClr val="dk1"/>
+                </a:solidFill>
+                <a:latin typeface="Consolas"/>
+              </a:rPr>
+              <a:t> </a:t>
+            </a:r>
+            <a:r>
+              <a:rPr b="0" i="0">
+                <a:solidFill>
+                  <a:srgbClr val="666666"/>
+                </a:solidFill>
+                <a:latin typeface="Consolas"/>
+              </a:rPr>
+              <a:t>24</a:t>
+            </a:r>
+            <a:r>
+              <a:rPr b="0" i="0">
+                <a:solidFill>
+                  <a:srgbClr val="B00040"/>
+                </a:solidFill>
+                <a:latin typeface="Consolas"/>
+              </a:rPr>
+              <a:t>px</a:t>
+            </a:r>
+            <a:r>
+              <a:rPr b="0" i="0">
+                <a:solidFill>
+                  <a:schemeClr val="dk1"/>
+                </a:solidFill>
+                <a:latin typeface="Consolas"/>
+              </a:rPr>
+              <a:t>;</a:t>
+            </a:r>
+            <a:br/>
+            <a:r>
+              <a:rPr b="0" i="0">
+                <a:solidFill>
+                  <a:schemeClr val="dk1"/>
+                </a:solidFill>
+                <a:latin typeface="Consolas"/>
+              </a:rPr>
+              <a:t>  </a:t>
+            </a:r>
+            <a:r>
+              <a:rPr b="1" i="0">
+                <a:solidFill>
+                  <a:srgbClr val="008000"/>
+                </a:solidFill>
+                <a:latin typeface="Consolas"/>
+              </a:rPr>
+              <a:t>color</a:t>
+            </a:r>
+            <a:r>
+              <a:rPr b="0" i="0">
+                <a:solidFill>
+                  <a:schemeClr val="dk1"/>
+                </a:solidFill>
+                <a:latin typeface="Consolas"/>
+              </a:rPr>
+              <a:t>:</a:t>
+            </a:r>
+            <a:r>
+              <a:rPr b="0" i="0">
+                <a:solidFill>
+                  <a:schemeClr val="dk1"/>
+                </a:solidFill>
+                <a:latin typeface="Consolas"/>
+              </a:rPr>
+              <a:t> </a:t>
+            </a:r>
+            <a:r>
+              <a:rPr b="0" i="0">
+                <a:solidFill>
+                  <a:srgbClr val="666666"/>
+                </a:solidFill>
+                <a:latin typeface="Consolas"/>
+              </a:rPr>
+              <a:t>#10263f</a:t>
+            </a:r>
+            <a:r>
+              <a:rPr b="0" i="0">
+                <a:solidFill>
+                  <a:schemeClr val="dk1"/>
+                </a:solidFill>
+                <a:latin typeface="Consolas"/>
+              </a:rPr>
+              <a:t>;</a:t>
+            </a:r>
+            <a:br/>
+            <a:r>
+              <a:rPr b="0" i="0">
+                <a:solidFill>
+                  <a:schemeClr val="dk1"/>
+                </a:solidFill>
+                <a:latin typeface="Consolas"/>
+              </a:rPr>
+              <a:t>  </a:t>
+            </a:r>
+            <a:r>
+              <a:rPr b="1" i="0">
+                <a:solidFill>
+                  <a:srgbClr val="008000"/>
+                </a:solidFill>
+                <a:latin typeface="Consolas"/>
+              </a:rPr>
+              <a:t>background</a:t>
+            </a:r>
+            <a:r>
+              <a:rPr b="0" i="0">
+                <a:solidFill>
+                  <a:schemeClr val="dk1"/>
+                </a:solidFill>
+                <a:latin typeface="Consolas"/>
+              </a:rPr>
+              <a:t>:</a:t>
+            </a:r>
+            <a:r>
+              <a:rPr b="0" i="0">
+                <a:solidFill>
+                  <a:schemeClr val="dk1"/>
+                </a:solidFill>
+                <a:latin typeface="Consolas"/>
+              </a:rPr>
+              <a:t> </a:t>
+            </a:r>
+            <a:r>
+              <a:rPr b="0" i="0">
+                <a:solidFill>
+                  <a:srgbClr val="666666"/>
+                </a:solidFill>
+                <a:latin typeface="Consolas"/>
+              </a:rPr>
+              <a:t>#eef8ff</a:t>
+            </a:r>
+            <a:r>
+              <a:rPr b="0" i="0">
+                <a:solidFill>
+                  <a:schemeClr val="dk1"/>
+                </a:solidFill>
+                <a:latin typeface="Consolas"/>
+              </a:rPr>
+              <a:t>;</a:t>
+            </a:r>
+            <a:br/>
+            <a:r>
+              <a:rPr b="0" i="0">
+                <a:solidFill>
+                  <a:schemeClr val="dk1"/>
+                </a:solidFill>
+                <a:latin typeface="Consolas"/>
+              </a:rPr>
+              <a:t>}</a:t>
+            </a:r>
+            <a:br/>
+            <a:br/>
+            <a:r>
+              <a:rPr b="0" i="0">
+                <a:solidFill>
+                  <a:schemeClr val="dk1"/>
+                </a:solidFill>
+                <a:latin typeface="Consolas"/>
+              </a:rPr>
+              <a:t>.</a:t>
+            </a:r>
+            <a:r>
+              <a:rPr b="1" i="0">
+                <a:solidFill>
+                  <a:srgbClr val="0000FF"/>
+                </a:solidFill>
+                <a:latin typeface="Consolas"/>
+              </a:rPr>
+              <a:t>project-card</a:t>
+            </a:r>
+            <a:r>
+              <a:rPr b="0" i="0">
+                <a:solidFill>
+                  <a:schemeClr val="dk1"/>
+                </a:solidFill>
+                <a:latin typeface="Consolas"/>
+              </a:rPr>
+              <a:t> </a:t>
+            </a:r>
+            <a:r>
+              <a:rPr b="1" i="0">
+                <a:solidFill>
+                  <a:srgbClr val="008000"/>
+                </a:solidFill>
+                <a:latin typeface="Consolas"/>
+              </a:rPr>
+              <a:t>a</a:t>
+            </a:r>
+            <a:r>
+              <a:rPr b="0" i="0">
+                <a:solidFill>
+                  <a:schemeClr val="dk1"/>
+                </a:solidFill>
+                <a:latin typeface="Consolas"/>
+              </a:rPr>
+              <a:t>:</a:t>
+            </a:r>
+            <a:r>
+              <a:rPr b="0" i="0">
+                <a:solidFill>
+                  <a:srgbClr val="AA22FF"/>
+                </a:solidFill>
+                <a:latin typeface="Consolas"/>
+              </a:rPr>
+              <a:t>hover</a:t>
+            </a:r>
+            <a:r>
+              <a:rPr b="0" i="0">
+                <a:solidFill>
+                  <a:schemeClr val="dk1"/>
+                </a:solidFill>
+                <a:latin typeface="Consolas"/>
+              </a:rPr>
+              <a:t> </a:t>
+            </a:r>
+            <a:r>
+              <a:rPr b="0" i="0">
+                <a:solidFill>
+                  <a:schemeClr val="dk1"/>
+                </a:solidFill>
+                <a:latin typeface="Consolas"/>
+              </a:rPr>
+              <a:t>{</a:t>
+            </a:r>
+            <a:r>
+              <a:rPr b="0" i="0">
+                <a:solidFill>
+                  <a:schemeClr val="dk1"/>
+                </a:solidFill>
+                <a:latin typeface="Consolas"/>
+              </a:rPr>
+              <a:t> </a:t>
+            </a:r>
+            <a:r>
+              <a:rPr b="1" i="0">
+                <a:solidFill>
+                  <a:srgbClr val="008000"/>
+                </a:solidFill>
+                <a:latin typeface="Consolas"/>
+              </a:rPr>
+              <a:t>color</a:t>
+            </a:r>
+            <a:r>
+              <a:rPr b="0" i="0">
+                <a:solidFill>
+                  <a:schemeClr val="dk1"/>
+                </a:solidFill>
+                <a:latin typeface="Consolas"/>
+              </a:rPr>
+              <a:t>:</a:t>
+            </a:r>
+            <a:r>
+              <a:rPr b="0" i="0">
+                <a:solidFill>
+                  <a:schemeClr val="dk1"/>
+                </a:solidFill>
+                <a:latin typeface="Consolas"/>
+              </a:rPr>
+              <a:t> </a:t>
+            </a:r>
+            <a:r>
+              <a:rPr b="0" i="0">
+                <a:solidFill>
+                  <a:srgbClr val="666666"/>
+                </a:solidFill>
+                <a:latin typeface="Consolas"/>
+              </a:rPr>
+              <a:t>#1d6fa8</a:t>
+            </a:r>
+            <a:r>
+              <a:rPr b="0" i="0">
+                <a:solidFill>
+                  <a:schemeClr val="dk1"/>
+                </a:solidFill>
+                <a:latin typeface="Consolas"/>
+              </a:rPr>
+              <a:t>;</a:t>
+            </a:r>
+            <a:r>
+              <a:rPr b="0" i="0">
+                <a:solidFill>
+                  <a:schemeClr val="dk1"/>
+                </a:solidFill>
+                <a:latin typeface="Consolas"/>
+              </a:rPr>
+              <a:t> </a:t>
+            </a:r>
+            <a:r>
+              <a:rPr b="0" i="0">
+                <a:solidFill>
+                  <a:schemeClr val="dk1"/>
+                </a:solidFill>
+                <a:latin typeface="Consolas"/>
+              </a:rPr>
+              <a:t>}</a:t>
+            </a:r>
+            <a:endParaRPr>
+              <a:solidFill>
+                <a:schemeClr val="dk1"/>
+              </a:solidFill>
+            </a:endParaRPr>
+          </a:p>
+        </p:txBody>
+      </p:sp>
+    </p:spTree>
+  </p:cSld>
+  <p:clrMapOvr>
+    <a:masterClrMapping/>
+  </p:clrMapOvr>
+</p:sld>
+</file>
+
+<file path=ppt/slides/slide32.xml><?xml version="1.0" encoding="utf-8"?>
 <p:sld xmlns:a="http://schemas.openxmlformats.org/drawingml/2006/main" xmlns:p="http://schemas.openxmlformats.org/presentationml/2006/main" xmlns:r="http://schemas.openxmlformats.org/officeDocument/2006/relationships">
   <p:cSld>
     <p:spTree>
@@ -8480,7 +12000,7 @@
 </p:sld>
 </file>
 
-<file path=ppt/slides/slide29.xml><?xml version="1.0" encoding="utf-8"?>
+<file path=ppt/slides/slide33.xml><?xml version="1.0" encoding="utf-8"?>
 <p:sld xmlns:a="http://schemas.openxmlformats.org/drawingml/2006/main" xmlns:p="http://schemas.openxmlformats.org/presentationml/2006/main" xmlns:r="http://schemas.openxmlformats.org/officeDocument/2006/relationships">
   <p:cSld>
     <p:spTree>
@@ -8579,155 +12099,7 @@
 </p:sld>
 </file>
 
-<file path=ppt/slides/slide3.xml><?xml version="1.0" encoding="utf-8"?>
-<p:sld xmlns:a="http://schemas.openxmlformats.org/drawingml/2006/main" xmlns:p="http://schemas.openxmlformats.org/presentationml/2006/main" xmlns:r="http://schemas.openxmlformats.org/officeDocument/2006/relationships">
-  <p:cSld>
-    <p:spTree>
-      <p:nvGrpSpPr>
-        <p:cNvPr id="1" name=""/>
-        <p:cNvGrpSpPr/>
-        <p:nvPr/>
-      </p:nvGrpSpPr>
-      <p:grpSpPr/>
-      <p:sp>
-        <p:nvSpPr>
-          <p:cNvPr id="2" name="Title 1"/>
-          <p:cNvSpPr>
-            <a:spLocks noGrp="1"/>
-          </p:cNvSpPr>
-          <p:nvPr>
-            <p:ph type="title"/>
-          </p:nvPr>
-        </p:nvSpPr>
-        <p:spPr/>
-        <p:txBody>
-          <a:bodyPr>
-            <a:normAutofit/>
-          </a:bodyPr>
-          <a:lstStyle/>
-          <a:p>
-            <a:pPr>
-              <a:defRPr>
-                <a:solidFill>
-                  <a:schemeClr val="accent6"/>
-                </a:solidFill>
-              </a:defRPr>
-            </a:pPr>
-            <a:r>
-              <a:rPr>
-                <a:solidFill>
-                  <a:schemeClr val="accent6"/>
-                </a:solidFill>
-              </a:rPr>
-              <a:t>How the format works</a:t>
-            </a:r>
-            <a:endParaRPr>
-              <a:solidFill>
-                <a:schemeClr val="accent6"/>
-              </a:solidFill>
-            </a:endParaRPr>
-          </a:p>
-        </p:txBody>
-      </p:sp>
-      <p:sp>
-        <p:nvSpPr>
-          <p:cNvPr id="3" name="Content Placeholder 2"/>
-          <p:cNvSpPr>
-            <a:spLocks noGrp="1"/>
-          </p:cNvSpPr>
-          <p:nvPr>
-            <p:ph idx="1"/>
-          </p:nvPr>
-        </p:nvSpPr>
-        <p:spPr/>
-        <p:txBody>
-          <a:bodyPr wrap="square">
-            <a:normAutofit/>
-          </a:bodyPr>
-          <a:lstStyle/>
-          <a:p>
-            <a:pPr marL="0" indent="0">
-              <a:buNone/>
-              <a:defRPr>
-                <a:solidFill>
-                  <a:schemeClr val="dk1"/>
-                </a:solidFill>
-              </a:defRPr>
-            </a:pPr>
-            <a:r>
-              <a:rPr b="0" i="0">
-                <a:solidFill>
-                  <a:schemeClr val="dk1"/>
-                </a:solidFill>
-                <a:latin typeface="+mn-lt"/>
-                <a:ea typeface="+mn-ea"/>
-                <a:cs typeface="+mn-cs"/>
-              </a:rPr>
-              <a:t>An optional document front matter block sets deck-wide defaults such as aspect ratio, fonts, colors, and background behavior.</a:t>
-            </a:r>
-            <a:endParaRPr>
-              <a:solidFill>
-                <a:schemeClr val="dk1"/>
-              </a:solidFill>
-            </a:endParaRPr>
-          </a:p>
-          <a:p>
-            <a:pPr marL="0" indent="0">
-              <a:buNone/>
-              <a:defRPr>
-                <a:solidFill>
-                  <a:schemeClr val="dk1"/>
-                </a:solidFill>
-              </a:defRPr>
-            </a:pPr>
-            <a:r>
-              <a:rPr b="0" i="0">
-                <a:solidFill>
-                  <a:schemeClr val="dk1"/>
-                </a:solidFill>
-                <a:latin typeface="+mn-lt"/>
-                <a:ea typeface="+mn-ea"/>
-                <a:cs typeface="+mn-cs"/>
-              </a:rPr>
-              <a:t>Each ATX </a:t>
-            </a:r>
-            <a:r>
-              <a:rPr b="0" i="0">
-                <a:solidFill>
-                  <a:schemeClr val="dk1"/>
-                </a:solidFill>
-                <a:latin typeface="Consolas"/>
-              </a:rPr>
-              <a:t># H1</a:t>
-            </a:r>
-            <a:r>
-              <a:rPr b="0" i="0">
-                <a:solidFill>
-                  <a:schemeClr val="dk1"/>
-                </a:solidFill>
-                <a:latin typeface="+mn-lt"/>
-                <a:ea typeface="+mn-ea"/>
-                <a:cs typeface="+mn-cs"/>
-              </a:rPr>
-              <a:t> or Setext H1 starts a new slide. Optional slide front matter appears immediately after the heading. Everything until the next H1 belongs to that slide.</a:t>
-            </a:r>
-            <a:endParaRPr>
-              <a:solidFill>
-                <a:schemeClr val="dk1"/>
-              </a:solidFill>
-            </a:endParaRPr>
-          </a:p>
-        </p:txBody>
-      </p:sp>
-    </p:spTree>
-  </p:cSld>
-  <p:clrMapOvr>
-    <a:masterClrMapping/>
-  </p:clrMapOvr>
-</p:sld>
-</file>
-
-<file path=ppt/slides/slide30.xml><?xml version="1.0" encoding="utf-8"?>
+<file path=ppt/slides/slide34.xml><?xml version="1.0" encoding="utf-8"?>
 <p:sld xmlns:a="http://schemas.openxmlformats.org/drawingml/2006/main" xmlns:p="http://schemas.openxmlformats.org/presentationml/2006/main" xmlns:r="http://schemas.openxmlformats.org/officeDocument/2006/relationships">
   <p:cSld>
     <p:bg>
@@ -8837,7 +12209,7 @@
 </p:sld>
 </file>
 
-<file path=ppt/slides/slide31.xml><?xml version="1.0" encoding="utf-8"?>
+<file path=ppt/slides/slide35.xml><?xml version="1.0" encoding="utf-8"?>
 <p:sld xmlns:a="http://schemas.openxmlformats.org/drawingml/2006/main" xmlns:p="http://schemas.openxmlformats.org/presentationml/2006/main" xmlns:r="http://schemas.openxmlformats.org/officeDocument/2006/relationships" showMasterSp="0">
   <p:cSld>
     <p:bg>
@@ -8945,7 +12317,7 @@
 </p:sld>
 </file>
 
-<file path=ppt/slides/slide32.xml><?xml version="1.0" encoding="utf-8"?>
+<file path=ppt/slides/slide36.xml><?xml version="1.0" encoding="utf-8"?>
 <p:sld xmlns:a="http://schemas.openxmlformats.org/drawingml/2006/main" xmlns:p="http://schemas.openxmlformats.org/presentationml/2006/main" xmlns:r="http://schemas.openxmlformats.org/officeDocument/2006/relationships">
   <p:cSld>
     <p:spTree>
@@ -8987,7 +12359,7 @@
 </p:sld>
 </file>
 
-<file path=ppt/slides/slide33.xml><?xml version="1.0" encoding="utf-8"?>
+<file path=ppt/slides/slide37.xml><?xml version="1.0" encoding="utf-8"?>
 <p:sld xmlns:a="http://schemas.openxmlformats.org/drawingml/2006/main" xmlns:p="http://schemas.openxmlformats.org/presentationml/2006/main" xmlns:r="http://schemas.openxmlformats.org/officeDocument/2006/relationships">
   <p:cSld>
     <p:bg>
@@ -9108,7 +12480,7 @@
 </p:sld>
 </file>
 
-<file path=ppt/slides/slide34.xml><?xml version="1.0" encoding="utf-8"?>
+<file path=ppt/slides/slide38.xml><?xml version="1.0" encoding="utf-8"?>
 <p:sld xmlns:a="http://schemas.openxmlformats.org/drawingml/2006/main" xmlns:p="http://schemas.openxmlformats.org/presentationml/2006/main" xmlns:r="http://schemas.openxmlformats.org/officeDocument/2006/relationships">
   <p:cSld>
     <p:bg>
@@ -9231,7 +12603,7 @@
 </p:sld>
 </file>
 
-<file path=ppt/slides/slide35.xml><?xml version="1.0" encoding="utf-8"?>
+<file path=ppt/slides/slide39.xml><?xml version="1.0" encoding="utf-8"?>
 <p:sld xmlns:a="http://schemas.openxmlformats.org/drawingml/2006/main" xmlns:p="http://schemas.openxmlformats.org/presentationml/2006/main" xmlns:r="http://schemas.openxmlformats.org/officeDocument/2006/relationships">
   <p:cSld>
     <p:bg>
@@ -9349,7 +12721,301 @@
 </p:sld>
 </file>
 
-<file path=ppt/slides/slide36.xml><?xml version="1.0" encoding="utf-8"?>
+<file path=ppt/slides/slide4.xml><?xml version="1.0" encoding="utf-8"?>
+<p:sld xmlns:a="http://schemas.openxmlformats.org/drawingml/2006/main" xmlns:p="http://schemas.openxmlformats.org/presentationml/2006/main" xmlns:r="http://schemas.openxmlformats.org/officeDocument/2006/relationships">
+  <p:cSld>
+    <p:spTree>
+      <p:nvGrpSpPr>
+        <p:cNvPr id="1" name=""/>
+        <p:cNvGrpSpPr/>
+        <p:nvPr/>
+      </p:nvGrpSpPr>
+      <p:grpSpPr/>
+      <p:sp>
+        <p:nvSpPr>
+          <p:cNvPr id="2" name="Title 1"/>
+          <p:cNvSpPr>
+            <a:spLocks noGrp="1"/>
+          </p:cNvSpPr>
+          <p:nvPr>
+            <p:ph type="title"/>
+          </p:nvPr>
+        </p:nvSpPr>
+        <p:spPr/>
+        <p:txBody>
+          <a:bodyPr>
+            <a:normAutofit/>
+          </a:bodyPr>
+          <a:lstStyle/>
+          <a:p>
+            <a:pPr>
+              <a:defRPr>
+                <a:solidFill>
+                  <a:schemeClr val="accent6"/>
+                </a:solidFill>
+              </a:defRPr>
+            </a:pPr>
+            <a:r>
+              <a:rPr>
+                <a:solidFill>
+                  <a:schemeClr val="accent6"/>
+                </a:solidFill>
+              </a:rPr>
+              <a:t>Basic CLI usage</a:t>
+            </a:r>
+            <a:endParaRPr>
+              <a:solidFill>
+                <a:schemeClr val="accent6"/>
+              </a:solidFill>
+            </a:endParaRPr>
+          </a:p>
+        </p:txBody>
+      </p:sp>
+      <p:sp>
+        <p:nvSpPr>
+          <p:cNvPr id="3" name="Content Placeholder 2"/>
+          <p:cNvSpPr>
+            <a:spLocks noGrp="1"/>
+          </p:cNvSpPr>
+          <p:nvPr>
+            <p:ph idx="1"/>
+          </p:nvPr>
+        </p:nvSpPr>
+        <p:spPr/>
+        <p:txBody>
+          <a:bodyPr wrap="square">
+            <a:normAutofit/>
+          </a:bodyPr>
+          <a:lstStyle/>
+          <a:p>
+            <a:pPr marL="0" indent="0">
+              <a:buNone/>
+              <a:defRPr>
+                <a:solidFill>
+                  <a:schemeClr val="dk1"/>
+                </a:solidFill>
+              </a:defRPr>
+            </a:pPr>
+            <a:r>
+              <a:rPr b="0" i="0">
+                <a:solidFill>
+                  <a:schemeClr val="dk1"/>
+                </a:solidFill>
+                <a:latin typeface="+mn-lt"/>
+                <a:ea typeface="+mn-ea"/>
+                <a:cs typeface="+mn-cs"/>
+              </a:rPr>
+              <a:t>Run </a:t>
+            </a:r>
+            <a:r>
+              <a:rPr b="0" i="0">
+                <a:solidFill>
+                  <a:schemeClr val="dk1"/>
+                </a:solidFill>
+                <a:latin typeface="Consolas"/>
+              </a:rPr>
+              <a:t>uvx markdown-pptx deck.md</a:t>
+            </a:r>
+            <a:r>
+              <a:rPr b="0" i="0">
+                <a:solidFill>
+                  <a:schemeClr val="dk1"/>
+                </a:solidFill>
+                <a:latin typeface="+mn-lt"/>
+                <a:ea typeface="+mn-ea"/>
+                <a:cs typeface="+mn-cs"/>
+              </a:rPr>
+              <a:t> to write </a:t>
+            </a:r>
+            <a:r>
+              <a:rPr b="0" i="0">
+                <a:solidFill>
+                  <a:schemeClr val="dk1"/>
+                </a:solidFill>
+                <a:latin typeface="Consolas"/>
+              </a:rPr>
+              <a:t>deck.pptx</a:t>
+            </a:r>
+            <a:r>
+              <a:rPr b="0" i="0">
+                <a:solidFill>
+                  <a:schemeClr val="dk1"/>
+                </a:solidFill>
+                <a:latin typeface="+mn-lt"/>
+                <a:ea typeface="+mn-ea"/>
+                <a:cs typeface="+mn-cs"/>
+              </a:rPr>
+              <a:t> next to the source markdown file.</a:t>
+            </a:r>
+            <a:endParaRPr>
+              <a:solidFill>
+                <a:schemeClr val="dk1"/>
+              </a:solidFill>
+            </a:endParaRPr>
+          </a:p>
+          <a:p>
+            <a:pPr marL="0" indent="0">
+              <a:buNone/>
+              <a:defRPr>
+                <a:solidFill>
+                  <a:schemeClr val="dk1"/>
+                </a:solidFill>
+              </a:defRPr>
+            </a:pPr>
+            <a:r>
+              <a:rPr b="0" i="0">
+                <a:solidFill>
+                  <a:schemeClr val="dk1"/>
+                </a:solidFill>
+                <a:latin typeface="+mn-lt"/>
+                <a:ea typeface="+mn-ea"/>
+                <a:cs typeface="+mn-cs"/>
+              </a:rPr>
+              <a:t>Use </a:t>
+            </a:r>
+            <a:r>
+              <a:rPr b="0" i="0">
+                <a:solidFill>
+                  <a:schemeClr val="dk1"/>
+                </a:solidFill>
+                <a:latin typeface="Consolas"/>
+              </a:rPr>
+              <a:t>uvx markdown-pptx deck.md out.pptx</a:t>
+            </a:r>
+            <a:r>
+              <a:rPr b="0" i="0">
+                <a:solidFill>
+                  <a:schemeClr val="dk1"/>
+                </a:solidFill>
+                <a:latin typeface="+mn-lt"/>
+                <a:ea typeface="+mn-ea"/>
+                <a:cs typeface="+mn-cs"/>
+              </a:rPr>
+              <a:t> to choose the output path, </a:t>
+            </a:r>
+            <a:r>
+              <a:rPr b="0" i="0">
+                <a:solidFill>
+                  <a:schemeClr val="dk1"/>
+                </a:solidFill>
+                <a:latin typeface="Consolas"/>
+              </a:rPr>
+              <a:t>--template theme.pptx</a:t>
+            </a:r>
+            <a:r>
+              <a:rPr b="0" i="0">
+                <a:solidFill>
+                  <a:schemeClr val="dk1"/>
+                </a:solidFill>
+                <a:latin typeface="+mn-lt"/>
+                <a:ea typeface="+mn-ea"/>
+                <a:cs typeface="+mn-cs"/>
+              </a:rPr>
+              <a:t> to render against an existing PowerPoint template, and </a:t>
+            </a:r>
+            <a:r>
+              <a:rPr b="0" i="0">
+                <a:solidFill>
+                  <a:schemeClr val="dk1"/>
+                </a:solidFill>
+                <a:latin typeface="Consolas"/>
+              </a:rPr>
+              <a:t>--force</a:t>
+            </a:r>
+            <a:r>
+              <a:rPr b="0" i="0">
+                <a:solidFill>
+                  <a:schemeClr val="dk1"/>
+                </a:solidFill>
+                <a:latin typeface="+mn-lt"/>
+                <a:ea typeface="+mn-ea"/>
+                <a:cs typeface="+mn-cs"/>
+              </a:rPr>
+              <a:t> to overwrite an existing file.</a:t>
+            </a:r>
+            <a:endParaRPr>
+              <a:solidFill>
+                <a:schemeClr val="dk1"/>
+              </a:solidFill>
+            </a:endParaRPr>
+          </a:p>
+          <a:p>
+            <a:pPr marL="0" indent="0">
+              <a:buNone/>
+              <a:defRPr>
+                <a:solidFill>
+                  <a:schemeClr val="dk1"/>
+                </a:solidFill>
+              </a:defRPr>
+            </a:pPr>
+            <a:r>
+              <a:rPr b="0" i="0">
+                <a:solidFill>
+                  <a:schemeClr val="dk1"/>
+                </a:solidFill>
+                <a:latin typeface="+mn-lt"/>
+                <a:ea typeface="+mn-ea"/>
+                <a:cs typeface="+mn-cs"/>
+              </a:rPr>
+              <a:t>Run </a:t>
+            </a:r>
+            <a:r>
+              <a:rPr b="0" i="0">
+                <a:solidFill>
+                  <a:schemeClr val="dk1"/>
+                </a:solidFill>
+                <a:latin typeface="Consolas"/>
+              </a:rPr>
+              <a:t>uvx markdown-pptx</a:t>
+            </a:r>
+            <a:r>
+              <a:rPr b="0" i="0">
+                <a:solidFill>
+                  <a:schemeClr val="dk1"/>
+                </a:solidFill>
+                <a:latin typeface="+mn-lt"/>
+                <a:ea typeface="+mn-ea"/>
+                <a:cs typeface="+mn-cs"/>
+              </a:rPr>
+              <a:t> with no arguments for the quick reference or use </a:t>
+            </a:r>
+            <a:r>
+              <a:rPr b="0" i="0">
+                <a:solidFill>
+                  <a:schemeClr val="dk1"/>
+                </a:solidFill>
+                <a:latin typeface="Consolas"/>
+              </a:rPr>
+              <a:t>--about</a:t>
+            </a:r>
+            <a:r>
+              <a:rPr b="0" i="0">
+                <a:solidFill>
+                  <a:schemeClr val="dk1"/>
+                </a:solidFill>
+                <a:latin typeface="+mn-lt"/>
+                <a:ea typeface="+mn-ea"/>
+                <a:cs typeface="+mn-cs"/>
+              </a:rPr>
+              <a:t> for project metadata.</a:t>
+            </a:r>
+            <a:endParaRPr>
+              <a:solidFill>
+                <a:schemeClr val="dk1"/>
+              </a:solidFill>
+            </a:endParaRPr>
+          </a:p>
+        </p:txBody>
+      </p:sp>
+    </p:spTree>
+  </p:cSld>
+  <p:clrMapOvr>
+    <a:masterClrMapping/>
+  </p:clrMapOvr>
+</p:sld>
+</file>
+
+<file path=ppt/slides/slide40.xml><?xml version="1.0" encoding="utf-8"?>
 <p:sld xmlns:a="http://schemas.openxmlformats.org/drawingml/2006/main" xmlns:p="http://schemas.openxmlformats.org/presentationml/2006/main" xmlns:r="http://schemas.openxmlformats.org/officeDocument/2006/relationships">
   <p:cSld>
     <p:spTree>
@@ -9367,7 +13033,7 @@
 </p:sld>
 </file>
 
-<file path=ppt/slides/slide37.xml><?xml version="1.0" encoding="utf-8"?>
+<file path=ppt/slides/slide41.xml><?xml version="1.0" encoding="utf-8"?>
 <p:sld xmlns:a="http://schemas.openxmlformats.org/drawingml/2006/main" xmlns:p="http://schemas.openxmlformats.org/presentationml/2006/main" xmlns:r="http://schemas.openxmlformats.org/officeDocument/2006/relationships">
   <p:cSld>
     <p:spTree>
@@ -9613,7 +13279,7 @@
 </p:sld>
 </file>
 
-<file path=ppt/slides/slide38.xml><?xml version="1.0" encoding="utf-8"?>
+<file path=ppt/slides/slide42.xml><?xml version="1.0" encoding="utf-8"?>
 <p:sld xmlns:a="http://schemas.openxmlformats.org/drawingml/2006/main" xmlns:p="http://schemas.openxmlformats.org/presentationml/2006/main" xmlns:r="http://schemas.openxmlformats.org/officeDocument/2006/relationships">
   <p:cSld>
     <p:spTree>
@@ -9940,7 +13606,7 @@
 </p:sld>
 </file>
 
-<file path=ppt/slides/slide39.xml><?xml version="1.0" encoding="utf-8"?>
+<file path=ppt/slides/slide43.xml><?xml version="1.0" encoding="utf-8"?>
 <p:sld xmlns:a="http://schemas.openxmlformats.org/drawingml/2006/main" xmlns:p="http://schemas.openxmlformats.org/presentationml/2006/main" xmlns:r="http://schemas.openxmlformats.org/officeDocument/2006/relationships">
   <p:cSld>
     <p:spTree>
@@ -10045,300 +13711,6 @@
                 <a:cs typeface="+mn-cs"/>
               </a:rPr>
               <a:t> to get started.</a:t>
-            </a:r>
-            <a:endParaRPr>
-              <a:solidFill>
-                <a:schemeClr val="dk1"/>
-              </a:solidFill>
-            </a:endParaRPr>
-          </a:p>
-        </p:txBody>
-      </p:sp>
-    </p:spTree>
-  </p:cSld>
-  <p:clrMapOvr>
-    <a:masterClrMapping/>
-  </p:clrMapOvr>
-</p:sld>
-</file>
-
-<file path=ppt/slides/slide4.xml><?xml version="1.0" encoding="utf-8"?>
-<p:sld xmlns:a="http://schemas.openxmlformats.org/drawingml/2006/main" xmlns:p="http://schemas.openxmlformats.org/presentationml/2006/main" xmlns:r="http://schemas.openxmlformats.org/officeDocument/2006/relationships">
-  <p:cSld>
-    <p:spTree>
-      <p:nvGrpSpPr>
-        <p:cNvPr id="1" name=""/>
-        <p:cNvGrpSpPr/>
-        <p:nvPr/>
-      </p:nvGrpSpPr>
-      <p:grpSpPr/>
-      <p:sp>
-        <p:nvSpPr>
-          <p:cNvPr id="2" name="Title 1"/>
-          <p:cNvSpPr>
-            <a:spLocks noGrp="1"/>
-          </p:cNvSpPr>
-          <p:nvPr>
-            <p:ph type="title"/>
-          </p:nvPr>
-        </p:nvSpPr>
-        <p:spPr/>
-        <p:txBody>
-          <a:bodyPr>
-            <a:normAutofit/>
-          </a:bodyPr>
-          <a:lstStyle/>
-          <a:p>
-            <a:pPr>
-              <a:defRPr>
-                <a:solidFill>
-                  <a:schemeClr val="accent6"/>
-                </a:solidFill>
-              </a:defRPr>
-            </a:pPr>
-            <a:r>
-              <a:rPr>
-                <a:solidFill>
-                  <a:schemeClr val="accent6"/>
-                </a:solidFill>
-              </a:rPr>
-              <a:t>Basic CLI usage</a:t>
-            </a:r>
-            <a:endParaRPr>
-              <a:solidFill>
-                <a:schemeClr val="accent6"/>
-              </a:solidFill>
-            </a:endParaRPr>
-          </a:p>
-        </p:txBody>
-      </p:sp>
-      <p:sp>
-        <p:nvSpPr>
-          <p:cNvPr id="3" name="Content Placeholder 2"/>
-          <p:cNvSpPr>
-            <a:spLocks noGrp="1"/>
-          </p:cNvSpPr>
-          <p:nvPr>
-            <p:ph idx="1"/>
-          </p:nvPr>
-        </p:nvSpPr>
-        <p:spPr/>
-        <p:txBody>
-          <a:bodyPr wrap="square">
-            <a:normAutofit/>
-          </a:bodyPr>
-          <a:lstStyle/>
-          <a:p>
-            <a:pPr marL="0" indent="0">
-              <a:buNone/>
-              <a:defRPr>
-                <a:solidFill>
-                  <a:schemeClr val="dk1"/>
-                </a:solidFill>
-              </a:defRPr>
-            </a:pPr>
-            <a:r>
-              <a:rPr b="0" i="0">
-                <a:solidFill>
-                  <a:schemeClr val="dk1"/>
-                </a:solidFill>
-                <a:latin typeface="+mn-lt"/>
-                <a:ea typeface="+mn-ea"/>
-                <a:cs typeface="+mn-cs"/>
-              </a:rPr>
-              <a:t>Run </a:t>
-            </a:r>
-            <a:r>
-              <a:rPr b="0" i="0">
-                <a:solidFill>
-                  <a:schemeClr val="dk1"/>
-                </a:solidFill>
-                <a:latin typeface="Consolas"/>
-              </a:rPr>
-              <a:t>uvx markdown-pptx deck.md</a:t>
-            </a:r>
-            <a:r>
-              <a:rPr b="0" i="0">
-                <a:solidFill>
-                  <a:schemeClr val="dk1"/>
-                </a:solidFill>
-                <a:latin typeface="+mn-lt"/>
-                <a:ea typeface="+mn-ea"/>
-                <a:cs typeface="+mn-cs"/>
-              </a:rPr>
-              <a:t> to write </a:t>
-            </a:r>
-            <a:r>
-              <a:rPr b="0" i="0">
-                <a:solidFill>
-                  <a:schemeClr val="dk1"/>
-                </a:solidFill>
-                <a:latin typeface="Consolas"/>
-              </a:rPr>
-              <a:t>deck.pptx</a:t>
-            </a:r>
-            <a:r>
-              <a:rPr b="0" i="0">
-                <a:solidFill>
-                  <a:schemeClr val="dk1"/>
-                </a:solidFill>
-                <a:latin typeface="+mn-lt"/>
-                <a:ea typeface="+mn-ea"/>
-                <a:cs typeface="+mn-cs"/>
-              </a:rPr>
-              <a:t> next to the source markdown file.</a:t>
-            </a:r>
-            <a:endParaRPr>
-              <a:solidFill>
-                <a:schemeClr val="dk1"/>
-              </a:solidFill>
-            </a:endParaRPr>
-          </a:p>
-          <a:p>
-            <a:pPr marL="0" indent="0">
-              <a:buNone/>
-              <a:defRPr>
-                <a:solidFill>
-                  <a:schemeClr val="dk1"/>
-                </a:solidFill>
-              </a:defRPr>
-            </a:pPr>
-            <a:r>
-              <a:rPr b="0" i="0">
-                <a:solidFill>
-                  <a:schemeClr val="dk1"/>
-                </a:solidFill>
-                <a:latin typeface="+mn-lt"/>
-                <a:ea typeface="+mn-ea"/>
-                <a:cs typeface="+mn-cs"/>
-              </a:rPr>
-              <a:t>Use </a:t>
-            </a:r>
-            <a:r>
-              <a:rPr b="0" i="0">
-                <a:solidFill>
-                  <a:schemeClr val="dk1"/>
-                </a:solidFill>
-                <a:latin typeface="Consolas"/>
-              </a:rPr>
-              <a:t>uvx markdown-pptx deck.md out.pptx</a:t>
-            </a:r>
-            <a:r>
-              <a:rPr b="0" i="0">
-                <a:solidFill>
-                  <a:schemeClr val="dk1"/>
-                </a:solidFill>
-                <a:latin typeface="+mn-lt"/>
-                <a:ea typeface="+mn-ea"/>
-                <a:cs typeface="+mn-cs"/>
-              </a:rPr>
-              <a:t> to choose the output path, </a:t>
-            </a:r>
-            <a:r>
-              <a:rPr b="0" i="0">
-                <a:solidFill>
-                  <a:schemeClr val="dk1"/>
-                </a:solidFill>
-                <a:latin typeface="Consolas"/>
-              </a:rPr>
-              <a:t>--template theme.pptx</a:t>
-            </a:r>
-            <a:r>
-              <a:rPr b="0" i="0">
-                <a:solidFill>
-                  <a:schemeClr val="dk1"/>
-                </a:solidFill>
-                <a:latin typeface="+mn-lt"/>
-                <a:ea typeface="+mn-ea"/>
-                <a:cs typeface="+mn-cs"/>
-              </a:rPr>
-              <a:t> to render against an existing PowerPoint template, and </a:t>
-            </a:r>
-            <a:r>
-              <a:rPr b="0" i="0">
-                <a:solidFill>
-                  <a:schemeClr val="dk1"/>
-                </a:solidFill>
-                <a:latin typeface="Consolas"/>
-              </a:rPr>
-              <a:t>--force</a:t>
-            </a:r>
-            <a:r>
-              <a:rPr b="0" i="0">
-                <a:solidFill>
-                  <a:schemeClr val="dk1"/>
-                </a:solidFill>
-                <a:latin typeface="+mn-lt"/>
-                <a:ea typeface="+mn-ea"/>
-                <a:cs typeface="+mn-cs"/>
-              </a:rPr>
-              <a:t> to overwrite an existing file.</a:t>
-            </a:r>
-            <a:endParaRPr>
-              <a:solidFill>
-                <a:schemeClr val="dk1"/>
-              </a:solidFill>
-            </a:endParaRPr>
-          </a:p>
-          <a:p>
-            <a:pPr marL="0" indent="0">
-              <a:buNone/>
-              <a:defRPr>
-                <a:solidFill>
-                  <a:schemeClr val="dk1"/>
-                </a:solidFill>
-              </a:defRPr>
-            </a:pPr>
-            <a:r>
-              <a:rPr b="0" i="0">
-                <a:solidFill>
-                  <a:schemeClr val="dk1"/>
-                </a:solidFill>
-                <a:latin typeface="+mn-lt"/>
-                <a:ea typeface="+mn-ea"/>
-                <a:cs typeface="+mn-cs"/>
-              </a:rPr>
-              <a:t>Run </a:t>
-            </a:r>
-            <a:r>
-              <a:rPr b="0" i="0">
-                <a:solidFill>
-                  <a:schemeClr val="dk1"/>
-                </a:solidFill>
-                <a:latin typeface="Consolas"/>
-              </a:rPr>
-              <a:t>uvx markdown-pptx</a:t>
-            </a:r>
-            <a:r>
-              <a:rPr b="0" i="0">
-                <a:solidFill>
-                  <a:schemeClr val="dk1"/>
-                </a:solidFill>
-                <a:latin typeface="+mn-lt"/>
-                <a:ea typeface="+mn-ea"/>
-                <a:cs typeface="+mn-cs"/>
-              </a:rPr>
-              <a:t> with no arguments for the quick reference or use </a:t>
-            </a:r>
-            <a:r>
-              <a:rPr b="0" i="0">
-                <a:solidFill>
-                  <a:schemeClr val="dk1"/>
-                </a:solidFill>
-                <a:latin typeface="Consolas"/>
-              </a:rPr>
-              <a:t>--about</a:t>
-            </a:r>
-            <a:r>
-              <a:rPr b="0" i="0">
-                <a:solidFill>
-                  <a:schemeClr val="dk1"/>
-                </a:solidFill>
-                <a:latin typeface="+mn-lt"/>
-                <a:ea typeface="+mn-ea"/>
-                <a:cs typeface="+mn-cs"/>
-              </a:rPr>
-              <a:t> for project metadata.</a:t>
             </a:r>
             <a:endParaRPr>
               <a:solidFill>

</xml_diff>

<commit_message>
Add optional theme syntax colors with contrast analysis
</commit_message>
<xml_diff>
--- a/sample/showcase.pptx
+++ b/sample/showcase.pptx
@@ -52,6 +52,10 @@
     <p:sldId xmlns:ns0="http://schemas.openxmlformats.org/officeDocument/2006/relationships" id="296" ns0:id="rId48"/>
     <p:sldId xmlns:ns0="http://schemas.openxmlformats.org/officeDocument/2006/relationships" id="297" ns0:id="rId49"/>
     <p:sldId xmlns:ns0="http://schemas.openxmlformats.org/officeDocument/2006/relationships" id="298" ns0:id="rId50"/>
+    <p:sldId xmlns:ns0="http://schemas.openxmlformats.org/officeDocument/2006/relationships" id="299" ns0:id="rId51"/>
+    <p:sldId xmlns:ns0="http://schemas.openxmlformats.org/officeDocument/2006/relationships" id="300" ns0:id="rId52"/>
+    <p:sldId xmlns:ns0="http://schemas.openxmlformats.org/officeDocument/2006/relationships" id="301" ns0:id="rId53"/>
+    <p:sldId xmlns:ns0="http://schemas.openxmlformats.org/officeDocument/2006/relationships" id="302" ns0:id="rId54"/>
   </p:sldIdLst>
   <p:sldSz cx="12192000" cy="6858000"/>
   <p:notesSz cx="6858000" cy="9144000"/>
@@ -536,6 +540,286 @@
           <a:p>
             <a:r>
               <a:t>From top to bottom: Dark 1, Light 1, Dark 2, Light 2, Accent 1 through Accent 6, Hyperlink, and Followed Hyperlink.</a:t>
+            </a:r>
+          </a:p>
+        </p:txBody>
+      </p:sp>
+      <p:sp>
+        <p:nvSpPr>
+          <p:cNvPr id="4" name="Slide Number Placeholder 3"/>
+          <p:cNvSpPr>
+            <a:spLocks noGrp="1"/>
+          </p:cNvSpPr>
+          <p:nvPr>
+            <p:ph type="sldNum" idx="5" sz="quarter"/>
+          </p:nvPr>
+        </p:nvSpPr>
+        <p:spPr/>
+      </p:sp>
+    </p:spTree>
+  </p:cSld>
+  <p:clrMapOvr>
+    <a:masterClrMapping/>
+  </p:clrMapOvr>
+</p:notes>
+</file>
+
+<file path=ppt/notesSlides/notesSlide10.xml><?xml version="1.0" encoding="utf-8"?>
+<p:notes xmlns:a="http://schemas.openxmlformats.org/drawingml/2006/main" xmlns:p="http://schemas.openxmlformats.org/presentationml/2006/main" xmlns:r="http://schemas.openxmlformats.org/officeDocument/2006/relationships">
+  <p:cSld>
+    <p:spTree>
+      <p:nvGrpSpPr>
+        <p:cNvPr id="1" name=""/>
+        <p:cNvGrpSpPr/>
+        <p:nvPr/>
+      </p:nvGrpSpPr>
+      <p:grpSpPr>
+        <a:xfrm>
+          <a:off x="0" y="0"/>
+          <a:ext cx="0" cy="0"/>
+          <a:chOff x="0" y="0"/>
+          <a:chExt cx="0" cy="0"/>
+        </a:xfrm>
+      </p:grpSpPr>
+      <p:sp>
+        <p:nvSpPr>
+          <p:cNvPr id="2" name="Slide Image Placeholder 1"/>
+          <p:cNvSpPr>
+            <a:spLocks noGrp="1"/>
+          </p:cNvSpPr>
+          <p:nvPr>
+            <p:ph type="sldImg" idx="2"/>
+          </p:nvPr>
+        </p:nvSpPr>
+        <p:spPr/>
+      </p:sp>
+      <p:sp>
+        <p:nvSpPr>
+          <p:cNvPr id="3" name="Notes Placeholder 2"/>
+          <p:cNvSpPr>
+            <a:spLocks noGrp="1"/>
+          </p:cNvSpPr>
+          <p:nvPr>
+            <p:ph type="body" idx="3" sz="quarter"/>
+          </p:nvPr>
+        </p:nvSpPr>
+        <p:spPr/>
+        <p:txBody>
+          <a:bodyPr/>
+          <a:lstStyle/>
+          <a:p>
+            <a:r>
+              <a:t>Dark 1 supplies ordinary code. Accents 1, 2, and 3 supply keywords, values, and named tokens. Brightness is adjusted only as needed for 4.5 to 1 contrast.</a:t>
+            </a:r>
+          </a:p>
+        </p:txBody>
+      </p:sp>
+      <p:sp>
+        <p:nvSpPr>
+          <p:cNvPr id="4" name="Slide Number Placeholder 3"/>
+          <p:cNvSpPr>
+            <a:spLocks noGrp="1"/>
+          </p:cNvSpPr>
+          <p:nvPr>
+            <p:ph type="sldNum" idx="5" sz="quarter"/>
+          </p:nvPr>
+        </p:nvSpPr>
+        <p:spPr/>
+      </p:sp>
+    </p:spTree>
+  </p:cSld>
+  <p:clrMapOvr>
+    <a:masterClrMapping/>
+  </p:clrMapOvr>
+</p:notes>
+</file>
+
+<file path=ppt/notesSlides/notesSlide11.xml><?xml version="1.0" encoding="utf-8"?>
+<p:notes xmlns:a="http://schemas.openxmlformats.org/drawingml/2006/main" xmlns:p="http://schemas.openxmlformats.org/presentationml/2006/main" xmlns:r="http://schemas.openxmlformats.org/officeDocument/2006/relationships">
+  <p:cSld>
+    <p:spTree>
+      <p:nvGrpSpPr>
+        <p:cNvPr id="1" name=""/>
+        <p:cNvGrpSpPr/>
+        <p:nvPr/>
+      </p:nvGrpSpPr>
+      <p:grpSpPr>
+        <a:xfrm>
+          <a:off x="0" y="0"/>
+          <a:ext cx="0" cy="0"/>
+          <a:chOff x="0" y="0"/>
+          <a:chExt cx="0" cy="0"/>
+        </a:xfrm>
+      </p:grpSpPr>
+      <p:sp>
+        <p:nvSpPr>
+          <p:cNvPr id="2" name="Slide Image Placeholder 1"/>
+          <p:cNvSpPr>
+            <a:spLocks noGrp="1"/>
+          </p:cNvSpPr>
+          <p:nvPr>
+            <p:ph type="sldImg" idx="2"/>
+          </p:nvPr>
+        </p:nvSpPr>
+        <p:spPr/>
+      </p:sp>
+      <p:sp>
+        <p:nvSpPr>
+          <p:cNvPr id="3" name="Notes Placeholder 2"/>
+          <p:cNvSpPr>
+            <a:spLocks noGrp="1"/>
+          </p:cNvSpPr>
+          <p:nvPr>
+            <p:ph type="body" idx="3" sz="quarter"/>
+          </p:nvPr>
+        </p:nvSpPr>
+        <p:spPr/>
+        <p:txBody>
+          <a:bodyPr/>
+          <a:lstStyle/>
+          <a:p>
+            <a:r>
+              <a:t>Light 1 supplies ordinary code. The same accent slots are used with lighter variants where needed. Comments meet the same contrast target as other code.</a:t>
+            </a:r>
+          </a:p>
+        </p:txBody>
+      </p:sp>
+      <p:sp>
+        <p:nvSpPr>
+          <p:cNvPr id="4" name="Slide Number Placeholder 3"/>
+          <p:cNvSpPr>
+            <a:spLocks noGrp="1"/>
+          </p:cNvSpPr>
+          <p:nvPr>
+            <p:ph type="sldNum" idx="5" sz="quarter"/>
+          </p:nvPr>
+        </p:nvSpPr>
+        <p:spPr/>
+      </p:sp>
+    </p:spTree>
+  </p:cSld>
+  <p:clrMapOvr>
+    <a:masterClrMapping/>
+  </p:clrMapOvr>
+</p:notes>
+</file>
+
+<file path=ppt/notesSlides/notesSlide12.xml><?xml version="1.0" encoding="utf-8"?>
+<p:notes xmlns:a="http://schemas.openxmlformats.org/drawingml/2006/main" xmlns:p="http://schemas.openxmlformats.org/presentationml/2006/main" xmlns:r="http://schemas.openxmlformats.org/officeDocument/2006/relationships">
+  <p:cSld>
+    <p:spTree>
+      <p:nvGrpSpPr>
+        <p:cNvPr id="1" name=""/>
+        <p:cNvGrpSpPr/>
+        <p:nvPr/>
+      </p:nvGrpSpPr>
+      <p:grpSpPr>
+        <a:xfrm>
+          <a:off x="0" y="0"/>
+          <a:ext cx="0" cy="0"/>
+          <a:chOff x="0" y="0"/>
+          <a:chExt cx="0" cy="0"/>
+        </a:xfrm>
+      </p:grpSpPr>
+      <p:sp>
+        <p:nvSpPr>
+          <p:cNvPr id="2" name="Slide Image Placeholder 1"/>
+          <p:cNvSpPr>
+            <a:spLocks noGrp="1"/>
+          </p:cNvSpPr>
+          <p:nvPr>
+            <p:ph type="sldImg" idx="2"/>
+          </p:nvPr>
+        </p:nvSpPr>
+        <p:spPr/>
+      </p:sp>
+      <p:sp>
+        <p:nvSpPr>
+          <p:cNvPr id="3" name="Notes Placeholder 2"/>
+          <p:cNvSpPr>
+            <a:spLocks noGrp="1"/>
+          </p:cNvSpPr>
+          <p:nvPr>
+            <p:ph type="body" idx="3" sz="quarter"/>
+          </p:nvPr>
+        </p:nvSpPr>
+        <p:spPr/>
+        <p:txBody>
+          <a:bodyPr/>
+          <a:lstStyle/>
+          <a:p>
+            <a:r>
+              <a:t>A 16 by 16 grid estimates the background range beneath the content placeholder. HTML tags use Accent 1, values use Accent 2, and attributes use Accent 3.</a:t>
+            </a:r>
+          </a:p>
+        </p:txBody>
+      </p:sp>
+      <p:sp>
+        <p:nvSpPr>
+          <p:cNvPr id="4" name="Slide Number Placeholder 3"/>
+          <p:cNvSpPr>
+            <a:spLocks noGrp="1"/>
+          </p:cNvSpPr>
+          <p:nvPr>
+            <p:ph type="sldNum" idx="5" sz="quarter"/>
+          </p:nvPr>
+        </p:nvSpPr>
+        <p:spPr/>
+      </p:sp>
+    </p:spTree>
+  </p:cSld>
+  <p:clrMapOvr>
+    <a:masterClrMapping/>
+  </p:clrMapOvr>
+</p:notes>
+</file>
+
+<file path=ppt/notesSlides/notesSlide13.xml><?xml version="1.0" encoding="utf-8"?>
+<p:notes xmlns:a="http://schemas.openxmlformats.org/drawingml/2006/main" xmlns:p="http://schemas.openxmlformats.org/presentationml/2006/main" xmlns:r="http://schemas.openxmlformats.org/officeDocument/2006/relationships">
+  <p:cSld>
+    <p:spTree>
+      <p:nvGrpSpPr>
+        <p:cNvPr id="1" name=""/>
+        <p:cNvGrpSpPr/>
+        <p:nvPr/>
+      </p:nvGrpSpPr>
+      <p:grpSpPr>
+        <a:xfrm>
+          <a:off x="0" y="0"/>
+          <a:ext cx="0" cy="0"/>
+          <a:chOff x="0" y="0"/>
+          <a:chExt cx="0" cy="0"/>
+        </a:xfrm>
+      </p:grpSpPr>
+      <p:sp>
+        <p:nvSpPr>
+          <p:cNvPr id="2" name="Slide Image Placeholder 1"/>
+          <p:cNvSpPr>
+            <a:spLocks noGrp="1"/>
+          </p:cNvSpPr>
+          <p:nvPr>
+            <p:ph type="sldImg" idx="2"/>
+          </p:nvPr>
+        </p:nvSpPr>
+        <p:spPr/>
+      </p:sp>
+      <p:sp>
+        <p:nvSpPr>
+          <p:cNvPr id="3" name="Notes Placeholder 2"/>
+          <p:cNvSpPr>
+            <a:spLocks noGrp="1"/>
+          </p:cNvSpPr>
+          <p:nvPr>
+            <p:ph type="body" idx="3" sz="quarter"/>
+          </p:nvPr>
+        </p:nvSpPr>
+        <p:spPr/>
+        <p:txBody>
+          <a:bodyPr/>
+          <a:lstStyle/>
+          <a:p>
+            <a:r>
+              <a:t>A dark radial gradient demonstrates the light variant. Native theme references retain their slot and use brightness adjustments for the estimated background range.</a:t>
             </a:r>
           </a:p>
         </p:txBody>
@@ -9094,6 +9378,7 @@
             </a:r>
             <a:br/>
             <a:br/>
+            <a:br/>
             <a:r>
               <a:rPr b="0" i="0">
                 <a:solidFill>
@@ -13607,6 +13892,2234 @@
 </file>
 
 <file path=ppt/slides/slide43.xml><?xml version="1.0" encoding="utf-8"?>
+<p:sld xmlns:a="http://schemas.openxmlformats.org/drawingml/2006/main" xmlns:p="http://schemas.openxmlformats.org/presentationml/2006/main" xmlns:r="http://schemas.openxmlformats.org/officeDocument/2006/relationships">
+  <p:cSld>
+    <p:bg>
+      <p:bgPr>
+        <a:solidFill>
+          <a:srgbClr val="FFFFFF"/>
+        </a:solidFill>
+        <a:effectLst/>
+      </p:bgPr>
+    </p:bg>
+    <p:spTree>
+      <p:nvGrpSpPr>
+        <p:cNvPr id="1" name=""/>
+        <p:cNvGrpSpPr/>
+        <p:nvPr/>
+      </p:nvGrpSpPr>
+      <p:grpSpPr/>
+      <p:sp>
+        <p:nvSpPr>
+          <p:cNvPr id="2" name="Title 1"/>
+          <p:cNvSpPr>
+            <a:spLocks noGrp="1"/>
+          </p:cNvSpPr>
+          <p:nvPr>
+            <p:ph type="title"/>
+          </p:nvPr>
+        </p:nvSpPr>
+        <p:spPr/>
+        <p:txBody>
+          <a:bodyPr>
+            <a:normAutofit/>
+          </a:bodyPr>
+          <a:lstStyle/>
+          <a:p>
+            <a:pPr>
+              <a:defRPr>
+                <a:solidFill>
+                  <a:schemeClr val="accent6"/>
+                </a:solidFill>
+              </a:defRPr>
+            </a:pPr>
+            <a:r>
+              <a:rPr>
+                <a:solidFill>
+                  <a:schemeClr val="accent6"/>
+                </a:solidFill>
+              </a:rPr>
+              <a:t>Theme syntax: dark colors</a:t>
+            </a:r>
+            <a:endParaRPr>
+              <a:solidFill>
+                <a:schemeClr val="accent6"/>
+              </a:solidFill>
+            </a:endParaRPr>
+          </a:p>
+        </p:txBody>
+      </p:sp>
+      <p:sp>
+        <p:nvSpPr>
+          <p:cNvPr id="3" name="Content Placeholder 2"/>
+          <p:cNvSpPr>
+            <a:spLocks noGrp="1"/>
+          </p:cNvSpPr>
+          <p:nvPr>
+            <p:ph idx="1"/>
+          </p:nvPr>
+        </p:nvSpPr>
+        <p:spPr/>
+        <p:txBody>
+          <a:bodyPr wrap="square">
+            <a:normAutofit/>
+          </a:bodyPr>
+          <a:lstStyle/>
+          <a:p>
+            <a:pPr marL="0" indent="0">
+              <a:buNone/>
+              <a:defRPr>
+                <a:solidFill>
+                  <a:schemeClr val="dk1"/>
+                </a:solidFill>
+              </a:defRPr>
+            </a:pPr>
+            <a:r>
+              <a:rPr b="0" i="0">
+                <a:solidFill>
+                  <a:schemeClr val="dk1"/>
+                </a:solidFill>
+                <a:latin typeface="Consolas"/>
+              </a:rPr>
+              <a:t>code_highlighting: theme-dark</a:t>
+            </a:r>
+            <a:r>
+              <a:rPr b="0" i="0">
+                <a:solidFill>
+                  <a:schemeClr val="dk1"/>
+                </a:solidFill>
+                <a:latin typeface="+mn-lt"/>
+                <a:ea typeface="+mn-ea"/>
+                <a:cs typeface="+mn-cs"/>
+              </a:rPr>
+              <a:t> on a white background.</a:t>
+            </a:r>
+            <a:endParaRPr>
+              <a:solidFill>
+                <a:schemeClr val="dk1"/>
+              </a:solidFill>
+            </a:endParaRPr>
+          </a:p>
+          <a:p>
+            <a:pPr marL="0" indent="0">
+              <a:buNone/>
+              <a:defRPr>
+                <a:solidFill>
+                  <a:schemeClr val="dk1"/>
+                </a:solidFill>
+              </a:defRPr>
+            </a:pPr>
+            <a:r>
+              <a:rPr b="0" i="1">
+                <a:solidFill>
+                  <a:schemeClr val="dk1"/>
+                </a:solidFill>
+                <a:latin typeface="Consolas"/>
+              </a:rPr>
+              <a:t># Colors follow this deck's blue theme</a:t>
+            </a:r>
+            <a:br/>
+            <a:r>
+              <a:rPr b="1" i="0">
+                <a:solidFill>
+                  <a:schemeClr val="accent1"/>
+                </a:solidFill>
+                <a:latin typeface="Consolas"/>
+              </a:rPr>
+              <a:t>def</a:t>
+            </a:r>
+            <a:r>
+              <a:rPr b="0" i="0">
+                <a:solidFill>
+                  <a:schemeClr val="dk1"/>
+                </a:solidFill>
+                <a:latin typeface="Consolas"/>
+              </a:rPr>
+              <a:t> </a:t>
+            </a:r>
+            <a:r>
+              <a:rPr b="0" i="0">
+                <a:solidFill>
+                  <a:schemeClr val="accent3">
+                    <a:lumMod val="55575"/>
+                  </a:schemeClr>
+                </a:solidFill>
+                <a:latin typeface="Consolas"/>
+              </a:rPr>
+              <a:t>greet</a:t>
+            </a:r>
+            <a:r>
+              <a:rPr b="0" i="0">
+                <a:solidFill>
+                  <a:schemeClr val="dk1"/>
+                </a:solidFill>
+                <a:latin typeface="Consolas"/>
+              </a:rPr>
+              <a:t>(</a:t>
+            </a:r>
+            <a:r>
+              <a:rPr b="0" i="0">
+                <a:solidFill>
+                  <a:schemeClr val="dk1"/>
+                </a:solidFill>
+                <a:latin typeface="Consolas"/>
+              </a:rPr>
+              <a:t>name</a:t>
+            </a:r>
+            <a:r>
+              <a:rPr b="0" i="0">
+                <a:solidFill>
+                  <a:schemeClr val="dk1"/>
+                </a:solidFill>
+                <a:latin typeface="Consolas"/>
+              </a:rPr>
+              <a:t>:</a:t>
+            </a:r>
+            <a:r>
+              <a:rPr b="0" i="0">
+                <a:solidFill>
+                  <a:schemeClr val="dk1"/>
+                </a:solidFill>
+                <a:latin typeface="Consolas"/>
+              </a:rPr>
+              <a:t> </a:t>
+            </a:r>
+            <a:r>
+              <a:rPr b="0" i="0">
+                <a:solidFill>
+                  <a:schemeClr val="accent3">
+                    <a:lumMod val="55575"/>
+                  </a:schemeClr>
+                </a:solidFill>
+                <a:latin typeface="Consolas"/>
+              </a:rPr>
+              <a:t>str</a:t>
+            </a:r>
+            <a:r>
+              <a:rPr b="0" i="0">
+                <a:solidFill>
+                  <a:schemeClr val="dk1"/>
+                </a:solidFill>
+                <a:latin typeface="Consolas"/>
+              </a:rPr>
+              <a:t>,</a:t>
+            </a:r>
+            <a:r>
+              <a:rPr b="0" i="0">
+                <a:solidFill>
+                  <a:schemeClr val="dk1"/>
+                </a:solidFill>
+                <a:latin typeface="Consolas"/>
+              </a:rPr>
+              <a:t> </a:t>
+            </a:r>
+            <a:r>
+              <a:rPr b="0" i="0">
+                <a:solidFill>
+                  <a:schemeClr val="dk1"/>
+                </a:solidFill>
+                <a:latin typeface="Consolas"/>
+              </a:rPr>
+              <a:t>count</a:t>
+            </a:r>
+            <a:r>
+              <a:rPr b="0" i="0">
+                <a:solidFill>
+                  <a:schemeClr val="dk1"/>
+                </a:solidFill>
+                <a:latin typeface="Consolas"/>
+              </a:rPr>
+              <a:t>:</a:t>
+            </a:r>
+            <a:r>
+              <a:rPr b="0" i="0">
+                <a:solidFill>
+                  <a:schemeClr val="dk1"/>
+                </a:solidFill>
+                <a:latin typeface="Consolas"/>
+              </a:rPr>
+              <a:t> </a:t>
+            </a:r>
+            <a:r>
+              <a:rPr b="0" i="0">
+                <a:solidFill>
+                  <a:schemeClr val="accent3">
+                    <a:lumMod val="55575"/>
+                  </a:schemeClr>
+                </a:solidFill>
+                <a:latin typeface="Consolas"/>
+              </a:rPr>
+              <a:t>int</a:t>
+            </a:r>
+            <a:r>
+              <a:rPr b="0" i="0">
+                <a:solidFill>
+                  <a:schemeClr val="dk1"/>
+                </a:solidFill>
+                <a:latin typeface="Consolas"/>
+              </a:rPr>
+              <a:t> </a:t>
+            </a:r>
+            <a:r>
+              <a:rPr b="0" i="0">
+                <a:solidFill>
+                  <a:schemeClr val="dk1"/>
+                </a:solidFill>
+                <a:latin typeface="Consolas"/>
+              </a:rPr>
+              <a:t>=</a:t>
+            </a:r>
+            <a:r>
+              <a:rPr b="0" i="0">
+                <a:solidFill>
+                  <a:schemeClr val="dk1"/>
+                </a:solidFill>
+                <a:latin typeface="Consolas"/>
+              </a:rPr>
+              <a:t> </a:t>
+            </a:r>
+            <a:r>
+              <a:rPr b="0" i="0">
+                <a:solidFill>
+                  <a:schemeClr val="accent2">
+                    <a:lumMod val="69990"/>
+                  </a:schemeClr>
+                </a:solidFill>
+                <a:latin typeface="Consolas"/>
+              </a:rPr>
+              <a:t>3</a:t>
+            </a:r>
+            <a:r>
+              <a:rPr b="0" i="0">
+                <a:solidFill>
+                  <a:schemeClr val="dk1"/>
+                </a:solidFill>
+                <a:latin typeface="Consolas"/>
+              </a:rPr>
+              <a:t>)</a:t>
+            </a:r>
+            <a:r>
+              <a:rPr b="0" i="0">
+                <a:solidFill>
+                  <a:schemeClr val="dk1"/>
+                </a:solidFill>
+                <a:latin typeface="Consolas"/>
+              </a:rPr>
+              <a:t>:</a:t>
+            </a:r>
+            <a:br/>
+            <a:r>
+              <a:rPr b="0" i="0">
+                <a:solidFill>
+                  <a:schemeClr val="dk1"/>
+                </a:solidFill>
+                <a:latin typeface="Consolas"/>
+              </a:rPr>
+              <a:t>    </a:t>
+            </a:r>
+            <a:r>
+              <a:rPr b="1" i="0">
+                <a:solidFill>
+                  <a:schemeClr val="accent1"/>
+                </a:solidFill>
+                <a:latin typeface="Consolas"/>
+              </a:rPr>
+              <a:t>for</a:t>
+            </a:r>
+            <a:r>
+              <a:rPr b="0" i="0">
+                <a:solidFill>
+                  <a:schemeClr val="dk1"/>
+                </a:solidFill>
+                <a:latin typeface="Consolas"/>
+              </a:rPr>
+              <a:t> </a:t>
+            </a:r>
+            <a:r>
+              <a:rPr b="0" i="0">
+                <a:solidFill>
+                  <a:schemeClr val="dk1"/>
+                </a:solidFill>
+                <a:latin typeface="Consolas"/>
+              </a:rPr>
+              <a:t>index</a:t>
+            </a:r>
+            <a:r>
+              <a:rPr b="0" i="0">
+                <a:solidFill>
+                  <a:schemeClr val="dk1"/>
+                </a:solidFill>
+                <a:latin typeface="Consolas"/>
+              </a:rPr>
+              <a:t> </a:t>
+            </a:r>
+            <a:r>
+              <a:rPr b="0" i="0">
+                <a:solidFill>
+                  <a:schemeClr val="dk1"/>
+                </a:solidFill>
+                <a:latin typeface="Consolas"/>
+              </a:rPr>
+              <a:t>in</a:t>
+            </a:r>
+            <a:r>
+              <a:rPr b="0" i="0">
+                <a:solidFill>
+                  <a:schemeClr val="dk1"/>
+                </a:solidFill>
+                <a:latin typeface="Consolas"/>
+              </a:rPr>
+              <a:t> </a:t>
+            </a:r>
+            <a:r>
+              <a:rPr b="0" i="0">
+                <a:solidFill>
+                  <a:schemeClr val="accent3">
+                    <a:lumMod val="55575"/>
+                  </a:schemeClr>
+                </a:solidFill>
+                <a:latin typeface="Consolas"/>
+              </a:rPr>
+              <a:t>range</a:t>
+            </a:r>
+            <a:r>
+              <a:rPr b="0" i="0">
+                <a:solidFill>
+                  <a:schemeClr val="dk1"/>
+                </a:solidFill>
+                <a:latin typeface="Consolas"/>
+              </a:rPr>
+              <a:t>(</a:t>
+            </a:r>
+            <a:r>
+              <a:rPr b="0" i="0">
+                <a:solidFill>
+                  <a:schemeClr val="dk1"/>
+                </a:solidFill>
+                <a:latin typeface="Consolas"/>
+              </a:rPr>
+              <a:t>count</a:t>
+            </a:r>
+            <a:r>
+              <a:rPr b="0" i="0">
+                <a:solidFill>
+                  <a:schemeClr val="dk1"/>
+                </a:solidFill>
+                <a:latin typeface="Consolas"/>
+              </a:rPr>
+              <a:t>)</a:t>
+            </a:r>
+            <a:r>
+              <a:rPr b="0" i="0">
+                <a:solidFill>
+                  <a:schemeClr val="dk1"/>
+                </a:solidFill>
+                <a:latin typeface="Consolas"/>
+              </a:rPr>
+              <a:t>:</a:t>
+            </a:r>
+            <a:br/>
+            <a:r>
+              <a:rPr b="0" i="0">
+                <a:solidFill>
+                  <a:schemeClr val="dk1"/>
+                </a:solidFill>
+                <a:latin typeface="Consolas"/>
+              </a:rPr>
+              <a:t>        </a:t>
+            </a:r>
+            <a:r>
+              <a:rPr b="0" i="0">
+                <a:solidFill>
+                  <a:schemeClr val="accent3">
+                    <a:lumMod val="55575"/>
+                  </a:schemeClr>
+                </a:solidFill>
+                <a:latin typeface="Consolas"/>
+              </a:rPr>
+              <a:t>print</a:t>
+            </a:r>
+            <a:r>
+              <a:rPr b="0" i="0">
+                <a:solidFill>
+                  <a:schemeClr val="dk1"/>
+                </a:solidFill>
+                <a:latin typeface="Consolas"/>
+              </a:rPr>
+              <a:t>(</a:t>
+            </a:r>
+            <a:r>
+              <a:rPr b="0" i="0">
+                <a:solidFill>
+                  <a:schemeClr val="accent2">
+                    <a:lumMod val="69990"/>
+                  </a:schemeClr>
+                </a:solidFill>
+                <a:latin typeface="Consolas"/>
+              </a:rPr>
+              <a:t>f</a:t>
+            </a:r>
+            <a:r>
+              <a:rPr b="0" i="0">
+                <a:solidFill>
+                  <a:schemeClr val="accent2">
+                    <a:lumMod val="69990"/>
+                  </a:schemeClr>
+                </a:solidFill>
+                <a:latin typeface="Consolas"/>
+              </a:rPr>
+              <a:t>"</a:t>
+            </a:r>
+            <a:r>
+              <a:rPr b="0" i="0">
+                <a:solidFill>
+                  <a:schemeClr val="accent2">
+                    <a:lumMod val="69990"/>
+                  </a:schemeClr>
+                </a:solidFill>
+                <a:latin typeface="Consolas"/>
+              </a:rPr>
+              <a:t>Hello, </a:t>
+            </a:r>
+            <a:r>
+              <a:rPr b="0" i="0">
+                <a:solidFill>
+                  <a:schemeClr val="accent2">
+                    <a:lumMod val="69990"/>
+                  </a:schemeClr>
+                </a:solidFill>
+                <a:latin typeface="Consolas"/>
+              </a:rPr>
+              <a:t>{</a:t>
+            </a:r>
+            <a:r>
+              <a:rPr b="0" i="0">
+                <a:solidFill>
+                  <a:schemeClr val="dk1"/>
+                </a:solidFill>
+                <a:latin typeface="Consolas"/>
+              </a:rPr>
+              <a:t>name</a:t>
+            </a:r>
+            <a:r>
+              <a:rPr b="0" i="0">
+                <a:solidFill>
+                  <a:schemeClr val="accent2">
+                    <a:lumMod val="69990"/>
+                  </a:schemeClr>
+                </a:solidFill>
+                <a:latin typeface="Consolas"/>
+              </a:rPr>
+              <a:t>}</a:t>
+            </a:r>
+            <a:r>
+              <a:rPr b="0" i="0">
+                <a:solidFill>
+                  <a:schemeClr val="accent2">
+                    <a:lumMod val="69990"/>
+                  </a:schemeClr>
+                </a:solidFill>
+                <a:latin typeface="Consolas"/>
+              </a:rPr>
+              <a:t>: </a:t>
+            </a:r>
+            <a:r>
+              <a:rPr b="0" i="0">
+                <a:solidFill>
+                  <a:schemeClr val="accent2">
+                    <a:lumMod val="69990"/>
+                  </a:schemeClr>
+                </a:solidFill>
+                <a:latin typeface="Consolas"/>
+              </a:rPr>
+              <a:t>{</a:t>
+            </a:r>
+            <a:r>
+              <a:rPr b="0" i="0">
+                <a:solidFill>
+                  <a:schemeClr val="dk1"/>
+                </a:solidFill>
+                <a:latin typeface="Consolas"/>
+              </a:rPr>
+              <a:t>index</a:t>
+            </a:r>
+            <a:r>
+              <a:rPr b="0" i="0">
+                <a:solidFill>
+                  <a:schemeClr val="accent2">
+                    <a:lumMod val="69990"/>
+                  </a:schemeClr>
+                </a:solidFill>
+                <a:latin typeface="Consolas"/>
+              </a:rPr>
+              <a:t>}</a:t>
+            </a:r>
+            <a:r>
+              <a:rPr b="0" i="0">
+                <a:solidFill>
+                  <a:schemeClr val="accent2">
+                    <a:lumMod val="69990"/>
+                  </a:schemeClr>
+                </a:solidFill>
+                <a:latin typeface="Consolas"/>
+              </a:rPr>
+              <a:t>"</a:t>
+            </a:r>
+            <a:r>
+              <a:rPr b="0" i="0">
+                <a:solidFill>
+                  <a:schemeClr val="dk1"/>
+                </a:solidFill>
+                <a:latin typeface="Consolas"/>
+              </a:rPr>
+              <a:t>)</a:t>
+            </a:r>
+            <a:br/>
+            <a:br/>
+            <a:br/>
+            <a:r>
+              <a:rPr b="0" i="0">
+                <a:solidFill>
+                  <a:schemeClr val="dk1"/>
+                </a:solidFill>
+                <a:latin typeface="Consolas"/>
+              </a:rPr>
+              <a:t>greet</a:t>
+            </a:r>
+            <a:r>
+              <a:rPr b="0" i="0">
+                <a:solidFill>
+                  <a:schemeClr val="dk1"/>
+                </a:solidFill>
+                <a:latin typeface="Consolas"/>
+              </a:rPr>
+              <a:t>(</a:t>
+            </a:r>
+            <a:r>
+              <a:rPr b="0" i="0">
+                <a:solidFill>
+                  <a:schemeClr val="accent2">
+                    <a:lumMod val="69990"/>
+                  </a:schemeClr>
+                </a:solidFill>
+                <a:latin typeface="Consolas"/>
+              </a:rPr>
+              <a:t>"</a:t>
+            </a:r>
+            <a:r>
+              <a:rPr b="0" i="0">
+                <a:solidFill>
+                  <a:schemeClr val="accent2">
+                    <a:lumMod val="69990"/>
+                  </a:schemeClr>
+                </a:solidFill>
+                <a:latin typeface="Consolas"/>
+              </a:rPr>
+              <a:t>PowerPoint</a:t>
+            </a:r>
+            <a:r>
+              <a:rPr b="0" i="0">
+                <a:solidFill>
+                  <a:schemeClr val="accent2">
+                    <a:lumMod val="69990"/>
+                  </a:schemeClr>
+                </a:solidFill>
+                <a:latin typeface="Consolas"/>
+              </a:rPr>
+              <a:t>"</a:t>
+            </a:r>
+            <a:r>
+              <a:rPr b="0" i="0">
+                <a:solidFill>
+                  <a:schemeClr val="dk1"/>
+                </a:solidFill>
+                <a:latin typeface="Consolas"/>
+              </a:rPr>
+              <a:t>)</a:t>
+            </a:r>
+            <a:endParaRPr>
+              <a:solidFill>
+                <a:schemeClr val="dk1"/>
+              </a:solidFill>
+            </a:endParaRPr>
+          </a:p>
+        </p:txBody>
+      </p:sp>
+    </p:spTree>
+  </p:cSld>
+  <p:clrMapOvr>
+    <a:masterClrMapping/>
+  </p:clrMapOvr>
+</p:sld>
+</file>
+
+<file path=ppt/slides/slide44.xml><?xml version="1.0" encoding="utf-8"?>
+<p:sld xmlns:a="http://schemas.openxmlformats.org/drawingml/2006/main" xmlns:p="http://schemas.openxmlformats.org/presentationml/2006/main" xmlns:r="http://schemas.openxmlformats.org/officeDocument/2006/relationships">
+  <p:cSld>
+    <p:bg>
+      <p:bgPr>
+        <a:solidFill>
+          <a:srgbClr val="10263F"/>
+        </a:solidFill>
+        <a:effectLst/>
+      </p:bgPr>
+    </p:bg>
+    <p:spTree>
+      <p:nvGrpSpPr>
+        <p:cNvPr id="1" name=""/>
+        <p:cNvGrpSpPr/>
+        <p:nvPr/>
+      </p:nvGrpSpPr>
+      <p:grpSpPr/>
+      <p:sp>
+        <p:nvSpPr>
+          <p:cNvPr id="2" name="Title 1"/>
+          <p:cNvSpPr>
+            <a:spLocks noGrp="1"/>
+          </p:cNvSpPr>
+          <p:nvPr>
+            <p:ph type="title"/>
+          </p:nvPr>
+        </p:nvSpPr>
+        <p:spPr/>
+        <p:txBody>
+          <a:bodyPr>
+            <a:normAutofit/>
+          </a:bodyPr>
+          <a:lstStyle/>
+          <a:p>
+            <a:pPr>
+              <a:defRPr>
+                <a:solidFill>
+                  <a:srgbClr val="FFFFFF"/>
+                </a:solidFill>
+              </a:defRPr>
+            </a:pPr>
+            <a:r>
+              <a:rPr>
+                <a:solidFill>
+                  <a:srgbClr val="FFFFFF"/>
+                </a:solidFill>
+              </a:rPr>
+              <a:t>Theme syntax: light colors</a:t>
+            </a:r>
+            <a:endParaRPr>
+              <a:solidFill>
+                <a:srgbClr val="FFFFFF"/>
+              </a:solidFill>
+            </a:endParaRPr>
+          </a:p>
+        </p:txBody>
+      </p:sp>
+      <p:sp>
+        <p:nvSpPr>
+          <p:cNvPr id="3" name="Content Placeholder 2"/>
+          <p:cNvSpPr>
+            <a:spLocks noGrp="1"/>
+          </p:cNvSpPr>
+          <p:nvPr>
+            <p:ph idx="1"/>
+          </p:nvPr>
+        </p:nvSpPr>
+        <p:spPr/>
+        <p:txBody>
+          <a:bodyPr wrap="square">
+            <a:normAutofit/>
+          </a:bodyPr>
+          <a:lstStyle/>
+          <a:p>
+            <a:pPr marL="0" indent="0">
+              <a:buNone/>
+              <a:defRPr>
+                <a:solidFill>
+                  <a:srgbClr val="FFFFFF"/>
+                </a:solidFill>
+              </a:defRPr>
+            </a:pPr>
+            <a:r>
+              <a:rPr b="0" i="0">
+                <a:solidFill>
+                  <a:srgbClr val="FFFFFF"/>
+                </a:solidFill>
+                <a:latin typeface="Consolas"/>
+              </a:rPr>
+              <a:t>code_highlighting: theme-light</a:t>
+            </a:r>
+            <a:r>
+              <a:rPr b="0" i="0">
+                <a:solidFill>
+                  <a:srgbClr val="FFFFFF"/>
+                </a:solidFill>
+                <a:latin typeface="+mn-lt"/>
+                <a:ea typeface="+mn-ea"/>
+                <a:cs typeface="+mn-cs"/>
+              </a:rPr>
+              <a:t> on a navy background.</a:t>
+            </a:r>
+            <a:endParaRPr>
+              <a:solidFill>
+                <a:srgbClr val="FFFFFF"/>
+              </a:solidFill>
+            </a:endParaRPr>
+          </a:p>
+          <a:p>
+            <a:pPr marL="0" indent="0">
+              <a:buNone/>
+              <a:defRPr>
+                <a:solidFill>
+                  <a:srgbClr val="FFFFFF"/>
+                </a:solidFill>
+              </a:defRPr>
+            </a:pPr>
+            <a:r>
+              <a:rPr b="0" i="1">
+                <a:solidFill>
+                  <a:schemeClr val="lt1"/>
+                </a:solidFill>
+                <a:latin typeface="Consolas"/>
+              </a:rPr>
+              <a:t>// Editable theme colors on a dark slide</a:t>
+            </a:r>
+            <a:br/>
+            <a:r>
+              <a:rPr b="1" i="0">
+                <a:solidFill>
+                  <a:schemeClr val="accent1">
+                    <a:lumMod val="80137"/>
+                    <a:lumOff val="19863"/>
+                  </a:schemeClr>
+                </a:solidFill>
+                <a:latin typeface="Consolas"/>
+              </a:rPr>
+              <a:t>interface</a:t>
+            </a:r>
+            <a:r>
+              <a:rPr b="0" i="0">
+                <a:solidFill>
+                  <a:schemeClr val="lt1"/>
+                </a:solidFill>
+                <a:latin typeface="Consolas"/>
+              </a:rPr>
+              <a:t> </a:t>
+            </a:r>
+            <a:r>
+              <a:rPr b="0" i="0">
+                <a:solidFill>
+                  <a:schemeClr val="lt1"/>
+                </a:solidFill>
+                <a:latin typeface="Consolas"/>
+              </a:rPr>
+              <a:t>Greeting</a:t>
+            </a:r>
+            <a:r>
+              <a:rPr b="0" i="0">
+                <a:solidFill>
+                  <a:schemeClr val="lt1"/>
+                </a:solidFill>
+                <a:latin typeface="Consolas"/>
+              </a:rPr>
+              <a:t> </a:t>
+            </a:r>
+            <a:r>
+              <a:rPr b="0" i="0">
+                <a:solidFill>
+                  <a:schemeClr val="lt1"/>
+                </a:solidFill>
+                <a:latin typeface="Consolas"/>
+              </a:rPr>
+              <a:t>{</a:t>
+            </a:r>
+            <a:r>
+              <a:rPr b="0" i="0">
+                <a:solidFill>
+                  <a:schemeClr val="lt1"/>
+                </a:solidFill>
+                <a:latin typeface="Consolas"/>
+              </a:rPr>
+              <a:t> </a:t>
+            </a:r>
+            <a:r>
+              <a:rPr b="0" i="0">
+                <a:solidFill>
+                  <a:schemeClr val="lt1"/>
+                </a:solidFill>
+                <a:latin typeface="Consolas"/>
+              </a:rPr>
+              <a:t>message</a:t>
+            </a:r>
+            <a:r>
+              <a:rPr b="0" i="0">
+                <a:solidFill>
+                  <a:schemeClr val="lt1"/>
+                </a:solidFill>
+                <a:latin typeface="Consolas"/>
+              </a:rPr>
+              <a:t>:</a:t>
+            </a:r>
+            <a:r>
+              <a:rPr b="0" i="0">
+                <a:solidFill>
+                  <a:schemeClr val="lt1"/>
+                </a:solidFill>
+                <a:latin typeface="Consolas"/>
+              </a:rPr>
+              <a:t> </a:t>
+            </a:r>
+            <a:r>
+              <a:rPr b="0" i="0">
+                <a:solidFill>
+                  <a:schemeClr val="accent3"/>
+                </a:solidFill>
+                <a:latin typeface="Consolas"/>
+              </a:rPr>
+              <a:t>string</a:t>
+            </a:r>
+            <a:r>
+              <a:rPr b="0" i="0">
+                <a:solidFill>
+                  <a:schemeClr val="lt1"/>
+                </a:solidFill>
+                <a:latin typeface="Consolas"/>
+              </a:rPr>
+              <a:t> </a:t>
+            </a:r>
+            <a:r>
+              <a:rPr b="0" i="0">
+                <a:solidFill>
+                  <a:schemeClr val="lt1"/>
+                </a:solidFill>
+                <a:latin typeface="Consolas"/>
+              </a:rPr>
+              <a:t>}</a:t>
+            </a:r>
+            <a:br/>
+            <a:r>
+              <a:rPr b="1" i="0">
+                <a:solidFill>
+                  <a:schemeClr val="accent1">
+                    <a:lumMod val="80137"/>
+                    <a:lumOff val="19863"/>
+                  </a:schemeClr>
+                </a:solidFill>
+                <a:latin typeface="Consolas"/>
+              </a:rPr>
+              <a:t>const</a:t>
+            </a:r>
+            <a:r>
+              <a:rPr b="0" i="0">
+                <a:solidFill>
+                  <a:schemeClr val="lt1"/>
+                </a:solidFill>
+                <a:latin typeface="Consolas"/>
+              </a:rPr>
+              <a:t> </a:t>
+            </a:r>
+            <a:r>
+              <a:rPr b="0" i="0">
+                <a:solidFill>
+                  <a:schemeClr val="lt1"/>
+                </a:solidFill>
+                <a:latin typeface="Consolas"/>
+              </a:rPr>
+              <a:t>greet</a:t>
+            </a:r>
+            <a:r>
+              <a:rPr b="0" i="0">
+                <a:solidFill>
+                  <a:schemeClr val="lt1"/>
+                </a:solidFill>
+                <a:latin typeface="Consolas"/>
+              </a:rPr>
+              <a:t> </a:t>
+            </a:r>
+            <a:r>
+              <a:rPr b="0" i="0">
+                <a:solidFill>
+                  <a:schemeClr val="lt1"/>
+                </a:solidFill>
+                <a:latin typeface="Consolas"/>
+              </a:rPr>
+              <a:t>=</a:t>
+            </a:r>
+            <a:r>
+              <a:rPr b="0" i="0">
+                <a:solidFill>
+                  <a:schemeClr val="lt1"/>
+                </a:solidFill>
+                <a:latin typeface="Consolas"/>
+              </a:rPr>
+              <a:t> </a:t>
+            </a:r>
+            <a:r>
+              <a:rPr b="0" i="0">
+                <a:solidFill>
+                  <a:schemeClr val="lt1"/>
+                </a:solidFill>
+                <a:latin typeface="Consolas"/>
+              </a:rPr>
+              <a:t>(</a:t>
+            </a:r>
+            <a:r>
+              <a:rPr b="0" i="0">
+                <a:solidFill>
+                  <a:schemeClr val="lt1"/>
+                </a:solidFill>
+                <a:latin typeface="Consolas"/>
+              </a:rPr>
+              <a:t>name</a:t>
+            </a:r>
+            <a:r>
+              <a:rPr b="0" i="0">
+                <a:solidFill>
+                  <a:schemeClr val="lt1"/>
+                </a:solidFill>
+                <a:latin typeface="Consolas"/>
+              </a:rPr>
+              <a:t>:</a:t>
+            </a:r>
+            <a:r>
+              <a:rPr b="0" i="0">
+                <a:solidFill>
+                  <a:schemeClr val="lt1"/>
+                </a:solidFill>
+                <a:latin typeface="Consolas"/>
+              </a:rPr>
+              <a:t> </a:t>
+            </a:r>
+            <a:r>
+              <a:rPr b="0" i="0">
+                <a:solidFill>
+                  <a:schemeClr val="accent3"/>
+                </a:solidFill>
+                <a:latin typeface="Consolas"/>
+              </a:rPr>
+              <a:t>string</a:t>
+            </a:r>
+            <a:r>
+              <a:rPr b="0" i="0">
+                <a:solidFill>
+                  <a:schemeClr val="lt1"/>
+                </a:solidFill>
+                <a:latin typeface="Consolas"/>
+              </a:rPr>
+              <a:t>)</a:t>
+            </a:r>
+            <a:r>
+              <a:rPr b="0" i="0">
+                <a:solidFill>
+                  <a:schemeClr val="lt1"/>
+                </a:solidFill>
+                <a:latin typeface="Consolas"/>
+              </a:rPr>
+              <a:t>:</a:t>
+            </a:r>
+            <a:r>
+              <a:rPr b="0" i="0">
+                <a:solidFill>
+                  <a:schemeClr val="lt1"/>
+                </a:solidFill>
+                <a:latin typeface="Consolas"/>
+              </a:rPr>
+              <a:t> </a:t>
+            </a:r>
+            <a:r>
+              <a:rPr b="0" i="0">
+                <a:solidFill>
+                  <a:schemeClr val="lt1"/>
+                </a:solidFill>
+                <a:latin typeface="Consolas"/>
+              </a:rPr>
+              <a:t>Greeting</a:t>
+            </a:r>
+            <a:r>
+              <a:rPr b="0" i="0">
+                <a:solidFill>
+                  <a:schemeClr val="lt1"/>
+                </a:solidFill>
+                <a:latin typeface="Consolas"/>
+              </a:rPr>
+              <a:t> </a:t>
+            </a:r>
+            <a:r>
+              <a:rPr b="0" i="0">
+                <a:solidFill>
+                  <a:schemeClr val="lt1"/>
+                </a:solidFill>
+                <a:latin typeface="Consolas"/>
+              </a:rPr>
+              <a:t>=&gt;</a:t>
+            </a:r>
+            <a:r>
+              <a:rPr b="0" i="0">
+                <a:solidFill>
+                  <a:schemeClr val="lt1"/>
+                </a:solidFill>
+                <a:latin typeface="Consolas"/>
+              </a:rPr>
+              <a:t> </a:t>
+            </a:r>
+            <a:r>
+              <a:rPr b="0" i="0">
+                <a:solidFill>
+                  <a:schemeClr val="lt1"/>
+                </a:solidFill>
+                <a:latin typeface="Consolas"/>
+              </a:rPr>
+              <a:t>(</a:t>
+            </a:r>
+            <a:r>
+              <a:rPr b="0" i="0">
+                <a:solidFill>
+                  <a:schemeClr val="lt1"/>
+                </a:solidFill>
+                <a:latin typeface="Consolas"/>
+              </a:rPr>
+              <a:t>{</a:t>
+            </a:r>
+            <a:br/>
+            <a:r>
+              <a:rPr b="0" i="0">
+                <a:solidFill>
+                  <a:schemeClr val="lt1"/>
+                </a:solidFill>
+                <a:latin typeface="Consolas"/>
+              </a:rPr>
+              <a:t>  </a:t>
+            </a:r>
+            <a:r>
+              <a:rPr b="0" i="0">
+                <a:solidFill>
+                  <a:schemeClr val="lt1"/>
+                </a:solidFill>
+                <a:latin typeface="Consolas"/>
+              </a:rPr>
+              <a:t>message</a:t>
+            </a:r>
+            <a:r>
+              <a:rPr b="0" i="0">
+                <a:solidFill>
+                  <a:schemeClr val="lt1"/>
+                </a:solidFill>
+                <a:latin typeface="Consolas"/>
+              </a:rPr>
+              <a:t>:</a:t>
+            </a:r>
+            <a:r>
+              <a:rPr b="0" i="0">
+                <a:solidFill>
+                  <a:schemeClr val="lt1"/>
+                </a:solidFill>
+                <a:latin typeface="Consolas"/>
+              </a:rPr>
+              <a:t> </a:t>
+            </a:r>
+            <a:r>
+              <a:rPr b="0" i="0">
+                <a:solidFill>
+                  <a:schemeClr val="accent2"/>
+                </a:solidFill>
+                <a:latin typeface="Consolas"/>
+              </a:rPr>
+              <a:t>`</a:t>
+            </a:r>
+            <a:r>
+              <a:rPr b="0" i="0">
+                <a:solidFill>
+                  <a:schemeClr val="accent2"/>
+                </a:solidFill>
+                <a:latin typeface="Consolas"/>
+              </a:rPr>
+              <a:t>Hello, </a:t>
+            </a:r>
+            <a:r>
+              <a:rPr b="0" i="0">
+                <a:solidFill>
+                  <a:schemeClr val="accent2"/>
+                </a:solidFill>
+                <a:latin typeface="Consolas"/>
+              </a:rPr>
+              <a:t>${</a:t>
+            </a:r>
+            <a:r>
+              <a:rPr b="0" i="0">
+                <a:solidFill>
+                  <a:schemeClr val="lt1"/>
+                </a:solidFill>
+                <a:latin typeface="Consolas"/>
+              </a:rPr>
+              <a:t>name</a:t>
+            </a:r>
+            <a:r>
+              <a:rPr b="0" i="0">
+                <a:solidFill>
+                  <a:schemeClr val="accent2"/>
+                </a:solidFill>
+                <a:latin typeface="Consolas"/>
+              </a:rPr>
+              <a:t>}</a:t>
+            </a:r>
+            <a:r>
+              <a:rPr b="0" i="0">
+                <a:solidFill>
+                  <a:schemeClr val="accent2"/>
+                </a:solidFill>
+                <a:latin typeface="Consolas"/>
+              </a:rPr>
+              <a:t>`</a:t>
+            </a:r>
+            <a:br/>
+            <a:r>
+              <a:rPr b="0" i="0">
+                <a:solidFill>
+                  <a:schemeClr val="lt1"/>
+                </a:solidFill>
+                <a:latin typeface="Consolas"/>
+              </a:rPr>
+              <a:t>}</a:t>
+            </a:r>
+            <a:r>
+              <a:rPr b="0" i="0">
+                <a:solidFill>
+                  <a:schemeClr val="lt1"/>
+                </a:solidFill>
+                <a:latin typeface="Consolas"/>
+              </a:rPr>
+              <a:t>)</a:t>
+            </a:r>
+            <a:r>
+              <a:rPr b="0" i="0">
+                <a:solidFill>
+                  <a:schemeClr val="lt1"/>
+                </a:solidFill>
+                <a:latin typeface="Consolas"/>
+              </a:rPr>
+              <a:t>;</a:t>
+            </a:r>
+            <a:br/>
+            <a:br/>
+            <a:r>
+              <a:rPr b="0" i="0">
+                <a:solidFill>
+                  <a:schemeClr val="lt1"/>
+                </a:solidFill>
+                <a:latin typeface="Consolas"/>
+              </a:rPr>
+              <a:t>console</a:t>
+            </a:r>
+            <a:r>
+              <a:rPr b="0" i="0">
+                <a:solidFill>
+                  <a:schemeClr val="lt1"/>
+                </a:solidFill>
+                <a:latin typeface="Consolas"/>
+              </a:rPr>
+              <a:t>.</a:t>
+            </a:r>
+            <a:r>
+              <a:rPr b="0" i="0">
+                <a:solidFill>
+                  <a:schemeClr val="lt1"/>
+                </a:solidFill>
+                <a:latin typeface="Consolas"/>
+              </a:rPr>
+              <a:t>log</a:t>
+            </a:r>
+            <a:r>
+              <a:rPr b="0" i="0">
+                <a:solidFill>
+                  <a:schemeClr val="lt1"/>
+                </a:solidFill>
+                <a:latin typeface="Consolas"/>
+              </a:rPr>
+              <a:t>(</a:t>
+            </a:r>
+            <a:r>
+              <a:rPr b="0" i="0">
+                <a:solidFill>
+                  <a:schemeClr val="lt1"/>
+                </a:solidFill>
+                <a:latin typeface="Consolas"/>
+              </a:rPr>
+              <a:t>greet</a:t>
+            </a:r>
+            <a:r>
+              <a:rPr b="0" i="0">
+                <a:solidFill>
+                  <a:schemeClr val="lt1"/>
+                </a:solidFill>
+                <a:latin typeface="Consolas"/>
+              </a:rPr>
+              <a:t>(</a:t>
+            </a:r>
+            <a:r>
+              <a:rPr b="0" i="0">
+                <a:solidFill>
+                  <a:schemeClr val="accent2"/>
+                </a:solidFill>
+                <a:latin typeface="Consolas"/>
+              </a:rPr>
+              <a:t>"PowerPoint"</a:t>
+            </a:r>
+            <a:r>
+              <a:rPr b="0" i="0">
+                <a:solidFill>
+                  <a:schemeClr val="lt1"/>
+                </a:solidFill>
+                <a:latin typeface="Consolas"/>
+              </a:rPr>
+              <a:t>)</a:t>
+            </a:r>
+            <a:r>
+              <a:rPr b="0" i="0">
+                <a:solidFill>
+                  <a:schemeClr val="lt1"/>
+                </a:solidFill>
+                <a:latin typeface="Consolas"/>
+              </a:rPr>
+              <a:t>)</a:t>
+            </a:r>
+            <a:r>
+              <a:rPr b="0" i="0">
+                <a:solidFill>
+                  <a:schemeClr val="lt1"/>
+                </a:solidFill>
+                <a:latin typeface="Consolas"/>
+              </a:rPr>
+              <a:t>;</a:t>
+            </a:r>
+            <a:endParaRPr>
+              <a:solidFill>
+                <a:srgbClr val="FFFFFF"/>
+              </a:solidFill>
+            </a:endParaRPr>
+          </a:p>
+        </p:txBody>
+      </p:sp>
+    </p:spTree>
+  </p:cSld>
+  <p:clrMapOvr>
+    <a:masterClrMapping/>
+  </p:clrMapOvr>
+</p:sld>
+</file>
+
+<file path=ppt/slides/slide45.xml><?xml version="1.0" encoding="utf-8"?>
+<p:sld xmlns:a="http://schemas.openxmlformats.org/drawingml/2006/main" xmlns:p="http://schemas.openxmlformats.org/presentationml/2006/main" xmlns:r="http://schemas.openxmlformats.org/officeDocument/2006/relationships">
+  <p:cSld>
+    <p:bg>
+      <p:bgPr>
+        <a:gradFill rotWithShape="1">
+          <a:gsLst>
+            <a:gs pos="0">
+              <a:srgbClr val="FFFFFF"/>
+            </a:gs>
+            <a:gs pos="100000">
+              <a:srgbClr val="D8EBFF"/>
+            </a:gs>
+          </a:gsLst>
+          <a:lin ang="0" scaled="0"/>
+        </a:gradFill>
+        <a:effectLst/>
+      </p:bgPr>
+    </p:bg>
+    <p:spTree>
+      <p:nvGrpSpPr>
+        <p:cNvPr id="1" name=""/>
+        <p:cNvGrpSpPr/>
+        <p:nvPr/>
+      </p:nvGrpSpPr>
+      <p:grpSpPr/>
+      <p:sp>
+        <p:nvSpPr>
+          <p:cNvPr id="2" name="Title 1"/>
+          <p:cNvSpPr>
+            <a:spLocks noGrp="1"/>
+          </p:cNvSpPr>
+          <p:nvPr>
+            <p:ph type="title"/>
+          </p:nvPr>
+        </p:nvSpPr>
+        <p:spPr/>
+        <p:txBody>
+          <a:bodyPr>
+            <a:normAutofit/>
+          </a:bodyPr>
+          <a:lstStyle/>
+          <a:p>
+            <a:pPr>
+              <a:defRPr>
+                <a:solidFill>
+                  <a:schemeClr val="accent6"/>
+                </a:solidFill>
+              </a:defRPr>
+            </a:pPr>
+            <a:r>
+              <a:rPr>
+                <a:solidFill>
+                  <a:schemeClr val="accent6"/>
+                </a:solidFill>
+              </a:rPr>
+              <a:t>Theme syntax: a light gradient</a:t>
+            </a:r>
+            <a:endParaRPr>
+              <a:solidFill>
+                <a:schemeClr val="accent6"/>
+              </a:solidFill>
+            </a:endParaRPr>
+          </a:p>
+        </p:txBody>
+      </p:sp>
+      <p:sp>
+        <p:nvSpPr>
+          <p:cNvPr id="3" name="Content Placeholder 2"/>
+          <p:cNvSpPr>
+            <a:spLocks noGrp="1"/>
+          </p:cNvSpPr>
+          <p:nvPr>
+            <p:ph idx="1"/>
+          </p:nvPr>
+        </p:nvSpPr>
+        <p:spPr/>
+        <p:txBody>
+          <a:bodyPr wrap="square">
+            <a:normAutofit/>
+          </a:bodyPr>
+          <a:lstStyle/>
+          <a:p>
+            <a:pPr marL="0" indent="0">
+              <a:buNone/>
+              <a:defRPr>
+                <a:solidFill>
+                  <a:schemeClr val="dk1"/>
+                </a:solidFill>
+              </a:defRPr>
+            </a:pPr>
+            <a:r>
+              <a:rPr b="0" i="0">
+                <a:solidFill>
+                  <a:schemeClr val="dk1"/>
+                </a:solidFill>
+                <a:latin typeface="+mn-lt"/>
+                <a:ea typeface="+mn-ea"/>
+                <a:cs typeface="+mn-cs"/>
+              </a:rPr>
+              <a:t>The background range guides the brightness adjustments.</a:t>
+            </a:r>
+            <a:endParaRPr>
+              <a:solidFill>
+                <a:schemeClr val="dk1"/>
+              </a:solidFill>
+            </a:endParaRPr>
+          </a:p>
+          <a:p>
+            <a:pPr marL="0" indent="0">
+              <a:buNone/>
+              <a:defRPr>
+                <a:solidFill>
+                  <a:schemeClr val="dk1"/>
+                </a:solidFill>
+              </a:defRPr>
+            </a:pPr>
+            <a:r>
+              <a:rPr b="0" i="1">
+                <a:solidFill>
+                  <a:schemeClr val="dk1"/>
+                </a:solidFill>
+                <a:latin typeface="Consolas"/>
+              </a:rPr>
+              <a:t>&lt;!-- Theme colors stay editable --&gt;</a:t>
+            </a:r>
+            <a:br/>
+            <a:r>
+              <a:rPr b="0" i="0">
+                <a:solidFill>
+                  <a:schemeClr val="dk1"/>
+                </a:solidFill>
+                <a:latin typeface="Consolas"/>
+              </a:rPr>
+              <a:t>&lt;</a:t>
+            </a:r>
+            <a:r>
+              <a:rPr b="1" i="0">
+                <a:solidFill>
+                  <a:schemeClr val="accent1">
+                    <a:lumMod val="99549"/>
+                  </a:schemeClr>
+                </a:solidFill>
+                <a:latin typeface="Consolas"/>
+              </a:rPr>
+              <a:t>article</a:t>
+            </a:r>
+            <a:r>
+              <a:rPr b="0" i="0">
+                <a:solidFill>
+                  <a:schemeClr val="dk1"/>
+                </a:solidFill>
+                <a:latin typeface="Consolas"/>
+              </a:rPr>
+              <a:t> </a:t>
+            </a:r>
+            <a:r>
+              <a:rPr b="0" i="0">
+                <a:solidFill>
+                  <a:schemeClr val="accent3">
+                    <a:lumMod val="49725"/>
+                  </a:schemeClr>
+                </a:solidFill>
+                <a:latin typeface="Consolas"/>
+              </a:rPr>
+              <a:t>class</a:t>
+            </a:r>
+            <a:r>
+              <a:rPr b="0" i="0">
+                <a:solidFill>
+                  <a:schemeClr val="dk1"/>
+                </a:solidFill>
+                <a:latin typeface="Consolas"/>
+              </a:rPr>
+              <a:t>=</a:t>
+            </a:r>
+            <a:r>
+              <a:rPr b="0" i="0">
+                <a:solidFill>
+                  <a:schemeClr val="accent2">
+                    <a:lumMod val="62515"/>
+                  </a:schemeClr>
+                </a:solidFill>
+                <a:latin typeface="Consolas"/>
+              </a:rPr>
+              <a:t>"greeting"</a:t>
+            </a:r>
+            <a:r>
+              <a:rPr b="0" i="0">
+                <a:solidFill>
+                  <a:schemeClr val="dk1"/>
+                </a:solidFill>
+                <a:latin typeface="Consolas"/>
+              </a:rPr>
+              <a:t>&gt;</a:t>
+            </a:r>
+            <a:br/>
+            <a:r>
+              <a:rPr b="0" i="0">
+                <a:solidFill>
+                  <a:schemeClr val="dk1"/>
+                </a:solidFill>
+                <a:latin typeface="Consolas"/>
+              </a:rPr>
+              <a:t>  </a:t>
+            </a:r>
+            <a:r>
+              <a:rPr b="0" i="0">
+                <a:solidFill>
+                  <a:schemeClr val="dk1"/>
+                </a:solidFill>
+                <a:latin typeface="Consolas"/>
+              </a:rPr>
+              <a:t>&lt;</a:t>
+            </a:r>
+            <a:r>
+              <a:rPr b="1" i="0">
+                <a:solidFill>
+                  <a:schemeClr val="accent1">
+                    <a:lumMod val="99549"/>
+                  </a:schemeClr>
+                </a:solidFill>
+                <a:latin typeface="Consolas"/>
+              </a:rPr>
+              <a:t>h2</a:t>
+            </a:r>
+            <a:r>
+              <a:rPr b="0" i="0">
+                <a:solidFill>
+                  <a:schemeClr val="dk1"/>
+                </a:solidFill>
+                <a:latin typeface="Consolas"/>
+              </a:rPr>
+              <a:t>&gt;</a:t>
+            </a:r>
+            <a:r>
+              <a:rPr b="0" i="0">
+                <a:solidFill>
+                  <a:schemeClr val="dk1"/>
+                </a:solidFill>
+                <a:latin typeface="Consolas"/>
+              </a:rPr>
+              <a:t>Hello, PowerPoint</a:t>
+            </a:r>
+            <a:r>
+              <a:rPr b="0" i="0">
+                <a:solidFill>
+                  <a:schemeClr val="dk1"/>
+                </a:solidFill>
+                <a:latin typeface="Consolas"/>
+              </a:rPr>
+              <a:t>&lt;</a:t>
+            </a:r>
+            <a:r>
+              <a:rPr b="0" i="0">
+                <a:solidFill>
+                  <a:schemeClr val="dk1"/>
+                </a:solidFill>
+                <a:latin typeface="Consolas"/>
+              </a:rPr>
+              <a:t>/</a:t>
+            </a:r>
+            <a:r>
+              <a:rPr b="1" i="0">
+                <a:solidFill>
+                  <a:schemeClr val="accent1">
+                    <a:lumMod val="99549"/>
+                  </a:schemeClr>
+                </a:solidFill>
+                <a:latin typeface="Consolas"/>
+              </a:rPr>
+              <a:t>h2</a:t>
+            </a:r>
+            <a:r>
+              <a:rPr b="0" i="0">
+                <a:solidFill>
+                  <a:schemeClr val="dk1"/>
+                </a:solidFill>
+                <a:latin typeface="Consolas"/>
+              </a:rPr>
+              <a:t>&gt;</a:t>
+            </a:r>
+            <a:br/>
+            <a:r>
+              <a:rPr b="0" i="0">
+                <a:solidFill>
+                  <a:schemeClr val="dk1"/>
+                </a:solidFill>
+                <a:latin typeface="Consolas"/>
+              </a:rPr>
+              <a:t>  </a:t>
+            </a:r>
+            <a:r>
+              <a:rPr b="0" i="0">
+                <a:solidFill>
+                  <a:schemeClr val="dk1"/>
+                </a:solidFill>
+                <a:latin typeface="Consolas"/>
+              </a:rPr>
+              <a:t>&lt;</a:t>
+            </a:r>
+            <a:r>
+              <a:rPr b="1" i="0">
+                <a:solidFill>
+                  <a:schemeClr val="accent1">
+                    <a:lumMod val="99549"/>
+                  </a:schemeClr>
+                </a:solidFill>
+                <a:latin typeface="Consolas"/>
+              </a:rPr>
+              <a:t>p</a:t>
+            </a:r>
+            <a:r>
+              <a:rPr b="0" i="0">
+                <a:solidFill>
+                  <a:schemeClr val="dk1"/>
+                </a:solidFill>
+                <a:latin typeface="Consolas"/>
+              </a:rPr>
+              <a:t> </a:t>
+            </a:r>
+            <a:r>
+              <a:rPr b="0" i="0">
+                <a:solidFill>
+                  <a:schemeClr val="accent3">
+                    <a:lumMod val="49725"/>
+                  </a:schemeClr>
+                </a:solidFill>
+                <a:latin typeface="Consolas"/>
+              </a:rPr>
+              <a:t>data-state</a:t>
+            </a:r>
+            <a:r>
+              <a:rPr b="0" i="0">
+                <a:solidFill>
+                  <a:schemeClr val="dk1"/>
+                </a:solidFill>
+                <a:latin typeface="Consolas"/>
+              </a:rPr>
+              <a:t>=</a:t>
+            </a:r>
+            <a:r>
+              <a:rPr b="0" i="0">
+                <a:solidFill>
+                  <a:schemeClr val="accent2">
+                    <a:lumMod val="62515"/>
+                  </a:schemeClr>
+                </a:solidFill>
+                <a:latin typeface="Consolas"/>
+              </a:rPr>
+              <a:t>"ready"</a:t>
+            </a:r>
+            <a:r>
+              <a:rPr b="0" i="0">
+                <a:solidFill>
+                  <a:schemeClr val="dk1"/>
+                </a:solidFill>
+                <a:latin typeface="Consolas"/>
+              </a:rPr>
+              <a:t>&gt;</a:t>
+            </a:r>
+            <a:r>
+              <a:rPr b="0" i="0">
+                <a:solidFill>
+                  <a:schemeClr val="dk1"/>
+                </a:solidFill>
+                <a:latin typeface="Consolas"/>
+              </a:rPr>
+              <a:t>Ready to present.</a:t>
+            </a:r>
+            <a:r>
+              <a:rPr b="0" i="0">
+                <a:solidFill>
+                  <a:schemeClr val="dk1"/>
+                </a:solidFill>
+                <a:latin typeface="Consolas"/>
+              </a:rPr>
+              <a:t>&lt;</a:t>
+            </a:r>
+            <a:r>
+              <a:rPr b="0" i="0">
+                <a:solidFill>
+                  <a:schemeClr val="dk1"/>
+                </a:solidFill>
+                <a:latin typeface="Consolas"/>
+              </a:rPr>
+              <a:t>/</a:t>
+            </a:r>
+            <a:r>
+              <a:rPr b="1" i="0">
+                <a:solidFill>
+                  <a:schemeClr val="accent1">
+                    <a:lumMod val="99549"/>
+                  </a:schemeClr>
+                </a:solidFill>
+                <a:latin typeface="Consolas"/>
+              </a:rPr>
+              <a:t>p</a:t>
+            </a:r>
+            <a:r>
+              <a:rPr b="0" i="0">
+                <a:solidFill>
+                  <a:schemeClr val="dk1"/>
+                </a:solidFill>
+                <a:latin typeface="Consolas"/>
+              </a:rPr>
+              <a:t>&gt;</a:t>
+            </a:r>
+            <a:br/>
+            <a:r>
+              <a:rPr b="0" i="0">
+                <a:solidFill>
+                  <a:schemeClr val="dk1"/>
+                </a:solidFill>
+                <a:latin typeface="Consolas"/>
+              </a:rPr>
+              <a:t>&lt;</a:t>
+            </a:r>
+            <a:r>
+              <a:rPr b="0" i="0">
+                <a:solidFill>
+                  <a:schemeClr val="dk1"/>
+                </a:solidFill>
+                <a:latin typeface="Consolas"/>
+              </a:rPr>
+              <a:t>/</a:t>
+            </a:r>
+            <a:r>
+              <a:rPr b="1" i="0">
+                <a:solidFill>
+                  <a:schemeClr val="accent1">
+                    <a:lumMod val="99549"/>
+                  </a:schemeClr>
+                </a:solidFill>
+                <a:latin typeface="Consolas"/>
+              </a:rPr>
+              <a:t>article</a:t>
+            </a:r>
+            <a:r>
+              <a:rPr b="0" i="0">
+                <a:solidFill>
+                  <a:schemeClr val="dk1"/>
+                </a:solidFill>
+                <a:latin typeface="Consolas"/>
+              </a:rPr>
+              <a:t>&gt;</a:t>
+            </a:r>
+            <a:endParaRPr>
+              <a:solidFill>
+                <a:schemeClr val="dk1"/>
+              </a:solidFill>
+            </a:endParaRPr>
+          </a:p>
+        </p:txBody>
+      </p:sp>
+    </p:spTree>
+  </p:cSld>
+  <p:clrMapOvr>
+    <a:masterClrMapping/>
+  </p:clrMapOvr>
+</p:sld>
+</file>
+
+<file path=ppt/slides/slide46.xml><?xml version="1.0" encoding="utf-8"?>
+<p:sld xmlns:a="http://schemas.openxmlformats.org/drawingml/2006/main" xmlns:p="http://schemas.openxmlformats.org/presentationml/2006/main" xmlns:r="http://schemas.openxmlformats.org/officeDocument/2006/relationships">
+  <p:cSld>
+    <p:bg>
+      <p:bgPr>
+        <a:gradFill rotWithShape="1">
+          <a:gsLst>
+            <a:gs pos="0">
+              <a:srgbClr val="254D70"/>
+            </a:gs>
+            <a:gs pos="100000">
+              <a:srgbClr val="102030"/>
+            </a:gs>
+          </a:gsLst>
+          <a:path path="circle">
+            <a:fillToRect l="50000" t="50000" r="50000" b="50000"/>
+          </a:path>
+        </a:gradFill>
+        <a:effectLst/>
+      </p:bgPr>
+    </p:bg>
+    <p:spTree>
+      <p:nvGrpSpPr>
+        <p:cNvPr id="1" name=""/>
+        <p:cNvGrpSpPr/>
+        <p:nvPr/>
+      </p:nvGrpSpPr>
+      <p:grpSpPr/>
+      <p:sp>
+        <p:nvSpPr>
+          <p:cNvPr id="2" name="Title 1"/>
+          <p:cNvSpPr>
+            <a:spLocks noGrp="1"/>
+          </p:cNvSpPr>
+          <p:nvPr>
+            <p:ph type="title"/>
+          </p:nvPr>
+        </p:nvSpPr>
+        <p:spPr/>
+        <p:txBody>
+          <a:bodyPr>
+            <a:normAutofit/>
+          </a:bodyPr>
+          <a:lstStyle/>
+          <a:p>
+            <a:pPr>
+              <a:defRPr>
+                <a:solidFill>
+                  <a:srgbClr val="FFFFFF"/>
+                </a:solidFill>
+              </a:defRPr>
+            </a:pPr>
+            <a:r>
+              <a:rPr>
+                <a:solidFill>
+                  <a:srgbClr val="FFFFFF"/>
+                </a:solidFill>
+              </a:rPr>
+              <a:t>Theme syntax: a dark gradient</a:t>
+            </a:r>
+            <a:endParaRPr>
+              <a:solidFill>
+                <a:srgbClr val="FFFFFF"/>
+              </a:solidFill>
+            </a:endParaRPr>
+          </a:p>
+        </p:txBody>
+      </p:sp>
+      <p:sp>
+        <p:nvSpPr>
+          <p:cNvPr id="3" name="Content Placeholder 2"/>
+          <p:cNvSpPr>
+            <a:spLocks noGrp="1"/>
+          </p:cNvSpPr>
+          <p:nvPr>
+            <p:ph idx="1"/>
+          </p:nvPr>
+        </p:nvSpPr>
+        <p:spPr/>
+        <p:txBody>
+          <a:bodyPr wrap="square">
+            <a:normAutofit/>
+          </a:bodyPr>
+          <a:lstStyle/>
+          <a:p>
+            <a:pPr marL="0" indent="0">
+              <a:buNone/>
+              <a:defRPr>
+                <a:solidFill>
+                  <a:srgbClr val="FFFFFF"/>
+                </a:solidFill>
+              </a:defRPr>
+            </a:pPr>
+            <a:r>
+              <a:rPr b="0" i="0">
+                <a:solidFill>
+                  <a:srgbClr val="FFFFFF"/>
+                </a:solidFill>
+                <a:latin typeface="+mn-lt"/>
+                <a:ea typeface="+mn-ea"/>
+                <a:cs typeface="+mn-cs"/>
+              </a:rPr>
+              <a:t>One palette is reused across all code blocks in this area.</a:t>
+            </a:r>
+            <a:endParaRPr>
+              <a:solidFill>
+                <a:srgbClr val="FFFFFF"/>
+              </a:solidFill>
+            </a:endParaRPr>
+          </a:p>
+          <a:p>
+            <a:pPr marL="0" indent="0">
+              <a:buNone/>
+              <a:defRPr>
+                <a:solidFill>
+                  <a:srgbClr val="FFFFFF"/>
+                </a:solidFill>
+              </a:defRPr>
+            </a:pPr>
+            <a:r>
+              <a:rPr b="0" i="1">
+                <a:solidFill>
+                  <a:schemeClr val="lt1"/>
+                </a:solidFill>
+                <a:latin typeface="Consolas"/>
+              </a:rPr>
+              <a:t>/* Presentation colors follow the theme */</a:t>
+            </a:r>
+            <a:br/>
+            <a:r>
+              <a:rPr b="0" i="0">
+                <a:solidFill>
+                  <a:schemeClr val="lt1"/>
+                </a:solidFill>
+                <a:latin typeface="Consolas"/>
+              </a:rPr>
+              <a:t>.</a:t>
+            </a:r>
+            <a:r>
+              <a:rPr b="0" i="0">
+                <a:solidFill>
+                  <a:schemeClr val="accent3"/>
+                </a:solidFill>
+                <a:latin typeface="Consolas"/>
+              </a:rPr>
+              <a:t>greeting</a:t>
+            </a:r>
+            <a:r>
+              <a:rPr b="0" i="0">
+                <a:solidFill>
+                  <a:schemeClr val="lt1"/>
+                </a:solidFill>
+                <a:latin typeface="Consolas"/>
+              </a:rPr>
+              <a:t> </a:t>
+            </a:r>
+            <a:r>
+              <a:rPr b="0" i="0">
+                <a:solidFill>
+                  <a:schemeClr val="lt1"/>
+                </a:solidFill>
+                <a:latin typeface="Consolas"/>
+              </a:rPr>
+              <a:t>{</a:t>
+            </a:r>
+            <a:br/>
+            <a:r>
+              <a:rPr b="0" i="0">
+                <a:solidFill>
+                  <a:schemeClr val="lt1"/>
+                </a:solidFill>
+                <a:latin typeface="Consolas"/>
+              </a:rPr>
+              <a:t>  </a:t>
+            </a:r>
+            <a:r>
+              <a:rPr b="1" i="0">
+                <a:solidFill>
+                  <a:schemeClr val="accent1">
+                    <a:lumMod val="47936"/>
+                    <a:lumOff val="52064"/>
+                  </a:schemeClr>
+                </a:solidFill>
+                <a:latin typeface="Consolas"/>
+              </a:rPr>
+              <a:t>color</a:t>
+            </a:r>
+            <a:r>
+              <a:rPr b="0" i="0">
+                <a:solidFill>
+                  <a:schemeClr val="lt1"/>
+                </a:solidFill>
+                <a:latin typeface="Consolas"/>
+              </a:rPr>
+              <a:t>:</a:t>
+            </a:r>
+            <a:r>
+              <a:rPr b="0" i="0">
+                <a:solidFill>
+                  <a:schemeClr val="lt1"/>
+                </a:solidFill>
+                <a:latin typeface="Consolas"/>
+              </a:rPr>
+              <a:t> </a:t>
+            </a:r>
+            <a:r>
+              <a:rPr b="0" i="0">
+                <a:solidFill>
+                  <a:schemeClr val="accent2">
+                    <a:lumMod val="77325"/>
+                    <a:lumOff val="22675"/>
+                  </a:schemeClr>
+                </a:solidFill>
+                <a:latin typeface="Consolas"/>
+              </a:rPr>
+              <a:t>#1d6fa8</a:t>
+            </a:r>
+            <a:r>
+              <a:rPr b="0" i="0">
+                <a:solidFill>
+                  <a:schemeClr val="lt1"/>
+                </a:solidFill>
+                <a:latin typeface="Consolas"/>
+              </a:rPr>
+              <a:t>;</a:t>
+            </a:r>
+            <a:br/>
+            <a:r>
+              <a:rPr b="0" i="0">
+                <a:solidFill>
+                  <a:schemeClr val="lt1"/>
+                </a:solidFill>
+                <a:latin typeface="Consolas"/>
+              </a:rPr>
+              <a:t>  </a:t>
+            </a:r>
+            <a:r>
+              <a:rPr b="1" i="0">
+                <a:solidFill>
+                  <a:schemeClr val="accent1">
+                    <a:lumMod val="47936"/>
+                    <a:lumOff val="52064"/>
+                  </a:schemeClr>
+                </a:solidFill>
+                <a:latin typeface="Consolas"/>
+              </a:rPr>
+              <a:t>padding</a:t>
+            </a:r>
+            <a:r>
+              <a:rPr b="0" i="0">
+                <a:solidFill>
+                  <a:schemeClr val="lt1"/>
+                </a:solidFill>
+                <a:latin typeface="Consolas"/>
+              </a:rPr>
+              <a:t>:</a:t>
+            </a:r>
+            <a:r>
+              <a:rPr b="0" i="0">
+                <a:solidFill>
+                  <a:schemeClr val="lt1"/>
+                </a:solidFill>
+                <a:latin typeface="Consolas"/>
+              </a:rPr>
+              <a:t> </a:t>
+            </a:r>
+            <a:r>
+              <a:rPr b="0" i="0">
+                <a:solidFill>
+                  <a:schemeClr val="accent2">
+                    <a:lumMod val="77325"/>
+                    <a:lumOff val="22675"/>
+                  </a:schemeClr>
+                </a:solidFill>
+                <a:latin typeface="Consolas"/>
+              </a:rPr>
+              <a:t>24</a:t>
+            </a:r>
+            <a:r>
+              <a:rPr b="0" i="0">
+                <a:solidFill>
+                  <a:schemeClr val="accent3"/>
+                </a:solidFill>
+                <a:latin typeface="Consolas"/>
+              </a:rPr>
+              <a:t>px</a:t>
+            </a:r>
+            <a:r>
+              <a:rPr b="0" i="0">
+                <a:solidFill>
+                  <a:schemeClr val="lt1"/>
+                </a:solidFill>
+                <a:latin typeface="Consolas"/>
+              </a:rPr>
+              <a:t>;</a:t>
+            </a:r>
+            <a:br/>
+            <a:r>
+              <a:rPr b="0" i="0">
+                <a:solidFill>
+                  <a:schemeClr val="lt1"/>
+                </a:solidFill>
+                <a:latin typeface="Consolas"/>
+              </a:rPr>
+              <a:t>  </a:t>
+            </a:r>
+            <a:r>
+              <a:rPr b="1" i="0">
+                <a:solidFill>
+                  <a:schemeClr val="accent1">
+                    <a:lumMod val="47936"/>
+                    <a:lumOff val="52064"/>
+                  </a:schemeClr>
+                </a:solidFill>
+                <a:latin typeface="Consolas"/>
+              </a:rPr>
+              <a:t>display</a:t>
+            </a:r>
+            <a:r>
+              <a:rPr b="0" i="0">
+                <a:solidFill>
+                  <a:schemeClr val="lt1"/>
+                </a:solidFill>
+                <a:latin typeface="Consolas"/>
+              </a:rPr>
+              <a:t>:</a:t>
+            </a:r>
+            <a:r>
+              <a:rPr b="0" i="0">
+                <a:solidFill>
+                  <a:schemeClr val="lt1"/>
+                </a:solidFill>
+                <a:latin typeface="Consolas"/>
+              </a:rPr>
+              <a:t> </a:t>
+            </a:r>
+            <a:r>
+              <a:rPr b="1" i="0">
+                <a:solidFill>
+                  <a:schemeClr val="accent1">
+                    <a:lumMod val="47936"/>
+                    <a:lumOff val="52064"/>
+                  </a:schemeClr>
+                </a:solidFill>
+                <a:latin typeface="Consolas"/>
+              </a:rPr>
+              <a:t>grid</a:t>
+            </a:r>
+            <a:r>
+              <a:rPr b="0" i="0">
+                <a:solidFill>
+                  <a:schemeClr val="lt1"/>
+                </a:solidFill>
+                <a:latin typeface="Consolas"/>
+              </a:rPr>
+              <a:t>;</a:t>
+            </a:r>
+            <a:br/>
+            <a:r>
+              <a:rPr b="0" i="0">
+                <a:solidFill>
+                  <a:schemeClr val="lt1"/>
+                </a:solidFill>
+                <a:latin typeface="Consolas"/>
+              </a:rPr>
+              <a:t>  </a:t>
+            </a:r>
+            <a:r>
+              <a:rPr b="1" i="0">
+                <a:solidFill>
+                  <a:schemeClr val="accent1">
+                    <a:lumMod val="47936"/>
+                    <a:lumOff val="52064"/>
+                  </a:schemeClr>
+                </a:solidFill>
+                <a:latin typeface="Consolas"/>
+              </a:rPr>
+              <a:t>gap</a:t>
+            </a:r>
+            <a:r>
+              <a:rPr b="0" i="0">
+                <a:solidFill>
+                  <a:schemeClr val="lt1"/>
+                </a:solidFill>
+                <a:latin typeface="Consolas"/>
+              </a:rPr>
+              <a:t>:</a:t>
+            </a:r>
+            <a:r>
+              <a:rPr b="0" i="0">
+                <a:solidFill>
+                  <a:schemeClr val="lt1"/>
+                </a:solidFill>
+                <a:latin typeface="Consolas"/>
+              </a:rPr>
+              <a:t> </a:t>
+            </a:r>
+            <a:r>
+              <a:rPr b="0" i="0">
+                <a:solidFill>
+                  <a:schemeClr val="accent2">
+                    <a:lumMod val="77325"/>
+                    <a:lumOff val="22675"/>
+                  </a:schemeClr>
+                </a:solidFill>
+                <a:latin typeface="Consolas"/>
+              </a:rPr>
+              <a:t>12</a:t>
+            </a:r>
+            <a:r>
+              <a:rPr b="0" i="0">
+                <a:solidFill>
+                  <a:schemeClr val="accent3"/>
+                </a:solidFill>
+                <a:latin typeface="Consolas"/>
+              </a:rPr>
+              <a:t>px</a:t>
+            </a:r>
+            <a:r>
+              <a:rPr b="0" i="0">
+                <a:solidFill>
+                  <a:schemeClr val="lt1"/>
+                </a:solidFill>
+                <a:latin typeface="Consolas"/>
+              </a:rPr>
+              <a:t>;</a:t>
+            </a:r>
+            <a:br/>
+            <a:r>
+              <a:rPr b="0" i="0">
+                <a:solidFill>
+                  <a:schemeClr val="lt1"/>
+                </a:solidFill>
+                <a:latin typeface="Consolas"/>
+              </a:rPr>
+              <a:t>}</a:t>
+            </a:r>
+            <a:endParaRPr>
+              <a:solidFill>
+                <a:srgbClr val="FFFFFF"/>
+              </a:solidFill>
+            </a:endParaRPr>
+          </a:p>
+        </p:txBody>
+      </p:sp>
+    </p:spTree>
+  </p:cSld>
+  <p:clrMapOvr>
+    <a:masterClrMapping/>
+  </p:clrMapOvr>
+</p:sld>
+</file>
+
+<file path=ppt/slides/slide47.xml><?xml version="1.0" encoding="utf-8"?>
 <p:sld xmlns:a="http://schemas.openxmlformats.org/drawingml/2006/main" xmlns:p="http://schemas.openxmlformats.org/presentationml/2006/main" xmlns:r="http://schemas.openxmlformats.org/officeDocument/2006/relationships">
   <p:cSld>
     <p:spTree>

</xml_diff>

<commit_message>
Resolve deck references and preserve list structure and link titles
</commit_message>
<xml_diff>
--- a/sample/showcase.pptx
+++ b/sample/showcase.pptx
@@ -56,6 +56,9 @@
     <p:sldId xmlns:ns0="http://schemas.openxmlformats.org/officeDocument/2006/relationships" id="300" ns0:id="rId52"/>
     <p:sldId xmlns:ns0="http://schemas.openxmlformats.org/officeDocument/2006/relationships" id="301" ns0:id="rId53"/>
     <p:sldId xmlns:ns0="http://schemas.openxmlformats.org/officeDocument/2006/relationships" id="302" ns0:id="rId54"/>
+    <p:sldId xmlns:ns0="http://schemas.openxmlformats.org/officeDocument/2006/relationships" id="303" ns0:id="rId55"/>
+    <p:sldId xmlns:ns0="http://schemas.openxmlformats.org/officeDocument/2006/relationships" id="304" ns0:id="rId56"/>
+    <p:sldId xmlns:ns0="http://schemas.openxmlformats.org/officeDocument/2006/relationships" id="305" ns0:id="rId57"/>
   </p:sldIdLst>
   <p:sldSz cx="12192000" cy="6858000"/>
   <p:notesSz cx="6858000" cy="9144000"/>
@@ -820,6 +823,216 @@
           <a:p>
             <a:r>
               <a:t>A dark radial gradient demonstrates the light variant. Native theme references retain their slot and use brightness adjustments for the estimated background range.</a:t>
+            </a:r>
+          </a:p>
+        </p:txBody>
+      </p:sp>
+      <p:sp>
+        <p:nvSpPr>
+          <p:cNvPr id="4" name="Slide Number Placeholder 3"/>
+          <p:cNvSpPr>
+            <a:spLocks noGrp="1"/>
+          </p:cNvSpPr>
+          <p:nvPr>
+            <p:ph type="sldNum" idx="5" sz="quarter"/>
+          </p:nvPr>
+        </p:nvSpPr>
+        <p:spPr/>
+      </p:sp>
+    </p:spTree>
+  </p:cSld>
+  <p:clrMapOvr>
+    <a:masterClrMapping/>
+  </p:clrMapOvr>
+</p:notes>
+</file>
+
+<file path=ppt/notesSlides/notesSlide14.xml><?xml version="1.0" encoding="utf-8"?>
+<p:notes xmlns:a="http://schemas.openxmlformats.org/drawingml/2006/main" xmlns:p="http://schemas.openxmlformats.org/presentationml/2006/main" xmlns:r="http://schemas.openxmlformats.org/officeDocument/2006/relationships">
+  <p:cSld>
+    <p:spTree>
+      <p:nvGrpSpPr>
+        <p:cNvPr id="1" name=""/>
+        <p:cNvGrpSpPr/>
+        <p:nvPr/>
+      </p:nvGrpSpPr>
+      <p:grpSpPr>
+        <a:xfrm>
+          <a:off x="0" y="0"/>
+          <a:ext cx="0" cy="0"/>
+          <a:chOff x="0" y="0"/>
+          <a:chExt cx="0" cy="0"/>
+        </a:xfrm>
+      </p:grpSpPr>
+      <p:sp>
+        <p:nvSpPr>
+          <p:cNvPr id="2" name="Slide Image Placeholder 1"/>
+          <p:cNvSpPr>
+            <a:spLocks noGrp="1"/>
+          </p:cNvSpPr>
+          <p:nvPr>
+            <p:ph type="sldImg" idx="2"/>
+          </p:nvPr>
+        </p:nvSpPr>
+        <p:spPr/>
+      </p:sp>
+      <p:sp>
+        <p:nvSpPr>
+          <p:cNvPr id="3" name="Notes Placeholder 2"/>
+          <p:cNvSpPr>
+            <a:spLocks noGrp="1"/>
+          </p:cNvSpPr>
+          <p:nvPr>
+            <p:ph type="body" idx="3" sz="quarter"/>
+          </p:nvPr>
+        </p:nvSpPr>
+        <p:spPr/>
+        <p:txBody>
+          <a:bodyPr/>
+          <a:lstStyle/>
+          <a:p>
+            <a:r>
+              <a:t>The title and body use a reference defined on a later slide. The optional link title becomes a ScreenTip in PowerPoint. Hover over a link in Slide Show view to see the tip.</a:t>
+            </a:r>
+          </a:p>
+        </p:txBody>
+      </p:sp>
+      <p:sp>
+        <p:nvSpPr>
+          <p:cNvPr id="4" name="Slide Number Placeholder 3"/>
+          <p:cNvSpPr>
+            <a:spLocks noGrp="1"/>
+          </p:cNvSpPr>
+          <p:nvPr>
+            <p:ph type="sldNum" idx="5" sz="quarter"/>
+          </p:nvPr>
+        </p:nvSpPr>
+        <p:spPr/>
+      </p:sp>
+    </p:spTree>
+  </p:cSld>
+  <p:clrMapOvr>
+    <a:masterClrMapping/>
+  </p:clrMapOvr>
+</p:notes>
+</file>
+
+<file path=ppt/notesSlides/notesSlide15.xml><?xml version="1.0" encoding="utf-8"?>
+<p:notes xmlns:a="http://schemas.openxmlformats.org/drawingml/2006/main" xmlns:p="http://schemas.openxmlformats.org/presentationml/2006/main" xmlns:r="http://schemas.openxmlformats.org/officeDocument/2006/relationships">
+  <p:cSld>
+    <p:spTree>
+      <p:nvGrpSpPr>
+        <p:cNvPr id="1" name=""/>
+        <p:cNvGrpSpPr/>
+        <p:nvPr/>
+      </p:nvGrpSpPr>
+      <p:grpSpPr>
+        <a:xfrm>
+          <a:off x="0" y="0"/>
+          <a:ext cx="0" cy="0"/>
+          <a:chOff x="0" y="0"/>
+          <a:chExt cx="0" cy="0"/>
+        </a:xfrm>
+      </p:grpSpPr>
+      <p:sp>
+        <p:nvSpPr>
+          <p:cNvPr id="2" name="Slide Image Placeholder 1"/>
+          <p:cNvSpPr>
+            <a:spLocks noGrp="1"/>
+          </p:cNvSpPr>
+          <p:nvPr>
+            <p:ph type="sldImg" idx="2"/>
+          </p:nvPr>
+        </p:nvSpPr>
+        <p:spPr/>
+      </p:sp>
+      <p:sp>
+        <p:nvSpPr>
+          <p:cNvPr id="3" name="Notes Placeholder 2"/>
+          <p:cNvSpPr>
+            <a:spLocks noGrp="1"/>
+          </p:cNvSpPr>
+          <p:nvPr>
+            <p:ph type="body" idx="3" sz="quarter"/>
+          </p:nvPr>
+        </p:nvSpPr>
+        <p:spPr/>
+        <p:txBody>
+          <a:bodyPr/>
+          <a:lstStyle/>
+          <a:p>
+            <a:r>
+              <a:t>The code block and result heading align with the parent list text. The HTML comment is omitted.</a:t>
+            </a:r>
+          </a:p>
+        </p:txBody>
+      </p:sp>
+      <p:sp>
+        <p:nvSpPr>
+          <p:cNvPr id="4" name="Slide Number Placeholder 3"/>
+          <p:cNvSpPr>
+            <a:spLocks noGrp="1"/>
+          </p:cNvSpPr>
+          <p:nvPr>
+            <p:ph type="sldNum" idx="5" sz="quarter"/>
+          </p:nvPr>
+        </p:nvSpPr>
+        <p:spPr/>
+      </p:sp>
+    </p:spTree>
+  </p:cSld>
+  <p:clrMapOvr>
+    <a:masterClrMapping/>
+  </p:clrMapOvr>
+</p:notes>
+</file>
+
+<file path=ppt/notesSlides/notesSlide16.xml><?xml version="1.0" encoding="utf-8"?>
+<p:notes xmlns:a="http://schemas.openxmlformats.org/drawingml/2006/main" xmlns:p="http://schemas.openxmlformats.org/presentationml/2006/main" xmlns:r="http://schemas.openxmlformats.org/officeDocument/2006/relationships">
+  <p:cSld>
+    <p:spTree>
+      <p:nvGrpSpPr>
+        <p:cNvPr id="1" name=""/>
+        <p:cNvGrpSpPr/>
+        <p:nvPr/>
+      </p:nvGrpSpPr>
+      <p:grpSpPr>
+        <a:xfrm>
+          <a:off x="0" y="0"/>
+          <a:ext cx="0" cy="0"/>
+          <a:chOff x="0" y="0"/>
+          <a:chExt cx="0" cy="0"/>
+        </a:xfrm>
+      </p:grpSpPr>
+      <p:sp>
+        <p:nvSpPr>
+          <p:cNvPr id="2" name="Slide Image Placeholder 1"/>
+          <p:cNvSpPr>
+            <a:spLocks noGrp="1"/>
+          </p:cNvSpPr>
+          <p:nvPr>
+            <p:ph type="sldImg" idx="2"/>
+          </p:nvPr>
+        </p:nvSpPr>
+        <p:spPr/>
+      </p:sp>
+      <p:sp>
+        <p:nvSpPr>
+          <p:cNvPr id="3" name="Notes Placeholder 2"/>
+          <p:cNvSpPr>
+            <a:spLocks noGrp="1"/>
+          </p:cNvSpPr>
+          <p:nvPr>
+            <p:ph type="body" idx="3" sz="quarter"/>
+          </p:nvPr>
+        </p:nvSpPr>
+        <p:spPr/>
+        <p:txBody>
+          <a:bodyPr/>
+          <a:lstStyle/>
+          <a:p>
+            <a:r>
+              <a:t>Zero is preserved with an editable text marker. Native numbering is used where PowerPoint supports it. The reference definition at the bottom is invisible and serves earlier slides.</a:t>
             </a:r>
           </a:p>
         </p:txBody>
@@ -16136,7 +16349,7 @@
             <a:spLocks noGrp="1"/>
           </p:cNvSpPr>
           <p:nvPr>
-            <p:ph type="ctrTitle"/>
+            <p:ph type="title"/>
           </p:nvPr>
         </p:nvSpPr>
         <p:spPr/>
@@ -16158,8 +16371,9 @@
                 <a:solidFill>
                   <a:schemeClr val="accent6"/>
                 </a:solidFill>
-              </a:rPr>
-              <a:t>Markdown in. Editable PowerPoint out.</a:t>
+                <a:hlinkClick r:id="rId2" tooltip="Read the markdown-pptx guide"/>
+              </a:rPr>
+              <a:t>Shared references</a:t>
             </a:r>
             <a:endParaRPr>
               <a:solidFill>
@@ -16171,12 +16385,12 @@
       </p:sp>
       <p:sp>
         <p:nvSpPr>
-          <p:cNvPr id="3" name="Subtitle 2"/>
+          <p:cNvPr id="3" name="Content Placeholder 2"/>
           <p:cNvSpPr>
             <a:spLocks noGrp="1"/>
           </p:cNvSpPr>
           <p:nvPr>
-            <p:ph type="subTitle" idx="1"/>
+            <p:ph idx="1"/>
           </p:nvPr>
         </p:nvSpPr>
         <p:spPr/>
@@ -16203,16 +16417,7 @@
                 <a:ea typeface="+mn-ea"/>
                 <a:cs typeface="+mn-cs"/>
               </a:rPr>
-              <a:t>Run </a:t>
-            </a:r>
-            <a:r>
-              <a:rPr b="0" i="0">
-                <a:solidFill>
-                  <a:schemeClr val="dk1"/>
-                </a:solidFill>
-                <a:latin typeface="Consolas"/>
-              </a:rPr>
-              <a:t>uvx markdown-pptx --help</a:t>
+              <a:t>Read the </a:t>
             </a:r>
             <a:r>
               <a:rPr b="0" i="0">
@@ -16222,8 +16427,633 @@
                 <a:latin typeface="+mn-lt"/>
                 <a:ea typeface="+mn-ea"/>
                 <a:cs typeface="+mn-cs"/>
-              </a:rPr>
-              <a:t> to get started.</a:t>
+                <a:hlinkClick r:id="rId2" tooltip="Read the markdown-pptx guide"/>
+              </a:rPr>
+              <a:t>project guide</a:t>
+            </a:r>
+            <a:r>
+              <a:rPr b="0" i="0">
+                <a:solidFill>
+                  <a:schemeClr val="dk1"/>
+                </a:solidFill>
+                <a:latin typeface="+mn-lt"/>
+                <a:ea typeface="+mn-ea"/>
+                <a:cs typeface="+mn-cs"/>
+              </a:rPr>
+              <a:t>.</a:t>
+            </a:r>
+            <a:endParaRPr>
+              <a:solidFill>
+                <a:schemeClr val="dk1"/>
+              </a:solidFill>
+            </a:endParaRPr>
+          </a:p>
+          <a:p>
+            <a:pPr marL="0" indent="0">
+              <a:buNone/>
+              <a:defRPr>
+                <a:solidFill>
+                  <a:schemeClr val="dk1"/>
+                </a:solidFill>
+              </a:defRPr>
+            </a:pPr>
+            <a:r>
+              <a:rPr b="0" i="0">
+                <a:solidFill>
+                  <a:schemeClr val="dk1"/>
+                </a:solidFill>
+                <a:latin typeface="+mn-lt"/>
+                <a:ea typeface="+mn-ea"/>
+                <a:cs typeface="+mn-cs"/>
+              </a:rPr>
+              <a:t>The same definition can supply links throughout the deck.</a:t>
+            </a:r>
+            <a:endParaRPr>
+              <a:solidFill>
+                <a:schemeClr val="dk1"/>
+              </a:solidFill>
+            </a:endParaRPr>
+          </a:p>
+          <a:p>
+            <a:pPr marL="0" indent="0">
+              <a:buNone/>
+              <a:defRPr>
+                <a:solidFill>
+                  <a:schemeClr val="dk1"/>
+                </a:solidFill>
+              </a:defRPr>
+            </a:pPr>
+            <a:r>
+              <a:rPr b="1" i="0">
+                <a:solidFill>
+                  <a:schemeClr val="dk1"/>
+                </a:solidFill>
+                <a:latin typeface="+mn-lt"/>
+                <a:ea typeface="+mn-ea"/>
+                <a:cs typeface="+mn-cs"/>
+                <a:hlinkClick r:id="rId2" tooltip="Open the markdown-pptx project"/>
+              </a:rPr>
+              <a:t>Formatted</a:t>
+            </a:r>
+            <a:r>
+              <a:rPr b="0" i="0">
+                <a:solidFill>
+                  <a:schemeClr val="dk1"/>
+                </a:solidFill>
+                <a:latin typeface="+mn-lt"/>
+                <a:ea typeface="+mn-ea"/>
+                <a:cs typeface="+mn-cs"/>
+                <a:hlinkClick r:id="rId2" tooltip="Open the markdown-pptx project"/>
+              </a:rPr>
+              <a:t> </a:t>
+            </a:r>
+            <a:r>
+              <a:rPr b="0" i="1">
+                <a:solidFill>
+                  <a:schemeClr val="dk1"/>
+                </a:solidFill>
+                <a:latin typeface="+mn-lt"/>
+                <a:ea typeface="+mn-ea"/>
+                <a:cs typeface="+mn-cs"/>
+                <a:hlinkClick r:id="rId2" tooltip="Open the markdown-pptx project"/>
+              </a:rPr>
+              <a:t>links</a:t>
+            </a:r>
+            <a:r>
+              <a:rPr b="0" i="0">
+                <a:solidFill>
+                  <a:schemeClr val="dk1"/>
+                </a:solidFill>
+                <a:latin typeface="+mn-lt"/>
+                <a:ea typeface="+mn-ea"/>
+                <a:cs typeface="+mn-cs"/>
+              </a:rPr>
+              <a:t> retain their ScreenTips.</a:t>
+            </a:r>
+            <a:endParaRPr>
+              <a:solidFill>
+                <a:schemeClr val="dk1"/>
+              </a:solidFill>
+            </a:endParaRPr>
+          </a:p>
+        </p:txBody>
+      </p:sp>
+    </p:spTree>
+  </p:cSld>
+  <p:clrMapOvr>
+    <a:masterClrMapping/>
+  </p:clrMapOvr>
+</p:sld>
+</file>
+
+<file path=ppt/slides/slide48.xml><?xml version="1.0" encoding="utf-8"?>
+<p:sld xmlns:a="http://schemas.openxmlformats.org/drawingml/2006/main" xmlns:p="http://schemas.openxmlformats.org/presentationml/2006/main" xmlns:r="http://schemas.openxmlformats.org/officeDocument/2006/relationships">
+  <p:cSld>
+    <p:bg>
+      <p:bgPr>
+        <a:solidFill>
+          <a:srgbClr val="FFFFFF"/>
+        </a:solidFill>
+        <a:effectLst/>
+      </p:bgPr>
+    </p:bg>
+    <p:spTree>
+      <p:nvGrpSpPr>
+        <p:cNvPr id="1" name=""/>
+        <p:cNvGrpSpPr/>
+        <p:nvPr/>
+      </p:nvGrpSpPr>
+      <p:grpSpPr/>
+      <p:sp>
+        <p:nvSpPr>
+          <p:cNvPr id="2" name="Title 1"/>
+          <p:cNvSpPr>
+            <a:spLocks noGrp="1"/>
+          </p:cNvSpPr>
+          <p:nvPr>
+            <p:ph type="title"/>
+          </p:nvPr>
+        </p:nvSpPr>
+        <p:spPr/>
+        <p:txBody>
+          <a:bodyPr>
+            <a:normAutofit/>
+          </a:bodyPr>
+          <a:lstStyle/>
+          <a:p>
+            <a:pPr>
+              <a:defRPr>
+                <a:solidFill>
+                  <a:schemeClr val="accent6"/>
+                </a:solidFill>
+              </a:defRPr>
+            </a:pPr>
+            <a:r>
+              <a:rPr>
+                <a:solidFill>
+                  <a:schemeClr val="accent6"/>
+                </a:solidFill>
+              </a:rPr>
+              <a:t>Code stays inside its list item</a:t>
+            </a:r>
+            <a:endParaRPr>
+              <a:solidFill>
+                <a:schemeClr val="accent6"/>
+              </a:solidFill>
+            </a:endParaRPr>
+          </a:p>
+        </p:txBody>
+      </p:sp>
+      <p:sp>
+        <p:nvSpPr>
+          <p:cNvPr id="3" name="Content Placeholder 2"/>
+          <p:cNvSpPr>
+            <a:spLocks noGrp="1"/>
+          </p:cNvSpPr>
+          <p:nvPr>
+            <p:ph idx="1"/>
+          </p:nvPr>
+        </p:nvSpPr>
+        <p:spPr/>
+        <p:txBody>
+          <a:bodyPr wrap="square">
+            <a:normAutofit/>
+          </a:bodyPr>
+          <a:lstStyle/>
+          <a:p>
+            <a:pPr marL="576072" indent="-365760">
+              <a:buAutoNum type="arabicPeriod" startAt="1"/>
+              <a:defRPr>
+                <a:solidFill>
+                  <a:schemeClr val="dk1"/>
+                </a:solidFill>
+              </a:defRPr>
+            </a:pPr>
+            <a:r>
+              <a:rPr b="0" i="0">
+                <a:solidFill>
+                  <a:schemeClr val="dk1"/>
+                </a:solidFill>
+                <a:latin typeface="+mn-lt"/>
+                <a:ea typeface="+mn-ea"/>
+                <a:cs typeface="+mn-cs"/>
+              </a:rPr>
+              <a:t>Run the check</a:t>
+            </a:r>
+            <a:endParaRPr>
+              <a:solidFill>
+                <a:schemeClr val="dk1"/>
+              </a:solidFill>
+            </a:endParaRPr>
+          </a:p>
+          <a:p>
+            <a:pPr marL="576072" indent="0">
+              <a:buNone/>
+              <a:defRPr>
+                <a:solidFill>
+                  <a:schemeClr val="dk1"/>
+                </a:solidFill>
+              </a:defRPr>
+            </a:pPr>
+            <a:r>
+              <a:rPr b="0" i="0">
+                <a:solidFill>
+                  <a:schemeClr val="dk1"/>
+                </a:solidFill>
+                <a:latin typeface="Consolas"/>
+              </a:rPr>
+              <a:t>status</a:t>
+            </a:r>
+            <a:r>
+              <a:rPr b="0" i="0">
+                <a:solidFill>
+                  <a:schemeClr val="dk1"/>
+                </a:solidFill>
+                <a:latin typeface="Consolas"/>
+              </a:rPr>
+              <a:t> </a:t>
+            </a:r>
+            <a:r>
+              <a:rPr b="0" i="0">
+                <a:solidFill>
+                  <a:schemeClr val="dk1"/>
+                </a:solidFill>
+                <a:latin typeface="Consolas"/>
+              </a:rPr>
+              <a:t>=</a:t>
+            </a:r>
+            <a:r>
+              <a:rPr b="0" i="0">
+                <a:solidFill>
+                  <a:schemeClr val="dk1"/>
+                </a:solidFill>
+                <a:latin typeface="Consolas"/>
+              </a:rPr>
+              <a:t> </a:t>
+            </a:r>
+            <a:r>
+              <a:rPr b="0" i="0">
+                <a:solidFill>
+                  <a:schemeClr val="accent2">
+                    <a:lumMod val="69990"/>
+                  </a:schemeClr>
+                </a:solidFill>
+                <a:latin typeface="Consolas"/>
+              </a:rPr>
+              <a:t>"</a:t>
+            </a:r>
+            <a:r>
+              <a:rPr b="0" i="0">
+                <a:solidFill>
+                  <a:schemeClr val="accent2">
+                    <a:lumMod val="69990"/>
+                  </a:schemeClr>
+                </a:solidFill>
+                <a:latin typeface="Consolas"/>
+              </a:rPr>
+              <a:t>Ready</a:t>
+            </a:r>
+            <a:r>
+              <a:rPr b="0" i="0">
+                <a:solidFill>
+                  <a:schemeClr val="accent2">
+                    <a:lumMod val="69990"/>
+                  </a:schemeClr>
+                </a:solidFill>
+                <a:latin typeface="Consolas"/>
+              </a:rPr>
+              <a:t>"</a:t>
+            </a:r>
+            <a:br/>
+            <a:r>
+              <a:rPr b="0" i="0">
+                <a:solidFill>
+                  <a:schemeClr val="accent3">
+                    <a:lumMod val="55575"/>
+                  </a:schemeClr>
+                </a:solidFill>
+                <a:latin typeface="Consolas"/>
+              </a:rPr>
+              <a:t>print</a:t>
+            </a:r>
+            <a:r>
+              <a:rPr b="0" i="0">
+                <a:solidFill>
+                  <a:schemeClr val="dk1"/>
+                </a:solidFill>
+                <a:latin typeface="Consolas"/>
+              </a:rPr>
+              <a:t>(</a:t>
+            </a:r>
+            <a:r>
+              <a:rPr b="0" i="0">
+                <a:solidFill>
+                  <a:schemeClr val="dk1"/>
+                </a:solidFill>
+                <a:latin typeface="Consolas"/>
+              </a:rPr>
+              <a:t>status</a:t>
+            </a:r>
+            <a:r>
+              <a:rPr b="0" i="0">
+                <a:solidFill>
+                  <a:schemeClr val="dk1"/>
+                </a:solidFill>
+                <a:latin typeface="Consolas"/>
+              </a:rPr>
+              <a:t>)</a:t>
+            </a:r>
+            <a:endParaRPr>
+              <a:solidFill>
+                <a:schemeClr val="dk1"/>
+              </a:solidFill>
+            </a:endParaRPr>
+          </a:p>
+          <a:p>
+            <a:pPr marL="576072" indent="0">
+              <a:buNone/>
+              <a:defRPr>
+                <a:solidFill>
+                  <a:schemeClr val="dk1"/>
+                </a:solidFill>
+              </a:defRPr>
+            </a:pPr>
+            <a:r>
+              <a:rPr sz="3700" b="1" i="0">
+                <a:solidFill>
+                  <a:schemeClr val="dk1"/>
+                </a:solidFill>
+                <a:latin typeface="+mj-lt"/>
+                <a:ea typeface="+mj-ea"/>
+                <a:cs typeface="+mj-cs"/>
+              </a:rPr>
+              <a:t>Result</a:t>
+            </a:r>
+            <a:endParaRPr>
+              <a:solidFill>
+                <a:schemeClr val="dk1"/>
+              </a:solidFill>
+            </a:endParaRPr>
+          </a:p>
+          <a:p>
+            <a:pPr marL="576072" indent="0">
+              <a:buNone/>
+              <a:defRPr>
+                <a:solidFill>
+                  <a:schemeClr val="dk1"/>
+                </a:solidFill>
+              </a:defRPr>
+            </a:pPr>
+            <a:r>
+              <a:rPr b="0" i="0">
+                <a:solidFill>
+                  <a:schemeClr val="dk1"/>
+                </a:solidFill>
+                <a:latin typeface="+mn-lt"/>
+                <a:ea typeface="+mn-ea"/>
+                <a:cs typeface="+mn-cs"/>
+              </a:rPr>
+              <a:t>Continue after checking the output.</a:t>
+            </a:r>
+            <a:endParaRPr>
+              <a:solidFill>
+                <a:schemeClr val="dk1"/>
+              </a:solidFill>
+            </a:endParaRPr>
+          </a:p>
+          <a:p>
+            <a:pPr marL="576072" indent="-365760">
+              <a:buAutoNum type="arabicPeriod" startAt="2"/>
+              <a:defRPr>
+                <a:solidFill>
+                  <a:schemeClr val="dk1"/>
+                </a:solidFill>
+              </a:defRPr>
+            </a:pPr>
+            <a:r>
+              <a:rPr b="0" i="0">
+                <a:solidFill>
+                  <a:schemeClr val="dk1"/>
+                </a:solidFill>
+                <a:latin typeface="+mn-lt"/>
+                <a:ea typeface="+mn-ea"/>
+                <a:cs typeface="+mn-cs"/>
+              </a:rPr>
+              <a:t>Present the result</a:t>
+            </a:r>
+            <a:endParaRPr>
+              <a:solidFill>
+                <a:schemeClr val="dk1"/>
+              </a:solidFill>
+            </a:endParaRPr>
+          </a:p>
+        </p:txBody>
+      </p:sp>
+    </p:spTree>
+  </p:cSld>
+  <p:clrMapOvr>
+    <a:masterClrMapping/>
+  </p:clrMapOvr>
+</p:sld>
+</file>
+
+<file path=ppt/slides/slide49.xml><?xml version="1.0" encoding="utf-8"?>
+<p:sld xmlns:a="http://schemas.openxmlformats.org/drawingml/2006/main" xmlns:p="http://schemas.openxmlformats.org/presentationml/2006/main" xmlns:r="http://schemas.openxmlformats.org/officeDocument/2006/relationships">
+  <p:cSld>
+    <p:spTree>
+      <p:nvGrpSpPr>
+        <p:cNvPr id="1" name=""/>
+        <p:cNvGrpSpPr/>
+        <p:nvPr/>
+      </p:nvGrpSpPr>
+      <p:grpSpPr/>
+      <p:sp>
+        <p:nvSpPr>
+          <p:cNvPr id="2" name="Title 1"/>
+          <p:cNvSpPr>
+            <a:spLocks noGrp="1"/>
+          </p:cNvSpPr>
+          <p:nvPr>
+            <p:ph type="title"/>
+          </p:nvPr>
+        </p:nvSpPr>
+        <p:spPr/>
+        <p:txBody>
+          <a:bodyPr>
+            <a:normAutofit/>
+          </a:bodyPr>
+          <a:lstStyle/>
+          <a:p>
+            <a:pPr>
+              <a:defRPr>
+                <a:solidFill>
+                  <a:schemeClr val="accent6"/>
+                </a:solidFill>
+              </a:defRPr>
+            </a:pPr>
+            <a:r>
+              <a:rPr>
+                <a:solidFill>
+                  <a:schemeClr val="accent6"/>
+                </a:solidFill>
+              </a:rPr>
+              <a:t>Numbering and reusable definitions</a:t>
+            </a:r>
+            <a:endParaRPr>
+              <a:solidFill>
+                <a:schemeClr val="accent6"/>
+              </a:solidFill>
+            </a:endParaRPr>
+          </a:p>
+        </p:txBody>
+      </p:sp>
+      <p:sp>
+        <p:nvSpPr>
+          <p:cNvPr id="3" name="Content Placeholder 2"/>
+          <p:cNvSpPr>
+            <a:spLocks noGrp="1"/>
+          </p:cNvSpPr>
+          <p:nvPr>
+            <p:ph idx="1"/>
+          </p:nvPr>
+        </p:nvSpPr>
+        <p:spPr/>
+        <p:txBody>
+          <a:bodyPr wrap="square">
+            <a:normAutofit/>
+          </a:bodyPr>
+          <a:lstStyle/>
+          <a:p>
+            <a:pPr marL="576072" indent="-365760">
+              <a:buNone/>
+              <a:defRPr>
+                <a:solidFill>
+                  <a:schemeClr val="dk1"/>
+                </a:solidFill>
+              </a:defRPr>
+            </a:pPr>
+            <a:r>
+              <a:rPr b="0" i="0">
+                <a:solidFill>
+                  <a:schemeClr val="dk1"/>
+                </a:solidFill>
+                <a:latin typeface="+mn-lt"/>
+                <a:ea typeface="+mn-ea"/>
+                <a:cs typeface="+mn-cs"/>
+              </a:rPr>
+              <a:t>0. </a:t>
+            </a:r>
+            <a:r>
+              <a:rPr b="0" i="0">
+                <a:solidFill>
+                  <a:schemeClr val="dk1"/>
+                </a:solidFill>
+                <a:latin typeface="+mn-lt"/>
+                <a:ea typeface="+mn-ea"/>
+                <a:cs typeface="+mn-cs"/>
+              </a:rPr>
+              <a:t>Prepare the content</a:t>
+            </a:r>
+            <a:endParaRPr>
+              <a:solidFill>
+                <a:schemeClr val="dk1"/>
+              </a:solidFill>
+            </a:endParaRPr>
+          </a:p>
+          <a:p>
+            <a:pPr marL="576072" indent="-365760">
+              <a:buAutoNum type="arabicPeriod" startAt="1"/>
+              <a:defRPr>
+                <a:solidFill>
+                  <a:schemeClr val="dk1"/>
+                </a:solidFill>
+              </a:defRPr>
+            </a:pPr>
+            <a:r>
+              <a:rPr b="0" i="0">
+                <a:solidFill>
+                  <a:schemeClr val="dk1"/>
+                </a:solidFill>
+                <a:latin typeface="+mn-lt"/>
+                <a:ea typeface="+mn-ea"/>
+                <a:cs typeface="+mn-cs"/>
+              </a:rPr>
+              <a:t>Render the presentation</a:t>
+            </a:r>
+            <a:endParaRPr>
+              <a:solidFill>
+                <a:schemeClr val="dk1"/>
+              </a:solidFill>
+            </a:endParaRPr>
+          </a:p>
+          <a:p>
+            <a:pPr marL="576072" indent="-365760">
+              <a:buAutoNum type="arabicPeriod" startAt="2"/>
+              <a:defRPr>
+                <a:solidFill>
+                  <a:schemeClr val="dk1"/>
+                </a:solidFill>
+              </a:defRPr>
+            </a:pPr>
+            <a:r>
+              <a:rPr b="0" i="0">
+                <a:solidFill>
+                  <a:schemeClr val="dk1"/>
+                </a:solidFill>
+                <a:latin typeface="+mn-lt"/>
+                <a:ea typeface="+mn-ea"/>
+                <a:cs typeface="+mn-cs"/>
+              </a:rPr>
+              <a:t>Review in PowerPoint</a:t>
+            </a:r>
+            <a:endParaRPr>
+              <a:solidFill>
+                <a:schemeClr val="dk1"/>
+              </a:solidFill>
+            </a:endParaRPr>
+          </a:p>
+          <a:p>
+            <a:pPr marL="0" indent="0">
+              <a:buNone/>
+              <a:defRPr>
+                <a:solidFill>
+                  <a:schemeClr val="dk1"/>
+                </a:solidFill>
+              </a:defRPr>
+            </a:pPr>
+            <a:r>
+              <a:rPr b="0" i="0">
+                <a:solidFill>
+                  <a:schemeClr val="dk1"/>
+                </a:solidFill>
+                <a:latin typeface="+mn-lt"/>
+                <a:ea typeface="+mn-ea"/>
+                <a:cs typeface="+mn-cs"/>
+              </a:rPr>
+              <a:t>Return to the </a:t>
+            </a:r>
+            <a:r>
+              <a:rPr b="0" i="0">
+                <a:solidFill>
+                  <a:schemeClr val="dk1"/>
+                </a:solidFill>
+                <a:latin typeface="+mn-lt"/>
+                <a:ea typeface="+mn-ea"/>
+                <a:cs typeface="+mn-cs"/>
+                <a:hlinkClick r:id="rId2" tooltip="Read the markdown-pptx guide"/>
+              </a:rPr>
+              <a:t>project guide</a:t>
+            </a:r>
+            <a:r>
+              <a:rPr b="0" i="0">
+                <a:solidFill>
+                  <a:schemeClr val="dk1"/>
+                </a:solidFill>
+                <a:latin typeface="+mn-lt"/>
+                <a:ea typeface="+mn-ea"/>
+                <a:cs typeface="+mn-cs"/>
+              </a:rPr>
+              <a:t> for more examples.</a:t>
             </a:r>
             <a:endParaRPr>
               <a:solidFill>
@@ -16452,6 +17282,128 @@
                 <a:cs typeface="+mn-cs"/>
               </a:rPr>
               <a:t> for structured results. Master and layout inspection report names, indices, placeholder inventory, and compatibility so people and coding agents can discover valid inputs before generating a deck.</a:t>
+            </a:r>
+            <a:endParaRPr>
+              <a:solidFill>
+                <a:schemeClr val="dk1"/>
+              </a:solidFill>
+            </a:endParaRPr>
+          </a:p>
+        </p:txBody>
+      </p:sp>
+    </p:spTree>
+  </p:cSld>
+  <p:clrMapOvr>
+    <a:masterClrMapping/>
+  </p:clrMapOvr>
+</p:sld>
+</file>
+
+<file path=ppt/slides/slide50.xml><?xml version="1.0" encoding="utf-8"?>
+<p:sld xmlns:a="http://schemas.openxmlformats.org/drawingml/2006/main" xmlns:p="http://schemas.openxmlformats.org/presentationml/2006/main" xmlns:r="http://schemas.openxmlformats.org/officeDocument/2006/relationships">
+  <p:cSld>
+    <p:spTree>
+      <p:nvGrpSpPr>
+        <p:cNvPr id="1" name=""/>
+        <p:cNvGrpSpPr/>
+        <p:nvPr/>
+      </p:nvGrpSpPr>
+      <p:grpSpPr/>
+      <p:sp>
+        <p:nvSpPr>
+          <p:cNvPr id="2" name="Title 1"/>
+          <p:cNvSpPr>
+            <a:spLocks noGrp="1"/>
+          </p:cNvSpPr>
+          <p:nvPr>
+            <p:ph type="ctrTitle"/>
+          </p:nvPr>
+        </p:nvSpPr>
+        <p:spPr/>
+        <p:txBody>
+          <a:bodyPr>
+            <a:normAutofit/>
+          </a:bodyPr>
+          <a:lstStyle/>
+          <a:p>
+            <a:pPr>
+              <a:defRPr>
+                <a:solidFill>
+                  <a:schemeClr val="accent6"/>
+                </a:solidFill>
+              </a:defRPr>
+            </a:pPr>
+            <a:r>
+              <a:rPr>
+                <a:solidFill>
+                  <a:schemeClr val="accent6"/>
+                </a:solidFill>
+              </a:rPr>
+              <a:t>Markdown in. Editable PowerPoint out.</a:t>
+            </a:r>
+            <a:endParaRPr>
+              <a:solidFill>
+                <a:schemeClr val="accent6"/>
+              </a:solidFill>
+            </a:endParaRPr>
+          </a:p>
+        </p:txBody>
+      </p:sp>
+      <p:sp>
+        <p:nvSpPr>
+          <p:cNvPr id="3" name="Subtitle 2"/>
+          <p:cNvSpPr>
+            <a:spLocks noGrp="1"/>
+          </p:cNvSpPr>
+          <p:nvPr>
+            <p:ph type="subTitle" idx="1"/>
+          </p:nvPr>
+        </p:nvSpPr>
+        <p:spPr/>
+        <p:txBody>
+          <a:bodyPr wrap="square">
+            <a:normAutofit/>
+          </a:bodyPr>
+          <a:lstStyle/>
+          <a:p>
+            <a:pPr marL="0" indent="0">
+              <a:buNone/>
+              <a:defRPr>
+                <a:solidFill>
+                  <a:schemeClr val="dk1"/>
+                </a:solidFill>
+              </a:defRPr>
+            </a:pPr>
+            <a:r>
+              <a:rPr b="0" i="0">
+                <a:solidFill>
+                  <a:schemeClr val="dk1"/>
+                </a:solidFill>
+                <a:latin typeface="+mn-lt"/>
+                <a:ea typeface="+mn-ea"/>
+                <a:cs typeface="+mn-cs"/>
+              </a:rPr>
+              <a:t>Run </a:t>
+            </a:r>
+            <a:r>
+              <a:rPr b="0" i="0">
+                <a:solidFill>
+                  <a:schemeClr val="dk1"/>
+                </a:solidFill>
+                <a:latin typeface="Consolas"/>
+              </a:rPr>
+              <a:t>uvx markdown-pptx --help</a:t>
+            </a:r>
+            <a:r>
+              <a:rPr b="0" i="0">
+                <a:solidFill>
+                  <a:schemeClr val="dk1"/>
+                </a:solidFill>
+                <a:latin typeface="+mn-lt"/>
+                <a:ea typeface="+mn-ea"/>
+                <a:cs typeface="+mn-cs"/>
+              </a:rPr>
+              <a:t> to get started.</a:t>
             </a:r>
             <a:endParaRPr>
               <a:solidFill>

</xml_diff>

<commit_message>
Release 2.0.0 with video embeds and comment metadata
</commit_message>
<xml_diff>
--- a/sample/showcase.pptx
+++ b/sample/showcase.pptx
@@ -59,6 +59,9 @@
     <p:sldId xmlns:ns0="http://schemas.openxmlformats.org/officeDocument/2006/relationships" id="303" ns0:id="rId55"/>
     <p:sldId xmlns:ns0="http://schemas.openxmlformats.org/officeDocument/2006/relationships" id="304" ns0:id="rId56"/>
     <p:sldId xmlns:ns0="http://schemas.openxmlformats.org/officeDocument/2006/relationships" id="305" ns0:id="rId57"/>
+    <p:sldId xmlns:ns0="http://schemas.openxmlformats.org/officeDocument/2006/relationships" id="306" ns0:id="rId58"/>
+    <p:sldId xmlns:ns0="http://schemas.openxmlformats.org/officeDocument/2006/relationships" id="307" ns0:id="rId59"/>
+    <p:sldId xmlns:ns0="http://schemas.openxmlformats.org/officeDocument/2006/relationships" id="308" ns0:id="rId60"/>
   </p:sldIdLst>
   <p:sldSz cx="12192000" cy="6858000"/>
   <p:notesSz cx="6858000" cy="9144000"/>
@@ -612,7 +615,7 @@
           <a:lstStyle/>
           <a:p>
             <a:r>
-              <a:t>Dark 1 supplies ordinary code. Accents 1, 2, and 3 supply keywords, values, and named tokens. Brightness is adjusted only as needed for 4.5 to 1 contrast.</a:t>
+              <a:t>This slide demonstrates a full-slide background image on the Blank layout.</a:t>
             </a:r>
           </a:p>
         </p:txBody>
@@ -682,7 +685,7 @@
           <a:lstStyle/>
           <a:p>
             <a:r>
-              <a:t>Light 1 supplies ordinary code. The same accent slots are used with lighter variants where needed. Comments meet the same contrast target as other code.</a:t>
+              <a:t>This slide intentionally demonstrates the Blank layout.</a:t>
             </a:r>
           </a:p>
         </p:txBody>
@@ -752,7 +755,7 @@
           <a:lstStyle/>
           <a:p>
             <a:r>
-              <a:t>A 16 by 16 grid estimates the background range beneath the content placeholder. HTML tags use Accent 1, values use Accent 2, and attributes use Accent 3.</a:t>
+              <a:t>A single top-level thematic break separates the left and right placeholders.</a:t>
             </a:r>
           </a:p>
         </p:txBody>
@@ -822,7 +825,7 @@
           <a:lstStyle/>
           <a:p>
             <a:r>
-              <a:t>A dark radial gradient demonstrates the light variant. Native theme references retain their slot and use brightness adjustments for the estimated background range.</a:t>
+              <a:t>Dark 1 supplies ordinary code. Accents 1, 2, and 3 supply keywords, values, and named tokens. Brightness is adjusted only as needed for 4.5 to 1 contrast.</a:t>
             </a:r>
           </a:p>
         </p:txBody>
@@ -892,7 +895,7 @@
           <a:lstStyle/>
           <a:p>
             <a:r>
-              <a:t>The title and body use a reference defined on a later slide. The optional link title becomes a ScreenTip in PowerPoint. Hover over a link in Slide Show view to see the tip.</a:t>
+              <a:t>Light 1 supplies ordinary code. The same accent slots are used with lighter variants where needed. Comments meet the same contrast target as other code.</a:t>
             </a:r>
           </a:p>
         </p:txBody>
@@ -962,7 +965,7 @@
           <a:lstStyle/>
           <a:p>
             <a:r>
-              <a:t>The code block and result heading align with the parent list text. The HTML comment is omitted.</a:t>
+              <a:t>A 16 by 16 grid estimates the background range beneath the content placeholder. HTML tags use Accent 1, values use Accent 2, and attributes use Accent 3.</a:t>
             </a:r>
           </a:p>
         </p:txBody>
@@ -1032,6 +1035,216 @@
           <a:lstStyle/>
           <a:p>
             <a:r>
+              <a:t>A dark radial gradient demonstrates the light variant. Native theme references retain their slot and use brightness adjustments for the estimated background range.</a:t>
+            </a:r>
+          </a:p>
+        </p:txBody>
+      </p:sp>
+      <p:sp>
+        <p:nvSpPr>
+          <p:cNvPr id="4" name="Slide Number Placeholder 3"/>
+          <p:cNvSpPr>
+            <a:spLocks noGrp="1"/>
+          </p:cNvSpPr>
+          <p:nvPr>
+            <p:ph type="sldNum" idx="5" sz="quarter"/>
+          </p:nvPr>
+        </p:nvSpPr>
+        <p:spPr/>
+      </p:sp>
+    </p:spTree>
+  </p:cSld>
+  <p:clrMapOvr>
+    <a:masterClrMapping/>
+  </p:clrMapOvr>
+</p:notes>
+</file>
+
+<file path=ppt/notesSlides/notesSlide17.xml><?xml version="1.0" encoding="utf-8"?>
+<p:notes xmlns:a="http://schemas.openxmlformats.org/drawingml/2006/main" xmlns:p="http://schemas.openxmlformats.org/presentationml/2006/main" xmlns:r="http://schemas.openxmlformats.org/officeDocument/2006/relationships">
+  <p:cSld>
+    <p:spTree>
+      <p:nvGrpSpPr>
+        <p:cNvPr id="1" name=""/>
+        <p:cNvGrpSpPr/>
+        <p:nvPr/>
+      </p:nvGrpSpPr>
+      <p:grpSpPr>
+        <a:xfrm>
+          <a:off x="0" y="0"/>
+          <a:ext cx="0" cy="0"/>
+          <a:chOff x="0" y="0"/>
+          <a:chExt cx="0" cy="0"/>
+        </a:xfrm>
+      </p:grpSpPr>
+      <p:sp>
+        <p:nvSpPr>
+          <p:cNvPr id="2" name="Slide Image Placeholder 1"/>
+          <p:cNvSpPr>
+            <a:spLocks noGrp="1"/>
+          </p:cNvSpPr>
+          <p:nvPr>
+            <p:ph type="sldImg" idx="2"/>
+          </p:nvPr>
+        </p:nvSpPr>
+        <p:spPr/>
+      </p:sp>
+      <p:sp>
+        <p:nvSpPr>
+          <p:cNvPr id="3" name="Notes Placeholder 2"/>
+          <p:cNvSpPr>
+            <a:spLocks noGrp="1"/>
+          </p:cNvSpPr>
+          <p:nvPr>
+            <p:ph type="body" idx="3" sz="quarter"/>
+          </p:nvPr>
+        </p:nvSpPr>
+        <p:spPr/>
+        <p:txBody>
+          <a:bodyPr/>
+          <a:lstStyle/>
+          <a:p>
+            <a:r>
+              <a:t>The title and body use a reference defined on a later slide. The optional link title becomes a ScreenTip in PowerPoint. Hover over a link in Slide Show view to see the tip.</a:t>
+            </a:r>
+          </a:p>
+        </p:txBody>
+      </p:sp>
+      <p:sp>
+        <p:nvSpPr>
+          <p:cNvPr id="4" name="Slide Number Placeholder 3"/>
+          <p:cNvSpPr>
+            <a:spLocks noGrp="1"/>
+          </p:cNvSpPr>
+          <p:nvPr>
+            <p:ph type="sldNum" idx="5" sz="quarter"/>
+          </p:nvPr>
+        </p:nvSpPr>
+        <p:spPr/>
+      </p:sp>
+    </p:spTree>
+  </p:cSld>
+  <p:clrMapOvr>
+    <a:masterClrMapping/>
+  </p:clrMapOvr>
+</p:notes>
+</file>
+
+<file path=ppt/notesSlides/notesSlide18.xml><?xml version="1.0" encoding="utf-8"?>
+<p:notes xmlns:a="http://schemas.openxmlformats.org/drawingml/2006/main" xmlns:p="http://schemas.openxmlformats.org/presentationml/2006/main" xmlns:r="http://schemas.openxmlformats.org/officeDocument/2006/relationships">
+  <p:cSld>
+    <p:spTree>
+      <p:nvGrpSpPr>
+        <p:cNvPr id="1" name=""/>
+        <p:cNvGrpSpPr/>
+        <p:nvPr/>
+      </p:nvGrpSpPr>
+      <p:grpSpPr>
+        <a:xfrm>
+          <a:off x="0" y="0"/>
+          <a:ext cx="0" cy="0"/>
+          <a:chOff x="0" y="0"/>
+          <a:chExt cx="0" cy="0"/>
+        </a:xfrm>
+      </p:grpSpPr>
+      <p:sp>
+        <p:nvSpPr>
+          <p:cNvPr id="2" name="Slide Image Placeholder 1"/>
+          <p:cNvSpPr>
+            <a:spLocks noGrp="1"/>
+          </p:cNvSpPr>
+          <p:nvPr>
+            <p:ph type="sldImg" idx="2"/>
+          </p:nvPr>
+        </p:nvSpPr>
+        <p:spPr/>
+      </p:sp>
+      <p:sp>
+        <p:nvSpPr>
+          <p:cNvPr id="3" name="Notes Placeholder 2"/>
+          <p:cNvSpPr>
+            <a:spLocks noGrp="1"/>
+          </p:cNvSpPr>
+          <p:nvPr>
+            <p:ph type="body" idx="3" sz="quarter"/>
+          </p:nvPr>
+        </p:nvSpPr>
+        <p:spPr/>
+        <p:txBody>
+          <a:bodyPr/>
+          <a:lstStyle/>
+          <a:p>
+            <a:r>
+              <a:t>The code block and result heading align with the parent list text. The HTML comment is omitted.</a:t>
+            </a:r>
+          </a:p>
+        </p:txBody>
+      </p:sp>
+      <p:sp>
+        <p:nvSpPr>
+          <p:cNvPr id="4" name="Slide Number Placeholder 3"/>
+          <p:cNvSpPr>
+            <a:spLocks noGrp="1"/>
+          </p:cNvSpPr>
+          <p:nvPr>
+            <p:ph type="sldNum" idx="5" sz="quarter"/>
+          </p:nvPr>
+        </p:nvSpPr>
+        <p:spPr/>
+      </p:sp>
+    </p:spTree>
+  </p:cSld>
+  <p:clrMapOvr>
+    <a:masterClrMapping/>
+  </p:clrMapOvr>
+</p:notes>
+</file>
+
+<file path=ppt/notesSlides/notesSlide19.xml><?xml version="1.0" encoding="utf-8"?>
+<p:notes xmlns:a="http://schemas.openxmlformats.org/drawingml/2006/main" xmlns:p="http://schemas.openxmlformats.org/presentationml/2006/main" xmlns:r="http://schemas.openxmlformats.org/officeDocument/2006/relationships">
+  <p:cSld>
+    <p:spTree>
+      <p:nvGrpSpPr>
+        <p:cNvPr id="1" name=""/>
+        <p:cNvGrpSpPr/>
+        <p:nvPr/>
+      </p:nvGrpSpPr>
+      <p:grpSpPr>
+        <a:xfrm>
+          <a:off x="0" y="0"/>
+          <a:ext cx="0" cy="0"/>
+          <a:chOff x="0" y="0"/>
+          <a:chExt cx="0" cy="0"/>
+        </a:xfrm>
+      </p:grpSpPr>
+      <p:sp>
+        <p:nvSpPr>
+          <p:cNvPr id="2" name="Slide Image Placeholder 1"/>
+          <p:cNvSpPr>
+            <a:spLocks noGrp="1"/>
+          </p:cNvSpPr>
+          <p:nvPr>
+            <p:ph type="sldImg" idx="2"/>
+          </p:nvPr>
+        </p:nvSpPr>
+        <p:spPr/>
+      </p:sp>
+      <p:sp>
+        <p:nvSpPr>
+          <p:cNvPr id="3" name="Notes Placeholder 2"/>
+          <p:cNvSpPr>
+            <a:spLocks noGrp="1"/>
+          </p:cNvSpPr>
+          <p:nvPr>
+            <p:ph type="body" idx="3" sz="quarter"/>
+          </p:nvPr>
+        </p:nvSpPr>
+        <p:spPr/>
+        <p:txBody>
+          <a:bodyPr/>
+          <a:lstStyle/>
+          <a:p>
+            <a:r>
               <a:t>Zero is preserved with an editable text marker. Native numbering is used where PowerPoint supports it. The reference definition at the bottom is invisible and serves earlier slides.</a:t>
             </a:r>
           </a:p>
@@ -1462,7 +1675,27 @@
           <a:lstStyle/>
           <a:p>
             <a:r>
-              <a:t>This slide demonstrates a full-slide background image on the Blank layout.</a:t>
+              <a:t>The local MP4 is embedded in this PowerPoint file. Click Next to start playback.</a:t>
+            </a:r>
+          </a:p>
+          <a:p>
+            <a:r>
+              <a:t>The slide stays in place when the clip ends.</a:t>
+            </a:r>
+          </a:p>
+          <a:p>
+            <a:r>
+              <a:t>The preview image is generated from the first video frame.</a:t>
+            </a:r>
+          </a:p>
+          <a:p>
+            <a:r>
+              <a:t>Clip: (c) copyright 2008, Blender Foundation / www.bigbuckbunny.org</a:t>
+            </a:r>
+          </a:p>
+          <a:p>
+            <a:r>
+              <a:t>Licensed under Creative Commons Attribution 3.0.</a:t>
             </a:r>
           </a:p>
         </p:txBody>
@@ -1532,7 +1765,27 @@
           <a:lstStyle/>
           <a:p>
             <a:r>
-              <a:t>This slide intentionally demonstrates the Blank layout.</a:t>
+              <a:t>The embedded Big Buck Bunny clip starts when this slide appears.</a:t>
+            </a:r>
+          </a:p>
+          <a:p>
+            <a:r>
+              <a:t>It fills the screen, loops, and plays with sound muted.</a:t>
+            </a:r>
+          </a:p>
+          <a:p>
+            <a:r>
+              <a:t>Advance the slide manually when you are ready to continue.</a:t>
+            </a:r>
+          </a:p>
+          <a:p>
+            <a:r>
+              <a:t>Clip and poster: (c) copyright 2008, Blender Foundation / www.bigbuckbunny.org</a:t>
+            </a:r>
+          </a:p>
+          <a:p>
+            <a:r>
+              <a:t>Licensed under Creative Commons Attribution 3.0.</a:t>
             </a:r>
           </a:p>
         </p:txBody>
@@ -1602,7 +1855,12 @@
           <a:lstStyle/>
           <a:p>
             <a:r>
-              <a:t>A single top-level thematic break separates the left and right placeholders.</a:t>
+              <a:t>This slide uses an online YouTube media object. Playback needs internet access.</a:t>
+            </a:r>
+          </a:p>
+          <a:p>
+            <a:r>
+              <a:t>The film is (c) copyright 2008, Blender Foundation / www.bigbuckbunny.org</a:t>
             </a:r>
           </a:p>
         </p:txBody>
@@ -10981,7 +11239,27 @@
                 <a:ea typeface="+mn-ea"/>
                 <a:cs typeface="+mn-cs"/>
               </a:rPr>
-              <a:t>An optional document front matter block sets deck-wide defaults such as aspect ratio, fonts, colors, and background behavior.</a:t>
+              <a:t>An optional </a:t>
+            </a:r>
+            <a:r>
+              <a:rPr b="0" i="0">
+                <a:solidFill>
+                  <a:schemeClr val="dk1"/>
+                </a:solidFill>
+                <a:latin typeface="Consolas"/>
+              </a:rPr>
+              <a:t>markdown-pptx:deck</a:t>
+            </a:r>
+            <a:r>
+              <a:rPr b="0" i="0">
+                <a:solidFill>
+                  <a:schemeClr val="dk1"/>
+                </a:solidFill>
+                <a:latin typeface="+mn-lt"/>
+                <a:ea typeface="+mn-ea"/>
+                <a:cs typeface="+mn-cs"/>
+              </a:rPr>
+              <a:t> comment sets deck-wide defaults such as aspect ratio, fonts, colors, and background behavior.</a:t>
             </a:r>
             <a:endParaRPr>
               <a:solidFill>
@@ -11027,7 +11305,27 @@
                 <a:ea typeface="+mn-ea"/>
                 <a:cs typeface="+mn-cs"/>
               </a:rPr>
-              <a:t> or Setext H1 starts a new slide. Optional slide front matter appears immediately after the heading. Everything until the next H1 belongs to that slide.</a:t>
+              <a:t> or Setext H1 starts a new slide. An optional </a:t>
+            </a:r>
+            <a:r>
+              <a:rPr b="0" i="0">
+                <a:solidFill>
+                  <a:schemeClr val="dk1"/>
+                </a:solidFill>
+                <a:latin typeface="Consolas"/>
+              </a:rPr>
+              <a:t>markdown-pptx:slide</a:t>
+            </a:r>
+            <a:r>
+              <a:rPr b="0" i="0">
+                <a:solidFill>
+                  <a:schemeClr val="dk1"/>
+                </a:solidFill>
+                <a:latin typeface="+mn-lt"/>
+                <a:ea typeface="+mn-ea"/>
+                <a:cs typeface="+mn-cs"/>
+              </a:rPr>
+              <a:t> comment appears immediately after the heading. Everything until the next H1 belongs to that slide.</a:t>
             </a:r>
             <a:endParaRPr>
               <a:solidFill>
@@ -12600,6 +12898,600 @@
 <file path=ppt/slides/slide34.xml><?xml version="1.0" encoding="utf-8"?>
 <p:sld xmlns:a="http://schemas.openxmlformats.org/drawingml/2006/main" xmlns:p="http://schemas.openxmlformats.org/presentationml/2006/main" xmlns:r="http://schemas.openxmlformats.org/officeDocument/2006/relationships">
   <p:cSld>
+    <p:spTree>
+      <p:nvGrpSpPr>
+        <p:cNvPr id="1" name=""/>
+        <p:cNvGrpSpPr/>
+        <p:nvPr/>
+      </p:nvGrpSpPr>
+      <p:grpSpPr/>
+      <p:sp>
+        <p:nvSpPr>
+          <p:cNvPr id="2" name="Title 1"/>
+          <p:cNvSpPr>
+            <a:spLocks noGrp="1"/>
+          </p:cNvSpPr>
+          <p:nvPr>
+            <p:ph type="title"/>
+          </p:nvPr>
+        </p:nvSpPr>
+        <p:spPr/>
+        <p:txBody>
+          <a:bodyPr>
+            <a:normAutofit/>
+          </a:bodyPr>
+          <a:lstStyle/>
+          <a:p>
+            <a:pPr>
+              <a:defRPr>
+                <a:solidFill>
+                  <a:schemeClr val="accent6"/>
+                </a:solidFill>
+              </a:defRPr>
+            </a:pPr>
+            <a:r>
+              <a:rPr>
+                <a:solidFill>
+                  <a:schemeClr val="accent6"/>
+                </a:solidFill>
+              </a:rPr>
+              <a:t>Local video: Big Buck Bunny</a:t>
+            </a:r>
+            <a:endParaRPr>
+              <a:solidFill>
+                <a:schemeClr val="accent6"/>
+              </a:solidFill>
+            </a:endParaRPr>
+          </a:p>
+        </p:txBody>
+      </p:sp>
+      <p:sp>
+        <p:nvSpPr>
+          <p:cNvPr id="3" name="Content Placeholder 2"/>
+          <p:cNvSpPr>
+            <a:spLocks noGrp="1"/>
+          </p:cNvSpPr>
+          <p:nvPr>
+            <p:ph idx="1"/>
+          </p:nvPr>
+        </p:nvSpPr>
+        <p:spPr/>
+        <p:txBody>
+          <a:bodyPr/>
+          <a:lstStyle/>
+          <a:p/>
+        </p:txBody>
+      </p:sp>
+      <p:pic>
+        <p:nvPicPr>
+          <p:cNvPr id="4" name="MarkdownSlidesVideo">
+            <a:hlinkClick r:id="" action="ppaction://media"/>
+          </p:cNvPr>
+          <p:cNvPicPr>
+            <a:picLocks noChangeAspect="1"/>
+          </p:cNvPicPr>
+          <p:nvPr>
+            <a:videoFile r:link="rId3"/>
+            <p:extLst>
+              <p:ext uri="{DAA4B4D4-6D71-4841-9C94-3DE7FCFB9230}">
+                <p14:media xmlns:p14="http://schemas.microsoft.com/office/powerpoint/2010/main" r:embed="rId2"/>
+              </p:ext>
+            </p:extLst>
+          </p:nvPr>
+        </p:nvPicPr>
+        <p:blipFill>
+          <a:blip r:embed="rId4"/>
+          <a:stretch>
+            <a:fillRect/>
+          </a:stretch>
+        </p:blipFill>
+        <p:spPr>
+          <a:xfrm>
+            <a:off x="2225122" y="1825625"/>
+            <a:ext cx="7741756" cy="4351338"/>
+          </a:xfrm>
+          <a:prstGeom prst="rect">
+            <a:avLst/>
+          </a:prstGeom>
+        </p:spPr>
+      </p:pic>
+    </p:spTree>
+  </p:cSld>
+  <p:clrMapOvr>
+    <a:masterClrMapping/>
+  </p:clrMapOvr>
+  <p:timing>
+    <p:tnLst>
+      <p:par>
+        <p:cTn id="1" dur="indefinite" restart="never" nodeType="tmRoot">
+          <p:childTnLst>
+            <p:seq concurrent="1" nextAc="seek">
+              <p:cTn id="3" dur="indefinite" nodeType="mainSeq">
+                <p:childTnLst>
+                  <p:par>
+                    <p:cTn id="4" fill="hold">
+                      <p:stCondLst>
+                        <p:cond delay="indefinite"/>
+                      </p:stCondLst>
+                      <p:childTnLst>
+                        <p:par>
+                          <p:cTn id="5" fill="hold">
+                            <p:stCondLst>
+                              <p:cond delay="0"/>
+                            </p:stCondLst>
+                            <p:childTnLst>
+                              <p:par>
+                                <p:cTn id="6" presetID="1" presetClass="mediacall" presetSubtype="0" fill="hold" nodeType="clickEffect">
+                                  <p:stCondLst>
+                                    <p:cond delay="0"/>
+                                  </p:stCondLst>
+                                  <p:childTnLst>
+                                    <p:cmd type="call" cmd="playFrom(0.0)">
+                                      <p:cBhvr>
+                                        <p:cTn id="7" dur="1" fill="hold"/>
+                                        <p:tgtEl>
+                                          <p:spTgt spid="4"/>
+                                        </p:tgtEl>
+                                      </p:cBhvr>
+                                    </p:cmd>
+                                  </p:childTnLst>
+                                </p:cTn>
+                              </p:par>
+                            </p:childTnLst>
+                          </p:cTn>
+                        </p:par>
+                      </p:childTnLst>
+                    </p:cTn>
+                  </p:par>
+                </p:childTnLst>
+              </p:cTn>
+              <p:prevCondLst>
+                <p:cond evt="onPrev" delay="0">
+                  <p:tgtEl>
+                    <p:sldTgt/>
+                  </p:tgtEl>
+                </p:cond>
+              </p:prevCondLst>
+              <p:nextCondLst>
+                <p:cond evt="onNext" delay="0">
+                  <p:tgtEl>
+                    <p:sldTgt/>
+                  </p:tgtEl>
+                </p:cond>
+              </p:nextCondLst>
+            </p:seq>
+            <p:video>
+              <p:cMediaNode vol="80000">
+                <p:cTn id="2" fill="hold" display="0">
+                  <p:stCondLst>
+                    <p:cond delay="indefinite"/>
+                  </p:stCondLst>
+                </p:cTn>
+                <p:tgtEl>
+                  <p:spTgt spid="4"/>
+                </p:tgtEl>
+              </p:cMediaNode>
+            </p:video>
+          </p:childTnLst>
+        </p:cTn>
+      </p:par>
+    </p:tnLst>
+  </p:timing>
+</p:sld>
+</file>
+
+<file path=ppt/slides/slide35.xml><?xml version="1.0" encoding="utf-8"?>
+<p:sld xmlns:a="http://schemas.openxmlformats.org/drawingml/2006/main" xmlns:p="http://schemas.openxmlformats.org/presentationml/2006/main" xmlns:r="http://schemas.openxmlformats.org/officeDocument/2006/relationships">
+  <p:cSld>
+    <p:spTree>
+      <p:nvGrpSpPr>
+        <p:cNvPr id="1" name=""/>
+        <p:cNvGrpSpPr/>
+        <p:nvPr/>
+      </p:nvGrpSpPr>
+      <p:grpSpPr/>
+      <p:sp>
+        <p:nvSpPr>
+          <p:cNvPr id="2" name="Title 1"/>
+          <p:cNvSpPr>
+            <a:spLocks noGrp="1"/>
+          </p:cNvSpPr>
+          <p:nvPr>
+            <p:ph type="title"/>
+          </p:nvPr>
+        </p:nvSpPr>
+        <p:spPr/>
+        <p:txBody>
+          <a:bodyPr>
+            <a:normAutofit/>
+          </a:bodyPr>
+          <a:lstStyle/>
+          <a:p>
+            <a:pPr>
+              <a:defRPr>
+                <a:solidFill>
+                  <a:schemeClr val="accent6"/>
+                </a:solidFill>
+              </a:defRPr>
+            </a:pPr>
+            <a:r>
+              <a:rPr>
+                <a:solidFill>
+                  <a:schemeClr val="accent6"/>
+                </a:solidFill>
+              </a:rPr>
+              <a:t>Local video: automatic fullscreen playback</a:t>
+            </a:r>
+            <a:endParaRPr>
+              <a:solidFill>
+                <a:schemeClr val="accent6"/>
+              </a:solidFill>
+            </a:endParaRPr>
+          </a:p>
+        </p:txBody>
+      </p:sp>
+      <p:sp>
+        <p:nvSpPr>
+          <p:cNvPr id="3" name="Content Placeholder 2"/>
+          <p:cNvSpPr>
+            <a:spLocks noGrp="1"/>
+          </p:cNvSpPr>
+          <p:nvPr>
+            <p:ph idx="1"/>
+          </p:nvPr>
+        </p:nvSpPr>
+        <p:spPr/>
+        <p:txBody>
+          <a:bodyPr/>
+          <a:lstStyle/>
+          <a:p/>
+        </p:txBody>
+      </p:sp>
+      <p:pic>
+        <p:nvPicPr>
+          <p:cNvPr id="4" name="MarkdownSlidesVideo">
+            <a:hlinkClick r:id="" action="ppaction://media"/>
+          </p:cNvPr>
+          <p:cNvPicPr>
+            <a:picLocks noChangeAspect="1"/>
+          </p:cNvPicPr>
+          <p:nvPr>
+            <a:videoFile r:link="rId3"/>
+            <p:extLst>
+              <p:ext uri="{DAA4B4D4-6D71-4841-9C94-3DE7FCFB9230}">
+                <p14:media xmlns:p14="http://schemas.microsoft.com/office/powerpoint/2010/main" r:embed="rId2"/>
+              </p:ext>
+            </p:extLst>
+          </p:nvPr>
+        </p:nvPicPr>
+        <p:blipFill>
+          <a:blip r:embed="rId4"/>
+          <a:stretch>
+            <a:fillRect/>
+          </a:stretch>
+        </p:blipFill>
+        <p:spPr>
+          <a:xfrm>
+            <a:off x="2225122" y="1825625"/>
+            <a:ext cx="7741756" cy="4351338"/>
+          </a:xfrm>
+          <a:prstGeom prst="rect">
+            <a:avLst/>
+          </a:prstGeom>
+        </p:spPr>
+      </p:pic>
+    </p:spTree>
+  </p:cSld>
+  <p:clrMapOvr>
+    <a:masterClrMapping/>
+  </p:clrMapOvr>
+  <p:timing>
+    <p:tnLst>
+      <p:par>
+        <p:cTn id="1" dur="indefinite" restart="never" nodeType="tmRoot">
+          <p:childTnLst>
+            <p:seq concurrent="1" nextAc="seek">
+              <p:cTn id="3" dur="indefinite" nodeType="mainSeq">
+                <p:childTnLst>
+                  <p:par>
+                    <p:cTn id="4" fill="hold">
+                      <p:stCondLst>
+                        <p:cond delay="indefinite"/>
+                        <p:cond evt="onBegin" delay="0">
+                          <p:tn val="3"/>
+                        </p:cond>
+                      </p:stCondLst>
+                      <p:childTnLst>
+                        <p:par>
+                          <p:cTn id="5" fill="hold">
+                            <p:stCondLst>
+                              <p:cond delay="0"/>
+                            </p:stCondLst>
+                            <p:childTnLst>
+                              <p:par>
+                                <p:cTn id="6" presetID="1" presetClass="mediacall" presetSubtype="0" fill="hold" nodeType="withEffect">
+                                  <p:stCondLst>
+                                    <p:cond delay="0"/>
+                                  </p:stCondLst>
+                                  <p:childTnLst>
+                                    <p:cmd type="call" cmd="playFrom(0.0)">
+                                      <p:cBhvr>
+                                        <p:cTn id="7" dur="1" fill="hold"/>
+                                        <p:tgtEl>
+                                          <p:spTgt spid="4"/>
+                                        </p:tgtEl>
+                                      </p:cBhvr>
+                                    </p:cmd>
+                                  </p:childTnLst>
+                                </p:cTn>
+                              </p:par>
+                            </p:childTnLst>
+                          </p:cTn>
+                        </p:par>
+                      </p:childTnLst>
+                    </p:cTn>
+                  </p:par>
+                </p:childTnLst>
+              </p:cTn>
+              <p:prevCondLst>
+                <p:cond evt="onPrev" delay="0">
+                  <p:tgtEl>
+                    <p:sldTgt/>
+                  </p:tgtEl>
+                </p:cond>
+              </p:prevCondLst>
+              <p:nextCondLst>
+                <p:cond evt="onNext" delay="0">
+                  <p:tgtEl>
+                    <p:sldTgt/>
+                  </p:tgtEl>
+                </p:cond>
+              </p:nextCondLst>
+            </p:seq>
+            <p:video fullScrn="1">
+              <p:cMediaNode vol="0">
+                <p:cTn id="2" fill="hold" display="0" repeatCount="indefinite">
+                  <p:stCondLst>
+                    <p:cond delay="indefinite"/>
+                  </p:stCondLst>
+                </p:cTn>
+                <p:tgtEl>
+                  <p:spTgt spid="4"/>
+                </p:tgtEl>
+              </p:cMediaNode>
+            </p:video>
+          </p:childTnLst>
+        </p:cTn>
+      </p:par>
+    </p:tnLst>
+  </p:timing>
+</p:sld>
+</file>
+
+<file path=ppt/slides/slide36.xml><?xml version="1.0" encoding="utf-8"?>
+<p:sld xmlns:a="http://schemas.openxmlformats.org/drawingml/2006/main" xmlns:p="http://schemas.openxmlformats.org/presentationml/2006/main" xmlns:r="http://schemas.openxmlformats.org/officeDocument/2006/relationships">
+  <p:cSld>
+    <p:spTree>
+      <p:nvGrpSpPr>
+        <p:cNvPr id="1" name=""/>
+        <p:cNvGrpSpPr/>
+        <p:nvPr/>
+      </p:nvGrpSpPr>
+      <p:grpSpPr/>
+      <p:sp>
+        <p:nvSpPr>
+          <p:cNvPr id="2" name="Title 1"/>
+          <p:cNvSpPr>
+            <a:spLocks noGrp="1"/>
+          </p:cNvSpPr>
+          <p:nvPr>
+            <p:ph type="title"/>
+          </p:nvPr>
+        </p:nvSpPr>
+        <p:spPr/>
+        <p:txBody>
+          <a:bodyPr>
+            <a:normAutofit/>
+          </a:bodyPr>
+          <a:lstStyle/>
+          <a:p>
+            <a:pPr>
+              <a:defRPr>
+                <a:solidFill>
+                  <a:schemeClr val="accent6"/>
+                </a:solidFill>
+              </a:defRPr>
+            </a:pPr>
+            <a:r>
+              <a:rPr>
+                <a:solidFill>
+                  <a:schemeClr val="accent6"/>
+                </a:solidFill>
+              </a:rPr>
+              <a:t>YouTube video: Big Buck Bunny</a:t>
+            </a:r>
+            <a:endParaRPr>
+              <a:solidFill>
+                <a:schemeClr val="accent6"/>
+              </a:solidFill>
+            </a:endParaRPr>
+          </a:p>
+        </p:txBody>
+      </p:sp>
+      <p:sp>
+        <p:nvSpPr>
+          <p:cNvPr id="3" name="Content Placeholder 2"/>
+          <p:cNvSpPr>
+            <a:spLocks noGrp="1"/>
+          </p:cNvSpPr>
+          <p:nvPr>
+            <p:ph idx="1"/>
+          </p:nvPr>
+        </p:nvSpPr>
+        <p:spPr/>
+        <p:txBody>
+          <a:bodyPr wrap="square">
+            <a:normAutofit/>
+          </a:bodyPr>
+          <a:lstStyle/>
+          <a:p>
+            <a:pPr marL="0" indent="0">
+              <a:buNone/>
+              <a:defRPr>
+                <a:solidFill>
+                  <a:schemeClr val="dk1"/>
+                </a:solidFill>
+              </a:defRPr>
+            </a:pPr>
+            <a:r>
+              <a:rPr sz="3700" b="1" i="0">
+                <a:solidFill>
+                  <a:schemeClr val="dk1"/>
+                </a:solidFill>
+                <a:latin typeface="+mj-lt"/>
+                <a:ea typeface="+mj-ea"/>
+                <a:cs typeface="+mj-cs"/>
+              </a:rPr>
+              <a:t>Online playback</a:t>
+            </a:r>
+            <a:endParaRPr>
+              <a:solidFill>
+                <a:schemeClr val="dk1"/>
+              </a:solidFill>
+            </a:endParaRPr>
+          </a:p>
+          <a:p>
+            <a:pPr marL="0" indent="0">
+              <a:buNone/>
+              <a:defRPr>
+                <a:solidFill>
+                  <a:schemeClr val="dk1"/>
+                </a:solidFill>
+              </a:defRPr>
+            </a:pPr>
+            <a:r>
+              <a:rPr b="0" i="0">
+                <a:solidFill>
+                  <a:schemeClr val="dk1"/>
+                </a:solidFill>
+                <a:latin typeface="+mn-lt"/>
+                <a:ea typeface="+mn-ea"/>
+                <a:cs typeface="+mn-cs"/>
+              </a:rPr>
+              <a:t>The video on the right is linked to YouTube.</a:t>
+            </a:r>
+            <a:endParaRPr>
+              <a:solidFill>
+                <a:schemeClr val="dk1"/>
+              </a:solidFill>
+            </a:endParaRPr>
+          </a:p>
+          <a:p>
+            <a:pPr marL="0" indent="0">
+              <a:buNone/>
+              <a:defRPr>
+                <a:solidFill>
+                  <a:schemeClr val="dk1"/>
+                </a:solidFill>
+              </a:defRPr>
+            </a:pPr>
+            <a:r>
+              <a:rPr b="0" i="0">
+                <a:solidFill>
+                  <a:schemeClr val="dk1"/>
+                </a:solidFill>
+                <a:latin typeface="+mn-lt"/>
+                <a:ea typeface="+mn-ea"/>
+                <a:cs typeface="+mn-cs"/>
+              </a:rPr>
+              <a:t>Click the video to play the full film in PowerPoint.</a:t>
+            </a:r>
+            <a:endParaRPr>
+              <a:solidFill>
+                <a:schemeClr val="dk1"/>
+              </a:solidFill>
+            </a:endParaRPr>
+          </a:p>
+        </p:txBody>
+      </p:sp>
+      <p:sp>
+        <p:nvSpPr>
+          <p:cNvPr id="4" name="Content Placeholder 3"/>
+          <p:cNvSpPr>
+            <a:spLocks noGrp="1"/>
+          </p:cNvSpPr>
+          <p:nvPr>
+            <p:ph idx="2"/>
+          </p:nvPr>
+        </p:nvSpPr>
+        <p:spPr/>
+        <p:txBody>
+          <a:bodyPr/>
+          <a:lstStyle/>
+          <a:p/>
+        </p:txBody>
+      </p:sp>
+      <p:pic>
+        <p:nvPicPr>
+          <p:cNvPr id="5" name="MarkdownSlidesYouTubeVideo" descr="image.png">
+            <a:hlinkClick action="ppaction://media" r:id=""/>
+          </p:cNvPr>
+          <p:cNvPicPr>
+            <a:picLocks noChangeAspect="1"/>
+          </p:cNvPicPr>
+          <p:nvPr>
+            <a:videoFile r:link="rId3"/>
+          </p:nvPr>
+        </p:nvPicPr>
+        <p:blipFill>
+          <a:blip r:embed="rId2"/>
+          <a:stretch>
+            <a:fillRect/>
+          </a:stretch>
+        </p:blipFill>
+        <p:spPr>
+          <a:xfrm>
+            <a:off x="6172200" y="2543969"/>
+            <a:ext cx="5181600" cy="2914650"/>
+          </a:xfrm>
+          <a:prstGeom prst="rect">
+            <a:avLst/>
+          </a:prstGeom>
+        </p:spPr>
+      </p:pic>
+    </p:spTree>
+  </p:cSld>
+  <p:clrMapOvr>
+    <a:masterClrMapping/>
+  </p:clrMapOvr>
+  <p:timing>
+    <p:tnLst>
+      <p:par>
+        <p:cTn id="1" dur="indefinite" restart="never" nodeType="tmRoot">
+          <p:childTnLst>
+            <p:video>
+              <p:cMediaNode vol="80000">
+                <p:cTn id="2" fill="hold" display="0">
+                  <p:stCondLst>
+                    <p:cond delay="indefinite"/>
+                  </p:stCondLst>
+                </p:cTn>
+                <p:tgtEl>
+                  <p:spTgt spid="5"/>
+                </p:tgtEl>
+              </p:cMediaNode>
+            </p:video>
+          </p:childTnLst>
+        </p:cTn>
+      </p:par>
+    </p:tnLst>
+  </p:timing>
+</p:sld>
+</file>
+
+<file path=ppt/slides/slide37.xml><?xml version="1.0" encoding="utf-8"?>
+<p:sld xmlns:a="http://schemas.openxmlformats.org/drawingml/2006/main" xmlns:p="http://schemas.openxmlformats.org/presentationml/2006/main" xmlns:r="http://schemas.openxmlformats.org/officeDocument/2006/relationships">
+  <p:cSld>
     <p:bg>
       <p:bgPr>
         <a:solidFill>
@@ -12707,7 +13599,7 @@
 </p:sld>
 </file>
 
-<file path=ppt/slides/slide35.xml><?xml version="1.0" encoding="utf-8"?>
+<file path=ppt/slides/slide38.xml><?xml version="1.0" encoding="utf-8"?>
 <p:sld xmlns:a="http://schemas.openxmlformats.org/drawingml/2006/main" xmlns:p="http://schemas.openxmlformats.org/presentationml/2006/main" xmlns:r="http://schemas.openxmlformats.org/officeDocument/2006/relationships" showMasterSp="0">
   <p:cSld>
     <p:bg>
@@ -12815,7 +13707,7 @@
 </p:sld>
 </file>
 
-<file path=ppt/slides/slide36.xml><?xml version="1.0" encoding="utf-8"?>
+<file path=ppt/slides/slide39.xml><?xml version="1.0" encoding="utf-8"?>
 <p:sld xmlns:a="http://schemas.openxmlformats.org/drawingml/2006/main" xmlns:p="http://schemas.openxmlformats.org/presentationml/2006/main" xmlns:r="http://schemas.openxmlformats.org/officeDocument/2006/relationships">
   <p:cSld>
     <p:spTree>
@@ -12857,7 +13749,301 @@
 </p:sld>
 </file>
 
-<file path=ppt/slides/slide37.xml><?xml version="1.0" encoding="utf-8"?>
+<file path=ppt/slides/slide4.xml><?xml version="1.0" encoding="utf-8"?>
+<p:sld xmlns:a="http://schemas.openxmlformats.org/drawingml/2006/main" xmlns:p="http://schemas.openxmlformats.org/presentationml/2006/main" xmlns:r="http://schemas.openxmlformats.org/officeDocument/2006/relationships">
+  <p:cSld>
+    <p:spTree>
+      <p:nvGrpSpPr>
+        <p:cNvPr id="1" name=""/>
+        <p:cNvGrpSpPr/>
+        <p:nvPr/>
+      </p:nvGrpSpPr>
+      <p:grpSpPr/>
+      <p:sp>
+        <p:nvSpPr>
+          <p:cNvPr id="2" name="Title 1"/>
+          <p:cNvSpPr>
+            <a:spLocks noGrp="1"/>
+          </p:cNvSpPr>
+          <p:nvPr>
+            <p:ph type="title"/>
+          </p:nvPr>
+        </p:nvSpPr>
+        <p:spPr/>
+        <p:txBody>
+          <a:bodyPr>
+            <a:normAutofit/>
+          </a:bodyPr>
+          <a:lstStyle/>
+          <a:p>
+            <a:pPr>
+              <a:defRPr>
+                <a:solidFill>
+                  <a:schemeClr val="accent6"/>
+                </a:solidFill>
+              </a:defRPr>
+            </a:pPr>
+            <a:r>
+              <a:rPr>
+                <a:solidFill>
+                  <a:schemeClr val="accent6"/>
+                </a:solidFill>
+              </a:rPr>
+              <a:t>Basic CLI usage</a:t>
+            </a:r>
+            <a:endParaRPr>
+              <a:solidFill>
+                <a:schemeClr val="accent6"/>
+              </a:solidFill>
+            </a:endParaRPr>
+          </a:p>
+        </p:txBody>
+      </p:sp>
+      <p:sp>
+        <p:nvSpPr>
+          <p:cNvPr id="3" name="Content Placeholder 2"/>
+          <p:cNvSpPr>
+            <a:spLocks noGrp="1"/>
+          </p:cNvSpPr>
+          <p:nvPr>
+            <p:ph idx="1"/>
+          </p:nvPr>
+        </p:nvSpPr>
+        <p:spPr/>
+        <p:txBody>
+          <a:bodyPr wrap="square">
+            <a:normAutofit/>
+          </a:bodyPr>
+          <a:lstStyle/>
+          <a:p>
+            <a:pPr marL="0" indent="0">
+              <a:buNone/>
+              <a:defRPr>
+                <a:solidFill>
+                  <a:schemeClr val="dk1"/>
+                </a:solidFill>
+              </a:defRPr>
+            </a:pPr>
+            <a:r>
+              <a:rPr b="0" i="0">
+                <a:solidFill>
+                  <a:schemeClr val="dk1"/>
+                </a:solidFill>
+                <a:latin typeface="+mn-lt"/>
+                <a:ea typeface="+mn-ea"/>
+                <a:cs typeface="+mn-cs"/>
+              </a:rPr>
+              <a:t>Run </a:t>
+            </a:r>
+            <a:r>
+              <a:rPr b="0" i="0">
+                <a:solidFill>
+                  <a:schemeClr val="dk1"/>
+                </a:solidFill>
+                <a:latin typeface="Consolas"/>
+              </a:rPr>
+              <a:t>uvx markdown-pptx deck.md</a:t>
+            </a:r>
+            <a:r>
+              <a:rPr b="0" i="0">
+                <a:solidFill>
+                  <a:schemeClr val="dk1"/>
+                </a:solidFill>
+                <a:latin typeface="+mn-lt"/>
+                <a:ea typeface="+mn-ea"/>
+                <a:cs typeface="+mn-cs"/>
+              </a:rPr>
+              <a:t> to write </a:t>
+            </a:r>
+            <a:r>
+              <a:rPr b="0" i="0">
+                <a:solidFill>
+                  <a:schemeClr val="dk1"/>
+                </a:solidFill>
+                <a:latin typeface="Consolas"/>
+              </a:rPr>
+              <a:t>deck.pptx</a:t>
+            </a:r>
+            <a:r>
+              <a:rPr b="0" i="0">
+                <a:solidFill>
+                  <a:schemeClr val="dk1"/>
+                </a:solidFill>
+                <a:latin typeface="+mn-lt"/>
+                <a:ea typeface="+mn-ea"/>
+                <a:cs typeface="+mn-cs"/>
+              </a:rPr>
+              <a:t> next to the source markdown file.</a:t>
+            </a:r>
+            <a:endParaRPr>
+              <a:solidFill>
+                <a:schemeClr val="dk1"/>
+              </a:solidFill>
+            </a:endParaRPr>
+          </a:p>
+          <a:p>
+            <a:pPr marL="0" indent="0">
+              <a:buNone/>
+              <a:defRPr>
+                <a:solidFill>
+                  <a:schemeClr val="dk1"/>
+                </a:solidFill>
+              </a:defRPr>
+            </a:pPr>
+            <a:r>
+              <a:rPr b="0" i="0">
+                <a:solidFill>
+                  <a:schemeClr val="dk1"/>
+                </a:solidFill>
+                <a:latin typeface="+mn-lt"/>
+                <a:ea typeface="+mn-ea"/>
+                <a:cs typeface="+mn-cs"/>
+              </a:rPr>
+              <a:t>Use </a:t>
+            </a:r>
+            <a:r>
+              <a:rPr b="0" i="0">
+                <a:solidFill>
+                  <a:schemeClr val="dk1"/>
+                </a:solidFill>
+                <a:latin typeface="Consolas"/>
+              </a:rPr>
+              <a:t>uvx markdown-pptx deck.md out.pptx</a:t>
+            </a:r>
+            <a:r>
+              <a:rPr b="0" i="0">
+                <a:solidFill>
+                  <a:schemeClr val="dk1"/>
+                </a:solidFill>
+                <a:latin typeface="+mn-lt"/>
+                <a:ea typeface="+mn-ea"/>
+                <a:cs typeface="+mn-cs"/>
+              </a:rPr>
+              <a:t> to choose the output path, </a:t>
+            </a:r>
+            <a:r>
+              <a:rPr b="0" i="0">
+                <a:solidFill>
+                  <a:schemeClr val="dk1"/>
+                </a:solidFill>
+                <a:latin typeface="Consolas"/>
+              </a:rPr>
+              <a:t>--template theme.pptx</a:t>
+            </a:r>
+            <a:r>
+              <a:rPr b="0" i="0">
+                <a:solidFill>
+                  <a:schemeClr val="dk1"/>
+                </a:solidFill>
+                <a:latin typeface="+mn-lt"/>
+                <a:ea typeface="+mn-ea"/>
+                <a:cs typeface="+mn-cs"/>
+              </a:rPr>
+              <a:t> to render against an existing PowerPoint template, and </a:t>
+            </a:r>
+            <a:r>
+              <a:rPr b="0" i="0">
+                <a:solidFill>
+                  <a:schemeClr val="dk1"/>
+                </a:solidFill>
+                <a:latin typeface="Consolas"/>
+              </a:rPr>
+              <a:t>--force</a:t>
+            </a:r>
+            <a:r>
+              <a:rPr b="0" i="0">
+                <a:solidFill>
+                  <a:schemeClr val="dk1"/>
+                </a:solidFill>
+                <a:latin typeface="+mn-lt"/>
+                <a:ea typeface="+mn-ea"/>
+                <a:cs typeface="+mn-cs"/>
+              </a:rPr>
+              <a:t> to overwrite an existing file.</a:t>
+            </a:r>
+            <a:endParaRPr>
+              <a:solidFill>
+                <a:schemeClr val="dk1"/>
+              </a:solidFill>
+            </a:endParaRPr>
+          </a:p>
+          <a:p>
+            <a:pPr marL="0" indent="0">
+              <a:buNone/>
+              <a:defRPr>
+                <a:solidFill>
+                  <a:schemeClr val="dk1"/>
+                </a:solidFill>
+              </a:defRPr>
+            </a:pPr>
+            <a:r>
+              <a:rPr b="0" i="0">
+                <a:solidFill>
+                  <a:schemeClr val="dk1"/>
+                </a:solidFill>
+                <a:latin typeface="+mn-lt"/>
+                <a:ea typeface="+mn-ea"/>
+                <a:cs typeface="+mn-cs"/>
+              </a:rPr>
+              <a:t>Run </a:t>
+            </a:r>
+            <a:r>
+              <a:rPr b="0" i="0">
+                <a:solidFill>
+                  <a:schemeClr val="dk1"/>
+                </a:solidFill>
+                <a:latin typeface="Consolas"/>
+              </a:rPr>
+              <a:t>uvx markdown-pptx</a:t>
+            </a:r>
+            <a:r>
+              <a:rPr b="0" i="0">
+                <a:solidFill>
+                  <a:schemeClr val="dk1"/>
+                </a:solidFill>
+                <a:latin typeface="+mn-lt"/>
+                <a:ea typeface="+mn-ea"/>
+                <a:cs typeface="+mn-cs"/>
+              </a:rPr>
+              <a:t> with no arguments for the quick reference or use </a:t>
+            </a:r>
+            <a:r>
+              <a:rPr b="0" i="0">
+                <a:solidFill>
+                  <a:schemeClr val="dk1"/>
+                </a:solidFill>
+                <a:latin typeface="Consolas"/>
+              </a:rPr>
+              <a:t>--about</a:t>
+            </a:r>
+            <a:r>
+              <a:rPr b="0" i="0">
+                <a:solidFill>
+                  <a:schemeClr val="dk1"/>
+                </a:solidFill>
+                <a:latin typeface="+mn-lt"/>
+                <a:ea typeface="+mn-ea"/>
+                <a:cs typeface="+mn-cs"/>
+              </a:rPr>
+              <a:t> for project metadata.</a:t>
+            </a:r>
+            <a:endParaRPr>
+              <a:solidFill>
+                <a:schemeClr val="dk1"/>
+              </a:solidFill>
+            </a:endParaRPr>
+          </a:p>
+        </p:txBody>
+      </p:sp>
+    </p:spTree>
+  </p:cSld>
+  <p:clrMapOvr>
+    <a:masterClrMapping/>
+  </p:clrMapOvr>
+</p:sld>
+</file>
+
+<file path=ppt/slides/slide40.xml><?xml version="1.0" encoding="utf-8"?>
 <p:sld xmlns:a="http://schemas.openxmlformats.org/drawingml/2006/main" xmlns:p="http://schemas.openxmlformats.org/presentationml/2006/main" xmlns:r="http://schemas.openxmlformats.org/officeDocument/2006/relationships">
   <p:cSld>
     <p:bg>
@@ -12978,7 +14164,7 @@
 </p:sld>
 </file>
 
-<file path=ppt/slides/slide38.xml><?xml version="1.0" encoding="utf-8"?>
+<file path=ppt/slides/slide41.xml><?xml version="1.0" encoding="utf-8"?>
 <p:sld xmlns:a="http://schemas.openxmlformats.org/drawingml/2006/main" xmlns:p="http://schemas.openxmlformats.org/presentationml/2006/main" xmlns:r="http://schemas.openxmlformats.org/officeDocument/2006/relationships">
   <p:cSld>
     <p:bg>
@@ -13101,7 +14287,7 @@
 </p:sld>
 </file>
 
-<file path=ppt/slides/slide39.xml><?xml version="1.0" encoding="utf-8"?>
+<file path=ppt/slides/slide42.xml><?xml version="1.0" encoding="utf-8"?>
 <p:sld xmlns:a="http://schemas.openxmlformats.org/drawingml/2006/main" xmlns:p="http://schemas.openxmlformats.org/presentationml/2006/main" xmlns:r="http://schemas.openxmlformats.org/officeDocument/2006/relationships">
   <p:cSld>
     <p:bg>
@@ -13219,301 +14405,7 @@
 </p:sld>
 </file>
 
-<file path=ppt/slides/slide4.xml><?xml version="1.0" encoding="utf-8"?>
-<p:sld xmlns:a="http://schemas.openxmlformats.org/drawingml/2006/main" xmlns:p="http://schemas.openxmlformats.org/presentationml/2006/main" xmlns:r="http://schemas.openxmlformats.org/officeDocument/2006/relationships">
-  <p:cSld>
-    <p:spTree>
-      <p:nvGrpSpPr>
-        <p:cNvPr id="1" name=""/>
-        <p:cNvGrpSpPr/>
-        <p:nvPr/>
-      </p:nvGrpSpPr>
-      <p:grpSpPr/>
-      <p:sp>
-        <p:nvSpPr>
-          <p:cNvPr id="2" name="Title 1"/>
-          <p:cNvSpPr>
-            <a:spLocks noGrp="1"/>
-          </p:cNvSpPr>
-          <p:nvPr>
-            <p:ph type="title"/>
-          </p:nvPr>
-        </p:nvSpPr>
-        <p:spPr/>
-        <p:txBody>
-          <a:bodyPr>
-            <a:normAutofit/>
-          </a:bodyPr>
-          <a:lstStyle/>
-          <a:p>
-            <a:pPr>
-              <a:defRPr>
-                <a:solidFill>
-                  <a:schemeClr val="accent6"/>
-                </a:solidFill>
-              </a:defRPr>
-            </a:pPr>
-            <a:r>
-              <a:rPr>
-                <a:solidFill>
-                  <a:schemeClr val="accent6"/>
-                </a:solidFill>
-              </a:rPr>
-              <a:t>Basic CLI usage</a:t>
-            </a:r>
-            <a:endParaRPr>
-              <a:solidFill>
-                <a:schemeClr val="accent6"/>
-              </a:solidFill>
-            </a:endParaRPr>
-          </a:p>
-        </p:txBody>
-      </p:sp>
-      <p:sp>
-        <p:nvSpPr>
-          <p:cNvPr id="3" name="Content Placeholder 2"/>
-          <p:cNvSpPr>
-            <a:spLocks noGrp="1"/>
-          </p:cNvSpPr>
-          <p:nvPr>
-            <p:ph idx="1"/>
-          </p:nvPr>
-        </p:nvSpPr>
-        <p:spPr/>
-        <p:txBody>
-          <a:bodyPr wrap="square">
-            <a:normAutofit/>
-          </a:bodyPr>
-          <a:lstStyle/>
-          <a:p>
-            <a:pPr marL="0" indent="0">
-              <a:buNone/>
-              <a:defRPr>
-                <a:solidFill>
-                  <a:schemeClr val="dk1"/>
-                </a:solidFill>
-              </a:defRPr>
-            </a:pPr>
-            <a:r>
-              <a:rPr b="0" i="0">
-                <a:solidFill>
-                  <a:schemeClr val="dk1"/>
-                </a:solidFill>
-                <a:latin typeface="+mn-lt"/>
-                <a:ea typeface="+mn-ea"/>
-                <a:cs typeface="+mn-cs"/>
-              </a:rPr>
-              <a:t>Run </a:t>
-            </a:r>
-            <a:r>
-              <a:rPr b="0" i="0">
-                <a:solidFill>
-                  <a:schemeClr val="dk1"/>
-                </a:solidFill>
-                <a:latin typeface="Consolas"/>
-              </a:rPr>
-              <a:t>uvx markdown-pptx deck.md</a:t>
-            </a:r>
-            <a:r>
-              <a:rPr b="0" i="0">
-                <a:solidFill>
-                  <a:schemeClr val="dk1"/>
-                </a:solidFill>
-                <a:latin typeface="+mn-lt"/>
-                <a:ea typeface="+mn-ea"/>
-                <a:cs typeface="+mn-cs"/>
-              </a:rPr>
-              <a:t> to write </a:t>
-            </a:r>
-            <a:r>
-              <a:rPr b="0" i="0">
-                <a:solidFill>
-                  <a:schemeClr val="dk1"/>
-                </a:solidFill>
-                <a:latin typeface="Consolas"/>
-              </a:rPr>
-              <a:t>deck.pptx</a:t>
-            </a:r>
-            <a:r>
-              <a:rPr b="0" i="0">
-                <a:solidFill>
-                  <a:schemeClr val="dk1"/>
-                </a:solidFill>
-                <a:latin typeface="+mn-lt"/>
-                <a:ea typeface="+mn-ea"/>
-                <a:cs typeface="+mn-cs"/>
-              </a:rPr>
-              <a:t> next to the source markdown file.</a:t>
-            </a:r>
-            <a:endParaRPr>
-              <a:solidFill>
-                <a:schemeClr val="dk1"/>
-              </a:solidFill>
-            </a:endParaRPr>
-          </a:p>
-          <a:p>
-            <a:pPr marL="0" indent="0">
-              <a:buNone/>
-              <a:defRPr>
-                <a:solidFill>
-                  <a:schemeClr val="dk1"/>
-                </a:solidFill>
-              </a:defRPr>
-            </a:pPr>
-            <a:r>
-              <a:rPr b="0" i="0">
-                <a:solidFill>
-                  <a:schemeClr val="dk1"/>
-                </a:solidFill>
-                <a:latin typeface="+mn-lt"/>
-                <a:ea typeface="+mn-ea"/>
-                <a:cs typeface="+mn-cs"/>
-              </a:rPr>
-              <a:t>Use </a:t>
-            </a:r>
-            <a:r>
-              <a:rPr b="0" i="0">
-                <a:solidFill>
-                  <a:schemeClr val="dk1"/>
-                </a:solidFill>
-                <a:latin typeface="Consolas"/>
-              </a:rPr>
-              <a:t>uvx markdown-pptx deck.md out.pptx</a:t>
-            </a:r>
-            <a:r>
-              <a:rPr b="0" i="0">
-                <a:solidFill>
-                  <a:schemeClr val="dk1"/>
-                </a:solidFill>
-                <a:latin typeface="+mn-lt"/>
-                <a:ea typeface="+mn-ea"/>
-                <a:cs typeface="+mn-cs"/>
-              </a:rPr>
-              <a:t> to choose the output path, </a:t>
-            </a:r>
-            <a:r>
-              <a:rPr b="0" i="0">
-                <a:solidFill>
-                  <a:schemeClr val="dk1"/>
-                </a:solidFill>
-                <a:latin typeface="Consolas"/>
-              </a:rPr>
-              <a:t>--template theme.pptx</a:t>
-            </a:r>
-            <a:r>
-              <a:rPr b="0" i="0">
-                <a:solidFill>
-                  <a:schemeClr val="dk1"/>
-                </a:solidFill>
-                <a:latin typeface="+mn-lt"/>
-                <a:ea typeface="+mn-ea"/>
-                <a:cs typeface="+mn-cs"/>
-              </a:rPr>
-              <a:t> to render against an existing PowerPoint template, and </a:t>
-            </a:r>
-            <a:r>
-              <a:rPr b="0" i="0">
-                <a:solidFill>
-                  <a:schemeClr val="dk1"/>
-                </a:solidFill>
-                <a:latin typeface="Consolas"/>
-              </a:rPr>
-              <a:t>--force</a:t>
-            </a:r>
-            <a:r>
-              <a:rPr b="0" i="0">
-                <a:solidFill>
-                  <a:schemeClr val="dk1"/>
-                </a:solidFill>
-                <a:latin typeface="+mn-lt"/>
-                <a:ea typeface="+mn-ea"/>
-                <a:cs typeface="+mn-cs"/>
-              </a:rPr>
-              <a:t> to overwrite an existing file.</a:t>
-            </a:r>
-            <a:endParaRPr>
-              <a:solidFill>
-                <a:schemeClr val="dk1"/>
-              </a:solidFill>
-            </a:endParaRPr>
-          </a:p>
-          <a:p>
-            <a:pPr marL="0" indent="0">
-              <a:buNone/>
-              <a:defRPr>
-                <a:solidFill>
-                  <a:schemeClr val="dk1"/>
-                </a:solidFill>
-              </a:defRPr>
-            </a:pPr>
-            <a:r>
-              <a:rPr b="0" i="0">
-                <a:solidFill>
-                  <a:schemeClr val="dk1"/>
-                </a:solidFill>
-                <a:latin typeface="+mn-lt"/>
-                <a:ea typeface="+mn-ea"/>
-                <a:cs typeface="+mn-cs"/>
-              </a:rPr>
-              <a:t>Run </a:t>
-            </a:r>
-            <a:r>
-              <a:rPr b="0" i="0">
-                <a:solidFill>
-                  <a:schemeClr val="dk1"/>
-                </a:solidFill>
-                <a:latin typeface="Consolas"/>
-              </a:rPr>
-              <a:t>uvx markdown-pptx</a:t>
-            </a:r>
-            <a:r>
-              <a:rPr b="0" i="0">
-                <a:solidFill>
-                  <a:schemeClr val="dk1"/>
-                </a:solidFill>
-                <a:latin typeface="+mn-lt"/>
-                <a:ea typeface="+mn-ea"/>
-                <a:cs typeface="+mn-cs"/>
-              </a:rPr>
-              <a:t> with no arguments for the quick reference or use </a:t>
-            </a:r>
-            <a:r>
-              <a:rPr b="0" i="0">
-                <a:solidFill>
-                  <a:schemeClr val="dk1"/>
-                </a:solidFill>
-                <a:latin typeface="Consolas"/>
-              </a:rPr>
-              <a:t>--about</a:t>
-            </a:r>
-            <a:r>
-              <a:rPr b="0" i="0">
-                <a:solidFill>
-                  <a:schemeClr val="dk1"/>
-                </a:solidFill>
-                <a:latin typeface="+mn-lt"/>
-                <a:ea typeface="+mn-ea"/>
-                <a:cs typeface="+mn-cs"/>
-              </a:rPr>
-              <a:t> for project metadata.</a:t>
-            </a:r>
-            <a:endParaRPr>
-              <a:solidFill>
-                <a:schemeClr val="dk1"/>
-              </a:solidFill>
-            </a:endParaRPr>
-          </a:p>
-        </p:txBody>
-      </p:sp>
-    </p:spTree>
-  </p:cSld>
-  <p:clrMapOvr>
-    <a:masterClrMapping/>
-  </p:clrMapOvr>
-</p:sld>
-</file>
-
-<file path=ppt/slides/slide40.xml><?xml version="1.0" encoding="utf-8"?>
+<file path=ppt/slides/slide43.xml><?xml version="1.0" encoding="utf-8"?>
 <p:sld xmlns:a="http://schemas.openxmlformats.org/drawingml/2006/main" xmlns:p="http://schemas.openxmlformats.org/presentationml/2006/main" xmlns:r="http://schemas.openxmlformats.org/officeDocument/2006/relationships">
   <p:cSld>
     <p:spTree>
@@ -13531,7 +14423,7 @@
 </p:sld>
 </file>
 
-<file path=ppt/slides/slide41.xml><?xml version="1.0" encoding="utf-8"?>
+<file path=ppt/slides/slide44.xml><?xml version="1.0" encoding="utf-8"?>
 <p:sld xmlns:a="http://schemas.openxmlformats.org/drawingml/2006/main" xmlns:p="http://schemas.openxmlformats.org/presentationml/2006/main" xmlns:r="http://schemas.openxmlformats.org/officeDocument/2006/relationships">
   <p:cSld>
     <p:spTree>
@@ -13777,7 +14669,7 @@
 </p:sld>
 </file>
 
-<file path=ppt/slides/slide42.xml><?xml version="1.0" encoding="utf-8"?>
+<file path=ppt/slides/slide45.xml><?xml version="1.0" encoding="utf-8"?>
 <p:sld xmlns:a="http://schemas.openxmlformats.org/drawingml/2006/main" xmlns:p="http://schemas.openxmlformats.org/presentationml/2006/main" xmlns:r="http://schemas.openxmlformats.org/officeDocument/2006/relationships">
   <p:cSld>
     <p:spTree>
@@ -14104,7 +14996,7 @@
 </p:sld>
 </file>
 
-<file path=ppt/slides/slide43.xml><?xml version="1.0" encoding="utf-8"?>
+<file path=ppt/slides/slide46.xml><?xml version="1.0" encoding="utf-8"?>
 <p:sld xmlns:a="http://schemas.openxmlformats.org/drawingml/2006/main" xmlns:p="http://schemas.openxmlformats.org/presentationml/2006/main" xmlns:r="http://schemas.openxmlformats.org/officeDocument/2006/relationships">
   <p:cSld>
     <p:bg>
@@ -14766,7 +15658,7 @@
 </p:sld>
 </file>
 
-<file path=ppt/slides/slide44.xml><?xml version="1.0" encoding="utf-8"?>
+<file path=ppt/slides/slide47.xml><?xml version="1.0" encoding="utf-8"?>
 <p:sld xmlns:a="http://schemas.openxmlformats.org/drawingml/2006/main" xmlns:p="http://schemas.openxmlformats.org/presentationml/2006/main" xmlns:r="http://schemas.openxmlformats.org/officeDocument/2006/relationships">
   <p:cSld>
     <p:bg>
@@ -15416,7 +16308,7 @@
 </p:sld>
 </file>
 
-<file path=ppt/slides/slide45.xml><?xml version="1.0" encoding="utf-8"?>
+<file path=ppt/slides/slide48.xml><?xml version="1.0" encoding="utf-8"?>
 <p:sld xmlns:a="http://schemas.openxmlformats.org/drawingml/2006/main" xmlns:p="http://schemas.openxmlformats.org/presentationml/2006/main" xmlns:r="http://schemas.openxmlformats.org/officeDocument/2006/relationships">
   <p:cSld>
     <p:bg>
@@ -15879,7 +16771,7 @@
 </p:sld>
 </file>
 
-<file path=ppt/slides/slide46.xml><?xml version="1.0" encoding="utf-8"?>
+<file path=ppt/slides/slide49.xml><?xml version="1.0" encoding="utf-8"?>
 <p:sld xmlns:a="http://schemas.openxmlformats.org/drawingml/2006/main" xmlns:p="http://schemas.openxmlformats.org/presentationml/2006/main" xmlns:r="http://schemas.openxmlformats.org/officeDocument/2006/relationships">
   <p:cSld>
     <p:bg>
@@ -16332,7 +17224,7 @@
 </p:sld>
 </file>
 
-<file path=ppt/slides/slide47.xml><?xml version="1.0" encoding="utf-8"?>
+<file path=ppt/slides/slide5.xml><?xml version="1.0" encoding="utf-8"?>
 <p:sld xmlns:a="http://schemas.openxmlformats.org/drawingml/2006/main" xmlns:p="http://schemas.openxmlformats.org/presentationml/2006/main" xmlns:r="http://schemas.openxmlformats.org/officeDocument/2006/relationships">
   <p:cSld>
     <p:spTree>
@@ -16371,9 +17263,8 @@
                 <a:solidFill>
                   <a:schemeClr val="accent6"/>
                 </a:solidFill>
-                <a:hlinkClick r:id="rId2" tooltip="Read the markdown-pptx guide"/>
-              </a:rPr>
-              <a:t>Shared references</a:t>
+              </a:rPr>
+              <a:t>Inspection-friendly CLI modes</a:t>
             </a:r>
             <a:endParaRPr>
               <a:solidFill>
@@ -16417,7 +17308,16 @@
                 <a:ea typeface="+mn-ea"/>
                 <a:cs typeface="+mn-cs"/>
               </a:rPr>
-              <a:t>Read the </a:t>
+              <a:t>Use </a:t>
+            </a:r>
+            <a:r>
+              <a:rPr b="0" i="0">
+                <a:solidFill>
+                  <a:schemeClr val="dk1"/>
+                </a:solidFill>
+                <a:latin typeface="Consolas"/>
+              </a:rPr>
+              <a:t>--syntax</a:t>
             </a:r>
             <a:r>
               <a:rPr b="0" i="0">
@@ -16427,9 +17327,17 @@
                 <a:latin typeface="+mn-lt"/>
                 <a:ea typeface="+mn-ea"/>
                 <a:cs typeface="+mn-cs"/>
-                <a:hlinkClick r:id="rId2" tooltip="Read the markdown-pptx guide"/>
-              </a:rPr>
-              <a:t>project guide</a:t>
+              </a:rPr>
+              <a:t> to print the supported deck format, </a:t>
+            </a:r>
+            <a:r>
+              <a:rPr b="0" i="0">
+                <a:solidFill>
+                  <a:schemeClr val="dk1"/>
+                </a:solidFill>
+                <a:latin typeface="Consolas"/>
+              </a:rPr>
+              <a:t>--list-masters</a:t>
             </a:r>
             <a:r>
               <a:rPr b="0" i="0">
@@ -16440,7 +17348,47 @@
                 <a:ea typeface="+mn-ea"/>
                 <a:cs typeface="+mn-cs"/>
               </a:rPr>
-              <a:t>.</a:t>
+              <a:t> to inspect a template's slide masters, </a:t>
+            </a:r>
+            <a:r>
+              <a:rPr b="0" i="0">
+                <a:solidFill>
+                  <a:schemeClr val="dk1"/>
+                </a:solidFill>
+                <a:latin typeface="Consolas"/>
+              </a:rPr>
+              <a:t>--list-layouts</a:t>
+            </a:r>
+            <a:r>
+              <a:rPr b="0" i="0">
+                <a:solidFill>
+                  <a:schemeClr val="dk1"/>
+                </a:solidFill>
+                <a:latin typeface="+mn-lt"/>
+                <a:ea typeface="+mn-ea"/>
+                <a:cs typeface="+mn-cs"/>
+              </a:rPr>
+              <a:t> to inspect layouts on a selected master, and </a:t>
+            </a:r>
+            <a:r>
+              <a:rPr b="0" i="0">
+                <a:solidFill>
+                  <a:schemeClr val="dk1"/>
+                </a:solidFill>
+                <a:latin typeface="Consolas"/>
+              </a:rPr>
+              <a:t>--list-color-schemes</a:t>
+            </a:r>
+            <a:r>
+              <a:rPr b="0" i="0">
+                <a:solidFill>
+                  <a:schemeClr val="dk1"/>
+                </a:solidFill>
+                <a:latin typeface="+mn-lt"/>
+                <a:ea typeface="+mn-ea"/>
+                <a:cs typeface="+mn-cs"/>
+              </a:rPr>
+              <a:t> to see the built-in theme presets.</a:t>
             </a:r>
             <a:endParaRPr>
               <a:solidFill>
@@ -16466,69 +17414,27 @@
                 <a:ea typeface="+mn-ea"/>
                 <a:cs typeface="+mn-cs"/>
               </a:rPr>
-              <a:t>The same definition can supply links throughout the deck.</a:t>
-            </a:r>
-            <a:endParaRPr>
-              <a:solidFill>
-                <a:schemeClr val="dk1"/>
-              </a:solidFill>
-            </a:endParaRPr>
-          </a:p>
-          <a:p>
-            <a:pPr marL="0" indent="0">
-              <a:buNone/>
-              <a:defRPr>
-                <a:solidFill>
-                  <a:schemeClr val="dk1"/>
-                </a:solidFill>
-              </a:defRPr>
-            </a:pPr>
-            <a:r>
-              <a:rPr b="1" i="0">
+              <a:t>Add </a:t>
+            </a:r>
+            <a:r>
+              <a:rPr b="0" i="0">
+                <a:solidFill>
+                  <a:schemeClr val="dk1"/>
+                </a:solidFill>
+                <a:latin typeface="Consolas"/>
+              </a:rPr>
+              <a:t>--json</a:t>
+            </a:r>
+            <a:r>
+              <a:rPr b="0" i="0">
                 <a:solidFill>
                   <a:schemeClr val="dk1"/>
                 </a:solidFill>
                 <a:latin typeface="+mn-lt"/>
                 <a:ea typeface="+mn-ea"/>
                 <a:cs typeface="+mn-cs"/>
-                <a:hlinkClick r:id="rId2" tooltip="Open the markdown-pptx project"/>
-              </a:rPr>
-              <a:t>Formatted</a:t>
-            </a:r>
-            <a:r>
-              <a:rPr b="0" i="0">
-                <a:solidFill>
-                  <a:schemeClr val="dk1"/>
-                </a:solidFill>
-                <a:latin typeface="+mn-lt"/>
-                <a:ea typeface="+mn-ea"/>
-                <a:cs typeface="+mn-cs"/>
-                <a:hlinkClick r:id="rId2" tooltip="Open the markdown-pptx project"/>
-              </a:rPr>
-              <a:t> </a:t>
-            </a:r>
-            <a:r>
-              <a:rPr b="0" i="1">
-                <a:solidFill>
-                  <a:schemeClr val="dk1"/>
-                </a:solidFill>
-                <a:latin typeface="+mn-lt"/>
-                <a:ea typeface="+mn-ea"/>
-                <a:cs typeface="+mn-cs"/>
-                <a:hlinkClick r:id="rId2" tooltip="Open the markdown-pptx project"/>
-              </a:rPr>
-              <a:t>links</a:t>
-            </a:r>
-            <a:r>
-              <a:rPr b="0" i="0">
-                <a:solidFill>
-                  <a:schemeClr val="dk1"/>
-                </a:solidFill>
-                <a:latin typeface="+mn-lt"/>
-                <a:ea typeface="+mn-ea"/>
-                <a:cs typeface="+mn-cs"/>
-              </a:rPr>
-              <a:t> retain their ScreenTips.</a:t>
+              </a:rPr>
+              <a:t> for structured results. Master and layout inspection report names, indices, placeholder inventory, and compatibility so people and coding agents can discover valid inputs before generating a deck.</a:t>
             </a:r>
             <a:endParaRPr>
               <a:solidFill>
@@ -16546,7 +17452,221 @@
 </p:sld>
 </file>
 
-<file path=ppt/slides/slide48.xml><?xml version="1.0" encoding="utf-8"?>
+<file path=ppt/slides/slide50.xml><?xml version="1.0" encoding="utf-8"?>
+<p:sld xmlns:a="http://schemas.openxmlformats.org/drawingml/2006/main" xmlns:p="http://schemas.openxmlformats.org/presentationml/2006/main" xmlns:r="http://schemas.openxmlformats.org/officeDocument/2006/relationships">
+  <p:cSld>
+    <p:spTree>
+      <p:nvGrpSpPr>
+        <p:cNvPr id="1" name=""/>
+        <p:cNvGrpSpPr/>
+        <p:nvPr/>
+      </p:nvGrpSpPr>
+      <p:grpSpPr/>
+      <p:sp>
+        <p:nvSpPr>
+          <p:cNvPr id="2" name="Title 1"/>
+          <p:cNvSpPr>
+            <a:spLocks noGrp="1"/>
+          </p:cNvSpPr>
+          <p:nvPr>
+            <p:ph type="title"/>
+          </p:nvPr>
+        </p:nvSpPr>
+        <p:spPr/>
+        <p:txBody>
+          <a:bodyPr>
+            <a:normAutofit/>
+          </a:bodyPr>
+          <a:lstStyle/>
+          <a:p>
+            <a:pPr>
+              <a:defRPr>
+                <a:solidFill>
+                  <a:schemeClr val="accent6"/>
+                </a:solidFill>
+              </a:defRPr>
+            </a:pPr>
+            <a:r>
+              <a:rPr>
+                <a:solidFill>
+                  <a:schemeClr val="accent6"/>
+                </a:solidFill>
+                <a:hlinkClick r:id="rId2" tooltip="Read the markdown-pptx guide"/>
+              </a:rPr>
+              <a:t>Shared references</a:t>
+            </a:r>
+            <a:endParaRPr>
+              <a:solidFill>
+                <a:schemeClr val="accent6"/>
+              </a:solidFill>
+            </a:endParaRPr>
+          </a:p>
+        </p:txBody>
+      </p:sp>
+      <p:sp>
+        <p:nvSpPr>
+          <p:cNvPr id="3" name="Content Placeholder 2"/>
+          <p:cNvSpPr>
+            <a:spLocks noGrp="1"/>
+          </p:cNvSpPr>
+          <p:nvPr>
+            <p:ph idx="1"/>
+          </p:nvPr>
+        </p:nvSpPr>
+        <p:spPr/>
+        <p:txBody>
+          <a:bodyPr wrap="square">
+            <a:normAutofit/>
+          </a:bodyPr>
+          <a:lstStyle/>
+          <a:p>
+            <a:pPr marL="0" indent="0">
+              <a:buNone/>
+              <a:defRPr>
+                <a:solidFill>
+                  <a:schemeClr val="dk1"/>
+                </a:solidFill>
+              </a:defRPr>
+            </a:pPr>
+            <a:r>
+              <a:rPr b="0" i="0">
+                <a:solidFill>
+                  <a:schemeClr val="dk1"/>
+                </a:solidFill>
+                <a:latin typeface="+mn-lt"/>
+                <a:ea typeface="+mn-ea"/>
+                <a:cs typeface="+mn-cs"/>
+              </a:rPr>
+              <a:t>Read the </a:t>
+            </a:r>
+            <a:r>
+              <a:rPr b="0" i="0">
+                <a:solidFill>
+                  <a:schemeClr val="dk1"/>
+                </a:solidFill>
+                <a:latin typeface="+mn-lt"/>
+                <a:ea typeface="+mn-ea"/>
+                <a:cs typeface="+mn-cs"/>
+                <a:hlinkClick r:id="rId2" tooltip="Read the markdown-pptx guide"/>
+              </a:rPr>
+              <a:t>project guide</a:t>
+            </a:r>
+            <a:r>
+              <a:rPr b="0" i="0">
+                <a:solidFill>
+                  <a:schemeClr val="dk1"/>
+                </a:solidFill>
+                <a:latin typeface="+mn-lt"/>
+                <a:ea typeface="+mn-ea"/>
+                <a:cs typeface="+mn-cs"/>
+              </a:rPr>
+              <a:t>.</a:t>
+            </a:r>
+            <a:endParaRPr>
+              <a:solidFill>
+                <a:schemeClr val="dk1"/>
+              </a:solidFill>
+            </a:endParaRPr>
+          </a:p>
+          <a:p>
+            <a:pPr marL="0" indent="0">
+              <a:buNone/>
+              <a:defRPr>
+                <a:solidFill>
+                  <a:schemeClr val="dk1"/>
+                </a:solidFill>
+              </a:defRPr>
+            </a:pPr>
+            <a:r>
+              <a:rPr b="0" i="0">
+                <a:solidFill>
+                  <a:schemeClr val="dk1"/>
+                </a:solidFill>
+                <a:latin typeface="+mn-lt"/>
+                <a:ea typeface="+mn-ea"/>
+                <a:cs typeface="+mn-cs"/>
+              </a:rPr>
+              <a:t>The same definition can supply links throughout the deck.</a:t>
+            </a:r>
+            <a:endParaRPr>
+              <a:solidFill>
+                <a:schemeClr val="dk1"/>
+              </a:solidFill>
+            </a:endParaRPr>
+          </a:p>
+          <a:p>
+            <a:pPr marL="0" indent="0">
+              <a:buNone/>
+              <a:defRPr>
+                <a:solidFill>
+                  <a:schemeClr val="dk1"/>
+                </a:solidFill>
+              </a:defRPr>
+            </a:pPr>
+            <a:r>
+              <a:rPr b="1" i="0">
+                <a:solidFill>
+                  <a:schemeClr val="dk1"/>
+                </a:solidFill>
+                <a:latin typeface="+mn-lt"/>
+                <a:ea typeface="+mn-ea"/>
+                <a:cs typeface="+mn-cs"/>
+                <a:hlinkClick r:id="rId2" tooltip="Open the markdown-pptx project"/>
+              </a:rPr>
+              <a:t>Formatted</a:t>
+            </a:r>
+            <a:r>
+              <a:rPr b="0" i="0">
+                <a:solidFill>
+                  <a:schemeClr val="dk1"/>
+                </a:solidFill>
+                <a:latin typeface="+mn-lt"/>
+                <a:ea typeface="+mn-ea"/>
+                <a:cs typeface="+mn-cs"/>
+                <a:hlinkClick r:id="rId2" tooltip="Open the markdown-pptx project"/>
+              </a:rPr>
+              <a:t> </a:t>
+            </a:r>
+            <a:r>
+              <a:rPr b="0" i="1">
+                <a:solidFill>
+                  <a:schemeClr val="dk1"/>
+                </a:solidFill>
+                <a:latin typeface="+mn-lt"/>
+                <a:ea typeface="+mn-ea"/>
+                <a:cs typeface="+mn-cs"/>
+                <a:hlinkClick r:id="rId2" tooltip="Open the markdown-pptx project"/>
+              </a:rPr>
+              <a:t>links</a:t>
+            </a:r>
+            <a:r>
+              <a:rPr b="0" i="0">
+                <a:solidFill>
+                  <a:schemeClr val="dk1"/>
+                </a:solidFill>
+                <a:latin typeface="+mn-lt"/>
+                <a:ea typeface="+mn-ea"/>
+                <a:cs typeface="+mn-cs"/>
+              </a:rPr>
+              <a:t> retain their ScreenTips.</a:t>
+            </a:r>
+            <a:endParaRPr>
+              <a:solidFill>
+                <a:schemeClr val="dk1"/>
+              </a:solidFill>
+            </a:endParaRPr>
+          </a:p>
+        </p:txBody>
+      </p:sp>
+    </p:spTree>
+  </p:cSld>
+  <p:clrMapOvr>
+    <a:masterClrMapping/>
+  </p:clrMapOvr>
+</p:sld>
+</file>
+
+<file path=ppt/slides/slide51.xml><?xml version="1.0" encoding="utf-8"?>
 <p:sld xmlns:a="http://schemas.openxmlformats.org/drawingml/2006/main" xmlns:p="http://schemas.openxmlformats.org/presentationml/2006/main" xmlns:r="http://schemas.openxmlformats.org/officeDocument/2006/relationships">
   <p:cSld>
     <p:bg>
@@ -16857,7 +17977,7 @@
 </p:sld>
 </file>
 
-<file path=ppt/slides/slide49.xml><?xml version="1.0" encoding="utf-8"?>
+<file path=ppt/slides/slide52.xml><?xml version="1.0" encoding="utf-8"?>
 <p:sld xmlns:a="http://schemas.openxmlformats.org/drawingml/2006/main" xmlns:p="http://schemas.openxmlformats.org/presentationml/2006/main" xmlns:r="http://schemas.openxmlformats.org/officeDocument/2006/relationships">
   <p:cSld>
     <p:spTree>
@@ -17071,235 +18191,7 @@
 </p:sld>
 </file>
 
-<file path=ppt/slides/slide5.xml><?xml version="1.0" encoding="utf-8"?>
-<p:sld xmlns:a="http://schemas.openxmlformats.org/drawingml/2006/main" xmlns:p="http://schemas.openxmlformats.org/presentationml/2006/main" xmlns:r="http://schemas.openxmlformats.org/officeDocument/2006/relationships">
-  <p:cSld>
-    <p:spTree>
-      <p:nvGrpSpPr>
-        <p:cNvPr id="1" name=""/>
-        <p:cNvGrpSpPr/>
-        <p:nvPr/>
-      </p:nvGrpSpPr>
-      <p:grpSpPr/>
-      <p:sp>
-        <p:nvSpPr>
-          <p:cNvPr id="2" name="Title 1"/>
-          <p:cNvSpPr>
-            <a:spLocks noGrp="1"/>
-          </p:cNvSpPr>
-          <p:nvPr>
-            <p:ph type="title"/>
-          </p:nvPr>
-        </p:nvSpPr>
-        <p:spPr/>
-        <p:txBody>
-          <a:bodyPr>
-            <a:normAutofit/>
-          </a:bodyPr>
-          <a:lstStyle/>
-          <a:p>
-            <a:pPr>
-              <a:defRPr>
-                <a:solidFill>
-                  <a:schemeClr val="accent6"/>
-                </a:solidFill>
-              </a:defRPr>
-            </a:pPr>
-            <a:r>
-              <a:rPr>
-                <a:solidFill>
-                  <a:schemeClr val="accent6"/>
-                </a:solidFill>
-              </a:rPr>
-              <a:t>Inspection-friendly CLI modes</a:t>
-            </a:r>
-            <a:endParaRPr>
-              <a:solidFill>
-                <a:schemeClr val="accent6"/>
-              </a:solidFill>
-            </a:endParaRPr>
-          </a:p>
-        </p:txBody>
-      </p:sp>
-      <p:sp>
-        <p:nvSpPr>
-          <p:cNvPr id="3" name="Content Placeholder 2"/>
-          <p:cNvSpPr>
-            <a:spLocks noGrp="1"/>
-          </p:cNvSpPr>
-          <p:nvPr>
-            <p:ph idx="1"/>
-          </p:nvPr>
-        </p:nvSpPr>
-        <p:spPr/>
-        <p:txBody>
-          <a:bodyPr wrap="square">
-            <a:normAutofit/>
-          </a:bodyPr>
-          <a:lstStyle/>
-          <a:p>
-            <a:pPr marL="0" indent="0">
-              <a:buNone/>
-              <a:defRPr>
-                <a:solidFill>
-                  <a:schemeClr val="dk1"/>
-                </a:solidFill>
-              </a:defRPr>
-            </a:pPr>
-            <a:r>
-              <a:rPr b="0" i="0">
-                <a:solidFill>
-                  <a:schemeClr val="dk1"/>
-                </a:solidFill>
-                <a:latin typeface="+mn-lt"/>
-                <a:ea typeface="+mn-ea"/>
-                <a:cs typeface="+mn-cs"/>
-              </a:rPr>
-              <a:t>Use </a:t>
-            </a:r>
-            <a:r>
-              <a:rPr b="0" i="0">
-                <a:solidFill>
-                  <a:schemeClr val="dk1"/>
-                </a:solidFill>
-                <a:latin typeface="Consolas"/>
-              </a:rPr>
-              <a:t>--syntax</a:t>
-            </a:r>
-            <a:r>
-              <a:rPr b="0" i="0">
-                <a:solidFill>
-                  <a:schemeClr val="dk1"/>
-                </a:solidFill>
-                <a:latin typeface="+mn-lt"/>
-                <a:ea typeface="+mn-ea"/>
-                <a:cs typeface="+mn-cs"/>
-              </a:rPr>
-              <a:t> to print the supported deck format, </a:t>
-            </a:r>
-            <a:r>
-              <a:rPr b="0" i="0">
-                <a:solidFill>
-                  <a:schemeClr val="dk1"/>
-                </a:solidFill>
-                <a:latin typeface="Consolas"/>
-              </a:rPr>
-              <a:t>--list-masters</a:t>
-            </a:r>
-            <a:r>
-              <a:rPr b="0" i="0">
-                <a:solidFill>
-                  <a:schemeClr val="dk1"/>
-                </a:solidFill>
-                <a:latin typeface="+mn-lt"/>
-                <a:ea typeface="+mn-ea"/>
-                <a:cs typeface="+mn-cs"/>
-              </a:rPr>
-              <a:t> to inspect a template's slide masters, </a:t>
-            </a:r>
-            <a:r>
-              <a:rPr b="0" i="0">
-                <a:solidFill>
-                  <a:schemeClr val="dk1"/>
-                </a:solidFill>
-                <a:latin typeface="Consolas"/>
-              </a:rPr>
-              <a:t>--list-layouts</a:t>
-            </a:r>
-            <a:r>
-              <a:rPr b="0" i="0">
-                <a:solidFill>
-                  <a:schemeClr val="dk1"/>
-                </a:solidFill>
-                <a:latin typeface="+mn-lt"/>
-                <a:ea typeface="+mn-ea"/>
-                <a:cs typeface="+mn-cs"/>
-              </a:rPr>
-              <a:t> to inspect layouts on a selected master, and </a:t>
-            </a:r>
-            <a:r>
-              <a:rPr b="0" i="0">
-                <a:solidFill>
-                  <a:schemeClr val="dk1"/>
-                </a:solidFill>
-                <a:latin typeface="Consolas"/>
-              </a:rPr>
-              <a:t>--list-color-schemes</a:t>
-            </a:r>
-            <a:r>
-              <a:rPr b="0" i="0">
-                <a:solidFill>
-                  <a:schemeClr val="dk1"/>
-                </a:solidFill>
-                <a:latin typeface="+mn-lt"/>
-                <a:ea typeface="+mn-ea"/>
-                <a:cs typeface="+mn-cs"/>
-              </a:rPr>
-              <a:t> to see the built-in theme presets.</a:t>
-            </a:r>
-            <a:endParaRPr>
-              <a:solidFill>
-                <a:schemeClr val="dk1"/>
-              </a:solidFill>
-            </a:endParaRPr>
-          </a:p>
-          <a:p>
-            <a:pPr marL="0" indent="0">
-              <a:buNone/>
-              <a:defRPr>
-                <a:solidFill>
-                  <a:schemeClr val="dk1"/>
-                </a:solidFill>
-              </a:defRPr>
-            </a:pPr>
-            <a:r>
-              <a:rPr b="0" i="0">
-                <a:solidFill>
-                  <a:schemeClr val="dk1"/>
-                </a:solidFill>
-                <a:latin typeface="+mn-lt"/>
-                <a:ea typeface="+mn-ea"/>
-                <a:cs typeface="+mn-cs"/>
-              </a:rPr>
-              <a:t>Add </a:t>
-            </a:r>
-            <a:r>
-              <a:rPr b="0" i="0">
-                <a:solidFill>
-                  <a:schemeClr val="dk1"/>
-                </a:solidFill>
-                <a:latin typeface="Consolas"/>
-              </a:rPr>
-              <a:t>--json</a:t>
-            </a:r>
-            <a:r>
-              <a:rPr b="0" i="0">
-                <a:solidFill>
-                  <a:schemeClr val="dk1"/>
-                </a:solidFill>
-                <a:latin typeface="+mn-lt"/>
-                <a:ea typeface="+mn-ea"/>
-                <a:cs typeface="+mn-cs"/>
-              </a:rPr>
-              <a:t> for structured results. Master and layout inspection report names, indices, placeholder inventory, and compatibility so people and coding agents can discover valid inputs before generating a deck.</a:t>
-            </a:r>
-            <a:endParaRPr>
-              <a:solidFill>
-                <a:schemeClr val="dk1"/>
-              </a:solidFill>
-            </a:endParaRPr>
-          </a:p>
-        </p:txBody>
-      </p:sp>
-    </p:spTree>
-  </p:cSld>
-  <p:clrMapOvr>
-    <a:masterClrMapping/>
-  </p:clrMapOvr>
-</p:sld>
-</file>
-
-<file path=ppt/slides/slide50.xml><?xml version="1.0" encoding="utf-8"?>
+<file path=ppt/slides/slide53.xml><?xml version="1.0" encoding="utf-8"?>
 <p:sld xmlns:a="http://schemas.openxmlformats.org/drawingml/2006/main" xmlns:p="http://schemas.openxmlformats.org/presentationml/2006/main" xmlns:r="http://schemas.openxmlformats.org/officeDocument/2006/relationships">
   <p:cSld>
     <p:spTree>

</xml_diff>